<commit_message>
Update portfolio concurrency experience
</commit_message>
<xml_diff>
--- a/portfolio/heetae-lee-portfolio.pptx
+++ b/portfolio/heetae-lee-portfolio.pptx
@@ -2,24 +2,24 @@
 <file path=ppt/presentation.xml><?xml version="1.0" encoding="utf-8"?>
 <p:presentation xmlns:p="http://schemas.openxmlformats.org/presentationml/2006/main">
   <p:sldMasterIdLst>
-    <p:sldMasterId xmlns:r="http://schemas.openxmlformats.org/officeDocument/2006/relationships" id="2147483648" r:id="R519f1845044c49af"/>
+    <p:sldMasterId xmlns:r="http://schemas.openxmlformats.org/officeDocument/2006/relationships" id="2147483648" r:id="R9e96a826022344ea"/>
   </p:sldMasterIdLst>
   <p:notesMasterIdLst>
-    <p:notesMasterId xmlns:r="http://schemas.openxmlformats.org/officeDocument/2006/relationships" r:id="R14cb300cc2e248ce"/>
+    <p:notesMasterId xmlns:r="http://schemas.openxmlformats.org/officeDocument/2006/relationships" r:id="R65d2d542cded41bf"/>
   </p:notesMasterIdLst>
   <p:sldIdLst>
-    <p:sldId xmlns:r="http://schemas.openxmlformats.org/officeDocument/2006/relationships" id="256" r:id="R99f759b12bb34dab"/>
-    <p:sldId xmlns:r="http://schemas.openxmlformats.org/officeDocument/2006/relationships" id="257" r:id="R6f9bedcf2b4c4d97"/>
-    <p:sldId xmlns:r="http://schemas.openxmlformats.org/officeDocument/2006/relationships" id="258" r:id="Rf745a889b6694c4f"/>
-    <p:sldId xmlns:r="http://schemas.openxmlformats.org/officeDocument/2006/relationships" id="259" r:id="R45e4afbafdf14345"/>
-    <p:sldId xmlns:r="http://schemas.openxmlformats.org/officeDocument/2006/relationships" id="260" r:id="R812f076eabd74cb2"/>
-    <p:sldId xmlns:r="http://schemas.openxmlformats.org/officeDocument/2006/relationships" id="261" r:id="R83794da97dbd47f7"/>
-    <p:sldId xmlns:r="http://schemas.openxmlformats.org/officeDocument/2006/relationships" id="262" r:id="Rea1d4e60db334e9c"/>
-    <p:sldId xmlns:r="http://schemas.openxmlformats.org/officeDocument/2006/relationships" id="263" r:id="R2fbaab35a1ab4bb6"/>
-    <p:sldId xmlns:r="http://schemas.openxmlformats.org/officeDocument/2006/relationships" id="264" r:id="R97e17d6f8cb24a6f"/>
-    <p:sldId xmlns:r="http://schemas.openxmlformats.org/officeDocument/2006/relationships" id="265" r:id="R68f363d7e2c74c7c"/>
-    <p:sldId xmlns:r="http://schemas.openxmlformats.org/officeDocument/2006/relationships" id="266" r:id="R2038e9d87f53496a"/>
-    <p:sldId xmlns:r="http://schemas.openxmlformats.org/officeDocument/2006/relationships" id="267" r:id="R35d05efa9fda43c1"/>
+    <p:sldId xmlns:r="http://schemas.openxmlformats.org/officeDocument/2006/relationships" id="256" r:id="R97c9d49a475a4916"/>
+    <p:sldId xmlns:r="http://schemas.openxmlformats.org/officeDocument/2006/relationships" id="257" r:id="R5a1d1a507e3e4418"/>
+    <p:sldId xmlns:r="http://schemas.openxmlformats.org/officeDocument/2006/relationships" id="258" r:id="R1a7e0feb59b74fdf"/>
+    <p:sldId xmlns:r="http://schemas.openxmlformats.org/officeDocument/2006/relationships" id="259" r:id="Re267cc6eb61e4ee7"/>
+    <p:sldId xmlns:r="http://schemas.openxmlformats.org/officeDocument/2006/relationships" id="260" r:id="R2f92c15733d045c6"/>
+    <p:sldId xmlns:r="http://schemas.openxmlformats.org/officeDocument/2006/relationships" id="261" r:id="Raf0e74cc7fd8419f"/>
+    <p:sldId xmlns:r="http://schemas.openxmlformats.org/officeDocument/2006/relationships" id="262" r:id="R66a29bac4ca64f2d"/>
+    <p:sldId xmlns:r="http://schemas.openxmlformats.org/officeDocument/2006/relationships" id="263" r:id="R2e5ea82fdf064d4e"/>
+    <p:sldId xmlns:r="http://schemas.openxmlformats.org/officeDocument/2006/relationships" id="264" r:id="Rc1f90e1d8825480a"/>
+    <p:sldId xmlns:r="http://schemas.openxmlformats.org/officeDocument/2006/relationships" id="265" r:id="Rcdf00582d2a2400a"/>
+    <p:sldId xmlns:r="http://schemas.openxmlformats.org/officeDocument/2006/relationships" id="266" r:id="R4c2ce11f843240af"/>
+    <p:sldId xmlns:r="http://schemas.openxmlformats.org/officeDocument/2006/relationships" id="267" r:id="Rc4d4b2d811814f5e"/>
   </p:sldIdLst>
   <p:sldSz cx="12192000" cy="6858000"/>
   <p:notesSz cx="6858000" cy="9144000"/>
@@ -1338,7 +1338,7 @@
   </p:cSld>
   <p:clrMap bg1="lt1" tx1="dk1" bg2="lt2" tx2="dk2" accent1="accent1" accent2="accent2" accent3="accent3" accent4="accent4" accent5="accent5" accent6="accent6" hlink="hlink" folHlink="folHlink"/>
   <p:sldLayoutIdLst>
-    <p:sldLayoutId xmlns:r="http://schemas.openxmlformats.org/officeDocument/2006/relationships" id="2147483649" r:id="R23964740dc5b40f3"/>
+    <p:sldLayoutId xmlns:r="http://schemas.openxmlformats.org/officeDocument/2006/relationships" id="2147483649" r:id="Rb7525d82702b4fea"/>
   </p:sldLayoutIdLst>
   <p:txStyles>
     <p:titleStyle>
@@ -1889,7 +1889,7 @@
           <p:cNvPr id="28" name="">
             <a:extLst xmlns:a="http://schemas.openxmlformats.org/drawingml/2006/main">
               <a:ext uri="{FF2B5EF4-FFF2-40B4-BE49-F238E27FC236}">
-                <a16:creationId xmlns:a16="http://schemas.microsoft.com/office/drawing/2014/main" id="{7C4D5E6B-D2F6-4811-B171-4EC918681675}"/>
+                <a16:creationId xmlns:a16="http://schemas.microsoft.com/office/drawing/2014/main" id="{00439CCA-CE47-4D9B-A633-1DC0157DCF43}"/>
               </a:ext>
             </a:extLst>
           </p:cNvPr>
@@ -1920,7 +1920,7 @@
           <p:cNvPr id="2" name="">
             <a:extLst xmlns:a="http://schemas.openxmlformats.org/drawingml/2006/main">
               <a:ext uri="{FF2B5EF4-FFF2-40B4-BE49-F238E27FC236}">
-                <a16:creationId xmlns:a16="http://schemas.microsoft.com/office/drawing/2014/main" id="{9A3C222C-F6D5-4196-A7FC-F14CED936EA7}"/>
+                <a16:creationId xmlns:a16="http://schemas.microsoft.com/office/drawing/2014/main" id="{B5B4A9E9-C788-46F7-B737-244FA6C533F5}"/>
               </a:ext>
             </a:extLst>
           </p:cNvPr>
@@ -1970,7 +1970,7 @@
           <p:cNvPr id="3" name="">
             <a:extLst xmlns:a="http://schemas.openxmlformats.org/drawingml/2006/main">
               <a:ext uri="{FF2B5EF4-FFF2-40B4-BE49-F238E27FC236}">
-                <a16:creationId xmlns:a16="http://schemas.microsoft.com/office/drawing/2014/main" id="{7866B5E5-97E9-447B-A390-11DDA5639682}"/>
+                <a16:creationId xmlns:a16="http://schemas.microsoft.com/office/drawing/2014/main" id="{E82F81EF-2300-4FD1-86B9-21ECD960727B}"/>
               </a:ext>
             </a:extLst>
           </p:cNvPr>
@@ -2020,7 +2020,7 @@
           <p:cNvPr id="4" name="">
             <a:extLst xmlns:a="http://schemas.openxmlformats.org/drawingml/2006/main">
               <a:ext uri="{FF2B5EF4-FFF2-40B4-BE49-F238E27FC236}">
-                <a16:creationId xmlns:a16="http://schemas.microsoft.com/office/drawing/2014/main" id="{D6C573DF-F9F5-4DD1-9CB1-4B8289341521}"/>
+                <a16:creationId xmlns:a16="http://schemas.microsoft.com/office/drawing/2014/main" id="{243806A0-E52F-4623-9763-67158457B809}"/>
               </a:ext>
             </a:extLst>
           </p:cNvPr>
@@ -2070,7 +2070,7 @@
           <p:cNvPr id="5" name="">
             <a:extLst xmlns:a="http://schemas.openxmlformats.org/drawingml/2006/main">
               <a:ext uri="{FF2B5EF4-FFF2-40B4-BE49-F238E27FC236}">
-                <a16:creationId xmlns:a16="http://schemas.microsoft.com/office/drawing/2014/main" id="{D6631802-8BAF-46CD-83EB-3CE84136037C}"/>
+                <a16:creationId xmlns:a16="http://schemas.microsoft.com/office/drawing/2014/main" id="{446D6FB9-7DC3-439D-A34E-5308FE8A6481}"/>
               </a:ext>
             </a:extLst>
           </p:cNvPr>
@@ -2137,7 +2137,7 @@
           <p:cNvPr id="6" name="">
             <a:extLst xmlns:a="http://schemas.openxmlformats.org/drawingml/2006/main">
               <a:ext uri="{FF2B5EF4-FFF2-40B4-BE49-F238E27FC236}">
-                <a16:creationId xmlns:a16="http://schemas.microsoft.com/office/drawing/2014/main" id="{ADC9C384-6098-40C3-9D42-5619927A06A3}"/>
+                <a16:creationId xmlns:a16="http://schemas.microsoft.com/office/drawing/2014/main" id="{5EE68021-1397-427A-8012-7D6C247000F2}"/>
               </a:ext>
             </a:extLst>
           </p:cNvPr>
@@ -2168,7 +2168,7 @@
           <p:cNvPr id="7" name="">
             <a:extLst xmlns:a="http://schemas.openxmlformats.org/drawingml/2006/main">
               <a:ext uri="{FF2B5EF4-FFF2-40B4-BE49-F238E27FC236}">
-                <a16:creationId xmlns:a16="http://schemas.microsoft.com/office/drawing/2014/main" id="{1BE9F6E5-EFE6-4D45-813B-23C89ABCCB98}"/>
+                <a16:creationId xmlns:a16="http://schemas.microsoft.com/office/drawing/2014/main" id="{102F3BFC-4BD2-4BFE-B68F-128EEEBE52A2}"/>
               </a:ext>
             </a:extLst>
           </p:cNvPr>
@@ -2218,7 +2218,7 @@
           <p:cNvPr id="8" name="">
             <a:extLst xmlns:a="http://schemas.openxmlformats.org/drawingml/2006/main">
               <a:ext uri="{FF2B5EF4-FFF2-40B4-BE49-F238E27FC236}">
-                <a16:creationId xmlns:a16="http://schemas.microsoft.com/office/drawing/2014/main" id="{CD3E09C4-7E74-416E-BC1A-2DEF07D4473C}"/>
+                <a16:creationId xmlns:a16="http://schemas.microsoft.com/office/drawing/2014/main" id="{E7CA9FF6-E3A6-4C89-8028-97A6C0DB39F3}"/>
               </a:ext>
             </a:extLst>
           </p:cNvPr>
@@ -2268,7 +2268,7 @@
           <p:cNvPr id="9" name="">
             <a:extLst xmlns:a="http://schemas.openxmlformats.org/drawingml/2006/main">
               <a:ext uri="{FF2B5EF4-FFF2-40B4-BE49-F238E27FC236}">
-                <a16:creationId xmlns:a16="http://schemas.microsoft.com/office/drawing/2014/main" id="{84735547-9436-4C1F-926C-91EC55E32D92}"/>
+                <a16:creationId xmlns:a16="http://schemas.microsoft.com/office/drawing/2014/main" id="{7570024B-F18C-4301-9AB2-0D875AA675CF}"/>
               </a:ext>
             </a:extLst>
           </p:cNvPr>
@@ -2318,7 +2318,7 @@
           <p:cNvPr id="10" name="">
             <a:extLst xmlns:a="http://schemas.openxmlformats.org/drawingml/2006/main">
               <a:ext uri="{FF2B5EF4-FFF2-40B4-BE49-F238E27FC236}">
-                <a16:creationId xmlns:a16="http://schemas.microsoft.com/office/drawing/2014/main" id="{88FD8150-9D4F-4867-81FB-5B5179686F32}"/>
+                <a16:creationId xmlns:a16="http://schemas.microsoft.com/office/drawing/2014/main" id="{841DD657-0727-4825-94EA-6C2E5CD05693}"/>
               </a:ext>
             </a:extLst>
           </p:cNvPr>
@@ -2368,7 +2368,7 @@
           <p:cNvPr id="11" name="">
             <a:extLst xmlns:a="http://schemas.openxmlformats.org/drawingml/2006/main">
               <a:ext uri="{FF2B5EF4-FFF2-40B4-BE49-F238E27FC236}">
-                <a16:creationId xmlns:a16="http://schemas.microsoft.com/office/drawing/2014/main" id="{BC85C9CA-3A69-4A5A-9568-D6F986E7902E}"/>
+                <a16:creationId xmlns:a16="http://schemas.microsoft.com/office/drawing/2014/main" id="{37388CAC-F872-42E5-9BA5-DA60A112F6D7}"/>
               </a:ext>
             </a:extLst>
           </p:cNvPr>
@@ -2399,7 +2399,7 @@
           <p:cNvPr id="12" name="">
             <a:extLst xmlns:a="http://schemas.openxmlformats.org/drawingml/2006/main">
               <a:ext uri="{FF2B5EF4-FFF2-40B4-BE49-F238E27FC236}">
-                <a16:creationId xmlns:a16="http://schemas.microsoft.com/office/drawing/2014/main" id="{6770DA12-7CCE-4812-A1E3-6C3C568EF05C}"/>
+                <a16:creationId xmlns:a16="http://schemas.microsoft.com/office/drawing/2014/main" id="{930CF748-C3B7-4EEF-9C4F-CA8D30681812}"/>
               </a:ext>
             </a:extLst>
           </p:cNvPr>
@@ -2449,7 +2449,7 @@
           <p:cNvPr id="13" name="">
             <a:extLst xmlns:a="http://schemas.openxmlformats.org/drawingml/2006/main">
               <a:ext uri="{FF2B5EF4-FFF2-40B4-BE49-F238E27FC236}">
-                <a16:creationId xmlns:a16="http://schemas.microsoft.com/office/drawing/2014/main" id="{ABB817D6-77A8-492F-B4D5-84CD613D6CCA}"/>
+                <a16:creationId xmlns:a16="http://schemas.microsoft.com/office/drawing/2014/main" id="{689749C3-E161-4B60-8E32-B9583C5DCC40}"/>
               </a:ext>
             </a:extLst>
           </p:cNvPr>
@@ -2499,7 +2499,7 @@
           <p:cNvPr id="14" name="">
             <a:extLst xmlns:a="http://schemas.openxmlformats.org/drawingml/2006/main">
               <a:ext uri="{FF2B5EF4-FFF2-40B4-BE49-F238E27FC236}">
-                <a16:creationId xmlns:a16="http://schemas.microsoft.com/office/drawing/2014/main" id="{7B6B8255-9F94-4188-87C6-D5882AB166BC}"/>
+                <a16:creationId xmlns:a16="http://schemas.microsoft.com/office/drawing/2014/main" id="{30E5645E-DA47-402E-958A-F11155B97E26}"/>
               </a:ext>
             </a:extLst>
           </p:cNvPr>
@@ -2549,7 +2549,7 @@
           <p:cNvPr id="15" name="">
             <a:extLst xmlns:a="http://schemas.openxmlformats.org/drawingml/2006/main">
               <a:ext uri="{FF2B5EF4-FFF2-40B4-BE49-F238E27FC236}">
-                <a16:creationId xmlns:a16="http://schemas.microsoft.com/office/drawing/2014/main" id="{128FD117-DE92-42D0-AB5D-9AE0050365C0}"/>
+                <a16:creationId xmlns:a16="http://schemas.microsoft.com/office/drawing/2014/main" id="{FF60D958-56F6-44AE-AFF6-D009E2245081}"/>
               </a:ext>
             </a:extLst>
           </p:cNvPr>
@@ -2599,7 +2599,7 @@
           <p:cNvPr id="16" name="">
             <a:extLst xmlns:a="http://schemas.openxmlformats.org/drawingml/2006/main">
               <a:ext uri="{FF2B5EF4-FFF2-40B4-BE49-F238E27FC236}">
-                <a16:creationId xmlns:a16="http://schemas.microsoft.com/office/drawing/2014/main" id="{56C4F7E2-927C-471B-B52A-A1309E7A3C48}"/>
+                <a16:creationId xmlns:a16="http://schemas.microsoft.com/office/drawing/2014/main" id="{F3EC2FEF-0F6D-4B6C-A311-CA55EF4D9B6F}"/>
               </a:ext>
             </a:extLst>
           </p:cNvPr>
@@ -2630,7 +2630,7 @@
           <p:cNvPr id="17" name="">
             <a:extLst xmlns:a="http://schemas.openxmlformats.org/drawingml/2006/main">
               <a:ext uri="{FF2B5EF4-FFF2-40B4-BE49-F238E27FC236}">
-                <a16:creationId xmlns:a16="http://schemas.microsoft.com/office/drawing/2014/main" id="{545FF77F-AB1C-47FB-A961-D5BD8FFFFA8D}"/>
+                <a16:creationId xmlns:a16="http://schemas.microsoft.com/office/drawing/2014/main" id="{D9B3DEC4-AC8C-4B23-87F2-91B4DA4D9680}"/>
               </a:ext>
             </a:extLst>
           </p:cNvPr>
@@ -2680,7 +2680,7 @@
           <p:cNvPr id="18" name="">
             <a:extLst xmlns:a="http://schemas.openxmlformats.org/drawingml/2006/main">
               <a:ext uri="{FF2B5EF4-FFF2-40B4-BE49-F238E27FC236}">
-                <a16:creationId xmlns:a16="http://schemas.microsoft.com/office/drawing/2014/main" id="{856290BF-9FD1-43D2-816B-FF957D87C149}"/>
+                <a16:creationId xmlns:a16="http://schemas.microsoft.com/office/drawing/2014/main" id="{4B37E968-9CBE-449F-A9FF-B33F85CE04E6}"/>
               </a:ext>
             </a:extLst>
           </p:cNvPr>
@@ -2730,7 +2730,7 @@
           <p:cNvPr id="19" name="">
             <a:extLst xmlns:a="http://schemas.openxmlformats.org/drawingml/2006/main">
               <a:ext uri="{FF2B5EF4-FFF2-40B4-BE49-F238E27FC236}">
-                <a16:creationId xmlns:a16="http://schemas.microsoft.com/office/drawing/2014/main" id="{FEB6ABAD-E572-4C4F-AE62-9F287FE04BD3}"/>
+                <a16:creationId xmlns:a16="http://schemas.microsoft.com/office/drawing/2014/main" id="{C5ADE32F-8713-4761-A98B-07569A68A47F}"/>
               </a:ext>
             </a:extLst>
           </p:cNvPr>
@@ -2780,7 +2780,7 @@
           <p:cNvPr id="20" name="">
             <a:extLst xmlns:a="http://schemas.openxmlformats.org/drawingml/2006/main">
               <a:ext uri="{FF2B5EF4-FFF2-40B4-BE49-F238E27FC236}">
-                <a16:creationId xmlns:a16="http://schemas.microsoft.com/office/drawing/2014/main" id="{3E9B9A3B-75A1-4488-AD48-5DB945B708F5}"/>
+                <a16:creationId xmlns:a16="http://schemas.microsoft.com/office/drawing/2014/main" id="{68747012-76A1-4D29-9651-AD483C05A489}"/>
               </a:ext>
             </a:extLst>
           </p:cNvPr>
@@ -2811,7 +2811,7 @@
           <p:cNvPr id="21" name="">
             <a:extLst xmlns:a="http://schemas.openxmlformats.org/drawingml/2006/main">
               <a:ext uri="{FF2B5EF4-FFF2-40B4-BE49-F238E27FC236}">
-                <a16:creationId xmlns:a16="http://schemas.microsoft.com/office/drawing/2014/main" id="{CB70D74E-7439-4B67-AF72-9A177B90318D}"/>
+                <a16:creationId xmlns:a16="http://schemas.microsoft.com/office/drawing/2014/main" id="{F6E0630C-B140-468E-83E6-44B5787DFFD2}"/>
               </a:ext>
             </a:extLst>
           </p:cNvPr>
@@ -2861,7 +2861,7 @@
           <p:cNvPr id="22" name="">
             <a:extLst xmlns:a="http://schemas.openxmlformats.org/drawingml/2006/main">
               <a:ext uri="{FF2B5EF4-FFF2-40B4-BE49-F238E27FC236}">
-                <a16:creationId xmlns:a16="http://schemas.microsoft.com/office/drawing/2014/main" id="{40AF1160-93E7-4994-8B48-9C710A08949A}"/>
+                <a16:creationId xmlns:a16="http://schemas.microsoft.com/office/drawing/2014/main" id="{A4ADE38D-FA0C-4EAC-A84D-98A7DAD29B0D}"/>
               </a:ext>
             </a:extLst>
           </p:cNvPr>
@@ -2911,7 +2911,7 @@
           <p:cNvPr id="23" name="">
             <a:extLst xmlns:a="http://schemas.openxmlformats.org/drawingml/2006/main">
               <a:ext uri="{FF2B5EF4-FFF2-40B4-BE49-F238E27FC236}">
-                <a16:creationId xmlns:a16="http://schemas.microsoft.com/office/drawing/2014/main" id="{E08523CD-3064-4609-A6FB-5A568201716F}"/>
+                <a16:creationId xmlns:a16="http://schemas.microsoft.com/office/drawing/2014/main" id="{5B10EF26-EE50-47D2-98F2-8FCE33BDBFEF}"/>
               </a:ext>
             </a:extLst>
           </p:cNvPr>
@@ -2961,7 +2961,7 @@
           <p:cNvPr id="24" name="">
             <a:extLst xmlns:a="http://schemas.openxmlformats.org/drawingml/2006/main">
               <a:ext uri="{FF2B5EF4-FFF2-40B4-BE49-F238E27FC236}">
-                <a16:creationId xmlns:a16="http://schemas.microsoft.com/office/drawing/2014/main" id="{B603424C-BFC0-443C-B32B-675843B2D47F}"/>
+                <a16:creationId xmlns:a16="http://schemas.microsoft.com/office/drawing/2014/main" id="{4AC6B851-02A5-464F-870A-13CEBC6A1F3E}"/>
               </a:ext>
             </a:extLst>
           </p:cNvPr>
@@ -2992,7 +2992,7 @@
           <p:cNvPr id="25" name="">
             <a:extLst xmlns:a="http://schemas.openxmlformats.org/drawingml/2006/main">
               <a:ext uri="{FF2B5EF4-FFF2-40B4-BE49-F238E27FC236}">
-                <a16:creationId xmlns:a16="http://schemas.microsoft.com/office/drawing/2014/main" id="{DDF3DAD4-B5DE-49AB-B4E5-C5A782F333AD}"/>
+                <a16:creationId xmlns:a16="http://schemas.microsoft.com/office/drawing/2014/main" id="{AF9A639E-3786-4E2B-97B0-7586B7761D1D}"/>
               </a:ext>
             </a:extLst>
           </p:cNvPr>
@@ -3042,7 +3042,7 @@
           <p:cNvPr id="26" name="">
             <a:extLst xmlns:a="http://schemas.openxmlformats.org/drawingml/2006/main">
               <a:ext uri="{FF2B5EF4-FFF2-40B4-BE49-F238E27FC236}">
-                <a16:creationId xmlns:a16="http://schemas.microsoft.com/office/drawing/2014/main" id="{757CB18B-F89E-45B0-9ACD-7A3D45E05BE8}"/>
+                <a16:creationId xmlns:a16="http://schemas.microsoft.com/office/drawing/2014/main" id="{58CF9F56-6AD3-41E5-9134-6FA0CF883E0F}"/>
               </a:ext>
             </a:extLst>
           </p:cNvPr>
@@ -3092,7 +3092,7 @@
           <p:cNvPr id="27" name="">
             <a:extLst xmlns:a="http://schemas.openxmlformats.org/drawingml/2006/main">
               <a:ext uri="{FF2B5EF4-FFF2-40B4-BE49-F238E27FC236}">
-                <a16:creationId xmlns:a16="http://schemas.microsoft.com/office/drawing/2014/main" id="{BF990DFF-46B2-4C99-A9E5-E43AB75831EB}"/>
+                <a16:creationId xmlns:a16="http://schemas.microsoft.com/office/drawing/2014/main" id="{1A71AD41-3C98-4701-94DE-302D4BFCB712}"/>
               </a:ext>
             </a:extLst>
           </p:cNvPr>
@@ -3140,7 +3140,7 @@
     </p:spTree>
     <p:extLst>
       <p:ext uri="{BB962C8B-B14F-4D97-AF65-F5344CB8AC3E}">
-        <p14:creationId xmlns:p14="http://schemas.microsoft.com/office/powerpoint/2010/main" val="291607184"/>
+        <p14:creationId xmlns:p14="http://schemas.microsoft.com/office/powerpoint/2010/main" val="1695730787"/>
       </p:ext>
     </p:extLst>
   </p:cSld>
@@ -3171,7 +3171,7 @@
           <p:cNvPr id="32" name="">
             <a:extLst xmlns:a="http://schemas.openxmlformats.org/drawingml/2006/main">
               <a:ext uri="{FF2B5EF4-FFF2-40B4-BE49-F238E27FC236}">
-                <a16:creationId xmlns:a16="http://schemas.microsoft.com/office/drawing/2014/main" id="{E0904426-8766-4C39-8409-D5610C416460}"/>
+                <a16:creationId xmlns:a16="http://schemas.microsoft.com/office/drawing/2014/main" id="{D406587B-DCB2-47B7-94E9-95172C2B5BE6}"/>
               </a:ext>
             </a:extLst>
           </p:cNvPr>
@@ -3221,7 +3221,7 @@
           <p:cNvPr id="2" name="">
             <a:extLst xmlns:a="http://schemas.openxmlformats.org/drawingml/2006/main">
               <a:ext uri="{FF2B5EF4-FFF2-40B4-BE49-F238E27FC236}">
-                <a16:creationId xmlns:a16="http://schemas.microsoft.com/office/drawing/2014/main" id="{90833ABC-F282-40AE-BF6C-BD48C052DBEE}"/>
+                <a16:creationId xmlns:a16="http://schemas.microsoft.com/office/drawing/2014/main" id="{F1BE1BEB-845C-44D6-A68C-F8B616E61095}"/>
               </a:ext>
             </a:extLst>
           </p:cNvPr>
@@ -3252,7 +3252,7 @@
           <p:cNvPr id="3" name="">
             <a:extLst xmlns:a="http://schemas.openxmlformats.org/drawingml/2006/main">
               <a:ext uri="{FF2B5EF4-FFF2-40B4-BE49-F238E27FC236}">
-                <a16:creationId xmlns:a16="http://schemas.microsoft.com/office/drawing/2014/main" id="{B834B51E-6918-4BB0-9986-64AF11EC1008}"/>
+                <a16:creationId xmlns:a16="http://schemas.microsoft.com/office/drawing/2014/main" id="{6905A8FE-04F2-4734-A508-67E549EB6A2B}"/>
               </a:ext>
             </a:extLst>
           </p:cNvPr>
@@ -3302,7 +3302,7 @@
           <p:cNvPr id="4" name="">
             <a:extLst xmlns:a="http://schemas.openxmlformats.org/drawingml/2006/main">
               <a:ext uri="{FF2B5EF4-FFF2-40B4-BE49-F238E27FC236}">
-                <a16:creationId xmlns:a16="http://schemas.microsoft.com/office/drawing/2014/main" id="{A72C21AB-90B7-4EFC-8435-38F141CBE327}"/>
+                <a16:creationId xmlns:a16="http://schemas.microsoft.com/office/drawing/2014/main" id="{47D08338-68F7-471F-8322-0EAE06F117A6}"/>
               </a:ext>
             </a:extLst>
           </p:cNvPr>
@@ -3352,7 +3352,7 @@
           <p:cNvPr id="5" name="">
             <a:extLst xmlns:a="http://schemas.openxmlformats.org/drawingml/2006/main">
               <a:ext uri="{FF2B5EF4-FFF2-40B4-BE49-F238E27FC236}">
-                <a16:creationId xmlns:a16="http://schemas.microsoft.com/office/drawing/2014/main" id="{F40DB08D-9DEC-494C-92E4-2264B6C7AC96}"/>
+                <a16:creationId xmlns:a16="http://schemas.microsoft.com/office/drawing/2014/main" id="{AC12A823-47FE-4A36-83C5-65468F5D9B72}"/>
               </a:ext>
             </a:extLst>
           </p:cNvPr>
@@ -3402,7 +3402,7 @@
           <p:cNvPr id="6" name="">
             <a:extLst xmlns:a="http://schemas.openxmlformats.org/drawingml/2006/main">
               <a:ext uri="{FF2B5EF4-FFF2-40B4-BE49-F238E27FC236}">
-                <a16:creationId xmlns:a16="http://schemas.microsoft.com/office/drawing/2014/main" id="{9E438CFF-1DA7-4555-85B0-835B244E9C57}"/>
+                <a16:creationId xmlns:a16="http://schemas.microsoft.com/office/drawing/2014/main" id="{1D7728E7-1051-4A61-A4C1-E3CD4CB8E784}"/>
               </a:ext>
             </a:extLst>
           </p:cNvPr>
@@ -3452,7 +3452,7 @@
           <p:cNvPr id="7" name="">
             <a:extLst xmlns:a="http://schemas.openxmlformats.org/drawingml/2006/main">
               <a:ext uri="{FF2B5EF4-FFF2-40B4-BE49-F238E27FC236}">
-                <a16:creationId xmlns:a16="http://schemas.microsoft.com/office/drawing/2014/main" id="{36503E7E-4BC3-4D4D-8B73-E0C206C4272C}"/>
+                <a16:creationId xmlns:a16="http://schemas.microsoft.com/office/drawing/2014/main" id="{F39AB330-F642-410C-B073-07D8AA7C480E}"/>
               </a:ext>
             </a:extLst>
           </p:cNvPr>
@@ -3483,7 +3483,7 @@
           <p:cNvPr id="8" name="">
             <a:extLst xmlns:a="http://schemas.openxmlformats.org/drawingml/2006/main">
               <a:ext uri="{FF2B5EF4-FFF2-40B4-BE49-F238E27FC236}">
-                <a16:creationId xmlns:a16="http://schemas.microsoft.com/office/drawing/2014/main" id="{7B4DE3BF-56AF-4C2A-AE79-031D198CD043}"/>
+                <a16:creationId xmlns:a16="http://schemas.microsoft.com/office/drawing/2014/main" id="{B4434ADA-668C-4716-8447-F7EC15D30A4B}"/>
               </a:ext>
             </a:extLst>
           </p:cNvPr>
@@ -3533,7 +3533,7 @@
           <p:cNvPr id="9" name="">
             <a:extLst xmlns:a="http://schemas.openxmlformats.org/drawingml/2006/main">
               <a:ext uri="{FF2B5EF4-FFF2-40B4-BE49-F238E27FC236}">
-                <a16:creationId xmlns:a16="http://schemas.microsoft.com/office/drawing/2014/main" id="{4420FB78-302E-42CE-8529-938A78522B84}"/>
+                <a16:creationId xmlns:a16="http://schemas.microsoft.com/office/drawing/2014/main" id="{ADE50E9D-8E1E-4C8C-9C5C-E4E18B8BB591}"/>
               </a:ext>
             </a:extLst>
           </p:cNvPr>
@@ -3600,7 +3600,7 @@
           <p:cNvPr id="10" name="">
             <a:extLst xmlns:a="http://schemas.openxmlformats.org/drawingml/2006/main">
               <a:ext uri="{FF2B5EF4-FFF2-40B4-BE49-F238E27FC236}">
-                <a16:creationId xmlns:a16="http://schemas.microsoft.com/office/drawing/2014/main" id="{567E3274-1D34-4054-B71F-5EC29A621219}"/>
+                <a16:creationId xmlns:a16="http://schemas.microsoft.com/office/drawing/2014/main" id="{8360E3CE-F3C0-4E4B-993B-BC59B54B617D}"/>
               </a:ext>
             </a:extLst>
           </p:cNvPr>
@@ -3650,7 +3650,7 @@
           <p:cNvPr id="11" name="">
             <a:extLst xmlns:a="http://schemas.openxmlformats.org/drawingml/2006/main">
               <a:ext uri="{FF2B5EF4-FFF2-40B4-BE49-F238E27FC236}">
-                <a16:creationId xmlns:a16="http://schemas.microsoft.com/office/drawing/2014/main" id="{144B9A16-ED4A-4BD9-9249-3F9792C82DE6}"/>
+                <a16:creationId xmlns:a16="http://schemas.microsoft.com/office/drawing/2014/main" id="{79DD2D8A-F648-48EC-8E91-1F248A37BAB3}"/>
               </a:ext>
             </a:extLst>
           </p:cNvPr>
@@ -3681,7 +3681,7 @@
           <p:cNvPr id="12" name="">
             <a:extLst xmlns:a="http://schemas.openxmlformats.org/drawingml/2006/main">
               <a:ext uri="{FF2B5EF4-FFF2-40B4-BE49-F238E27FC236}">
-                <a16:creationId xmlns:a16="http://schemas.microsoft.com/office/drawing/2014/main" id="{A7D6424C-FC39-414F-989A-05145E8EFAE7}"/>
+                <a16:creationId xmlns:a16="http://schemas.microsoft.com/office/drawing/2014/main" id="{99F11765-3D6D-4C0D-82AC-EAC58C143730}"/>
               </a:ext>
             </a:extLst>
           </p:cNvPr>
@@ -3731,7 +3731,7 @@
           <p:cNvPr id="13" name="">
             <a:extLst xmlns:a="http://schemas.openxmlformats.org/drawingml/2006/main">
               <a:ext uri="{FF2B5EF4-FFF2-40B4-BE49-F238E27FC236}">
-                <a16:creationId xmlns:a16="http://schemas.microsoft.com/office/drawing/2014/main" id="{659F8CA6-D3F2-42BE-85EC-DF3886E3703B}"/>
+                <a16:creationId xmlns:a16="http://schemas.microsoft.com/office/drawing/2014/main" id="{31C41884-CED9-47A6-A487-58E0FDA89B6C}"/>
               </a:ext>
             </a:extLst>
           </p:cNvPr>
@@ -3798,7 +3798,7 @@
           <p:cNvPr id="14" name="">
             <a:extLst xmlns:a="http://schemas.openxmlformats.org/drawingml/2006/main">
               <a:ext uri="{FF2B5EF4-FFF2-40B4-BE49-F238E27FC236}">
-                <a16:creationId xmlns:a16="http://schemas.microsoft.com/office/drawing/2014/main" id="{EFEB389B-B001-46C1-B99B-23B7F41396D4}"/>
+                <a16:creationId xmlns:a16="http://schemas.microsoft.com/office/drawing/2014/main" id="{B69129F2-D1E7-4FF7-A95E-43956FBB62B1}"/>
               </a:ext>
             </a:extLst>
           </p:cNvPr>
@@ -3848,7 +3848,7 @@
           <p:cNvPr id="15" name="">
             <a:extLst xmlns:a="http://schemas.openxmlformats.org/drawingml/2006/main">
               <a:ext uri="{FF2B5EF4-FFF2-40B4-BE49-F238E27FC236}">
-                <a16:creationId xmlns:a16="http://schemas.microsoft.com/office/drawing/2014/main" id="{A1C760F8-61EC-4AFC-8E38-66E53080E6B7}"/>
+                <a16:creationId xmlns:a16="http://schemas.microsoft.com/office/drawing/2014/main" id="{E82BB1D7-B5A3-4162-842B-D3A86FB8BEAE}"/>
               </a:ext>
             </a:extLst>
           </p:cNvPr>
@@ -3879,7 +3879,7 @@
           <p:cNvPr id="16" name="">
             <a:extLst xmlns:a="http://schemas.openxmlformats.org/drawingml/2006/main">
               <a:ext uri="{FF2B5EF4-FFF2-40B4-BE49-F238E27FC236}">
-                <a16:creationId xmlns:a16="http://schemas.microsoft.com/office/drawing/2014/main" id="{F8D8286F-6099-484B-B7EF-6D573A381A29}"/>
+                <a16:creationId xmlns:a16="http://schemas.microsoft.com/office/drawing/2014/main" id="{197F8A78-D71B-41CE-9A15-63411669F65A}"/>
               </a:ext>
             </a:extLst>
           </p:cNvPr>
@@ -3929,7 +3929,7 @@
           <p:cNvPr id="17" name="">
             <a:extLst xmlns:a="http://schemas.openxmlformats.org/drawingml/2006/main">
               <a:ext uri="{FF2B5EF4-FFF2-40B4-BE49-F238E27FC236}">
-                <a16:creationId xmlns:a16="http://schemas.microsoft.com/office/drawing/2014/main" id="{B4A541A4-B448-49A7-859A-73E865F3DB6C}"/>
+                <a16:creationId xmlns:a16="http://schemas.microsoft.com/office/drawing/2014/main" id="{F9534531-C39B-43CC-946C-5C2353D38527}"/>
               </a:ext>
             </a:extLst>
           </p:cNvPr>
@@ -3996,7 +3996,7 @@
           <p:cNvPr id="18" name="">
             <a:extLst xmlns:a="http://schemas.openxmlformats.org/drawingml/2006/main">
               <a:ext uri="{FF2B5EF4-FFF2-40B4-BE49-F238E27FC236}">
-                <a16:creationId xmlns:a16="http://schemas.microsoft.com/office/drawing/2014/main" id="{FF1B67EF-A9C3-4333-B56D-5B666E613F4E}"/>
+                <a16:creationId xmlns:a16="http://schemas.microsoft.com/office/drawing/2014/main" id="{12CE1FCB-0356-45BD-B5D4-8FD48FA6C8A4}"/>
               </a:ext>
             </a:extLst>
           </p:cNvPr>
@@ -4046,7 +4046,7 @@
           <p:cNvPr id="19" name="">
             <a:extLst xmlns:a="http://schemas.openxmlformats.org/drawingml/2006/main">
               <a:ext uri="{FF2B5EF4-FFF2-40B4-BE49-F238E27FC236}">
-                <a16:creationId xmlns:a16="http://schemas.microsoft.com/office/drawing/2014/main" id="{02A2C228-91D9-42FA-9EE6-2823E5AE27C5}"/>
+                <a16:creationId xmlns:a16="http://schemas.microsoft.com/office/drawing/2014/main" id="{089717BC-CD65-4B31-8E2E-3E76E8F97A9A}"/>
               </a:ext>
             </a:extLst>
           </p:cNvPr>
@@ -4077,7 +4077,7 @@
           <p:cNvPr id="20" name="">
             <a:extLst xmlns:a="http://schemas.openxmlformats.org/drawingml/2006/main">
               <a:ext uri="{FF2B5EF4-FFF2-40B4-BE49-F238E27FC236}">
-                <a16:creationId xmlns:a16="http://schemas.microsoft.com/office/drawing/2014/main" id="{9E319C6E-B682-48EB-8754-11D04F3F4AA8}"/>
+                <a16:creationId xmlns:a16="http://schemas.microsoft.com/office/drawing/2014/main" id="{CE648F77-1BBB-42BC-BC23-13DCDDD8CC8F}"/>
               </a:ext>
             </a:extLst>
           </p:cNvPr>
@@ -4127,7 +4127,7 @@
           <p:cNvPr id="21" name="">
             <a:extLst xmlns:a="http://schemas.openxmlformats.org/drawingml/2006/main">
               <a:ext uri="{FF2B5EF4-FFF2-40B4-BE49-F238E27FC236}">
-                <a16:creationId xmlns:a16="http://schemas.microsoft.com/office/drawing/2014/main" id="{41AFDF4C-2C3A-4E2B-8240-5B629602D57B}"/>
+                <a16:creationId xmlns:a16="http://schemas.microsoft.com/office/drawing/2014/main" id="{41983D02-A58F-49D6-B072-4710F4F5DFB8}"/>
               </a:ext>
             </a:extLst>
           </p:cNvPr>
@@ -4194,7 +4194,7 @@
           <p:cNvPr id="22" name="">
             <a:extLst xmlns:a="http://schemas.openxmlformats.org/drawingml/2006/main">
               <a:ext uri="{FF2B5EF4-FFF2-40B4-BE49-F238E27FC236}">
-                <a16:creationId xmlns:a16="http://schemas.microsoft.com/office/drawing/2014/main" id="{54B26148-BF41-4E8A-9532-17F74F0BC95D}"/>
+                <a16:creationId xmlns:a16="http://schemas.microsoft.com/office/drawing/2014/main" id="{40F947C3-B990-4E68-B671-E3066CCB9DAB}"/>
               </a:ext>
             </a:extLst>
           </p:cNvPr>
@@ -4225,7 +4225,7 @@
           <p:cNvPr id="23" name="">
             <a:extLst xmlns:a="http://schemas.openxmlformats.org/drawingml/2006/main">
               <a:ext uri="{FF2B5EF4-FFF2-40B4-BE49-F238E27FC236}">
-                <a16:creationId xmlns:a16="http://schemas.microsoft.com/office/drawing/2014/main" id="{0DB88ED1-DD28-47AE-B5B4-F52F8A82AC40}"/>
+                <a16:creationId xmlns:a16="http://schemas.microsoft.com/office/drawing/2014/main" id="{B941B85D-4E5C-4692-A002-A207BA0628FE}"/>
               </a:ext>
             </a:extLst>
           </p:cNvPr>
@@ -4275,7 +4275,7 @@
           <p:cNvPr id="24" name="">
             <a:extLst xmlns:a="http://schemas.openxmlformats.org/drawingml/2006/main">
               <a:ext uri="{FF2B5EF4-FFF2-40B4-BE49-F238E27FC236}">
-                <a16:creationId xmlns:a16="http://schemas.microsoft.com/office/drawing/2014/main" id="{88702F79-746A-4614-933B-623936044AD1}"/>
+                <a16:creationId xmlns:a16="http://schemas.microsoft.com/office/drawing/2014/main" id="{E87949B8-A86A-4667-8B21-09FE76EA1631}"/>
               </a:ext>
             </a:extLst>
           </p:cNvPr>
@@ -4325,7 +4325,7 @@
           <p:cNvPr id="25" name="">
             <a:extLst xmlns:a="http://schemas.openxmlformats.org/drawingml/2006/main">
               <a:ext uri="{FF2B5EF4-FFF2-40B4-BE49-F238E27FC236}">
-                <a16:creationId xmlns:a16="http://schemas.microsoft.com/office/drawing/2014/main" id="{356252AA-4452-4AFB-9445-A8EF4F794EA2}"/>
+                <a16:creationId xmlns:a16="http://schemas.microsoft.com/office/drawing/2014/main" id="{16455486-4249-4046-A9BA-978C663055DE}"/>
               </a:ext>
             </a:extLst>
           </p:cNvPr>
@@ -4392,7 +4392,7 @@
           <p:cNvPr id="26" name="">
             <a:extLst xmlns:a="http://schemas.openxmlformats.org/drawingml/2006/main">
               <a:ext uri="{FF2B5EF4-FFF2-40B4-BE49-F238E27FC236}">
-                <a16:creationId xmlns:a16="http://schemas.microsoft.com/office/drawing/2014/main" id="{E9B8790D-DBE4-4C6B-962C-CE076B070ED3}"/>
+                <a16:creationId xmlns:a16="http://schemas.microsoft.com/office/drawing/2014/main" id="{F6F26EC9-EC65-4B99-836E-9BDC2AC4587D}"/>
               </a:ext>
             </a:extLst>
           </p:cNvPr>
@@ -4423,7 +4423,7 @@
           <p:cNvPr id="27" name="">
             <a:extLst xmlns:a="http://schemas.openxmlformats.org/drawingml/2006/main">
               <a:ext uri="{FF2B5EF4-FFF2-40B4-BE49-F238E27FC236}">
-                <a16:creationId xmlns:a16="http://schemas.microsoft.com/office/drawing/2014/main" id="{2D5581BE-6DF6-4A1D-B85B-53E2E01310B9}"/>
+                <a16:creationId xmlns:a16="http://schemas.microsoft.com/office/drawing/2014/main" id="{4EF1DE08-ECE9-4B27-A60B-3BD01A40EF61}"/>
               </a:ext>
             </a:extLst>
           </p:cNvPr>
@@ -4473,7 +4473,7 @@
           <p:cNvPr id="28" name="">
             <a:extLst xmlns:a="http://schemas.openxmlformats.org/drawingml/2006/main">
               <a:ext uri="{FF2B5EF4-FFF2-40B4-BE49-F238E27FC236}">
-                <a16:creationId xmlns:a16="http://schemas.microsoft.com/office/drawing/2014/main" id="{4FF995A5-69C4-47ED-9A60-A2B2372E8648}"/>
+                <a16:creationId xmlns:a16="http://schemas.microsoft.com/office/drawing/2014/main" id="{8AB48A55-CBEA-439F-86BB-2C8DD398B50B}"/>
               </a:ext>
             </a:extLst>
           </p:cNvPr>
@@ -4540,7 +4540,7 @@
           <p:cNvPr id="29" name="">
             <a:extLst xmlns:a="http://schemas.openxmlformats.org/drawingml/2006/main">
               <a:ext uri="{FF2B5EF4-FFF2-40B4-BE49-F238E27FC236}">
-                <a16:creationId xmlns:a16="http://schemas.microsoft.com/office/drawing/2014/main" id="{449EFA97-06E7-45E4-8CA1-C9A0F1E9E773}"/>
+                <a16:creationId xmlns:a16="http://schemas.microsoft.com/office/drawing/2014/main" id="{061C1349-0B43-4AD0-8EE2-7BC82614CAF5}"/>
               </a:ext>
             </a:extLst>
           </p:cNvPr>
@@ -4571,7 +4571,7 @@
           <p:cNvPr id="30" name="">
             <a:extLst xmlns:a="http://schemas.openxmlformats.org/drawingml/2006/main">
               <a:ext uri="{FF2B5EF4-FFF2-40B4-BE49-F238E27FC236}">
-                <a16:creationId xmlns:a16="http://schemas.microsoft.com/office/drawing/2014/main" id="{49449EF7-A208-4742-B267-50CD62A62364}"/>
+                <a16:creationId xmlns:a16="http://schemas.microsoft.com/office/drawing/2014/main" id="{7BB3FC8A-C171-46C3-AED9-8E93B575D346}"/>
               </a:ext>
             </a:extLst>
           </p:cNvPr>
@@ -4621,7 +4621,7 @@
           <p:cNvPr id="31" name="">
             <a:extLst xmlns:a="http://schemas.openxmlformats.org/drawingml/2006/main">
               <a:ext uri="{FF2B5EF4-FFF2-40B4-BE49-F238E27FC236}">
-                <a16:creationId xmlns:a16="http://schemas.microsoft.com/office/drawing/2014/main" id="{27993E1B-E139-4E48-89D6-87D6D13D4052}"/>
+                <a16:creationId xmlns:a16="http://schemas.microsoft.com/office/drawing/2014/main" id="{5D280173-BC69-4BDC-96FF-51A2EC37B187}"/>
               </a:ext>
             </a:extLst>
           </p:cNvPr>
@@ -4669,7 +4669,7 @@
     </p:spTree>
     <p:extLst>
       <p:ext uri="{BB962C8B-B14F-4D97-AF65-F5344CB8AC3E}">
-        <p14:creationId xmlns:p14="http://schemas.microsoft.com/office/powerpoint/2010/main" val="820495359"/>
+        <p14:creationId xmlns:p14="http://schemas.microsoft.com/office/powerpoint/2010/main" val="123252048"/>
       </p:ext>
     </p:extLst>
   </p:cSld>
@@ -4700,7 +4700,7 @@
           <p:cNvPr id="36" name="">
             <a:extLst xmlns:a="http://schemas.openxmlformats.org/drawingml/2006/main">
               <a:ext uri="{FF2B5EF4-FFF2-40B4-BE49-F238E27FC236}">
-                <a16:creationId xmlns:a16="http://schemas.microsoft.com/office/drawing/2014/main" id="{F7F9B53E-D214-4B44-80AB-76F6EB097DDA}"/>
+                <a16:creationId xmlns:a16="http://schemas.microsoft.com/office/drawing/2014/main" id="{25E72572-3A3B-48E0-86E5-1646E636C44B}"/>
               </a:ext>
             </a:extLst>
           </p:cNvPr>
@@ -4750,7 +4750,7 @@
           <p:cNvPr id="2" name="">
             <a:extLst xmlns:a="http://schemas.openxmlformats.org/drawingml/2006/main">
               <a:ext uri="{FF2B5EF4-FFF2-40B4-BE49-F238E27FC236}">
-                <a16:creationId xmlns:a16="http://schemas.microsoft.com/office/drawing/2014/main" id="{D4F754D5-DD7B-4F2C-81D1-526BCEAC4A65}"/>
+                <a16:creationId xmlns:a16="http://schemas.microsoft.com/office/drawing/2014/main" id="{D8EB5A07-B476-4D82-8DB5-550F93DD02F3}"/>
               </a:ext>
             </a:extLst>
           </p:cNvPr>
@@ -4781,7 +4781,7 @@
           <p:cNvPr id="3" name="">
             <a:extLst xmlns:a="http://schemas.openxmlformats.org/drawingml/2006/main">
               <a:ext uri="{FF2B5EF4-FFF2-40B4-BE49-F238E27FC236}">
-                <a16:creationId xmlns:a16="http://schemas.microsoft.com/office/drawing/2014/main" id="{23BA9C44-35CF-45A7-9050-7827ABF6578D}"/>
+                <a16:creationId xmlns:a16="http://schemas.microsoft.com/office/drawing/2014/main" id="{E9DBA14E-08CC-4A5C-9AF1-CF3507C08A72}"/>
               </a:ext>
             </a:extLst>
           </p:cNvPr>
@@ -4831,7 +4831,7 @@
           <p:cNvPr id="4" name="">
             <a:extLst xmlns:a="http://schemas.openxmlformats.org/drawingml/2006/main">
               <a:ext uri="{FF2B5EF4-FFF2-40B4-BE49-F238E27FC236}">
-                <a16:creationId xmlns:a16="http://schemas.microsoft.com/office/drawing/2014/main" id="{D0C46F11-8EEE-4989-9D60-735E2AD4FB43}"/>
+                <a16:creationId xmlns:a16="http://schemas.microsoft.com/office/drawing/2014/main" id="{5AE2EB22-0E6D-4AAF-8E1C-993B27C7E0C9}"/>
               </a:ext>
             </a:extLst>
           </p:cNvPr>
@@ -4881,7 +4881,7 @@
           <p:cNvPr id="5" name="">
             <a:extLst xmlns:a="http://schemas.openxmlformats.org/drawingml/2006/main">
               <a:ext uri="{FF2B5EF4-FFF2-40B4-BE49-F238E27FC236}">
-                <a16:creationId xmlns:a16="http://schemas.microsoft.com/office/drawing/2014/main" id="{34A2634E-30F6-417F-9821-AE98B23CB1E0}"/>
+                <a16:creationId xmlns:a16="http://schemas.microsoft.com/office/drawing/2014/main" id="{06690769-7EA2-4833-8CF5-7B6C50C92250}"/>
               </a:ext>
             </a:extLst>
           </p:cNvPr>
@@ -4931,7 +4931,7 @@
           <p:cNvPr id="6" name="">
             <a:extLst xmlns:a="http://schemas.openxmlformats.org/drawingml/2006/main">
               <a:ext uri="{FF2B5EF4-FFF2-40B4-BE49-F238E27FC236}">
-                <a16:creationId xmlns:a16="http://schemas.microsoft.com/office/drawing/2014/main" id="{94D5017D-5F96-425E-AC08-E7AE4635BFA0}"/>
+                <a16:creationId xmlns:a16="http://schemas.microsoft.com/office/drawing/2014/main" id="{2210682B-6335-485F-9B9C-7EAA2683F5F2}"/>
               </a:ext>
             </a:extLst>
           </p:cNvPr>
@@ -4981,7 +4981,7 @@
           <p:cNvPr id="7" name="">
             <a:extLst xmlns:a="http://schemas.openxmlformats.org/drawingml/2006/main">
               <a:ext uri="{FF2B5EF4-FFF2-40B4-BE49-F238E27FC236}">
-                <a16:creationId xmlns:a16="http://schemas.microsoft.com/office/drawing/2014/main" id="{D1900EE2-4493-45DE-BBAA-4B0033C21A0B}"/>
+                <a16:creationId xmlns:a16="http://schemas.microsoft.com/office/drawing/2014/main" id="{F60E959B-EA2B-458D-922E-6BA75C790BC1}"/>
               </a:ext>
             </a:extLst>
           </p:cNvPr>
@@ -5031,7 +5031,7 @@
           <p:cNvPr id="8" name="">
             <a:extLst xmlns:a="http://schemas.openxmlformats.org/drawingml/2006/main">
               <a:ext uri="{FF2B5EF4-FFF2-40B4-BE49-F238E27FC236}">
-                <a16:creationId xmlns:a16="http://schemas.microsoft.com/office/drawing/2014/main" id="{829B2558-563F-4242-A4E3-C3CCB82400B4}"/>
+                <a16:creationId xmlns:a16="http://schemas.microsoft.com/office/drawing/2014/main" id="{64A717C5-A06D-4EEA-A084-7E7A3D7A92FE}"/>
               </a:ext>
             </a:extLst>
           </p:cNvPr>
@@ -5081,7 +5081,7 @@
           <p:cNvPr id="9" name="">
             <a:extLst xmlns:a="http://schemas.openxmlformats.org/drawingml/2006/main">
               <a:ext uri="{FF2B5EF4-FFF2-40B4-BE49-F238E27FC236}">
-                <a16:creationId xmlns:a16="http://schemas.microsoft.com/office/drawing/2014/main" id="{041C7C9A-F551-43A7-9B28-818F97000855}"/>
+                <a16:creationId xmlns:a16="http://schemas.microsoft.com/office/drawing/2014/main" id="{F1074941-7D66-4A4E-81F2-0A0FF4E3FD17}"/>
               </a:ext>
             </a:extLst>
           </p:cNvPr>
@@ -5131,7 +5131,7 @@
           <p:cNvPr id="10" name="">
             <a:extLst xmlns:a="http://schemas.openxmlformats.org/drawingml/2006/main">
               <a:ext uri="{FF2B5EF4-FFF2-40B4-BE49-F238E27FC236}">
-                <a16:creationId xmlns:a16="http://schemas.microsoft.com/office/drawing/2014/main" id="{1FA3D15E-CC83-4F84-BCB5-F81848E188F7}"/>
+                <a16:creationId xmlns:a16="http://schemas.microsoft.com/office/drawing/2014/main" id="{AD597217-3E73-4CCE-8661-77A0811D4F19}"/>
               </a:ext>
             </a:extLst>
           </p:cNvPr>
@@ -5162,7 +5162,7 @@
           <p:cNvPr id="11" name="">
             <a:extLst xmlns:a="http://schemas.openxmlformats.org/drawingml/2006/main">
               <a:ext uri="{FF2B5EF4-FFF2-40B4-BE49-F238E27FC236}">
-                <a16:creationId xmlns:a16="http://schemas.microsoft.com/office/drawing/2014/main" id="{925D357F-7D87-436D-8E51-1FCE7F14D761}"/>
+                <a16:creationId xmlns:a16="http://schemas.microsoft.com/office/drawing/2014/main" id="{81A0254E-4D2E-4A46-9ECF-E39F169175C5}"/>
               </a:ext>
             </a:extLst>
           </p:cNvPr>
@@ -5212,7 +5212,7 @@
           <p:cNvPr id="12" name="">
             <a:extLst xmlns:a="http://schemas.openxmlformats.org/drawingml/2006/main">
               <a:ext uri="{FF2B5EF4-FFF2-40B4-BE49-F238E27FC236}">
-                <a16:creationId xmlns:a16="http://schemas.microsoft.com/office/drawing/2014/main" id="{D4AF6DE1-0105-4033-AFCA-7D5DF688A1FC}"/>
+                <a16:creationId xmlns:a16="http://schemas.microsoft.com/office/drawing/2014/main" id="{F0284082-F722-49E5-B374-21467C34FE0F}"/>
               </a:ext>
             </a:extLst>
           </p:cNvPr>
@@ -5262,7 +5262,7 @@
           <p:cNvPr id="13" name="">
             <a:extLst xmlns:a="http://schemas.openxmlformats.org/drawingml/2006/main">
               <a:ext uri="{FF2B5EF4-FFF2-40B4-BE49-F238E27FC236}">
-                <a16:creationId xmlns:a16="http://schemas.microsoft.com/office/drawing/2014/main" id="{525CB5F5-683C-4ABF-B70D-7F66EC83F0AF}"/>
+                <a16:creationId xmlns:a16="http://schemas.microsoft.com/office/drawing/2014/main" id="{B0E0F351-C0F4-47DF-89DC-4819D74D2CF3}"/>
               </a:ext>
             </a:extLst>
           </p:cNvPr>
@@ -5302,7 +5302,7 @@
                   <a:srgbClr val="5B6472"/>
                 </a:solidFill>
               </a:rPr>
-              <a:t>Java · Concurrency</a:t>
+              <a:t>Java · Concurrency · WebFlux</a:t>
             </a:r>
           </a:p>
         </p:txBody>
@@ -5312,7 +5312,7 @@
           <p:cNvPr id="14" name="">
             <a:extLst xmlns:a="http://schemas.openxmlformats.org/drawingml/2006/main">
               <a:ext uri="{FF2B5EF4-FFF2-40B4-BE49-F238E27FC236}">
-                <a16:creationId xmlns:a16="http://schemas.microsoft.com/office/drawing/2014/main" id="{BE84A08F-4A37-4597-AF24-BF3E543A661F}"/>
+                <a16:creationId xmlns:a16="http://schemas.microsoft.com/office/drawing/2014/main" id="{29C3EAF9-9704-4321-9331-B03904B53841}"/>
               </a:ext>
             </a:extLst>
           </p:cNvPr>
@@ -5352,7 +5352,7 @@
                   <a:srgbClr val="121722"/>
                 </a:solidFill>
               </a:rPr>
-              <a:t>공통 검증·온보딩 기준</a:t>
+              <a:t>순서 안정화·실패 격리</a:t>
             </a:r>
           </a:p>
         </p:txBody>
@@ -5362,7 +5362,7 @@
           <p:cNvPr id="15" name="">
             <a:extLst xmlns:a="http://schemas.openxmlformats.org/drawingml/2006/main">
               <a:ext uri="{FF2B5EF4-FFF2-40B4-BE49-F238E27FC236}">
-                <a16:creationId xmlns:a16="http://schemas.microsoft.com/office/drawing/2014/main" id="{A83534CC-BC76-409E-82A4-668C6C620B40}"/>
+                <a16:creationId xmlns:a16="http://schemas.microsoft.com/office/drawing/2014/main" id="{ED7A27B1-3D85-4C47-AFC1-71716B4F1198}"/>
               </a:ext>
             </a:extLst>
           </p:cNvPr>
@@ -5393,7 +5393,7 @@
           <p:cNvPr id="16" name="">
             <a:extLst xmlns:a="http://schemas.openxmlformats.org/drawingml/2006/main">
               <a:ext uri="{FF2B5EF4-FFF2-40B4-BE49-F238E27FC236}">
-                <a16:creationId xmlns:a16="http://schemas.microsoft.com/office/drawing/2014/main" id="{BEECD367-AB87-4408-99E6-B8AC5C2B3990}"/>
+                <a16:creationId xmlns:a16="http://schemas.microsoft.com/office/drawing/2014/main" id="{7EC782DD-0FE6-4E08-93C0-29E61771077C}"/>
               </a:ext>
             </a:extLst>
           </p:cNvPr>
@@ -5443,7 +5443,7 @@
           <p:cNvPr id="17" name="">
             <a:extLst xmlns:a="http://schemas.openxmlformats.org/drawingml/2006/main">
               <a:ext uri="{FF2B5EF4-FFF2-40B4-BE49-F238E27FC236}">
-                <a16:creationId xmlns:a16="http://schemas.microsoft.com/office/drawing/2014/main" id="{6C163EDD-5AAA-4A17-9F28-65034506B445}"/>
+                <a16:creationId xmlns:a16="http://schemas.microsoft.com/office/drawing/2014/main" id="{F0CEB044-73EC-465E-942A-60F672420D68}"/>
               </a:ext>
             </a:extLst>
           </p:cNvPr>
@@ -5493,7 +5493,7 @@
           <p:cNvPr id="18" name="">
             <a:extLst xmlns:a="http://schemas.openxmlformats.org/drawingml/2006/main">
               <a:ext uri="{FF2B5EF4-FFF2-40B4-BE49-F238E27FC236}">
-                <a16:creationId xmlns:a16="http://schemas.microsoft.com/office/drawing/2014/main" id="{F2AB20E5-0E50-4C62-A916-2A39D08D8D4B}"/>
+                <a16:creationId xmlns:a16="http://schemas.microsoft.com/office/drawing/2014/main" id="{3D998770-1D4E-4DF2-8397-D99520AD0AAE}"/>
               </a:ext>
             </a:extLst>
           </p:cNvPr>
@@ -5543,7 +5543,7 @@
           <p:cNvPr id="19" name="">
             <a:extLst xmlns:a="http://schemas.openxmlformats.org/drawingml/2006/main">
               <a:ext uri="{FF2B5EF4-FFF2-40B4-BE49-F238E27FC236}">
-                <a16:creationId xmlns:a16="http://schemas.microsoft.com/office/drawing/2014/main" id="{96296958-336A-49C8-A73D-0BE5C116C837}"/>
+                <a16:creationId xmlns:a16="http://schemas.microsoft.com/office/drawing/2014/main" id="{B62E0A22-6930-4426-A9AA-057E25F0231E}"/>
               </a:ext>
             </a:extLst>
           </p:cNvPr>
@@ -5593,7 +5593,7 @@
           <p:cNvPr id="20" name="">
             <a:extLst xmlns:a="http://schemas.openxmlformats.org/drawingml/2006/main">
               <a:ext uri="{FF2B5EF4-FFF2-40B4-BE49-F238E27FC236}">
-                <a16:creationId xmlns:a16="http://schemas.microsoft.com/office/drawing/2014/main" id="{EBEA0DFB-14E3-4EDD-9E1B-95BB0B496506}"/>
+                <a16:creationId xmlns:a16="http://schemas.microsoft.com/office/drawing/2014/main" id="{B1EBF347-2115-43A5-B9E7-E2DA6C9C7114}"/>
               </a:ext>
             </a:extLst>
           </p:cNvPr>
@@ -5624,7 +5624,7 @@
           <p:cNvPr id="21" name="">
             <a:extLst xmlns:a="http://schemas.openxmlformats.org/drawingml/2006/main">
               <a:ext uri="{FF2B5EF4-FFF2-40B4-BE49-F238E27FC236}">
-                <a16:creationId xmlns:a16="http://schemas.microsoft.com/office/drawing/2014/main" id="{6E8BC826-6C63-4192-BF09-02BA92A2AF30}"/>
+                <a16:creationId xmlns:a16="http://schemas.microsoft.com/office/drawing/2014/main" id="{01A38828-D820-4ADE-BE07-F56E0C784BCA}"/>
               </a:ext>
             </a:extLst>
           </p:cNvPr>
@@ -5674,7 +5674,7 @@
           <p:cNvPr id="22" name="">
             <a:extLst xmlns:a="http://schemas.openxmlformats.org/drawingml/2006/main">
               <a:ext uri="{FF2B5EF4-FFF2-40B4-BE49-F238E27FC236}">
-                <a16:creationId xmlns:a16="http://schemas.microsoft.com/office/drawing/2014/main" id="{79578D33-245A-4BA7-92CD-B78E68289325}"/>
+                <a16:creationId xmlns:a16="http://schemas.microsoft.com/office/drawing/2014/main" id="{B510A8FD-6D45-4321-B6B0-A6FB0B6A16EF}"/>
               </a:ext>
             </a:extLst>
           </p:cNvPr>
@@ -5724,7 +5724,7 @@
           <p:cNvPr id="23" name="">
             <a:extLst xmlns:a="http://schemas.openxmlformats.org/drawingml/2006/main">
               <a:ext uri="{FF2B5EF4-FFF2-40B4-BE49-F238E27FC236}">
-                <a16:creationId xmlns:a16="http://schemas.microsoft.com/office/drawing/2014/main" id="{3AA6CEF8-1698-4AB6-BC47-683A83CB5497}"/>
+                <a16:creationId xmlns:a16="http://schemas.microsoft.com/office/drawing/2014/main" id="{B00A60BA-DAD0-42AC-9EFD-60A7A1EC09D1}"/>
               </a:ext>
             </a:extLst>
           </p:cNvPr>
@@ -5774,7 +5774,7 @@
           <p:cNvPr id="24" name="">
             <a:extLst xmlns:a="http://schemas.openxmlformats.org/drawingml/2006/main">
               <a:ext uri="{FF2B5EF4-FFF2-40B4-BE49-F238E27FC236}">
-                <a16:creationId xmlns:a16="http://schemas.microsoft.com/office/drawing/2014/main" id="{1F573E7C-86D9-41EE-A078-9C8EDEBD37D5}"/>
+                <a16:creationId xmlns:a16="http://schemas.microsoft.com/office/drawing/2014/main" id="{7798A629-C973-468A-8AC4-21A51A1AEBC8}"/>
               </a:ext>
             </a:extLst>
           </p:cNvPr>
@@ -5824,7 +5824,7 @@
           <p:cNvPr id="25" name="">
             <a:extLst xmlns:a="http://schemas.openxmlformats.org/drawingml/2006/main">
               <a:ext uri="{FF2B5EF4-FFF2-40B4-BE49-F238E27FC236}">
-                <a16:creationId xmlns:a16="http://schemas.microsoft.com/office/drawing/2014/main" id="{5B14F594-3198-402F-803B-ABE34491C2B1}"/>
+                <a16:creationId xmlns:a16="http://schemas.microsoft.com/office/drawing/2014/main" id="{D3D1B8C6-8D64-4E10-ACE5-A5FEF84CA105}"/>
               </a:ext>
             </a:extLst>
           </p:cNvPr>
@@ -5855,7 +5855,7 @@
           <p:cNvPr id="26" name="">
             <a:extLst xmlns:a="http://schemas.openxmlformats.org/drawingml/2006/main">
               <a:ext uri="{FF2B5EF4-FFF2-40B4-BE49-F238E27FC236}">
-                <a16:creationId xmlns:a16="http://schemas.microsoft.com/office/drawing/2014/main" id="{2AD4870A-4826-4713-9060-1BBB7E94D882}"/>
+                <a16:creationId xmlns:a16="http://schemas.microsoft.com/office/drawing/2014/main" id="{C452158C-DBD7-4C40-B618-0CC2EABE4ED2}"/>
               </a:ext>
             </a:extLst>
           </p:cNvPr>
@@ -5905,7 +5905,7 @@
           <p:cNvPr id="27" name="">
             <a:extLst xmlns:a="http://schemas.openxmlformats.org/drawingml/2006/main">
               <a:ext uri="{FF2B5EF4-FFF2-40B4-BE49-F238E27FC236}">
-                <a16:creationId xmlns:a16="http://schemas.microsoft.com/office/drawing/2014/main" id="{946B4DB1-727B-491D-9A0A-B3D24427A27D}"/>
+                <a16:creationId xmlns:a16="http://schemas.microsoft.com/office/drawing/2014/main" id="{6BEFC246-97D2-456D-A355-28543B76EFC8}"/>
               </a:ext>
             </a:extLst>
           </p:cNvPr>
@@ -5955,7 +5955,7 @@
           <p:cNvPr id="28" name="">
             <a:extLst xmlns:a="http://schemas.openxmlformats.org/drawingml/2006/main">
               <a:ext uri="{FF2B5EF4-FFF2-40B4-BE49-F238E27FC236}">
-                <a16:creationId xmlns:a16="http://schemas.microsoft.com/office/drawing/2014/main" id="{C1B7E0B7-F4CC-425E-B293-B233B24A277F}"/>
+                <a16:creationId xmlns:a16="http://schemas.microsoft.com/office/drawing/2014/main" id="{BF166E4E-0598-4DAF-81E6-8D55651846CB}"/>
               </a:ext>
             </a:extLst>
           </p:cNvPr>
@@ -6005,7 +6005,7 @@
           <p:cNvPr id="29" name="">
             <a:extLst xmlns:a="http://schemas.openxmlformats.org/drawingml/2006/main">
               <a:ext uri="{FF2B5EF4-FFF2-40B4-BE49-F238E27FC236}">
-                <a16:creationId xmlns:a16="http://schemas.microsoft.com/office/drawing/2014/main" id="{11737AAF-8E76-4DD6-B662-67ACE5EE32B7}"/>
+                <a16:creationId xmlns:a16="http://schemas.microsoft.com/office/drawing/2014/main" id="{5B31369D-6F0B-4A97-AD37-7458EF35EC3D}"/>
               </a:ext>
             </a:extLst>
           </p:cNvPr>
@@ -6055,7 +6055,7 @@
           <p:cNvPr id="30" name="">
             <a:extLst xmlns:a="http://schemas.openxmlformats.org/drawingml/2006/main">
               <a:ext uri="{FF2B5EF4-FFF2-40B4-BE49-F238E27FC236}">
-                <a16:creationId xmlns:a16="http://schemas.microsoft.com/office/drawing/2014/main" id="{4B701292-94C2-4E8F-8739-902D8885573A}"/>
+                <a16:creationId xmlns:a16="http://schemas.microsoft.com/office/drawing/2014/main" id="{15CB6F54-66AE-4D7E-AA54-E8009B6ECD39}"/>
               </a:ext>
             </a:extLst>
           </p:cNvPr>
@@ -6086,7 +6086,7 @@
           <p:cNvPr id="31" name="">
             <a:extLst xmlns:a="http://schemas.openxmlformats.org/drawingml/2006/main">
               <a:ext uri="{FF2B5EF4-FFF2-40B4-BE49-F238E27FC236}">
-                <a16:creationId xmlns:a16="http://schemas.microsoft.com/office/drawing/2014/main" id="{511D23CF-7C2A-407C-AA7E-C204EC6A408F}"/>
+                <a16:creationId xmlns:a16="http://schemas.microsoft.com/office/drawing/2014/main" id="{D3FE3868-653B-41C4-B4E7-CF9BEBC77F13}"/>
               </a:ext>
             </a:extLst>
           </p:cNvPr>
@@ -6136,7 +6136,7 @@
           <p:cNvPr id="32" name="">
             <a:extLst xmlns:a="http://schemas.openxmlformats.org/drawingml/2006/main">
               <a:ext uri="{FF2B5EF4-FFF2-40B4-BE49-F238E27FC236}">
-                <a16:creationId xmlns:a16="http://schemas.microsoft.com/office/drawing/2014/main" id="{3C512A68-0C43-4BD5-8C60-260DA05A70EB}"/>
+                <a16:creationId xmlns:a16="http://schemas.microsoft.com/office/drawing/2014/main" id="{D5A16AC2-98F2-46A9-BFD2-F5988227C8DD}"/>
               </a:ext>
             </a:extLst>
           </p:cNvPr>
@@ -6186,7 +6186,7 @@
           <p:cNvPr id="33" name="">
             <a:extLst xmlns:a="http://schemas.openxmlformats.org/drawingml/2006/main">
               <a:ext uri="{FF2B5EF4-FFF2-40B4-BE49-F238E27FC236}">
-                <a16:creationId xmlns:a16="http://schemas.microsoft.com/office/drawing/2014/main" id="{70B6B2E9-8F2C-476A-B8D7-2996C5E3B16B}"/>
+                <a16:creationId xmlns:a16="http://schemas.microsoft.com/office/drawing/2014/main" id="{0D341FAF-1049-46E5-A6CD-894485008BBB}"/>
               </a:ext>
             </a:extLst>
           </p:cNvPr>
@@ -6217,7 +6217,7 @@
           <p:cNvPr id="34" name="">
             <a:extLst xmlns:a="http://schemas.openxmlformats.org/drawingml/2006/main">
               <a:ext uri="{FF2B5EF4-FFF2-40B4-BE49-F238E27FC236}">
-                <a16:creationId xmlns:a16="http://schemas.microsoft.com/office/drawing/2014/main" id="{86A43333-E7AF-4108-9E6E-B83504C26FBF}"/>
+                <a16:creationId xmlns:a16="http://schemas.microsoft.com/office/drawing/2014/main" id="{F1CAD7F5-49E9-495B-AE1E-772328A8C214}"/>
               </a:ext>
             </a:extLst>
           </p:cNvPr>
@@ -6267,7 +6267,7 @@
           <p:cNvPr id="35" name="">
             <a:extLst xmlns:a="http://schemas.openxmlformats.org/drawingml/2006/main">
               <a:ext uri="{FF2B5EF4-FFF2-40B4-BE49-F238E27FC236}">
-                <a16:creationId xmlns:a16="http://schemas.microsoft.com/office/drawing/2014/main" id="{62CBFB8F-C0C0-47C6-97B8-436AB49D16B3}"/>
+                <a16:creationId xmlns:a16="http://schemas.microsoft.com/office/drawing/2014/main" id="{09561E52-6E15-41BC-81E3-00AA1C2339FA}"/>
               </a:ext>
             </a:extLst>
           </p:cNvPr>
@@ -6315,7 +6315,7 @@
     </p:spTree>
     <p:extLst>
       <p:ext uri="{BB962C8B-B14F-4D97-AF65-F5344CB8AC3E}">
-        <p14:creationId xmlns:p14="http://schemas.microsoft.com/office/powerpoint/2010/main" val="1960633412"/>
+        <p14:creationId xmlns:p14="http://schemas.microsoft.com/office/powerpoint/2010/main" val="682083840"/>
       </p:ext>
     </p:extLst>
   </p:cSld>
@@ -6346,7 +6346,7 @@
           <p:cNvPr id="17" name="">
             <a:extLst xmlns:a="http://schemas.openxmlformats.org/drawingml/2006/main">
               <a:ext uri="{FF2B5EF4-FFF2-40B4-BE49-F238E27FC236}">
-                <a16:creationId xmlns:a16="http://schemas.microsoft.com/office/drawing/2014/main" id="{8982F5F4-4108-4226-8B91-B74A731CCD31}"/>
+                <a16:creationId xmlns:a16="http://schemas.microsoft.com/office/drawing/2014/main" id="{659F02F3-CF25-4B23-8E8D-8EB8A41BE9F2}"/>
               </a:ext>
             </a:extLst>
           </p:cNvPr>
@@ -6377,7 +6377,7 @@
           <p:cNvPr id="2" name="">
             <a:extLst xmlns:a="http://schemas.openxmlformats.org/drawingml/2006/main">
               <a:ext uri="{FF2B5EF4-FFF2-40B4-BE49-F238E27FC236}">
-                <a16:creationId xmlns:a16="http://schemas.microsoft.com/office/drawing/2014/main" id="{B3866159-575A-494F-BBDA-C3DE77E5F3DA}"/>
+                <a16:creationId xmlns:a16="http://schemas.microsoft.com/office/drawing/2014/main" id="{AE049495-8D24-4346-A226-0264F21AAA4F}"/>
               </a:ext>
             </a:extLst>
           </p:cNvPr>
@@ -6427,7 +6427,7 @@
           <p:cNvPr id="3" name="">
             <a:extLst xmlns:a="http://schemas.openxmlformats.org/drawingml/2006/main">
               <a:ext uri="{FF2B5EF4-FFF2-40B4-BE49-F238E27FC236}">
-                <a16:creationId xmlns:a16="http://schemas.microsoft.com/office/drawing/2014/main" id="{0601377F-2F4B-462F-9313-3141368D7AF8}"/>
+                <a16:creationId xmlns:a16="http://schemas.microsoft.com/office/drawing/2014/main" id="{6121BFBA-BCAA-4AEA-8FC7-48FF8366B5E3}"/>
               </a:ext>
             </a:extLst>
           </p:cNvPr>
@@ -6494,7 +6494,7 @@
           <p:cNvPr id="4" name="">
             <a:extLst xmlns:a="http://schemas.openxmlformats.org/drawingml/2006/main">
               <a:ext uri="{FF2B5EF4-FFF2-40B4-BE49-F238E27FC236}">
-                <a16:creationId xmlns:a16="http://schemas.microsoft.com/office/drawing/2014/main" id="{E61A1E97-8644-4EA6-892A-7EBF3A9CCC1F}"/>
+                <a16:creationId xmlns:a16="http://schemas.microsoft.com/office/drawing/2014/main" id="{A5148336-3D1D-4591-8C76-08785B88FCA9}"/>
               </a:ext>
             </a:extLst>
           </p:cNvPr>
@@ -6544,7 +6544,7 @@
           <p:cNvPr id="5" name="">
             <a:extLst xmlns:a="http://schemas.openxmlformats.org/drawingml/2006/main">
               <a:ext uri="{FF2B5EF4-FFF2-40B4-BE49-F238E27FC236}">
-                <a16:creationId xmlns:a16="http://schemas.microsoft.com/office/drawing/2014/main" id="{1390E664-9BD3-4670-A7C6-F029DB0E5DA6}"/>
+                <a16:creationId xmlns:a16="http://schemas.microsoft.com/office/drawing/2014/main" id="{81D07BEE-0DE6-4BB1-AEF2-3A7B47CCF83B}"/>
               </a:ext>
             </a:extLst>
           </p:cNvPr>
@@ -6594,7 +6594,7 @@
           <p:cNvPr id="6" name="">
             <a:extLst xmlns:a="http://schemas.openxmlformats.org/drawingml/2006/main">
               <a:ext uri="{FF2B5EF4-FFF2-40B4-BE49-F238E27FC236}">
-                <a16:creationId xmlns:a16="http://schemas.microsoft.com/office/drawing/2014/main" id="{55824CFF-E8FB-4066-BA9B-00B8C0451EDA}"/>
+                <a16:creationId xmlns:a16="http://schemas.microsoft.com/office/drawing/2014/main" id="{CE478773-7A29-469D-9A5A-0395AE53A04C}"/>
               </a:ext>
             </a:extLst>
           </p:cNvPr>
@@ -6644,7 +6644,7 @@
           <p:cNvPr id="7" name="">
             <a:extLst xmlns:a="http://schemas.openxmlformats.org/drawingml/2006/main">
               <a:ext uri="{FF2B5EF4-FFF2-40B4-BE49-F238E27FC236}">
-                <a16:creationId xmlns:a16="http://schemas.microsoft.com/office/drawing/2014/main" id="{B7A47BEF-7E8C-4AD5-B445-33B163A5ACBA}"/>
+                <a16:creationId xmlns:a16="http://schemas.microsoft.com/office/drawing/2014/main" id="{E440FA24-1231-4498-BE19-CD580BB6B797}"/>
               </a:ext>
             </a:extLst>
           </p:cNvPr>
@@ -6675,7 +6675,7 @@
           <p:cNvPr id="8" name="">
             <a:extLst xmlns:a="http://schemas.openxmlformats.org/drawingml/2006/main">
               <a:ext uri="{FF2B5EF4-FFF2-40B4-BE49-F238E27FC236}">
-                <a16:creationId xmlns:a16="http://schemas.microsoft.com/office/drawing/2014/main" id="{7C76A1BC-8B8D-4AA5-968D-798C8D1554E8}"/>
+                <a16:creationId xmlns:a16="http://schemas.microsoft.com/office/drawing/2014/main" id="{A5F82941-5254-4AA0-8246-CA754368DC90}"/>
               </a:ext>
             </a:extLst>
           </p:cNvPr>
@@ -6725,7 +6725,7 @@
           <p:cNvPr id="9" name="">
             <a:extLst xmlns:a="http://schemas.openxmlformats.org/drawingml/2006/main">
               <a:ext uri="{FF2B5EF4-FFF2-40B4-BE49-F238E27FC236}">
-                <a16:creationId xmlns:a16="http://schemas.microsoft.com/office/drawing/2014/main" id="{7813C34F-53F0-4CE8-B636-BD3B1D576C0A}"/>
+                <a16:creationId xmlns:a16="http://schemas.microsoft.com/office/drawing/2014/main" id="{B0E519D2-6E37-4020-AB56-F965FCDB9BCF}"/>
               </a:ext>
             </a:extLst>
           </p:cNvPr>
@@ -6775,7 +6775,7 @@
           <p:cNvPr id="10" name="">
             <a:extLst xmlns:a="http://schemas.openxmlformats.org/drawingml/2006/main">
               <a:ext uri="{FF2B5EF4-FFF2-40B4-BE49-F238E27FC236}">
-                <a16:creationId xmlns:a16="http://schemas.microsoft.com/office/drawing/2014/main" id="{6A0DEC7C-8BD9-485D-88BD-6DE1F1C32F28}"/>
+                <a16:creationId xmlns:a16="http://schemas.microsoft.com/office/drawing/2014/main" id="{4FAF9CEC-8D44-403D-8384-7793CC5CB9DB}"/>
               </a:ext>
             </a:extLst>
           </p:cNvPr>
@@ -6806,7 +6806,7 @@
           <p:cNvPr id="11" name="">
             <a:extLst xmlns:a="http://schemas.openxmlformats.org/drawingml/2006/main">
               <a:ext uri="{FF2B5EF4-FFF2-40B4-BE49-F238E27FC236}">
-                <a16:creationId xmlns:a16="http://schemas.microsoft.com/office/drawing/2014/main" id="{FF0FCE10-8945-4B2D-A6C7-03FB2AA94070}"/>
+                <a16:creationId xmlns:a16="http://schemas.microsoft.com/office/drawing/2014/main" id="{DACA583A-448C-4ED8-9673-BF247429337F}"/>
               </a:ext>
             </a:extLst>
           </p:cNvPr>
@@ -6856,7 +6856,7 @@
           <p:cNvPr id="12" name="">
             <a:extLst xmlns:a="http://schemas.openxmlformats.org/drawingml/2006/main">
               <a:ext uri="{FF2B5EF4-FFF2-40B4-BE49-F238E27FC236}">
-                <a16:creationId xmlns:a16="http://schemas.microsoft.com/office/drawing/2014/main" id="{22E488D8-7AD8-4ABD-9817-C982A330284B}"/>
+                <a16:creationId xmlns:a16="http://schemas.microsoft.com/office/drawing/2014/main" id="{BEB758D4-62BA-4D08-831A-6C629B7EE55C}"/>
               </a:ext>
             </a:extLst>
           </p:cNvPr>
@@ -6906,7 +6906,7 @@
           <p:cNvPr id="13" name="">
             <a:extLst xmlns:a="http://schemas.openxmlformats.org/drawingml/2006/main">
               <a:ext uri="{FF2B5EF4-FFF2-40B4-BE49-F238E27FC236}">
-                <a16:creationId xmlns:a16="http://schemas.microsoft.com/office/drawing/2014/main" id="{803DAC95-880C-47AC-8647-F046D3A7F71C}"/>
+                <a16:creationId xmlns:a16="http://schemas.microsoft.com/office/drawing/2014/main" id="{CAD5E1B5-9857-44D6-B5D4-78FB29BB5FE9}"/>
               </a:ext>
             </a:extLst>
           </p:cNvPr>
@@ -6956,7 +6956,7 @@
           <p:cNvPr id="14" name="">
             <a:extLst xmlns:a="http://schemas.openxmlformats.org/drawingml/2006/main">
               <a:ext uri="{FF2B5EF4-FFF2-40B4-BE49-F238E27FC236}">
-                <a16:creationId xmlns:a16="http://schemas.microsoft.com/office/drawing/2014/main" id="{880523C1-9703-45C4-96DE-B2D805C4A6BA}"/>
+                <a16:creationId xmlns:a16="http://schemas.microsoft.com/office/drawing/2014/main" id="{51A1C680-C51B-4A33-A181-1614E6EB85D2}"/>
               </a:ext>
             </a:extLst>
           </p:cNvPr>
@@ -7006,7 +7006,7 @@
           <p:cNvPr id="15" name="">
             <a:extLst xmlns:a="http://schemas.openxmlformats.org/drawingml/2006/main">
               <a:ext uri="{FF2B5EF4-FFF2-40B4-BE49-F238E27FC236}">
-                <a16:creationId xmlns:a16="http://schemas.microsoft.com/office/drawing/2014/main" id="{C7FEC72D-C0B4-4646-B78C-4BD3B7A0D11F}"/>
+                <a16:creationId xmlns:a16="http://schemas.microsoft.com/office/drawing/2014/main" id="{08AF3174-20DE-4024-A9DB-4E142DD17FA6}"/>
               </a:ext>
             </a:extLst>
           </p:cNvPr>
@@ -7037,7 +7037,7 @@
           <p:cNvPr id="16" name="">
             <a:extLst xmlns:a="http://schemas.openxmlformats.org/drawingml/2006/main">
               <a:ext uri="{FF2B5EF4-FFF2-40B4-BE49-F238E27FC236}">
-                <a16:creationId xmlns:a16="http://schemas.microsoft.com/office/drawing/2014/main" id="{F2026135-92AD-4714-A68E-7A41D05F6396}"/>
+                <a16:creationId xmlns:a16="http://schemas.microsoft.com/office/drawing/2014/main" id="{7D8110F1-DDC2-41B4-8F93-9483677CE61F}"/>
               </a:ext>
             </a:extLst>
           </p:cNvPr>
@@ -7085,7 +7085,7 @@
     </p:spTree>
     <p:extLst>
       <p:ext uri="{BB962C8B-B14F-4D97-AF65-F5344CB8AC3E}">
-        <p14:creationId xmlns:p14="http://schemas.microsoft.com/office/powerpoint/2010/main" val="79943041"/>
+        <p14:creationId xmlns:p14="http://schemas.microsoft.com/office/powerpoint/2010/main" val="1170082003"/>
       </p:ext>
     </p:extLst>
   </p:cSld>
@@ -7116,7 +7116,7 @@
           <p:cNvPr id="29" name="">
             <a:extLst xmlns:a="http://schemas.openxmlformats.org/drawingml/2006/main">
               <a:ext uri="{FF2B5EF4-FFF2-40B4-BE49-F238E27FC236}">
-                <a16:creationId xmlns:a16="http://schemas.microsoft.com/office/drawing/2014/main" id="{069B8BDB-AA3B-4839-9ADD-2A0608A94CC4}"/>
+                <a16:creationId xmlns:a16="http://schemas.microsoft.com/office/drawing/2014/main" id="{1A16D18E-402D-462A-A682-F1114C89C75B}"/>
               </a:ext>
             </a:extLst>
           </p:cNvPr>
@@ -7166,7 +7166,7 @@
           <p:cNvPr id="2" name="">
             <a:extLst xmlns:a="http://schemas.openxmlformats.org/drawingml/2006/main">
               <a:ext uri="{FF2B5EF4-FFF2-40B4-BE49-F238E27FC236}">
-                <a16:creationId xmlns:a16="http://schemas.microsoft.com/office/drawing/2014/main" id="{E4904863-6C4D-41A0-8577-F9FC4C0E1843}"/>
+                <a16:creationId xmlns:a16="http://schemas.microsoft.com/office/drawing/2014/main" id="{112E5606-834F-44A4-B6E9-DCE0EBEE5803}"/>
               </a:ext>
             </a:extLst>
           </p:cNvPr>
@@ -7197,7 +7197,7 @@
           <p:cNvPr id="3" name="">
             <a:extLst xmlns:a="http://schemas.openxmlformats.org/drawingml/2006/main">
               <a:ext uri="{FF2B5EF4-FFF2-40B4-BE49-F238E27FC236}">
-                <a16:creationId xmlns:a16="http://schemas.microsoft.com/office/drawing/2014/main" id="{94B4F2DD-0AED-4DCB-97FE-170379F16A08}"/>
+                <a16:creationId xmlns:a16="http://schemas.microsoft.com/office/drawing/2014/main" id="{7E9D31A5-9C08-44C0-ABFE-5456958BECCB}"/>
               </a:ext>
             </a:extLst>
           </p:cNvPr>
@@ -7247,7 +7247,7 @@
           <p:cNvPr id="4" name="">
             <a:extLst xmlns:a="http://schemas.openxmlformats.org/drawingml/2006/main">
               <a:ext uri="{FF2B5EF4-FFF2-40B4-BE49-F238E27FC236}">
-                <a16:creationId xmlns:a16="http://schemas.microsoft.com/office/drawing/2014/main" id="{4F30FCD3-BE3E-40FD-9C3A-5198BDA59B22}"/>
+                <a16:creationId xmlns:a16="http://schemas.microsoft.com/office/drawing/2014/main" id="{A3570595-F5F6-45F3-AA8E-2F7A6D24BE43}"/>
               </a:ext>
             </a:extLst>
           </p:cNvPr>
@@ -7297,7 +7297,7 @@
           <p:cNvPr id="5" name="">
             <a:extLst xmlns:a="http://schemas.openxmlformats.org/drawingml/2006/main">
               <a:ext uri="{FF2B5EF4-FFF2-40B4-BE49-F238E27FC236}">
-                <a16:creationId xmlns:a16="http://schemas.microsoft.com/office/drawing/2014/main" id="{03920764-E3AA-4B0C-8146-0A840C0B660A}"/>
+                <a16:creationId xmlns:a16="http://schemas.microsoft.com/office/drawing/2014/main" id="{FB9FB8D0-5619-4720-8736-DA2F37830E30}"/>
               </a:ext>
             </a:extLst>
           </p:cNvPr>
@@ -7347,7 +7347,7 @@
           <p:cNvPr id="6" name="">
             <a:extLst xmlns:a="http://schemas.openxmlformats.org/drawingml/2006/main">
               <a:ext uri="{FF2B5EF4-FFF2-40B4-BE49-F238E27FC236}">
-                <a16:creationId xmlns:a16="http://schemas.microsoft.com/office/drawing/2014/main" id="{144958A8-BFE7-4737-A5E5-C93CDEA849ED}"/>
+                <a16:creationId xmlns:a16="http://schemas.microsoft.com/office/drawing/2014/main" id="{D40831FC-BA2C-497D-83A3-0CB779E2F0EA}"/>
               </a:ext>
             </a:extLst>
           </p:cNvPr>
@@ -7397,7 +7397,7 @@
           <p:cNvPr id="7" name="">
             <a:extLst xmlns:a="http://schemas.openxmlformats.org/drawingml/2006/main">
               <a:ext uri="{FF2B5EF4-FFF2-40B4-BE49-F238E27FC236}">
-                <a16:creationId xmlns:a16="http://schemas.microsoft.com/office/drawing/2014/main" id="{AA68791D-4B4A-4454-ABB7-0E764CCEF0A6}"/>
+                <a16:creationId xmlns:a16="http://schemas.microsoft.com/office/drawing/2014/main" id="{672F75B6-A8DF-43B6-B527-A15C860558C4}"/>
               </a:ext>
             </a:extLst>
           </p:cNvPr>
@@ -7447,7 +7447,7 @@
           <p:cNvPr id="8" name="">
             <a:extLst xmlns:a="http://schemas.openxmlformats.org/drawingml/2006/main">
               <a:ext uri="{FF2B5EF4-FFF2-40B4-BE49-F238E27FC236}">
-                <a16:creationId xmlns:a16="http://schemas.microsoft.com/office/drawing/2014/main" id="{9375B568-7E95-4F7F-A3BF-1368F0FA6E15}"/>
+                <a16:creationId xmlns:a16="http://schemas.microsoft.com/office/drawing/2014/main" id="{EDDB251E-583D-46F6-9403-C1F2F91EB0FB}"/>
               </a:ext>
             </a:extLst>
           </p:cNvPr>
@@ -7497,7 +7497,7 @@
           <p:cNvPr id="9" name="">
             <a:extLst xmlns:a="http://schemas.openxmlformats.org/drawingml/2006/main">
               <a:ext uri="{FF2B5EF4-FFF2-40B4-BE49-F238E27FC236}">
-                <a16:creationId xmlns:a16="http://schemas.microsoft.com/office/drawing/2014/main" id="{16D399CC-DF0C-4A4E-A5CF-79E7DEE0C9A6}"/>
+                <a16:creationId xmlns:a16="http://schemas.microsoft.com/office/drawing/2014/main" id="{48B0959B-06A0-445A-B6E9-9EC1E47CEA3B}"/>
               </a:ext>
             </a:extLst>
           </p:cNvPr>
@@ -7547,7 +7547,7 @@
           <p:cNvPr id="10" name="">
             <a:extLst xmlns:a="http://schemas.openxmlformats.org/drawingml/2006/main">
               <a:ext uri="{FF2B5EF4-FFF2-40B4-BE49-F238E27FC236}">
-                <a16:creationId xmlns:a16="http://schemas.microsoft.com/office/drawing/2014/main" id="{3788D671-4601-441F-8B43-19ECA0FC9563}"/>
+                <a16:creationId xmlns:a16="http://schemas.microsoft.com/office/drawing/2014/main" id="{19573661-0DBD-4F1A-B360-618E85B78EAC}"/>
               </a:ext>
             </a:extLst>
           </p:cNvPr>
@@ -7597,7 +7597,7 @@
           <p:cNvPr id="11" name="">
             <a:extLst xmlns:a="http://schemas.openxmlformats.org/drawingml/2006/main">
               <a:ext uri="{FF2B5EF4-FFF2-40B4-BE49-F238E27FC236}">
-                <a16:creationId xmlns:a16="http://schemas.microsoft.com/office/drawing/2014/main" id="{72B2793B-BA50-4C7B-9097-4F4DD250C60E}"/>
+                <a16:creationId xmlns:a16="http://schemas.microsoft.com/office/drawing/2014/main" id="{6F123251-6B90-4082-8ADB-C8CF07AC40A6}"/>
               </a:ext>
             </a:extLst>
           </p:cNvPr>
@@ -7647,7 +7647,7 @@
           <p:cNvPr id="12" name="">
             <a:extLst xmlns:a="http://schemas.openxmlformats.org/drawingml/2006/main">
               <a:ext uri="{FF2B5EF4-FFF2-40B4-BE49-F238E27FC236}">
-                <a16:creationId xmlns:a16="http://schemas.microsoft.com/office/drawing/2014/main" id="{4BDFFA12-D194-4CAF-9FD6-435180AE89CE}"/>
+                <a16:creationId xmlns:a16="http://schemas.microsoft.com/office/drawing/2014/main" id="{55BDF6E0-645A-4DEB-9151-67B0AAC640E0}"/>
               </a:ext>
             </a:extLst>
           </p:cNvPr>
@@ -7678,7 +7678,7 @@
           <p:cNvPr id="13" name="">
             <a:extLst xmlns:a="http://schemas.openxmlformats.org/drawingml/2006/main">
               <a:ext uri="{FF2B5EF4-FFF2-40B4-BE49-F238E27FC236}">
-                <a16:creationId xmlns:a16="http://schemas.microsoft.com/office/drawing/2014/main" id="{2F9D013E-D51F-4E87-B47C-330447986963}"/>
+                <a16:creationId xmlns:a16="http://schemas.microsoft.com/office/drawing/2014/main" id="{44F9A177-7C44-4F0E-90E3-2D42FBFBF50C}"/>
               </a:ext>
             </a:extLst>
           </p:cNvPr>
@@ -7709,7 +7709,7 @@
           <p:cNvPr id="14" name="">
             <a:extLst xmlns:a="http://schemas.openxmlformats.org/drawingml/2006/main">
               <a:ext uri="{FF2B5EF4-FFF2-40B4-BE49-F238E27FC236}">
-                <a16:creationId xmlns:a16="http://schemas.microsoft.com/office/drawing/2014/main" id="{3083CD90-9E59-4DE4-9B9E-EDFCC08E8001}"/>
+                <a16:creationId xmlns:a16="http://schemas.microsoft.com/office/drawing/2014/main" id="{043441B8-DC7D-47ED-BE7C-C88CF9974CA3}"/>
               </a:ext>
             </a:extLst>
           </p:cNvPr>
@@ -7759,7 +7759,7 @@
           <p:cNvPr id="15" name="">
             <a:extLst xmlns:a="http://schemas.openxmlformats.org/drawingml/2006/main">
               <a:ext uri="{FF2B5EF4-FFF2-40B4-BE49-F238E27FC236}">
-                <a16:creationId xmlns:a16="http://schemas.microsoft.com/office/drawing/2014/main" id="{35C229F1-2451-4A87-898F-FDA55FE370F6}"/>
+                <a16:creationId xmlns:a16="http://schemas.microsoft.com/office/drawing/2014/main" id="{F12E0892-4C69-4CAB-967C-C0D51BED9FCD}"/>
               </a:ext>
             </a:extLst>
           </p:cNvPr>
@@ -7790,7 +7790,7 @@
           <p:cNvPr id="16" name="">
             <a:extLst xmlns:a="http://schemas.openxmlformats.org/drawingml/2006/main">
               <a:ext uri="{FF2B5EF4-FFF2-40B4-BE49-F238E27FC236}">
-                <a16:creationId xmlns:a16="http://schemas.microsoft.com/office/drawing/2014/main" id="{CF3FCE1C-CC87-4B67-8D1C-2AA6E53D1DAC}"/>
+                <a16:creationId xmlns:a16="http://schemas.microsoft.com/office/drawing/2014/main" id="{A4142212-2F8F-42E5-9476-521E0B2A89BD}"/>
               </a:ext>
             </a:extLst>
           </p:cNvPr>
@@ -7840,7 +7840,7 @@
           <p:cNvPr id="17" name="">
             <a:extLst xmlns:a="http://schemas.openxmlformats.org/drawingml/2006/main">
               <a:ext uri="{FF2B5EF4-FFF2-40B4-BE49-F238E27FC236}">
-                <a16:creationId xmlns:a16="http://schemas.microsoft.com/office/drawing/2014/main" id="{83A66E45-6663-4F6B-B34B-4A25C07E43BB}"/>
+                <a16:creationId xmlns:a16="http://schemas.microsoft.com/office/drawing/2014/main" id="{0B1D5F05-CD07-4B65-93DB-A7F3B6466C63}"/>
               </a:ext>
             </a:extLst>
           </p:cNvPr>
@@ -7871,7 +7871,7 @@
           <p:cNvPr id="18" name="">
             <a:extLst xmlns:a="http://schemas.openxmlformats.org/drawingml/2006/main">
               <a:ext uri="{FF2B5EF4-FFF2-40B4-BE49-F238E27FC236}">
-                <a16:creationId xmlns:a16="http://schemas.microsoft.com/office/drawing/2014/main" id="{DD9B8026-3BFE-42FD-8280-17DA593BF063}"/>
+                <a16:creationId xmlns:a16="http://schemas.microsoft.com/office/drawing/2014/main" id="{14261D02-15B3-4CE4-9279-7AE512CF4182}"/>
               </a:ext>
             </a:extLst>
           </p:cNvPr>
@@ -7921,7 +7921,7 @@
           <p:cNvPr id="19" name="">
             <a:extLst xmlns:a="http://schemas.openxmlformats.org/drawingml/2006/main">
               <a:ext uri="{FF2B5EF4-FFF2-40B4-BE49-F238E27FC236}">
-                <a16:creationId xmlns:a16="http://schemas.microsoft.com/office/drawing/2014/main" id="{F4D9FC7F-007F-4DC1-BE63-253FA88398B8}"/>
+                <a16:creationId xmlns:a16="http://schemas.microsoft.com/office/drawing/2014/main" id="{29CCB3C9-98A7-436D-B91B-6BD7979C9451}"/>
               </a:ext>
             </a:extLst>
           </p:cNvPr>
@@ -7952,7 +7952,7 @@
           <p:cNvPr id="20" name="">
             <a:extLst xmlns:a="http://schemas.openxmlformats.org/drawingml/2006/main">
               <a:ext uri="{FF2B5EF4-FFF2-40B4-BE49-F238E27FC236}">
-                <a16:creationId xmlns:a16="http://schemas.microsoft.com/office/drawing/2014/main" id="{B603D400-05A6-44BB-BDBE-36E3B607DBA0}"/>
+                <a16:creationId xmlns:a16="http://schemas.microsoft.com/office/drawing/2014/main" id="{B9F40A20-43EB-4753-A588-66655724F8B0}"/>
               </a:ext>
             </a:extLst>
           </p:cNvPr>
@@ -8002,7 +8002,7 @@
           <p:cNvPr id="21" name="">
             <a:extLst xmlns:a="http://schemas.openxmlformats.org/drawingml/2006/main">
               <a:ext uri="{FF2B5EF4-FFF2-40B4-BE49-F238E27FC236}">
-                <a16:creationId xmlns:a16="http://schemas.microsoft.com/office/drawing/2014/main" id="{8886EF7C-1B68-4086-B53D-C5430F9D40AA}"/>
+                <a16:creationId xmlns:a16="http://schemas.microsoft.com/office/drawing/2014/main" id="{AF47F4A5-4590-459B-BE56-92E4FA81C459}"/>
               </a:ext>
             </a:extLst>
           </p:cNvPr>
@@ -8052,7 +8052,7 @@
           <p:cNvPr id="22" name="">
             <a:extLst xmlns:a="http://schemas.openxmlformats.org/drawingml/2006/main">
               <a:ext uri="{FF2B5EF4-FFF2-40B4-BE49-F238E27FC236}">
-                <a16:creationId xmlns:a16="http://schemas.microsoft.com/office/drawing/2014/main" id="{5D652212-4CCE-4FCC-A33E-37B6A6C2F075}"/>
+                <a16:creationId xmlns:a16="http://schemas.microsoft.com/office/drawing/2014/main" id="{EE0FEB20-9BD1-4148-9480-B628DA63BC12}"/>
               </a:ext>
             </a:extLst>
           </p:cNvPr>
@@ -8102,7 +8102,7 @@
           <p:cNvPr id="23" name="">
             <a:extLst xmlns:a="http://schemas.openxmlformats.org/drawingml/2006/main">
               <a:ext uri="{FF2B5EF4-FFF2-40B4-BE49-F238E27FC236}">
-                <a16:creationId xmlns:a16="http://schemas.microsoft.com/office/drawing/2014/main" id="{4284B872-20EB-4FD7-BE91-1E9D1E4CF7D3}"/>
+                <a16:creationId xmlns:a16="http://schemas.microsoft.com/office/drawing/2014/main" id="{27536961-7745-435D-94F1-C636319C75C2}"/>
               </a:ext>
             </a:extLst>
           </p:cNvPr>
@@ -8152,7 +8152,7 @@
           <p:cNvPr id="24" name="">
             <a:extLst xmlns:a="http://schemas.openxmlformats.org/drawingml/2006/main">
               <a:ext uri="{FF2B5EF4-FFF2-40B4-BE49-F238E27FC236}">
-                <a16:creationId xmlns:a16="http://schemas.microsoft.com/office/drawing/2014/main" id="{57A2309A-D316-43C8-9AE3-99249EC1F2EB}"/>
+                <a16:creationId xmlns:a16="http://schemas.microsoft.com/office/drawing/2014/main" id="{58F2CD0F-B3CA-4357-B6C8-E3279CC335B0}"/>
               </a:ext>
             </a:extLst>
           </p:cNvPr>
@@ -8202,7 +8202,7 @@
           <p:cNvPr id="25" name="">
             <a:extLst xmlns:a="http://schemas.openxmlformats.org/drawingml/2006/main">
               <a:ext uri="{FF2B5EF4-FFF2-40B4-BE49-F238E27FC236}">
-                <a16:creationId xmlns:a16="http://schemas.microsoft.com/office/drawing/2014/main" id="{63A1949F-603F-430D-B5B1-D42EEC25D841}"/>
+                <a16:creationId xmlns:a16="http://schemas.microsoft.com/office/drawing/2014/main" id="{BBE9BED4-D1B9-4B3F-A8A2-FF7C6A1D74D6}"/>
               </a:ext>
             </a:extLst>
           </p:cNvPr>
@@ -8252,7 +8252,7 @@
           <p:cNvPr id="26" name="">
             <a:extLst xmlns:a="http://schemas.openxmlformats.org/drawingml/2006/main">
               <a:ext uri="{FF2B5EF4-FFF2-40B4-BE49-F238E27FC236}">
-                <a16:creationId xmlns:a16="http://schemas.microsoft.com/office/drawing/2014/main" id="{DCE65FEB-BC57-4C0D-9B03-97A332222FE4}"/>
+                <a16:creationId xmlns:a16="http://schemas.microsoft.com/office/drawing/2014/main" id="{F516B399-D0A2-466A-92AC-73F48DAE65AE}"/>
               </a:ext>
             </a:extLst>
           </p:cNvPr>
@@ -8283,7 +8283,7 @@
           <p:cNvPr id="27" name="">
             <a:extLst xmlns:a="http://schemas.openxmlformats.org/drawingml/2006/main">
               <a:ext uri="{FF2B5EF4-FFF2-40B4-BE49-F238E27FC236}">
-                <a16:creationId xmlns:a16="http://schemas.microsoft.com/office/drawing/2014/main" id="{F7141172-EED6-4C71-9931-4F1541A7BB57}"/>
+                <a16:creationId xmlns:a16="http://schemas.microsoft.com/office/drawing/2014/main" id="{CF8F432A-EF51-414E-BBBA-EB9347826E26}"/>
               </a:ext>
             </a:extLst>
           </p:cNvPr>
@@ -8333,7 +8333,7 @@
           <p:cNvPr id="28" name="">
             <a:extLst xmlns:a="http://schemas.openxmlformats.org/drawingml/2006/main">
               <a:ext uri="{FF2B5EF4-FFF2-40B4-BE49-F238E27FC236}">
-                <a16:creationId xmlns:a16="http://schemas.microsoft.com/office/drawing/2014/main" id="{5D3D74CF-6EDC-4C3B-BC06-5D64BA9037BC}"/>
+                <a16:creationId xmlns:a16="http://schemas.microsoft.com/office/drawing/2014/main" id="{9E5C0C23-0AFD-46AA-B9DE-6DD62D9447C6}"/>
               </a:ext>
             </a:extLst>
           </p:cNvPr>
@@ -8381,7 +8381,7 @@
     </p:spTree>
     <p:extLst>
       <p:ext uri="{BB962C8B-B14F-4D97-AF65-F5344CB8AC3E}">
-        <p14:creationId xmlns:p14="http://schemas.microsoft.com/office/powerpoint/2010/main" val="1198462609"/>
+        <p14:creationId xmlns:p14="http://schemas.microsoft.com/office/powerpoint/2010/main" val="1353282550"/>
       </p:ext>
     </p:extLst>
   </p:cSld>
@@ -8412,7 +8412,7 @@
           <p:cNvPr id="41" name="">
             <a:extLst xmlns:a="http://schemas.openxmlformats.org/drawingml/2006/main">
               <a:ext uri="{FF2B5EF4-FFF2-40B4-BE49-F238E27FC236}">
-                <a16:creationId xmlns:a16="http://schemas.microsoft.com/office/drawing/2014/main" id="{A7FF4822-6BB1-4475-8728-4A00BDDA6EBB}"/>
+                <a16:creationId xmlns:a16="http://schemas.microsoft.com/office/drawing/2014/main" id="{38C8571E-27E0-4ED0-A22B-E9C300BC4BF8}"/>
               </a:ext>
             </a:extLst>
           </p:cNvPr>
@@ -8462,7 +8462,7 @@
           <p:cNvPr id="2" name="">
             <a:extLst xmlns:a="http://schemas.openxmlformats.org/drawingml/2006/main">
               <a:ext uri="{FF2B5EF4-FFF2-40B4-BE49-F238E27FC236}">
-                <a16:creationId xmlns:a16="http://schemas.microsoft.com/office/drawing/2014/main" id="{4A7A6EE6-6360-41B0-8DC1-6043DAC915C2}"/>
+                <a16:creationId xmlns:a16="http://schemas.microsoft.com/office/drawing/2014/main" id="{4745896F-152F-43FA-B08A-A8094C425B98}"/>
               </a:ext>
             </a:extLst>
           </p:cNvPr>
@@ -8493,7 +8493,7 @@
           <p:cNvPr id="3" name="">
             <a:extLst xmlns:a="http://schemas.openxmlformats.org/drawingml/2006/main">
               <a:ext uri="{FF2B5EF4-FFF2-40B4-BE49-F238E27FC236}">
-                <a16:creationId xmlns:a16="http://schemas.microsoft.com/office/drawing/2014/main" id="{B7AAC49A-0EC9-4116-A412-49B455BEB208}"/>
+                <a16:creationId xmlns:a16="http://schemas.microsoft.com/office/drawing/2014/main" id="{F9EB43A6-B038-4EC9-AEB8-1C9E055EC879}"/>
               </a:ext>
             </a:extLst>
           </p:cNvPr>
@@ -8543,7 +8543,7 @@
           <p:cNvPr id="4" name="">
             <a:extLst xmlns:a="http://schemas.openxmlformats.org/drawingml/2006/main">
               <a:ext uri="{FF2B5EF4-FFF2-40B4-BE49-F238E27FC236}">
-                <a16:creationId xmlns:a16="http://schemas.microsoft.com/office/drawing/2014/main" id="{EDA1269F-447C-4554-A981-A1A9844057E5}"/>
+                <a16:creationId xmlns:a16="http://schemas.microsoft.com/office/drawing/2014/main" id="{FFFF24B9-56D0-485F-B2C7-CEC3BABA295E}"/>
               </a:ext>
             </a:extLst>
           </p:cNvPr>
@@ -8593,7 +8593,7 @@
           <p:cNvPr id="5" name="">
             <a:extLst xmlns:a="http://schemas.openxmlformats.org/drawingml/2006/main">
               <a:ext uri="{FF2B5EF4-FFF2-40B4-BE49-F238E27FC236}">
-                <a16:creationId xmlns:a16="http://schemas.microsoft.com/office/drawing/2014/main" id="{AC4BF588-1623-4B1E-9E7C-FB702D89779A}"/>
+                <a16:creationId xmlns:a16="http://schemas.microsoft.com/office/drawing/2014/main" id="{90438453-BED1-44E0-BC65-BBC15CE88A5B}"/>
               </a:ext>
             </a:extLst>
           </p:cNvPr>
@@ -8643,7 +8643,7 @@
           <p:cNvPr id="6" name="">
             <a:extLst xmlns:a="http://schemas.openxmlformats.org/drawingml/2006/main">
               <a:ext uri="{FF2B5EF4-FFF2-40B4-BE49-F238E27FC236}">
-                <a16:creationId xmlns:a16="http://schemas.microsoft.com/office/drawing/2014/main" id="{194AB473-AE5C-4449-9388-7E50DBFC901B}"/>
+                <a16:creationId xmlns:a16="http://schemas.microsoft.com/office/drawing/2014/main" id="{B322A2B8-E834-4B1B-8288-9C5D50C73A43}"/>
               </a:ext>
             </a:extLst>
           </p:cNvPr>
@@ -8693,7 +8693,7 @@
           <p:cNvPr id="7" name="">
             <a:extLst xmlns:a="http://schemas.openxmlformats.org/drawingml/2006/main">
               <a:ext uri="{FF2B5EF4-FFF2-40B4-BE49-F238E27FC236}">
-                <a16:creationId xmlns:a16="http://schemas.microsoft.com/office/drawing/2014/main" id="{48B93454-FE63-41E7-BF13-0690692CDDE1}"/>
+                <a16:creationId xmlns:a16="http://schemas.microsoft.com/office/drawing/2014/main" id="{ABD016F2-D759-46C2-ACEB-8F967C412FE6}"/>
               </a:ext>
             </a:extLst>
           </p:cNvPr>
@@ -8743,7 +8743,7 @@
           <p:cNvPr id="8" name="">
             <a:extLst xmlns:a="http://schemas.openxmlformats.org/drawingml/2006/main">
               <a:ext uri="{FF2B5EF4-FFF2-40B4-BE49-F238E27FC236}">
-                <a16:creationId xmlns:a16="http://schemas.microsoft.com/office/drawing/2014/main" id="{5B1927FC-4819-4706-BF5F-09DAD6FBDC6D}"/>
+                <a16:creationId xmlns:a16="http://schemas.microsoft.com/office/drawing/2014/main" id="{C65223DD-19CC-4F96-9558-A82455083E7B}"/>
               </a:ext>
             </a:extLst>
           </p:cNvPr>
@@ -8774,7 +8774,7 @@
           <p:cNvPr id="9" name="">
             <a:extLst xmlns:a="http://schemas.openxmlformats.org/drawingml/2006/main">
               <a:ext uri="{FF2B5EF4-FFF2-40B4-BE49-F238E27FC236}">
-                <a16:creationId xmlns:a16="http://schemas.microsoft.com/office/drawing/2014/main" id="{5D85D918-E1CE-4BD3-8DEF-756E58B581BE}"/>
+                <a16:creationId xmlns:a16="http://schemas.microsoft.com/office/drawing/2014/main" id="{642F4D4A-B078-48B0-8DD1-2B857BF7F352}"/>
               </a:ext>
             </a:extLst>
           </p:cNvPr>
@@ -8805,7 +8805,7 @@
           <p:cNvPr id="10" name="">
             <a:extLst xmlns:a="http://schemas.openxmlformats.org/drawingml/2006/main">
               <a:ext uri="{FF2B5EF4-FFF2-40B4-BE49-F238E27FC236}">
-                <a16:creationId xmlns:a16="http://schemas.microsoft.com/office/drawing/2014/main" id="{45F571F3-EE70-469B-AA64-56E6EBF9C1CB}"/>
+                <a16:creationId xmlns:a16="http://schemas.microsoft.com/office/drawing/2014/main" id="{A1FA860B-2DB0-4239-A1ED-AAEB9EDA569D}"/>
               </a:ext>
             </a:extLst>
           </p:cNvPr>
@@ -8836,7 +8836,7 @@
           <p:cNvPr id="11" name="">
             <a:extLst xmlns:a="http://schemas.openxmlformats.org/drawingml/2006/main">
               <a:ext uri="{FF2B5EF4-FFF2-40B4-BE49-F238E27FC236}">
-                <a16:creationId xmlns:a16="http://schemas.microsoft.com/office/drawing/2014/main" id="{9E36AC80-3482-432D-A3D0-D53CA699D25B}"/>
+                <a16:creationId xmlns:a16="http://schemas.microsoft.com/office/drawing/2014/main" id="{D80D69C5-BDF2-4915-9B72-3D37032D180B}"/>
               </a:ext>
             </a:extLst>
           </p:cNvPr>
@@ -8886,7 +8886,7 @@
           <p:cNvPr id="12" name="">
             <a:extLst xmlns:a="http://schemas.openxmlformats.org/drawingml/2006/main">
               <a:ext uri="{FF2B5EF4-FFF2-40B4-BE49-F238E27FC236}">
-                <a16:creationId xmlns:a16="http://schemas.microsoft.com/office/drawing/2014/main" id="{556654A5-ACCA-43DD-8849-0EB6E8C51C1B}"/>
+                <a16:creationId xmlns:a16="http://schemas.microsoft.com/office/drawing/2014/main" id="{C8133C1B-3DAA-4240-B671-955D7B851AF7}"/>
               </a:ext>
             </a:extLst>
           </p:cNvPr>
@@ -8936,7 +8936,7 @@
           <p:cNvPr id="13" name="">
             <a:extLst xmlns:a="http://schemas.openxmlformats.org/drawingml/2006/main">
               <a:ext uri="{FF2B5EF4-FFF2-40B4-BE49-F238E27FC236}">
-                <a16:creationId xmlns:a16="http://schemas.microsoft.com/office/drawing/2014/main" id="{9430EBDC-1C25-4A79-8B7F-730FDA0038CE}"/>
+                <a16:creationId xmlns:a16="http://schemas.microsoft.com/office/drawing/2014/main" id="{FBFC04C3-2497-4D58-BF0B-D601B6E6C57F}"/>
               </a:ext>
             </a:extLst>
           </p:cNvPr>
@@ -8986,7 +8986,7 @@
           <p:cNvPr id="14" name="">
             <a:extLst xmlns:a="http://schemas.openxmlformats.org/drawingml/2006/main">
               <a:ext uri="{FF2B5EF4-FFF2-40B4-BE49-F238E27FC236}">
-                <a16:creationId xmlns:a16="http://schemas.microsoft.com/office/drawing/2014/main" id="{EB1DAF9C-4857-48EF-B066-942C6D2A8CEE}"/>
+                <a16:creationId xmlns:a16="http://schemas.microsoft.com/office/drawing/2014/main" id="{FC168D8C-2884-45E0-B814-BD713AE63B18}"/>
               </a:ext>
             </a:extLst>
           </p:cNvPr>
@@ -9036,7 +9036,7 @@
           <p:cNvPr id="15" name="">
             <a:extLst xmlns:a="http://schemas.openxmlformats.org/drawingml/2006/main">
               <a:ext uri="{FF2B5EF4-FFF2-40B4-BE49-F238E27FC236}">
-                <a16:creationId xmlns:a16="http://schemas.microsoft.com/office/drawing/2014/main" id="{D1100FB3-9A55-491E-B439-A499A31872C2}"/>
+                <a16:creationId xmlns:a16="http://schemas.microsoft.com/office/drawing/2014/main" id="{DC863454-39BC-4AAB-AC8C-97DB4B83C840}"/>
               </a:ext>
             </a:extLst>
           </p:cNvPr>
@@ -9067,7 +9067,7 @@
           <p:cNvPr id="16" name="">
             <a:extLst xmlns:a="http://schemas.openxmlformats.org/drawingml/2006/main">
               <a:ext uri="{FF2B5EF4-FFF2-40B4-BE49-F238E27FC236}">
-                <a16:creationId xmlns:a16="http://schemas.microsoft.com/office/drawing/2014/main" id="{D5A519D6-2F9D-40D4-AA9C-F6655C9FFCB4}"/>
+                <a16:creationId xmlns:a16="http://schemas.microsoft.com/office/drawing/2014/main" id="{1229BB5C-494B-4AFF-B28A-2040977DFDE5}"/>
               </a:ext>
             </a:extLst>
           </p:cNvPr>
@@ -9117,7 +9117,7 @@
           <p:cNvPr id="17" name="">
             <a:extLst xmlns:a="http://schemas.openxmlformats.org/drawingml/2006/main">
               <a:ext uri="{FF2B5EF4-FFF2-40B4-BE49-F238E27FC236}">
-                <a16:creationId xmlns:a16="http://schemas.microsoft.com/office/drawing/2014/main" id="{F38F3AA0-7792-4455-A017-0D0BB41C972D}"/>
+                <a16:creationId xmlns:a16="http://schemas.microsoft.com/office/drawing/2014/main" id="{C5131EF5-8405-4D1C-921D-4FB05909AE44}"/>
               </a:ext>
             </a:extLst>
           </p:cNvPr>
@@ -9167,7 +9167,7 @@
           <p:cNvPr id="18" name="">
             <a:extLst xmlns:a="http://schemas.openxmlformats.org/drawingml/2006/main">
               <a:ext uri="{FF2B5EF4-FFF2-40B4-BE49-F238E27FC236}">
-                <a16:creationId xmlns:a16="http://schemas.microsoft.com/office/drawing/2014/main" id="{177AF2EC-CA2F-4782-A632-73B2A35DA64B}"/>
+                <a16:creationId xmlns:a16="http://schemas.microsoft.com/office/drawing/2014/main" id="{F917D844-7847-46AD-9021-B065E7338CE6}"/>
               </a:ext>
             </a:extLst>
           </p:cNvPr>
@@ -9217,7 +9217,7 @@
           <p:cNvPr id="19" name="">
             <a:extLst xmlns:a="http://schemas.openxmlformats.org/drawingml/2006/main">
               <a:ext uri="{FF2B5EF4-FFF2-40B4-BE49-F238E27FC236}">
-                <a16:creationId xmlns:a16="http://schemas.microsoft.com/office/drawing/2014/main" id="{9DDD3E29-6D29-41F4-BDCA-14B8431E1254}"/>
+                <a16:creationId xmlns:a16="http://schemas.microsoft.com/office/drawing/2014/main" id="{D2530869-CB67-43F6-BAEC-724CCDBC1B2C}"/>
               </a:ext>
             </a:extLst>
           </p:cNvPr>
@@ -9248,7 +9248,7 @@
           <p:cNvPr id="20" name="">
             <a:extLst xmlns:a="http://schemas.openxmlformats.org/drawingml/2006/main">
               <a:ext uri="{FF2B5EF4-FFF2-40B4-BE49-F238E27FC236}">
-                <a16:creationId xmlns:a16="http://schemas.microsoft.com/office/drawing/2014/main" id="{4BD05DB6-C9FA-4D85-A6F4-72815C42A266}"/>
+                <a16:creationId xmlns:a16="http://schemas.microsoft.com/office/drawing/2014/main" id="{A58CCC7E-DF97-4430-B800-BEAA1F78697E}"/>
               </a:ext>
             </a:extLst>
           </p:cNvPr>
@@ -9298,7 +9298,7 @@
           <p:cNvPr id="21" name="">
             <a:extLst xmlns:a="http://schemas.openxmlformats.org/drawingml/2006/main">
               <a:ext uri="{FF2B5EF4-FFF2-40B4-BE49-F238E27FC236}">
-                <a16:creationId xmlns:a16="http://schemas.microsoft.com/office/drawing/2014/main" id="{A199E87A-3A3B-426B-B92E-68EA6AA94A85}"/>
+                <a16:creationId xmlns:a16="http://schemas.microsoft.com/office/drawing/2014/main" id="{64130AAE-4F03-4DD6-994E-A74E93610129}"/>
               </a:ext>
             </a:extLst>
           </p:cNvPr>
@@ -9348,7 +9348,7 @@
           <p:cNvPr id="22" name="">
             <a:extLst xmlns:a="http://schemas.openxmlformats.org/drawingml/2006/main">
               <a:ext uri="{FF2B5EF4-FFF2-40B4-BE49-F238E27FC236}">
-                <a16:creationId xmlns:a16="http://schemas.microsoft.com/office/drawing/2014/main" id="{9BA1697C-B14A-4733-BAB6-F39FF0128BCE}"/>
+                <a16:creationId xmlns:a16="http://schemas.microsoft.com/office/drawing/2014/main" id="{F2DBB23F-89F8-4CA6-91AA-24B2D67C87FC}"/>
               </a:ext>
             </a:extLst>
           </p:cNvPr>
@@ -9398,7 +9398,7 @@
           <p:cNvPr id="23" name="">
             <a:extLst xmlns:a="http://schemas.openxmlformats.org/drawingml/2006/main">
               <a:ext uri="{FF2B5EF4-FFF2-40B4-BE49-F238E27FC236}">
-                <a16:creationId xmlns:a16="http://schemas.microsoft.com/office/drawing/2014/main" id="{7FE8E571-DB7F-49E7-AF3A-63B01B103178}"/>
+                <a16:creationId xmlns:a16="http://schemas.microsoft.com/office/drawing/2014/main" id="{0FC20E4C-AD43-4787-BF3C-99B21D1DF7CD}"/>
               </a:ext>
             </a:extLst>
           </p:cNvPr>
@@ -9429,7 +9429,7 @@
           <p:cNvPr id="24" name="">
             <a:extLst xmlns:a="http://schemas.openxmlformats.org/drawingml/2006/main">
               <a:ext uri="{FF2B5EF4-FFF2-40B4-BE49-F238E27FC236}">
-                <a16:creationId xmlns:a16="http://schemas.microsoft.com/office/drawing/2014/main" id="{324AE692-4F2A-4526-B1DC-A862D63167EC}"/>
+                <a16:creationId xmlns:a16="http://schemas.microsoft.com/office/drawing/2014/main" id="{534195EA-CB35-44C5-9347-002987C132F1}"/>
               </a:ext>
             </a:extLst>
           </p:cNvPr>
@@ -9460,7 +9460,7 @@
           <p:cNvPr id="25" name="">
             <a:extLst xmlns:a="http://schemas.openxmlformats.org/drawingml/2006/main">
               <a:ext uri="{FF2B5EF4-FFF2-40B4-BE49-F238E27FC236}">
-                <a16:creationId xmlns:a16="http://schemas.microsoft.com/office/drawing/2014/main" id="{58FFB6F6-CA92-4EF5-A736-BF32AFADB3C1}"/>
+                <a16:creationId xmlns:a16="http://schemas.microsoft.com/office/drawing/2014/main" id="{67A9A801-DF5A-4DEF-9DF5-C2EAE9007725}"/>
               </a:ext>
             </a:extLst>
           </p:cNvPr>
@@ -9510,7 +9510,7 @@
           <p:cNvPr id="26" name="">
             <a:extLst xmlns:a="http://schemas.openxmlformats.org/drawingml/2006/main">
               <a:ext uri="{FF2B5EF4-FFF2-40B4-BE49-F238E27FC236}">
-                <a16:creationId xmlns:a16="http://schemas.microsoft.com/office/drawing/2014/main" id="{C2DC5415-E525-4113-8CB1-29BBB03C0C00}"/>
+                <a16:creationId xmlns:a16="http://schemas.microsoft.com/office/drawing/2014/main" id="{4415070E-7A80-4AB1-B009-CACA7252992A}"/>
               </a:ext>
             </a:extLst>
           </p:cNvPr>
@@ -9560,7 +9560,7 @@
           <p:cNvPr id="27" name="">
             <a:extLst xmlns:a="http://schemas.openxmlformats.org/drawingml/2006/main">
               <a:ext uri="{FF2B5EF4-FFF2-40B4-BE49-F238E27FC236}">
-                <a16:creationId xmlns:a16="http://schemas.microsoft.com/office/drawing/2014/main" id="{FF4522D5-C9F2-4D14-8681-E4F347D33B77}"/>
+                <a16:creationId xmlns:a16="http://schemas.microsoft.com/office/drawing/2014/main" id="{7BCA2EBB-1B49-4FB2-A719-5F8BA00E88C5}"/>
               </a:ext>
             </a:extLst>
           </p:cNvPr>
@@ -9610,7 +9610,7 @@
           <p:cNvPr id="28" name="">
             <a:extLst xmlns:a="http://schemas.openxmlformats.org/drawingml/2006/main">
               <a:ext uri="{FF2B5EF4-FFF2-40B4-BE49-F238E27FC236}">
-                <a16:creationId xmlns:a16="http://schemas.microsoft.com/office/drawing/2014/main" id="{5884C79E-3EF1-4CB9-9A57-4F7B5DC050DC}"/>
+                <a16:creationId xmlns:a16="http://schemas.microsoft.com/office/drawing/2014/main" id="{E5F1AB8B-ED42-4D19-96C2-F3F775F11E14}"/>
               </a:ext>
             </a:extLst>
           </p:cNvPr>
@@ -9641,7 +9641,7 @@
           <p:cNvPr id="29" name="">
             <a:extLst xmlns:a="http://schemas.openxmlformats.org/drawingml/2006/main">
               <a:ext uri="{FF2B5EF4-FFF2-40B4-BE49-F238E27FC236}">
-                <a16:creationId xmlns:a16="http://schemas.microsoft.com/office/drawing/2014/main" id="{630D3BB2-6EC8-413A-B73A-631F12B53BF1}"/>
+                <a16:creationId xmlns:a16="http://schemas.microsoft.com/office/drawing/2014/main" id="{704D0C66-5CDD-4D81-85A9-EC24EB285963}"/>
               </a:ext>
             </a:extLst>
           </p:cNvPr>
@@ -9672,7 +9672,7 @@
           <p:cNvPr id="30" name="">
             <a:extLst xmlns:a="http://schemas.openxmlformats.org/drawingml/2006/main">
               <a:ext uri="{FF2B5EF4-FFF2-40B4-BE49-F238E27FC236}">
-                <a16:creationId xmlns:a16="http://schemas.microsoft.com/office/drawing/2014/main" id="{BB58E302-4666-4948-B226-2E3841E6F99D}"/>
+                <a16:creationId xmlns:a16="http://schemas.microsoft.com/office/drawing/2014/main" id="{961818BA-896B-4EAD-A090-8BCEAB0FD182}"/>
               </a:ext>
             </a:extLst>
           </p:cNvPr>
@@ -9722,7 +9722,7 @@
           <p:cNvPr id="31" name="">
             <a:extLst xmlns:a="http://schemas.openxmlformats.org/drawingml/2006/main">
               <a:ext uri="{FF2B5EF4-FFF2-40B4-BE49-F238E27FC236}">
-                <a16:creationId xmlns:a16="http://schemas.microsoft.com/office/drawing/2014/main" id="{E856A5A3-D6E4-4A55-825B-10992B743A55}"/>
+                <a16:creationId xmlns:a16="http://schemas.microsoft.com/office/drawing/2014/main" id="{42BAAF9A-CF80-4F97-933A-5591C5CEC77B}"/>
               </a:ext>
             </a:extLst>
           </p:cNvPr>
@@ -9772,7 +9772,7 @@
           <p:cNvPr id="32" name="">
             <a:extLst xmlns:a="http://schemas.openxmlformats.org/drawingml/2006/main">
               <a:ext uri="{FF2B5EF4-FFF2-40B4-BE49-F238E27FC236}">
-                <a16:creationId xmlns:a16="http://schemas.microsoft.com/office/drawing/2014/main" id="{D3EA5119-CBA0-4599-B4BD-EAB0D8D9C225}"/>
+                <a16:creationId xmlns:a16="http://schemas.microsoft.com/office/drawing/2014/main" id="{4FD3FCCB-57A1-436B-BF6F-2A4FD5CA8216}"/>
               </a:ext>
             </a:extLst>
           </p:cNvPr>
@@ -9822,7 +9822,7 @@
           <p:cNvPr id="33" name="">
             <a:extLst xmlns:a="http://schemas.openxmlformats.org/drawingml/2006/main">
               <a:ext uri="{FF2B5EF4-FFF2-40B4-BE49-F238E27FC236}">
-                <a16:creationId xmlns:a16="http://schemas.microsoft.com/office/drawing/2014/main" id="{CA5C1910-4609-4BF3-915B-4B369D4262DB}"/>
+                <a16:creationId xmlns:a16="http://schemas.microsoft.com/office/drawing/2014/main" id="{24E006E7-C9B7-455E-860D-28E94B67F93C}"/>
               </a:ext>
             </a:extLst>
           </p:cNvPr>
@@ -9853,7 +9853,7 @@
           <p:cNvPr id="34" name="">
             <a:extLst xmlns:a="http://schemas.openxmlformats.org/drawingml/2006/main">
               <a:ext uri="{FF2B5EF4-FFF2-40B4-BE49-F238E27FC236}">
-                <a16:creationId xmlns:a16="http://schemas.microsoft.com/office/drawing/2014/main" id="{BD57CC1D-C739-4CE9-BFFC-9B74D9DC2880}"/>
+                <a16:creationId xmlns:a16="http://schemas.microsoft.com/office/drawing/2014/main" id="{F8A7DC2A-2A29-4839-8380-1AE59C16F514}"/>
               </a:ext>
             </a:extLst>
           </p:cNvPr>
@@ -9884,7 +9884,7 @@
           <p:cNvPr id="35" name="">
             <a:extLst xmlns:a="http://schemas.openxmlformats.org/drawingml/2006/main">
               <a:ext uri="{FF2B5EF4-FFF2-40B4-BE49-F238E27FC236}">
-                <a16:creationId xmlns:a16="http://schemas.microsoft.com/office/drawing/2014/main" id="{DC515BB2-BC06-4DCC-9AD1-6822CFE2635F}"/>
+                <a16:creationId xmlns:a16="http://schemas.microsoft.com/office/drawing/2014/main" id="{6D137DE4-B544-40D0-8277-098AEFD5EB8C}"/>
               </a:ext>
             </a:extLst>
           </p:cNvPr>
@@ -9934,7 +9934,7 @@
           <p:cNvPr id="36" name="">
             <a:extLst xmlns:a="http://schemas.openxmlformats.org/drawingml/2006/main">
               <a:ext uri="{FF2B5EF4-FFF2-40B4-BE49-F238E27FC236}">
-                <a16:creationId xmlns:a16="http://schemas.microsoft.com/office/drawing/2014/main" id="{48C8E97D-A719-4735-B18B-D294B68946E5}"/>
+                <a16:creationId xmlns:a16="http://schemas.microsoft.com/office/drawing/2014/main" id="{7D92FAB1-C060-498D-9F8E-E9BA0B73BF0B}"/>
               </a:ext>
             </a:extLst>
           </p:cNvPr>
@@ -9984,7 +9984,7 @@
           <p:cNvPr id="37" name="">
             <a:extLst xmlns:a="http://schemas.openxmlformats.org/drawingml/2006/main">
               <a:ext uri="{FF2B5EF4-FFF2-40B4-BE49-F238E27FC236}">
-                <a16:creationId xmlns:a16="http://schemas.microsoft.com/office/drawing/2014/main" id="{D04DB5B5-11AC-4243-88C5-BF67E0A83967}"/>
+                <a16:creationId xmlns:a16="http://schemas.microsoft.com/office/drawing/2014/main" id="{73C38FDC-321C-48DF-A22F-500A639174D7}"/>
               </a:ext>
             </a:extLst>
           </p:cNvPr>
@@ -10034,7 +10034,7 @@
           <p:cNvPr id="38" name="">
             <a:extLst xmlns:a="http://schemas.openxmlformats.org/drawingml/2006/main">
               <a:ext uri="{FF2B5EF4-FFF2-40B4-BE49-F238E27FC236}">
-                <a16:creationId xmlns:a16="http://schemas.microsoft.com/office/drawing/2014/main" id="{B87ED84A-D57E-42F4-9008-D6B67F67F72C}"/>
+                <a16:creationId xmlns:a16="http://schemas.microsoft.com/office/drawing/2014/main" id="{C87CCC94-8EBF-44A8-A790-EC8A4F7F4283}"/>
               </a:ext>
             </a:extLst>
           </p:cNvPr>
@@ -10065,7 +10065,7 @@
           <p:cNvPr id="39" name="">
             <a:extLst xmlns:a="http://schemas.openxmlformats.org/drawingml/2006/main">
               <a:ext uri="{FF2B5EF4-FFF2-40B4-BE49-F238E27FC236}">
-                <a16:creationId xmlns:a16="http://schemas.microsoft.com/office/drawing/2014/main" id="{91B145A6-D754-4866-A355-DD6271932933}"/>
+                <a16:creationId xmlns:a16="http://schemas.microsoft.com/office/drawing/2014/main" id="{61C4B509-3330-495F-97B8-78DDE2B1F3E4}"/>
               </a:ext>
             </a:extLst>
           </p:cNvPr>
@@ -10115,7 +10115,7 @@
           <p:cNvPr id="40" name="">
             <a:extLst xmlns:a="http://schemas.openxmlformats.org/drawingml/2006/main">
               <a:ext uri="{FF2B5EF4-FFF2-40B4-BE49-F238E27FC236}">
-                <a16:creationId xmlns:a16="http://schemas.microsoft.com/office/drawing/2014/main" id="{12544FFB-5816-4DFD-9387-C5D5007F48AD}"/>
+                <a16:creationId xmlns:a16="http://schemas.microsoft.com/office/drawing/2014/main" id="{1FD470BD-6DBA-408A-A4E4-6A677B5DCA29}"/>
               </a:ext>
             </a:extLst>
           </p:cNvPr>
@@ -10163,7 +10163,7 @@
     </p:spTree>
     <p:extLst>
       <p:ext uri="{BB962C8B-B14F-4D97-AF65-F5344CB8AC3E}">
-        <p14:creationId xmlns:p14="http://schemas.microsoft.com/office/powerpoint/2010/main" val="979328216"/>
+        <p14:creationId xmlns:p14="http://schemas.microsoft.com/office/powerpoint/2010/main" val="914438918"/>
       </p:ext>
     </p:extLst>
   </p:cSld>
@@ -10194,7 +10194,7 @@
           <p:cNvPr id="38" name="">
             <a:extLst xmlns:a="http://schemas.openxmlformats.org/drawingml/2006/main">
               <a:ext uri="{FF2B5EF4-FFF2-40B4-BE49-F238E27FC236}">
-                <a16:creationId xmlns:a16="http://schemas.microsoft.com/office/drawing/2014/main" id="{586EC847-94D3-4BEE-B66A-F77E6E31D500}"/>
+                <a16:creationId xmlns:a16="http://schemas.microsoft.com/office/drawing/2014/main" id="{53C3F351-A4BD-42A4-848A-39EE79011E80}"/>
               </a:ext>
             </a:extLst>
           </p:cNvPr>
@@ -10244,7 +10244,7 @@
           <p:cNvPr id="2" name="">
             <a:extLst xmlns:a="http://schemas.openxmlformats.org/drawingml/2006/main">
               <a:ext uri="{FF2B5EF4-FFF2-40B4-BE49-F238E27FC236}">
-                <a16:creationId xmlns:a16="http://schemas.microsoft.com/office/drawing/2014/main" id="{A0E70EBC-37B0-4BF0-8A44-9B6E459F02D9}"/>
+                <a16:creationId xmlns:a16="http://schemas.microsoft.com/office/drawing/2014/main" id="{6282CFB5-99EE-4271-A5B3-CC32131CF377}"/>
               </a:ext>
             </a:extLst>
           </p:cNvPr>
@@ -10275,7 +10275,7 @@
           <p:cNvPr id="3" name="">
             <a:extLst xmlns:a="http://schemas.openxmlformats.org/drawingml/2006/main">
               <a:ext uri="{FF2B5EF4-FFF2-40B4-BE49-F238E27FC236}">
-                <a16:creationId xmlns:a16="http://schemas.microsoft.com/office/drawing/2014/main" id="{3A6B8382-6510-4910-8389-B1A88ACC7708}"/>
+                <a16:creationId xmlns:a16="http://schemas.microsoft.com/office/drawing/2014/main" id="{462E9625-0B7D-4931-B43A-56F0601C2DAA}"/>
               </a:ext>
             </a:extLst>
           </p:cNvPr>
@@ -10325,7 +10325,7 @@
           <p:cNvPr id="4" name="">
             <a:extLst xmlns:a="http://schemas.openxmlformats.org/drawingml/2006/main">
               <a:ext uri="{FF2B5EF4-FFF2-40B4-BE49-F238E27FC236}">
-                <a16:creationId xmlns:a16="http://schemas.microsoft.com/office/drawing/2014/main" id="{03D8FA3C-D530-49B4-B981-16801FE97E7C}"/>
+                <a16:creationId xmlns:a16="http://schemas.microsoft.com/office/drawing/2014/main" id="{BD85DB2C-0115-4F1F-9D28-3E6CF165F091}"/>
               </a:ext>
             </a:extLst>
           </p:cNvPr>
@@ -10375,7 +10375,7 @@
           <p:cNvPr id="5" name="">
             <a:extLst xmlns:a="http://schemas.openxmlformats.org/drawingml/2006/main">
               <a:ext uri="{FF2B5EF4-FFF2-40B4-BE49-F238E27FC236}">
-                <a16:creationId xmlns:a16="http://schemas.microsoft.com/office/drawing/2014/main" id="{18B9A1B2-2693-4C51-88A0-BE488C0D0DB5}"/>
+                <a16:creationId xmlns:a16="http://schemas.microsoft.com/office/drawing/2014/main" id="{2C652B64-DF24-413A-9DC5-2ACEBD881B94}"/>
               </a:ext>
             </a:extLst>
           </p:cNvPr>
@@ -10425,7 +10425,7 @@
           <p:cNvPr id="6" name="">
             <a:extLst xmlns:a="http://schemas.openxmlformats.org/drawingml/2006/main">
               <a:ext uri="{FF2B5EF4-FFF2-40B4-BE49-F238E27FC236}">
-                <a16:creationId xmlns:a16="http://schemas.microsoft.com/office/drawing/2014/main" id="{FECF47D2-2F96-4B22-8B0F-370AA1C72658}"/>
+                <a16:creationId xmlns:a16="http://schemas.microsoft.com/office/drawing/2014/main" id="{F35F2C95-5E66-495C-8152-98ED6D865C6C}"/>
               </a:ext>
             </a:extLst>
           </p:cNvPr>
@@ -10458,7 +10458,7 @@
           <p:cNvPr id="7" name="">
             <a:extLst xmlns:a="http://schemas.openxmlformats.org/drawingml/2006/main">
               <a:ext uri="{FF2B5EF4-FFF2-40B4-BE49-F238E27FC236}">
-                <a16:creationId xmlns:a16="http://schemas.microsoft.com/office/drawing/2014/main" id="{DD808603-90C1-4D1C-9DA5-0AE99C3DE8C9}"/>
+                <a16:creationId xmlns:a16="http://schemas.microsoft.com/office/drawing/2014/main" id="{B3662648-43B9-4664-A5E2-EBF3233B1B31}"/>
               </a:ext>
             </a:extLst>
           </p:cNvPr>
@@ -10508,7 +10508,7 @@
           <p:cNvPr id="8" name="">
             <a:extLst xmlns:a="http://schemas.openxmlformats.org/drawingml/2006/main">
               <a:ext uri="{FF2B5EF4-FFF2-40B4-BE49-F238E27FC236}">
-                <a16:creationId xmlns:a16="http://schemas.microsoft.com/office/drawing/2014/main" id="{5FE54168-FAD7-45DC-BD05-F9871C48592C}"/>
+                <a16:creationId xmlns:a16="http://schemas.microsoft.com/office/drawing/2014/main" id="{0D063583-E473-4C52-9EFA-81C58D2837F9}"/>
               </a:ext>
             </a:extLst>
           </p:cNvPr>
@@ -10558,7 +10558,7 @@
           <p:cNvPr id="9" name="">
             <a:extLst xmlns:a="http://schemas.openxmlformats.org/drawingml/2006/main">
               <a:ext uri="{FF2B5EF4-FFF2-40B4-BE49-F238E27FC236}">
-                <a16:creationId xmlns:a16="http://schemas.microsoft.com/office/drawing/2014/main" id="{36AA89C4-E47E-40A2-AE50-191CF3658917}"/>
+                <a16:creationId xmlns:a16="http://schemas.microsoft.com/office/drawing/2014/main" id="{DB9EB0A4-851C-4047-9056-0B9EF69AE1C9}"/>
               </a:ext>
             </a:extLst>
           </p:cNvPr>
@@ -10608,7 +10608,7 @@
           <p:cNvPr id="10" name="">
             <a:extLst xmlns:a="http://schemas.openxmlformats.org/drawingml/2006/main">
               <a:ext uri="{FF2B5EF4-FFF2-40B4-BE49-F238E27FC236}">
-                <a16:creationId xmlns:a16="http://schemas.microsoft.com/office/drawing/2014/main" id="{E9D8DA29-A475-4AF4-9828-F7040C36EA27}"/>
+                <a16:creationId xmlns:a16="http://schemas.microsoft.com/office/drawing/2014/main" id="{922ED472-3A8A-401C-B1F1-5CFBC7AEF522}"/>
               </a:ext>
             </a:extLst>
           </p:cNvPr>
@@ -10639,7 +10639,7 @@
           <p:cNvPr id="11" name="">
             <a:extLst xmlns:a="http://schemas.openxmlformats.org/drawingml/2006/main">
               <a:ext uri="{FF2B5EF4-FFF2-40B4-BE49-F238E27FC236}">
-                <a16:creationId xmlns:a16="http://schemas.microsoft.com/office/drawing/2014/main" id="{FF81EDB9-BBF4-49EA-BE4D-D63E05D50C0E}"/>
+                <a16:creationId xmlns:a16="http://schemas.microsoft.com/office/drawing/2014/main" id="{1E5A108B-4078-4B82-A62C-9E4065FEA435}"/>
               </a:ext>
             </a:extLst>
           </p:cNvPr>
@@ -10672,7 +10672,7 @@
           <p:cNvPr id="12" name="">
             <a:extLst xmlns:a="http://schemas.openxmlformats.org/drawingml/2006/main">
               <a:ext uri="{FF2B5EF4-FFF2-40B4-BE49-F238E27FC236}">
-                <a16:creationId xmlns:a16="http://schemas.microsoft.com/office/drawing/2014/main" id="{60B33CF9-A25D-4D31-917F-665926CAD7BB}"/>
+                <a16:creationId xmlns:a16="http://schemas.microsoft.com/office/drawing/2014/main" id="{433309FC-CCB7-4C86-A472-BBFDCDD38859}"/>
               </a:ext>
             </a:extLst>
           </p:cNvPr>
@@ -10722,7 +10722,7 @@
           <p:cNvPr id="13" name="">
             <a:extLst xmlns:a="http://schemas.openxmlformats.org/drawingml/2006/main">
               <a:ext uri="{FF2B5EF4-FFF2-40B4-BE49-F238E27FC236}">
-                <a16:creationId xmlns:a16="http://schemas.microsoft.com/office/drawing/2014/main" id="{72618DC0-75D9-452C-96DB-B7BFD201E0E8}"/>
+                <a16:creationId xmlns:a16="http://schemas.microsoft.com/office/drawing/2014/main" id="{2BD0C36D-D7FC-4A56-B023-0094731DC14F}"/>
               </a:ext>
             </a:extLst>
           </p:cNvPr>
@@ -10772,7 +10772,7 @@
           <p:cNvPr id="14" name="">
             <a:extLst xmlns:a="http://schemas.openxmlformats.org/drawingml/2006/main">
               <a:ext uri="{FF2B5EF4-FFF2-40B4-BE49-F238E27FC236}">
-                <a16:creationId xmlns:a16="http://schemas.microsoft.com/office/drawing/2014/main" id="{4608D48B-F042-49F5-9ADC-5FB5CC94DAD7}"/>
+                <a16:creationId xmlns:a16="http://schemas.microsoft.com/office/drawing/2014/main" id="{66282B5D-64C5-4401-8A38-DD5382731843}"/>
               </a:ext>
             </a:extLst>
           </p:cNvPr>
@@ -10822,7 +10822,7 @@
           <p:cNvPr id="15" name="">
             <a:extLst xmlns:a="http://schemas.openxmlformats.org/drawingml/2006/main">
               <a:ext uri="{FF2B5EF4-FFF2-40B4-BE49-F238E27FC236}">
-                <a16:creationId xmlns:a16="http://schemas.microsoft.com/office/drawing/2014/main" id="{9E7F8989-DA01-4329-9877-06967532C083}"/>
+                <a16:creationId xmlns:a16="http://schemas.microsoft.com/office/drawing/2014/main" id="{52C87AD7-9A6C-4D0D-94A6-6A49D846572B}"/>
               </a:ext>
             </a:extLst>
           </p:cNvPr>
@@ -10853,7 +10853,7 @@
           <p:cNvPr id="16" name="">
             <a:extLst xmlns:a="http://schemas.openxmlformats.org/drawingml/2006/main">
               <a:ext uri="{FF2B5EF4-FFF2-40B4-BE49-F238E27FC236}">
-                <a16:creationId xmlns:a16="http://schemas.microsoft.com/office/drawing/2014/main" id="{C74F3FD0-CD90-4597-B4FF-5ED68BE94F6A}"/>
+                <a16:creationId xmlns:a16="http://schemas.microsoft.com/office/drawing/2014/main" id="{FCBBC23A-5D35-41BF-841D-5E3D64DCD863}"/>
               </a:ext>
             </a:extLst>
           </p:cNvPr>
@@ -10886,7 +10886,7 @@
           <p:cNvPr id="17" name="">
             <a:extLst xmlns:a="http://schemas.openxmlformats.org/drawingml/2006/main">
               <a:ext uri="{FF2B5EF4-FFF2-40B4-BE49-F238E27FC236}">
-                <a16:creationId xmlns:a16="http://schemas.microsoft.com/office/drawing/2014/main" id="{B0F0767D-90A1-47CE-BFC0-DDC00D4E5D44}"/>
+                <a16:creationId xmlns:a16="http://schemas.microsoft.com/office/drawing/2014/main" id="{6379071B-13C5-45F5-BF18-98DBA8D674CB}"/>
               </a:ext>
             </a:extLst>
           </p:cNvPr>
@@ -10936,7 +10936,7 @@
           <p:cNvPr id="18" name="">
             <a:extLst xmlns:a="http://schemas.openxmlformats.org/drawingml/2006/main">
               <a:ext uri="{FF2B5EF4-FFF2-40B4-BE49-F238E27FC236}">
-                <a16:creationId xmlns:a16="http://schemas.microsoft.com/office/drawing/2014/main" id="{3B85576A-9DFB-42CC-9FC6-D5A799961FA9}"/>
+                <a16:creationId xmlns:a16="http://schemas.microsoft.com/office/drawing/2014/main" id="{026FD20A-F3FE-46CE-A84E-A4E5EAA6D420}"/>
               </a:ext>
             </a:extLst>
           </p:cNvPr>
@@ -10986,7 +10986,7 @@
           <p:cNvPr id="19" name="">
             <a:extLst xmlns:a="http://schemas.openxmlformats.org/drawingml/2006/main">
               <a:ext uri="{FF2B5EF4-FFF2-40B4-BE49-F238E27FC236}">
-                <a16:creationId xmlns:a16="http://schemas.microsoft.com/office/drawing/2014/main" id="{3331835A-D8D9-4D52-82AF-9AA7A3234491}"/>
+                <a16:creationId xmlns:a16="http://schemas.microsoft.com/office/drawing/2014/main" id="{20C31768-C2A1-4653-800F-CC8F460240C6}"/>
               </a:ext>
             </a:extLst>
           </p:cNvPr>
@@ -11036,7 +11036,7 @@
           <p:cNvPr id="20" name="">
             <a:extLst xmlns:a="http://schemas.openxmlformats.org/drawingml/2006/main">
               <a:ext uri="{FF2B5EF4-FFF2-40B4-BE49-F238E27FC236}">
-                <a16:creationId xmlns:a16="http://schemas.microsoft.com/office/drawing/2014/main" id="{7C54B08F-04A0-4348-B10D-00CAEDA9D495}"/>
+                <a16:creationId xmlns:a16="http://schemas.microsoft.com/office/drawing/2014/main" id="{ED2DB9B3-5E89-47C2-A0C6-95C4FE05C9A0}"/>
               </a:ext>
             </a:extLst>
           </p:cNvPr>
@@ -11067,7 +11067,7 @@
           <p:cNvPr id="21" name="">
             <a:extLst xmlns:a="http://schemas.openxmlformats.org/drawingml/2006/main">
               <a:ext uri="{FF2B5EF4-FFF2-40B4-BE49-F238E27FC236}">
-                <a16:creationId xmlns:a16="http://schemas.microsoft.com/office/drawing/2014/main" id="{10B5558E-4943-452F-9936-44B32104616A}"/>
+                <a16:creationId xmlns:a16="http://schemas.microsoft.com/office/drawing/2014/main" id="{AC56BBC6-6D2D-4744-A737-FAA20A6D7EE9}"/>
               </a:ext>
             </a:extLst>
           </p:cNvPr>
@@ -11100,7 +11100,7 @@
           <p:cNvPr id="22" name="">
             <a:extLst xmlns:a="http://schemas.openxmlformats.org/drawingml/2006/main">
               <a:ext uri="{FF2B5EF4-FFF2-40B4-BE49-F238E27FC236}">
-                <a16:creationId xmlns:a16="http://schemas.microsoft.com/office/drawing/2014/main" id="{9E249E2D-9CC8-4AFC-B4A7-81F7DEB33C42}"/>
+                <a16:creationId xmlns:a16="http://schemas.microsoft.com/office/drawing/2014/main" id="{E2E69FCC-8C70-4DB2-B0FD-0623AFD5E1D1}"/>
               </a:ext>
             </a:extLst>
           </p:cNvPr>
@@ -11150,7 +11150,7 @@
           <p:cNvPr id="23" name="">
             <a:extLst xmlns:a="http://schemas.openxmlformats.org/drawingml/2006/main">
               <a:ext uri="{FF2B5EF4-FFF2-40B4-BE49-F238E27FC236}">
-                <a16:creationId xmlns:a16="http://schemas.microsoft.com/office/drawing/2014/main" id="{86D9A585-F073-4FC2-8A30-2E91CD02FDCA}"/>
+                <a16:creationId xmlns:a16="http://schemas.microsoft.com/office/drawing/2014/main" id="{3247380F-6114-45CE-9722-DF89AC98E0BF}"/>
               </a:ext>
             </a:extLst>
           </p:cNvPr>
@@ -11200,7 +11200,7 @@
           <p:cNvPr id="24" name="">
             <a:extLst xmlns:a="http://schemas.openxmlformats.org/drawingml/2006/main">
               <a:ext uri="{FF2B5EF4-FFF2-40B4-BE49-F238E27FC236}">
-                <a16:creationId xmlns:a16="http://schemas.microsoft.com/office/drawing/2014/main" id="{72EE0998-8CDD-48F8-8776-2D419B0985C6}"/>
+                <a16:creationId xmlns:a16="http://schemas.microsoft.com/office/drawing/2014/main" id="{650DB0B5-647B-4987-BF60-23B31895DB42}"/>
               </a:ext>
             </a:extLst>
           </p:cNvPr>
@@ -11240,7 +11240,7 @@
                   <a:srgbClr val="121722"/>
                 </a:solidFill>
               </a:rPr>
-              <a:t>Partner API · CompletableFuture · ThreadPoolTaskExecutor</a:t>
+              <a:t>Partner API · Java Concurrency · WebFlux / WebClient</a:t>
             </a:r>
           </a:p>
         </p:txBody>
@@ -11250,7 +11250,7 @@
           <p:cNvPr id="25" name="">
             <a:extLst xmlns:a="http://schemas.openxmlformats.org/drawingml/2006/main">
               <a:ext uri="{FF2B5EF4-FFF2-40B4-BE49-F238E27FC236}">
-                <a16:creationId xmlns:a16="http://schemas.microsoft.com/office/drawing/2014/main" id="{8ED75FDF-034F-4392-9971-7B93EE85EB09}"/>
+                <a16:creationId xmlns:a16="http://schemas.microsoft.com/office/drawing/2014/main" id="{4E765136-D448-4410-BBC7-4E5A1FF111E5}"/>
               </a:ext>
             </a:extLst>
           </p:cNvPr>
@@ -11281,7 +11281,7 @@
           <p:cNvPr id="26" name="">
             <a:extLst xmlns:a="http://schemas.openxmlformats.org/drawingml/2006/main">
               <a:ext uri="{FF2B5EF4-FFF2-40B4-BE49-F238E27FC236}">
-                <a16:creationId xmlns:a16="http://schemas.microsoft.com/office/drawing/2014/main" id="{ACE1409D-A041-49AD-BD8D-37EDB08B6F03}"/>
+                <a16:creationId xmlns:a16="http://schemas.microsoft.com/office/drawing/2014/main" id="{0E196689-5854-478F-B9F9-8876A1CDD985}"/>
               </a:ext>
             </a:extLst>
           </p:cNvPr>
@@ -11314,7 +11314,7 @@
           <p:cNvPr id="27" name="">
             <a:extLst xmlns:a="http://schemas.openxmlformats.org/drawingml/2006/main">
               <a:ext uri="{FF2B5EF4-FFF2-40B4-BE49-F238E27FC236}">
-                <a16:creationId xmlns:a16="http://schemas.microsoft.com/office/drawing/2014/main" id="{B7DA30D6-30BC-4F7E-A011-925CC0C674CE}"/>
+                <a16:creationId xmlns:a16="http://schemas.microsoft.com/office/drawing/2014/main" id="{1AAD5F91-CD95-4B7D-A7F7-2843B48EF8C5}"/>
               </a:ext>
             </a:extLst>
           </p:cNvPr>
@@ -11364,7 +11364,7 @@
           <p:cNvPr id="28" name="">
             <a:extLst xmlns:a="http://schemas.openxmlformats.org/drawingml/2006/main">
               <a:ext uri="{FF2B5EF4-FFF2-40B4-BE49-F238E27FC236}">
-                <a16:creationId xmlns:a16="http://schemas.microsoft.com/office/drawing/2014/main" id="{8B125B36-6AF0-4A52-BF1B-4B5BBB2057F9}"/>
+                <a16:creationId xmlns:a16="http://schemas.microsoft.com/office/drawing/2014/main" id="{35D0D5DA-F67E-4B49-9B8B-DD74F7058422}"/>
               </a:ext>
             </a:extLst>
           </p:cNvPr>
@@ -11414,7 +11414,7 @@
           <p:cNvPr id="29" name="">
             <a:extLst xmlns:a="http://schemas.openxmlformats.org/drawingml/2006/main">
               <a:ext uri="{FF2B5EF4-FFF2-40B4-BE49-F238E27FC236}">
-                <a16:creationId xmlns:a16="http://schemas.microsoft.com/office/drawing/2014/main" id="{75465731-881F-4FF1-B4A6-118ACCAEA064}"/>
+                <a16:creationId xmlns:a16="http://schemas.microsoft.com/office/drawing/2014/main" id="{385F8E48-E93D-4B4F-B890-FFC1C83395CC}"/>
               </a:ext>
             </a:extLst>
           </p:cNvPr>
@@ -11464,7 +11464,7 @@
           <p:cNvPr id="30" name="">
             <a:extLst xmlns:a="http://schemas.openxmlformats.org/drawingml/2006/main">
               <a:ext uri="{FF2B5EF4-FFF2-40B4-BE49-F238E27FC236}">
-                <a16:creationId xmlns:a16="http://schemas.microsoft.com/office/drawing/2014/main" id="{871D08A6-BBCD-43D2-BA7A-502881BD6EB0}"/>
+                <a16:creationId xmlns:a16="http://schemas.microsoft.com/office/drawing/2014/main" id="{CD0B9905-F784-45EC-B4CA-B6B720FE25B2}"/>
               </a:ext>
             </a:extLst>
           </p:cNvPr>
@@ -11495,7 +11495,7 @@
           <p:cNvPr id="31" name="">
             <a:extLst xmlns:a="http://schemas.openxmlformats.org/drawingml/2006/main">
               <a:ext uri="{FF2B5EF4-FFF2-40B4-BE49-F238E27FC236}">
-                <a16:creationId xmlns:a16="http://schemas.microsoft.com/office/drawing/2014/main" id="{66F1656B-FB65-4BBC-AEBA-802E98B2A759}"/>
+                <a16:creationId xmlns:a16="http://schemas.microsoft.com/office/drawing/2014/main" id="{09803775-B05D-4395-A56F-4E28CE864808}"/>
               </a:ext>
             </a:extLst>
           </p:cNvPr>
@@ -11528,7 +11528,7 @@
           <p:cNvPr id="32" name="">
             <a:extLst xmlns:a="http://schemas.openxmlformats.org/drawingml/2006/main">
               <a:ext uri="{FF2B5EF4-FFF2-40B4-BE49-F238E27FC236}">
-                <a16:creationId xmlns:a16="http://schemas.microsoft.com/office/drawing/2014/main" id="{7F771740-16F6-47CE-91E3-015C7C075DA7}"/>
+                <a16:creationId xmlns:a16="http://schemas.microsoft.com/office/drawing/2014/main" id="{D17E8CA0-4C11-4806-896C-FD0E53B76A75}"/>
               </a:ext>
             </a:extLst>
           </p:cNvPr>
@@ -11578,7 +11578,7 @@
           <p:cNvPr id="33" name="">
             <a:extLst xmlns:a="http://schemas.openxmlformats.org/drawingml/2006/main">
               <a:ext uri="{FF2B5EF4-FFF2-40B4-BE49-F238E27FC236}">
-                <a16:creationId xmlns:a16="http://schemas.microsoft.com/office/drawing/2014/main" id="{AA1AF9E1-72A8-4500-942E-C239D87D5D95}"/>
+                <a16:creationId xmlns:a16="http://schemas.microsoft.com/office/drawing/2014/main" id="{928E5A03-69DB-450D-B461-FD8683B35874}"/>
               </a:ext>
             </a:extLst>
           </p:cNvPr>
@@ -11628,7 +11628,7 @@
           <p:cNvPr id="34" name="">
             <a:extLst xmlns:a="http://schemas.openxmlformats.org/drawingml/2006/main">
               <a:ext uri="{FF2B5EF4-FFF2-40B4-BE49-F238E27FC236}">
-                <a16:creationId xmlns:a16="http://schemas.microsoft.com/office/drawing/2014/main" id="{FFFC5C0B-1E24-4CC5-8907-900A8996CE3A}"/>
+                <a16:creationId xmlns:a16="http://schemas.microsoft.com/office/drawing/2014/main" id="{4097558B-E702-4116-B6D3-1192B443B5F3}"/>
               </a:ext>
             </a:extLst>
           </p:cNvPr>
@@ -11678,7 +11678,7 @@
           <p:cNvPr id="35" name="">
             <a:extLst xmlns:a="http://schemas.openxmlformats.org/drawingml/2006/main">
               <a:ext uri="{FF2B5EF4-FFF2-40B4-BE49-F238E27FC236}">
-                <a16:creationId xmlns:a16="http://schemas.microsoft.com/office/drawing/2014/main" id="{E8010655-7B53-4F48-9D3B-4D3BC9E8528B}"/>
+                <a16:creationId xmlns:a16="http://schemas.microsoft.com/office/drawing/2014/main" id="{12FA7BCB-FAF8-4EDE-AF71-A646B6017776}"/>
               </a:ext>
             </a:extLst>
           </p:cNvPr>
@@ -11709,7 +11709,7 @@
           <p:cNvPr id="36" name="">
             <a:extLst xmlns:a="http://schemas.openxmlformats.org/drawingml/2006/main">
               <a:ext uri="{FF2B5EF4-FFF2-40B4-BE49-F238E27FC236}">
-                <a16:creationId xmlns:a16="http://schemas.microsoft.com/office/drawing/2014/main" id="{65F169EF-8554-46E9-9013-69E7E6EC60C5}"/>
+                <a16:creationId xmlns:a16="http://schemas.microsoft.com/office/drawing/2014/main" id="{A94AEF4D-89BC-4715-8346-6ED0148D6AC5}"/>
               </a:ext>
             </a:extLst>
           </p:cNvPr>
@@ -11759,7 +11759,7 @@
           <p:cNvPr id="37" name="">
             <a:extLst xmlns:a="http://schemas.openxmlformats.org/drawingml/2006/main">
               <a:ext uri="{FF2B5EF4-FFF2-40B4-BE49-F238E27FC236}">
-                <a16:creationId xmlns:a16="http://schemas.microsoft.com/office/drawing/2014/main" id="{D1732F77-19F7-443C-B7FD-92E9E2189370}"/>
+                <a16:creationId xmlns:a16="http://schemas.microsoft.com/office/drawing/2014/main" id="{53ECD302-D126-49A0-B96D-59577E798EF3}"/>
               </a:ext>
             </a:extLst>
           </p:cNvPr>
@@ -11807,7 +11807,7 @@
     </p:spTree>
     <p:extLst>
       <p:ext uri="{BB962C8B-B14F-4D97-AF65-F5344CB8AC3E}">
-        <p14:creationId xmlns:p14="http://schemas.microsoft.com/office/powerpoint/2010/main" val="1944217884"/>
+        <p14:creationId xmlns:p14="http://schemas.microsoft.com/office/powerpoint/2010/main" val="3982284"/>
       </p:ext>
     </p:extLst>
   </p:cSld>
@@ -11838,7 +11838,7 @@
           <p:cNvPr id="36" name="">
             <a:extLst xmlns:a="http://schemas.openxmlformats.org/drawingml/2006/main">
               <a:ext uri="{FF2B5EF4-FFF2-40B4-BE49-F238E27FC236}">
-                <a16:creationId xmlns:a16="http://schemas.microsoft.com/office/drawing/2014/main" id="{0DEED29B-F4FF-4F9B-B8A8-F2F230621695}"/>
+                <a16:creationId xmlns:a16="http://schemas.microsoft.com/office/drawing/2014/main" id="{10EE3AC9-5728-4B51-B47A-DE1395771052}"/>
               </a:ext>
             </a:extLst>
           </p:cNvPr>
@@ -11888,7 +11888,7 @@
           <p:cNvPr id="2" name="">
             <a:extLst xmlns:a="http://schemas.openxmlformats.org/drawingml/2006/main">
               <a:ext uri="{FF2B5EF4-FFF2-40B4-BE49-F238E27FC236}">
-                <a16:creationId xmlns:a16="http://schemas.microsoft.com/office/drawing/2014/main" id="{CDB1EDBE-E20C-48F3-A4A4-96A675770FF0}"/>
+                <a16:creationId xmlns:a16="http://schemas.microsoft.com/office/drawing/2014/main" id="{40B2379B-5E1D-4B49-98A4-6826234F5AA2}"/>
               </a:ext>
             </a:extLst>
           </p:cNvPr>
@@ -11919,7 +11919,7 @@
           <p:cNvPr id="3" name="">
             <a:extLst xmlns:a="http://schemas.openxmlformats.org/drawingml/2006/main">
               <a:ext uri="{FF2B5EF4-FFF2-40B4-BE49-F238E27FC236}">
-                <a16:creationId xmlns:a16="http://schemas.microsoft.com/office/drawing/2014/main" id="{F543B1D6-3EA4-49A0-BC17-9576B497C91B}"/>
+                <a16:creationId xmlns:a16="http://schemas.microsoft.com/office/drawing/2014/main" id="{E5E67CB9-B284-47D2-A759-955ED55E3DAD}"/>
               </a:ext>
             </a:extLst>
           </p:cNvPr>
@@ -11969,7 +11969,7 @@
           <p:cNvPr id="4" name="">
             <a:extLst xmlns:a="http://schemas.openxmlformats.org/drawingml/2006/main">
               <a:ext uri="{FF2B5EF4-FFF2-40B4-BE49-F238E27FC236}">
-                <a16:creationId xmlns:a16="http://schemas.microsoft.com/office/drawing/2014/main" id="{0297288C-E4E9-45E2-8E4E-9FCB7DCACE61}"/>
+                <a16:creationId xmlns:a16="http://schemas.microsoft.com/office/drawing/2014/main" id="{766ABC46-CBF9-4711-A51B-37442DEC8E17}"/>
               </a:ext>
             </a:extLst>
           </p:cNvPr>
@@ -12019,7 +12019,7 @@
           <p:cNvPr id="5" name="">
             <a:extLst xmlns:a="http://schemas.openxmlformats.org/drawingml/2006/main">
               <a:ext uri="{FF2B5EF4-FFF2-40B4-BE49-F238E27FC236}">
-                <a16:creationId xmlns:a16="http://schemas.microsoft.com/office/drawing/2014/main" id="{D5E1B08A-C82A-4B3A-BF23-6753DFA5BB48}"/>
+                <a16:creationId xmlns:a16="http://schemas.microsoft.com/office/drawing/2014/main" id="{0BE13CCD-D698-434B-9CD1-C5CBE9320AF8}"/>
               </a:ext>
             </a:extLst>
           </p:cNvPr>
@@ -12069,7 +12069,7 @@
           <p:cNvPr id="6" name="">
             <a:extLst xmlns:a="http://schemas.openxmlformats.org/drawingml/2006/main">
               <a:ext uri="{FF2B5EF4-FFF2-40B4-BE49-F238E27FC236}">
-                <a16:creationId xmlns:a16="http://schemas.microsoft.com/office/drawing/2014/main" id="{28FF87F9-AB43-41E8-9917-C586DEA0687B}"/>
+                <a16:creationId xmlns:a16="http://schemas.microsoft.com/office/drawing/2014/main" id="{91502CED-0156-4ACA-A99C-7BBAAC89C482}"/>
               </a:ext>
             </a:extLst>
           </p:cNvPr>
@@ -12119,7 +12119,7 @@
           <p:cNvPr id="7" name="">
             <a:extLst xmlns:a="http://schemas.openxmlformats.org/drawingml/2006/main">
               <a:ext uri="{FF2B5EF4-FFF2-40B4-BE49-F238E27FC236}">
-                <a16:creationId xmlns:a16="http://schemas.microsoft.com/office/drawing/2014/main" id="{D755CF16-C34E-48D6-BF81-71CAA3F934BC}"/>
+                <a16:creationId xmlns:a16="http://schemas.microsoft.com/office/drawing/2014/main" id="{F95B465E-3C16-4E93-A4EF-A2070B689F90}"/>
               </a:ext>
             </a:extLst>
           </p:cNvPr>
@@ -12169,7 +12169,7 @@
           <p:cNvPr id="8" name="">
             <a:extLst xmlns:a="http://schemas.openxmlformats.org/drawingml/2006/main">
               <a:ext uri="{FF2B5EF4-FFF2-40B4-BE49-F238E27FC236}">
-                <a16:creationId xmlns:a16="http://schemas.microsoft.com/office/drawing/2014/main" id="{DE2FE6F2-7B7F-4D2F-BF07-74A7491ACDE2}"/>
+                <a16:creationId xmlns:a16="http://schemas.microsoft.com/office/drawing/2014/main" id="{F9D62911-D94B-4337-A2F6-23D29483AE92}"/>
               </a:ext>
             </a:extLst>
           </p:cNvPr>
@@ -12219,7 +12219,7 @@
           <p:cNvPr id="9" name="">
             <a:extLst xmlns:a="http://schemas.openxmlformats.org/drawingml/2006/main">
               <a:ext uri="{FF2B5EF4-FFF2-40B4-BE49-F238E27FC236}">
-                <a16:creationId xmlns:a16="http://schemas.microsoft.com/office/drawing/2014/main" id="{094AC782-AD05-4FCC-8A81-B70EF7F906B0}"/>
+                <a16:creationId xmlns:a16="http://schemas.microsoft.com/office/drawing/2014/main" id="{A34F61F6-E421-40B8-953D-5C5907C83F76}"/>
               </a:ext>
             </a:extLst>
           </p:cNvPr>
@@ -12269,7 +12269,7 @@
           <p:cNvPr id="10" name="">
             <a:extLst xmlns:a="http://schemas.openxmlformats.org/drawingml/2006/main">
               <a:ext uri="{FF2B5EF4-FFF2-40B4-BE49-F238E27FC236}">
-                <a16:creationId xmlns:a16="http://schemas.microsoft.com/office/drawing/2014/main" id="{A2C96935-9D28-4054-A125-8FC8E8FD76B4}"/>
+                <a16:creationId xmlns:a16="http://schemas.microsoft.com/office/drawing/2014/main" id="{7C4A4747-BE27-4B7A-A992-6B4898AF0BBA}"/>
               </a:ext>
             </a:extLst>
           </p:cNvPr>
@@ -12319,7 +12319,7 @@
           <p:cNvPr id="11" name="">
             <a:extLst xmlns:a="http://schemas.openxmlformats.org/drawingml/2006/main">
               <a:ext uri="{FF2B5EF4-FFF2-40B4-BE49-F238E27FC236}">
-                <a16:creationId xmlns:a16="http://schemas.microsoft.com/office/drawing/2014/main" id="{46CB7FA0-3017-4086-B140-A7E43568C138}"/>
+                <a16:creationId xmlns:a16="http://schemas.microsoft.com/office/drawing/2014/main" id="{89F80973-C0B7-4BEC-867E-89BABA59D7D9}"/>
               </a:ext>
             </a:extLst>
           </p:cNvPr>
@@ -12369,7 +12369,7 @@
           <p:cNvPr id="12" name="">
             <a:extLst xmlns:a="http://schemas.openxmlformats.org/drawingml/2006/main">
               <a:ext uri="{FF2B5EF4-FFF2-40B4-BE49-F238E27FC236}">
-                <a16:creationId xmlns:a16="http://schemas.microsoft.com/office/drawing/2014/main" id="{52A893CA-576D-4928-ABA5-1B8CB4A37F28}"/>
+                <a16:creationId xmlns:a16="http://schemas.microsoft.com/office/drawing/2014/main" id="{5B50D6C9-4E98-4467-BD71-D7D963920CAA}"/>
               </a:ext>
             </a:extLst>
           </p:cNvPr>
@@ -12400,7 +12400,7 @@
           <p:cNvPr id="13" name="">
             <a:extLst xmlns:a="http://schemas.openxmlformats.org/drawingml/2006/main">
               <a:ext uri="{FF2B5EF4-FFF2-40B4-BE49-F238E27FC236}">
-                <a16:creationId xmlns:a16="http://schemas.microsoft.com/office/drawing/2014/main" id="{07DB1AA5-3F44-4E3D-9E56-1FCA420CAB8B}"/>
+                <a16:creationId xmlns:a16="http://schemas.microsoft.com/office/drawing/2014/main" id="{A9680506-6505-4BAA-B097-4A7598CC1D8A}"/>
               </a:ext>
             </a:extLst>
           </p:cNvPr>
@@ -12431,7 +12431,7 @@
           <p:cNvPr id="14" name="">
             <a:extLst xmlns:a="http://schemas.openxmlformats.org/drawingml/2006/main">
               <a:ext uri="{FF2B5EF4-FFF2-40B4-BE49-F238E27FC236}">
-                <a16:creationId xmlns:a16="http://schemas.microsoft.com/office/drawing/2014/main" id="{94BCE872-AF12-4DA0-A3A6-9F7A58633B9E}"/>
+                <a16:creationId xmlns:a16="http://schemas.microsoft.com/office/drawing/2014/main" id="{08316B08-D368-49BB-867D-0C7FEC45EAA3}"/>
               </a:ext>
             </a:extLst>
           </p:cNvPr>
@@ -12481,7 +12481,7 @@
           <p:cNvPr id="15" name="">
             <a:extLst xmlns:a="http://schemas.openxmlformats.org/drawingml/2006/main">
               <a:ext uri="{FF2B5EF4-FFF2-40B4-BE49-F238E27FC236}">
-                <a16:creationId xmlns:a16="http://schemas.microsoft.com/office/drawing/2014/main" id="{A67158A3-1B68-44C8-8815-755C9C059128}"/>
+                <a16:creationId xmlns:a16="http://schemas.microsoft.com/office/drawing/2014/main" id="{F6E792FD-98F1-4C51-A823-CC1AC45D0957}"/>
               </a:ext>
             </a:extLst>
           </p:cNvPr>
@@ -12531,7 +12531,7 @@
           <p:cNvPr id="16" name="">
             <a:extLst xmlns:a="http://schemas.openxmlformats.org/drawingml/2006/main">
               <a:ext uri="{FF2B5EF4-FFF2-40B4-BE49-F238E27FC236}">
-                <a16:creationId xmlns:a16="http://schemas.microsoft.com/office/drawing/2014/main" id="{97E4028A-E6BF-426D-9863-52A4AB7AE29A}"/>
+                <a16:creationId xmlns:a16="http://schemas.microsoft.com/office/drawing/2014/main" id="{0D366ED1-8BAC-4758-A6C7-ED609912F0D0}"/>
               </a:ext>
             </a:extLst>
           </p:cNvPr>
@@ -12562,7 +12562,7 @@
           <p:cNvPr id="17" name="">
             <a:extLst xmlns:a="http://schemas.openxmlformats.org/drawingml/2006/main">
               <a:ext uri="{FF2B5EF4-FFF2-40B4-BE49-F238E27FC236}">
-                <a16:creationId xmlns:a16="http://schemas.microsoft.com/office/drawing/2014/main" id="{B8599C4F-B8AE-4351-9EFA-ECB4D57E20B2}"/>
+                <a16:creationId xmlns:a16="http://schemas.microsoft.com/office/drawing/2014/main" id="{79D95B6A-BB35-48A4-9F7B-E380F0475ACD}"/>
               </a:ext>
             </a:extLst>
           </p:cNvPr>
@@ -12612,7 +12612,7 @@
           <p:cNvPr id="18" name="">
             <a:extLst xmlns:a="http://schemas.openxmlformats.org/drawingml/2006/main">
               <a:ext uri="{FF2B5EF4-FFF2-40B4-BE49-F238E27FC236}">
-                <a16:creationId xmlns:a16="http://schemas.microsoft.com/office/drawing/2014/main" id="{D5CE463E-96E0-483D-8D65-1163169F6B7F}"/>
+                <a16:creationId xmlns:a16="http://schemas.microsoft.com/office/drawing/2014/main" id="{2B76112D-6734-41DE-A6E1-0962CB51519E}"/>
               </a:ext>
             </a:extLst>
           </p:cNvPr>
@@ -12662,7 +12662,7 @@
           <p:cNvPr id="19" name="">
             <a:extLst xmlns:a="http://schemas.openxmlformats.org/drawingml/2006/main">
               <a:ext uri="{FF2B5EF4-FFF2-40B4-BE49-F238E27FC236}">
-                <a16:creationId xmlns:a16="http://schemas.microsoft.com/office/drawing/2014/main" id="{0F2E7A22-DE31-4132-9C1D-2364E6AB08B8}"/>
+                <a16:creationId xmlns:a16="http://schemas.microsoft.com/office/drawing/2014/main" id="{542E573E-33ED-404A-8CA2-DF1BE8511C15}"/>
               </a:ext>
             </a:extLst>
           </p:cNvPr>
@@ -12693,7 +12693,7 @@
           <p:cNvPr id="20" name="">
             <a:extLst xmlns:a="http://schemas.openxmlformats.org/drawingml/2006/main">
               <a:ext uri="{FF2B5EF4-FFF2-40B4-BE49-F238E27FC236}">
-                <a16:creationId xmlns:a16="http://schemas.microsoft.com/office/drawing/2014/main" id="{891D3870-B05B-4436-9808-48E4BD748439}"/>
+                <a16:creationId xmlns:a16="http://schemas.microsoft.com/office/drawing/2014/main" id="{3BBA380D-27A5-4A4A-939C-D17968926BA2}"/>
               </a:ext>
             </a:extLst>
           </p:cNvPr>
@@ -12743,7 +12743,7 @@
           <p:cNvPr id="21" name="">
             <a:extLst xmlns:a="http://schemas.openxmlformats.org/drawingml/2006/main">
               <a:ext uri="{FF2B5EF4-FFF2-40B4-BE49-F238E27FC236}">
-                <a16:creationId xmlns:a16="http://schemas.microsoft.com/office/drawing/2014/main" id="{6BCC0856-3909-4A4D-BD48-0DBA53207330}"/>
+                <a16:creationId xmlns:a16="http://schemas.microsoft.com/office/drawing/2014/main" id="{969C4CF9-24C6-4AB2-9BA9-49126762E3C4}"/>
               </a:ext>
             </a:extLst>
           </p:cNvPr>
@@ -12793,7 +12793,7 @@
           <p:cNvPr id="22" name="">
             <a:extLst xmlns:a="http://schemas.openxmlformats.org/drawingml/2006/main">
               <a:ext uri="{FF2B5EF4-FFF2-40B4-BE49-F238E27FC236}">
-                <a16:creationId xmlns:a16="http://schemas.microsoft.com/office/drawing/2014/main" id="{8C559A8E-CC5D-4A4F-BBE6-B9F482B89765}"/>
+                <a16:creationId xmlns:a16="http://schemas.microsoft.com/office/drawing/2014/main" id="{F8E01557-D8A1-4482-83FA-E07647EC0B3E}"/>
               </a:ext>
             </a:extLst>
           </p:cNvPr>
@@ -12824,7 +12824,7 @@
           <p:cNvPr id="23" name="">
             <a:extLst xmlns:a="http://schemas.openxmlformats.org/drawingml/2006/main">
               <a:ext uri="{FF2B5EF4-FFF2-40B4-BE49-F238E27FC236}">
-                <a16:creationId xmlns:a16="http://schemas.microsoft.com/office/drawing/2014/main" id="{8E7FA87E-03A2-4BA3-B795-CA5241B88D7F}"/>
+                <a16:creationId xmlns:a16="http://schemas.microsoft.com/office/drawing/2014/main" id="{56600ECD-F3A1-46B2-8E36-89E2233DD607}"/>
               </a:ext>
             </a:extLst>
           </p:cNvPr>
@@ -12874,7 +12874,7 @@
           <p:cNvPr id="24" name="">
             <a:extLst xmlns:a="http://schemas.openxmlformats.org/drawingml/2006/main">
               <a:ext uri="{FF2B5EF4-FFF2-40B4-BE49-F238E27FC236}">
-                <a16:creationId xmlns:a16="http://schemas.microsoft.com/office/drawing/2014/main" id="{66A02B91-E1FD-4E15-87C0-3CFF106F8155}"/>
+                <a16:creationId xmlns:a16="http://schemas.microsoft.com/office/drawing/2014/main" id="{106554C5-78BF-45FF-A778-3D659AD66952}"/>
               </a:ext>
             </a:extLst>
           </p:cNvPr>
@@ -12924,7 +12924,7 @@
           <p:cNvPr id="25" name="">
             <a:extLst xmlns:a="http://schemas.openxmlformats.org/drawingml/2006/main">
               <a:ext uri="{FF2B5EF4-FFF2-40B4-BE49-F238E27FC236}">
-                <a16:creationId xmlns:a16="http://schemas.microsoft.com/office/drawing/2014/main" id="{394D0220-0B1E-40D8-964C-9555BDAD2D4C}"/>
+                <a16:creationId xmlns:a16="http://schemas.microsoft.com/office/drawing/2014/main" id="{B93EB006-D7F1-4FAF-BD9D-5184CC5625AF}"/>
               </a:ext>
             </a:extLst>
           </p:cNvPr>
@@ -12955,7 +12955,7 @@
           <p:cNvPr id="26" name="">
             <a:extLst xmlns:a="http://schemas.openxmlformats.org/drawingml/2006/main">
               <a:ext uri="{FF2B5EF4-FFF2-40B4-BE49-F238E27FC236}">
-                <a16:creationId xmlns:a16="http://schemas.microsoft.com/office/drawing/2014/main" id="{C66FB3B0-6D55-48CC-9562-769CA750EA25}"/>
+                <a16:creationId xmlns:a16="http://schemas.microsoft.com/office/drawing/2014/main" id="{6D543BE9-4D86-4382-9E0A-EAF9C4187210}"/>
               </a:ext>
             </a:extLst>
           </p:cNvPr>
@@ -13005,7 +13005,7 @@
           <p:cNvPr id="27" name="">
             <a:extLst xmlns:a="http://schemas.openxmlformats.org/drawingml/2006/main">
               <a:ext uri="{FF2B5EF4-FFF2-40B4-BE49-F238E27FC236}">
-                <a16:creationId xmlns:a16="http://schemas.microsoft.com/office/drawing/2014/main" id="{0E23FB88-E3BD-4234-BE97-100EB4E05442}"/>
+                <a16:creationId xmlns:a16="http://schemas.microsoft.com/office/drawing/2014/main" id="{BA132DA8-4D7B-4475-8707-ADABF7FCF52B}"/>
               </a:ext>
             </a:extLst>
           </p:cNvPr>
@@ -13045,7 +13045,7 @@
                   <a:srgbClr val="121722"/>
                 </a:solidFill>
               </a:rPr>
-              <a:t>SEARCH / API</a:t>
+              <a:t>PARALLEL API</a:t>
             </a:r>
           </a:p>
         </p:txBody>
@@ -13055,7 +13055,7 @@
           <p:cNvPr id="28" name="">
             <a:extLst xmlns:a="http://schemas.openxmlformats.org/drawingml/2006/main">
               <a:ext uri="{FF2B5EF4-FFF2-40B4-BE49-F238E27FC236}">
-                <a16:creationId xmlns:a16="http://schemas.microsoft.com/office/drawing/2014/main" id="{42B45EE1-363D-4178-AB1F-AEADFACF81FB}"/>
+                <a16:creationId xmlns:a16="http://schemas.microsoft.com/office/drawing/2014/main" id="{31EE9F33-DD00-4687-8ED9-481F4214192F}"/>
               </a:ext>
             </a:extLst>
           </p:cNvPr>
@@ -13086,7 +13086,7 @@
           <p:cNvPr id="29" name="">
             <a:extLst xmlns:a="http://schemas.openxmlformats.org/drawingml/2006/main">
               <a:ext uri="{FF2B5EF4-FFF2-40B4-BE49-F238E27FC236}">
-                <a16:creationId xmlns:a16="http://schemas.microsoft.com/office/drawing/2014/main" id="{027377D3-4078-4812-AB9E-72EF73D9B877}"/>
+                <a16:creationId xmlns:a16="http://schemas.microsoft.com/office/drawing/2014/main" id="{BE80D296-7D72-4980-AAE3-BA04590495AB}"/>
               </a:ext>
             </a:extLst>
           </p:cNvPr>
@@ -13136,7 +13136,7 @@
           <p:cNvPr id="30" name="">
             <a:extLst xmlns:a="http://schemas.openxmlformats.org/drawingml/2006/main">
               <a:ext uri="{FF2B5EF4-FFF2-40B4-BE49-F238E27FC236}">
-                <a16:creationId xmlns:a16="http://schemas.microsoft.com/office/drawing/2014/main" id="{A31C2005-7303-44F3-82B6-D5BA16EE5BC2}"/>
+                <a16:creationId xmlns:a16="http://schemas.microsoft.com/office/drawing/2014/main" id="{A8D158BF-B355-4854-BA15-AC5CD2F70CD3}"/>
               </a:ext>
             </a:extLst>
           </p:cNvPr>
@@ -13186,7 +13186,7 @@
           <p:cNvPr id="31" name="">
             <a:extLst xmlns:a="http://schemas.openxmlformats.org/drawingml/2006/main">
               <a:ext uri="{FF2B5EF4-FFF2-40B4-BE49-F238E27FC236}">
-                <a16:creationId xmlns:a16="http://schemas.microsoft.com/office/drawing/2014/main" id="{F110ED48-DA0F-4242-A501-20014C5299DC}"/>
+                <a16:creationId xmlns:a16="http://schemas.microsoft.com/office/drawing/2014/main" id="{21473254-9004-438E-9747-B5DD349A586E}"/>
               </a:ext>
             </a:extLst>
           </p:cNvPr>
@@ -13236,7 +13236,7 @@
           <p:cNvPr id="32" name="">
             <a:extLst xmlns:a="http://schemas.openxmlformats.org/drawingml/2006/main">
               <a:ext uri="{FF2B5EF4-FFF2-40B4-BE49-F238E27FC236}">
-                <a16:creationId xmlns:a16="http://schemas.microsoft.com/office/drawing/2014/main" id="{0918FDA5-24DD-4D6B-9B79-669BA41BFED0}"/>
+                <a16:creationId xmlns:a16="http://schemas.microsoft.com/office/drawing/2014/main" id="{8D0F6097-FD68-451A-92F6-95B77B550124}"/>
               </a:ext>
             </a:extLst>
           </p:cNvPr>
@@ -13286,7 +13286,7 @@
           <p:cNvPr id="33" name="">
             <a:extLst xmlns:a="http://schemas.openxmlformats.org/drawingml/2006/main">
               <a:ext uri="{FF2B5EF4-FFF2-40B4-BE49-F238E27FC236}">
-                <a16:creationId xmlns:a16="http://schemas.microsoft.com/office/drawing/2014/main" id="{5B9C9910-6D31-4FE9-BB93-AA62B37CAEBF}"/>
+                <a16:creationId xmlns:a16="http://schemas.microsoft.com/office/drawing/2014/main" id="{5EBFB8BA-BF77-42F3-8A13-4A3F8EEC3FAA}"/>
               </a:ext>
             </a:extLst>
           </p:cNvPr>
@@ -13317,7 +13317,7 @@
           <p:cNvPr id="34" name="">
             <a:extLst xmlns:a="http://schemas.openxmlformats.org/drawingml/2006/main">
               <a:ext uri="{FF2B5EF4-FFF2-40B4-BE49-F238E27FC236}">
-                <a16:creationId xmlns:a16="http://schemas.microsoft.com/office/drawing/2014/main" id="{40A892FB-6981-4EA8-83F7-893487903D26}"/>
+                <a16:creationId xmlns:a16="http://schemas.microsoft.com/office/drawing/2014/main" id="{13E02B1B-A074-4907-9DE6-AA34E82D003B}"/>
               </a:ext>
             </a:extLst>
           </p:cNvPr>
@@ -13367,7 +13367,7 @@
           <p:cNvPr id="35" name="">
             <a:extLst xmlns:a="http://schemas.openxmlformats.org/drawingml/2006/main">
               <a:ext uri="{FF2B5EF4-FFF2-40B4-BE49-F238E27FC236}">
-                <a16:creationId xmlns:a16="http://schemas.microsoft.com/office/drawing/2014/main" id="{4FF43B3F-122B-47ED-8C5D-5CE9B44D7A12}"/>
+                <a16:creationId xmlns:a16="http://schemas.microsoft.com/office/drawing/2014/main" id="{F89C8353-F169-4608-9806-D950B1B14CDE}"/>
               </a:ext>
             </a:extLst>
           </p:cNvPr>
@@ -13415,7 +13415,7 @@
     </p:spTree>
     <p:extLst>
       <p:ext uri="{BB962C8B-B14F-4D97-AF65-F5344CB8AC3E}">
-        <p14:creationId xmlns:p14="http://schemas.microsoft.com/office/powerpoint/2010/main" val="871625716"/>
+        <p14:creationId xmlns:p14="http://schemas.microsoft.com/office/powerpoint/2010/main" val="1746262204"/>
       </p:ext>
     </p:extLst>
   </p:cSld>
@@ -13443,10 +13443,10 @@
       </p:grpSpPr>
       <p:sp>
         <p:nvSpPr>
-          <p:cNvPr id="32" name="">
-            <a:extLst xmlns:a="http://schemas.openxmlformats.org/drawingml/2006/main">
-              <a:ext uri="{FF2B5EF4-FFF2-40B4-BE49-F238E27FC236}">
-                <a16:creationId xmlns:a16="http://schemas.microsoft.com/office/drawing/2014/main" id="{7918D4D0-9215-4552-8780-C77E514FBF87}"/>
+          <p:cNvPr id="33" name="">
+            <a:extLst xmlns:a="http://schemas.openxmlformats.org/drawingml/2006/main">
+              <a:ext uri="{FF2B5EF4-FFF2-40B4-BE49-F238E27FC236}">
+                <a16:creationId xmlns:a16="http://schemas.microsoft.com/office/drawing/2014/main" id="{E8337CA4-BFBB-49B3-9094-826A6ABA201D}"/>
               </a:ext>
             </a:extLst>
           </p:cNvPr>
@@ -13496,7 +13496,7 @@
           <p:cNvPr id="2" name="">
             <a:extLst xmlns:a="http://schemas.openxmlformats.org/drawingml/2006/main">
               <a:ext uri="{FF2B5EF4-FFF2-40B4-BE49-F238E27FC236}">
-                <a16:creationId xmlns:a16="http://schemas.microsoft.com/office/drawing/2014/main" id="{6AA00C72-BD66-4D77-A103-5602A2A4EAC5}"/>
+                <a16:creationId xmlns:a16="http://schemas.microsoft.com/office/drawing/2014/main" id="{6613E1EC-A3F0-4E3F-ADBF-51562D26D13F}"/>
               </a:ext>
             </a:extLst>
           </p:cNvPr>
@@ -13527,7 +13527,7 @@
           <p:cNvPr id="3" name="">
             <a:extLst xmlns:a="http://schemas.openxmlformats.org/drawingml/2006/main">
               <a:ext uri="{FF2B5EF4-FFF2-40B4-BE49-F238E27FC236}">
-                <a16:creationId xmlns:a16="http://schemas.microsoft.com/office/drawing/2014/main" id="{E8DBDB96-80CA-41CF-A4BF-A1BA487AD492}"/>
+                <a16:creationId xmlns:a16="http://schemas.microsoft.com/office/drawing/2014/main" id="{070F8D77-2BF3-4C4A-ABF5-6730D021BFC3}"/>
               </a:ext>
             </a:extLst>
           </p:cNvPr>
@@ -13577,7 +13577,7 @@
           <p:cNvPr id="4" name="">
             <a:extLst xmlns:a="http://schemas.openxmlformats.org/drawingml/2006/main">
               <a:ext uri="{FF2B5EF4-FFF2-40B4-BE49-F238E27FC236}">
-                <a16:creationId xmlns:a16="http://schemas.microsoft.com/office/drawing/2014/main" id="{C054C3A3-DE0B-48C0-AC8A-F4AB66761F43}"/>
+                <a16:creationId xmlns:a16="http://schemas.microsoft.com/office/drawing/2014/main" id="{C2F54C9E-850E-40FE-ADCC-B5A51F896632}"/>
               </a:ext>
             </a:extLst>
           </p:cNvPr>
@@ -13617,7 +13617,7 @@
                   <a:srgbClr val="121722"/>
                 </a:solidFill>
               </a:rPr>
-              <a:t>병렬 검증 구조가 적용된 검색 서비스 개발·운영</a:t>
+              <a:t>복수 제휴사 병렬 검색의 안정성 개선</a:t>
             </a:r>
           </a:p>
         </p:txBody>
@@ -13627,7 +13627,7 @@
           <p:cNvPr id="5" name="">
             <a:extLst xmlns:a="http://schemas.openxmlformats.org/drawingml/2006/main">
               <a:ext uri="{FF2B5EF4-FFF2-40B4-BE49-F238E27FC236}">
-                <a16:creationId xmlns:a16="http://schemas.microsoft.com/office/drawing/2014/main" id="{BCD5E312-5FB8-4242-B4A8-9C64BB386A9A}"/>
+                <a16:creationId xmlns:a16="http://schemas.microsoft.com/office/drawing/2014/main" id="{EF43F39E-66CF-4201-89B4-DFC46F24FFC9}"/>
               </a:ext>
             </a:extLst>
           </p:cNvPr>
@@ -13667,7 +13667,7 @@
                   <a:srgbClr val="5B6472"/>
                 </a:solidFill>
               </a:rPr>
-              <a:t>복수 제휴사 API 병렬 검증 구조의 기능 개발·운영 및 전체 흐름 분석</a:t>
+              <a:t>적용된 Thread·WebFlux 경로를 분석하고, 순서 안정화와 부분 실패 격리를 개선</a:t>
             </a:r>
           </a:p>
         </p:txBody>
@@ -13677,7 +13677,7 @@
           <p:cNvPr id="6" name="">
             <a:extLst xmlns:a="http://schemas.openxmlformats.org/drawingml/2006/main">
               <a:ext uri="{FF2B5EF4-FFF2-40B4-BE49-F238E27FC236}">
-                <a16:creationId xmlns:a16="http://schemas.microsoft.com/office/drawing/2014/main" id="{AAF5C642-3458-44B7-A77A-585D46FCD238}"/>
+                <a16:creationId xmlns:a16="http://schemas.microsoft.com/office/drawing/2014/main" id="{8ED1C84B-BC6C-4026-81E2-DB76E7558E2C}"/>
               </a:ext>
             </a:extLst>
           </p:cNvPr>
@@ -13708,7 +13708,7 @@
           <p:cNvPr id="7" name="">
             <a:extLst xmlns:a="http://schemas.openxmlformats.org/drawingml/2006/main">
               <a:ext uri="{FF2B5EF4-FFF2-40B4-BE49-F238E27FC236}">
-                <a16:creationId xmlns:a16="http://schemas.microsoft.com/office/drawing/2014/main" id="{84CCEE00-B686-4AE8-B92A-F7544ABF53A0}"/>
+                <a16:creationId xmlns:a16="http://schemas.microsoft.com/office/drawing/2014/main" id="{32F69178-ECC6-4BE6-9638-877A365D263C}"/>
               </a:ext>
             </a:extLst>
           </p:cNvPr>
@@ -13758,7 +13758,7 @@
           <p:cNvPr id="8" name="">
             <a:extLst xmlns:a="http://schemas.openxmlformats.org/drawingml/2006/main">
               <a:ext uri="{FF2B5EF4-FFF2-40B4-BE49-F238E27FC236}">
-                <a16:creationId xmlns:a16="http://schemas.microsoft.com/office/drawing/2014/main" id="{86DF915C-25D2-4D7C-9385-4F3C36E05165}"/>
+                <a16:creationId xmlns:a16="http://schemas.microsoft.com/office/drawing/2014/main" id="{989A76CE-402B-451E-9497-3989556F49B0}"/>
               </a:ext>
             </a:extLst>
           </p:cNvPr>
@@ -13798,7 +13798,7 @@
                   <a:srgbClr val="FFFFFF"/>
                 </a:solidFill>
               </a:rPr>
-              <a:t>복수 제휴사 API</a:t>
+              <a:t>병렬 검색</a:t>
             </a:r>
           </a:p>
         </p:txBody>
@@ -13808,7 +13808,7 @@
           <p:cNvPr id="9" name="">
             <a:extLst xmlns:a="http://schemas.openxmlformats.org/drawingml/2006/main">
               <a:ext uri="{FF2B5EF4-FFF2-40B4-BE49-F238E27FC236}">
-                <a16:creationId xmlns:a16="http://schemas.microsoft.com/office/drawing/2014/main" id="{A5E486A8-F845-4330-9C3B-3352146B5114}"/>
+                <a16:creationId xmlns:a16="http://schemas.microsoft.com/office/drawing/2014/main" id="{E6BBD84F-F708-4591-9FFA-80DE14886F89}"/>
               </a:ext>
             </a:extLst>
           </p:cNvPr>
@@ -13848,7 +13848,7 @@
                   <a:srgbClr val="B8C0CE"/>
                 </a:solidFill>
               </a:rPr>
-              <a:t>병렬 검증 구조가 적용된</a:t>
+              <a:t>Thread / WebFlux 경로가</a:t>
             </a:r>
           </a:p>
           <a:p xmlns:a="http://schemas.openxmlformats.org/drawingml/2006/main">
@@ -13865,7 +13865,7 @@
                   <a:srgbClr val="B8C0CE"/>
                 </a:solidFill>
               </a:rPr>
-              <a:t>운영 서비스</a:t>
+              <a:t>공존하는 운영 서비스</a:t>
             </a:r>
           </a:p>
         </p:txBody>
@@ -13875,42 +13875,42 @@
           <p:cNvPr id="10" name="">
             <a:extLst xmlns:a="http://schemas.openxmlformats.org/drawingml/2006/main">
               <a:ext uri="{FF2B5EF4-FFF2-40B4-BE49-F238E27FC236}">
-                <a16:creationId xmlns:a16="http://schemas.microsoft.com/office/drawing/2014/main" id="{93C6A9F5-3BF5-43DE-8F1A-109F462178C4}"/>
-              </a:ext>
-            </a:extLst>
-          </p:cNvPr>
-          <p:cNvSpPr>
-            <a:spLocks xmlns:a="http://schemas.openxmlformats.org/drawingml/2006/main" noGrp="1"/>
-          </p:cNvSpPr>
-          <p:nvPr/>
-        </p:nvSpPr>
-        <p:spPr>
-          <a:xfrm xmlns:a="http://schemas.openxmlformats.org/drawingml/2006/main">
-            <a:off x="952500" y="4362450"/>
-            <a:ext cx="2381250" cy="247650"/>
-          </a:xfrm>
-          <a:prstGeom xmlns:a="http://schemas.openxmlformats.org/drawingml/2006/main" prst="rect">
-            <a:avLst/>
-          </a:prstGeom>
-          <a:noFill xmlns:a="http://schemas.openxmlformats.org/drawingml/2006/main"/>
-          <a:ln xmlns:a="http://schemas.openxmlformats.org/drawingml/2006/main" w="0">
-            <a:noFill/>
-            <a:prstDash val="solid"/>
-          </a:ln>
-        </p:spPr>
-        <p:txBody>
-          <a:bodyPr xmlns:a="http://schemas.openxmlformats.org/drawingml/2006/main" anchor="t"/>
-          <a:lstStyle xmlns:a="http://schemas.openxmlformats.org/drawingml/2006/main"/>
-          <a:p xmlns:a="http://schemas.openxmlformats.org/drawingml/2006/main">
-            <a:pPr algn="l">
-              <a:defRPr sz="1200" b="1" i="0">
+                <a16:creationId xmlns:a16="http://schemas.microsoft.com/office/drawing/2014/main" id="{1D114F06-681D-47A0-A35C-A63A3945AF24}"/>
+              </a:ext>
+            </a:extLst>
+          </p:cNvPr>
+          <p:cNvSpPr>
+            <a:spLocks xmlns:a="http://schemas.openxmlformats.org/drawingml/2006/main" noGrp="1"/>
+          </p:cNvSpPr>
+          <p:nvPr/>
+        </p:nvSpPr>
+        <p:spPr>
+          <a:xfrm xmlns:a="http://schemas.openxmlformats.org/drawingml/2006/main">
+            <a:off x="952500" y="4229100"/>
+            <a:ext cx="2381250" cy="228600"/>
+          </a:xfrm>
+          <a:prstGeom xmlns:a="http://schemas.openxmlformats.org/drawingml/2006/main" prst="rect">
+            <a:avLst/>
+          </a:prstGeom>
+          <a:noFill xmlns:a="http://schemas.openxmlformats.org/drawingml/2006/main"/>
+          <a:ln xmlns:a="http://schemas.openxmlformats.org/drawingml/2006/main" w="0">
+            <a:noFill/>
+            <a:prstDash val="solid"/>
+          </a:ln>
+        </p:spPr>
+        <p:txBody>
+          <a:bodyPr xmlns:a="http://schemas.openxmlformats.org/drawingml/2006/main" anchor="t"/>
+          <a:lstStyle xmlns:a="http://schemas.openxmlformats.org/drawingml/2006/main"/>
+          <a:p xmlns:a="http://schemas.openxmlformats.org/drawingml/2006/main">
+            <a:pPr algn="l">
+              <a:defRPr sz="1125" b="1" i="0">
                 <a:solidFill>
                   <a:srgbClr val="85A0FF"/>
                 </a:solidFill>
               </a:defRPr>
             </a:pPr>
             <a:r>
-              <a:rPr sz="1200" b="1" i="0">
+              <a:rPr sz="1125" b="1" i="0">
                 <a:solidFill>
                   <a:srgbClr val="85A0FF"/>
                 </a:solidFill>
@@ -13925,42 +13925,42 @@
           <p:cNvPr id="11" name="">
             <a:extLst xmlns:a="http://schemas.openxmlformats.org/drawingml/2006/main">
               <a:ext uri="{FF2B5EF4-FFF2-40B4-BE49-F238E27FC236}">
-                <a16:creationId xmlns:a16="http://schemas.microsoft.com/office/drawing/2014/main" id="{E52A8CC8-74F7-4C4A-9CE5-401695BEA97E}"/>
-              </a:ext>
-            </a:extLst>
-          </p:cNvPr>
-          <p:cNvSpPr>
-            <a:spLocks xmlns:a="http://schemas.openxmlformats.org/drawingml/2006/main" noGrp="1"/>
-          </p:cNvSpPr>
-          <p:nvPr/>
-        </p:nvSpPr>
-        <p:spPr>
-          <a:xfrm xmlns:a="http://schemas.openxmlformats.org/drawingml/2006/main">
-            <a:off x="952500" y="4705350"/>
-            <a:ext cx="2381250" cy="247650"/>
-          </a:xfrm>
-          <a:prstGeom xmlns:a="http://schemas.openxmlformats.org/drawingml/2006/main" prst="rect">
-            <a:avLst/>
-          </a:prstGeom>
-          <a:noFill xmlns:a="http://schemas.openxmlformats.org/drawingml/2006/main"/>
-          <a:ln xmlns:a="http://schemas.openxmlformats.org/drawingml/2006/main" w="0">
-            <a:noFill/>
-            <a:prstDash val="solid"/>
-          </a:ln>
-        </p:spPr>
-        <p:txBody>
-          <a:bodyPr xmlns:a="http://schemas.openxmlformats.org/drawingml/2006/main" anchor="t"/>
-          <a:lstStyle xmlns:a="http://schemas.openxmlformats.org/drawingml/2006/main"/>
-          <a:p xmlns:a="http://schemas.openxmlformats.org/drawingml/2006/main">
-            <a:pPr algn="l">
-              <a:defRPr sz="1200" b="1" i="0">
+                <a16:creationId xmlns:a16="http://schemas.microsoft.com/office/drawing/2014/main" id="{1FABCE22-855C-4070-A4B9-A056D71AC2BF}"/>
+              </a:ext>
+            </a:extLst>
+          </p:cNvPr>
+          <p:cNvSpPr>
+            <a:spLocks xmlns:a="http://schemas.openxmlformats.org/drawingml/2006/main" noGrp="1"/>
+          </p:cNvSpPr>
+          <p:nvPr/>
+        </p:nvSpPr>
+        <p:spPr>
+          <a:xfrm xmlns:a="http://schemas.openxmlformats.org/drawingml/2006/main">
+            <a:off x="952500" y="4533900"/>
+            <a:ext cx="2381250" cy="228600"/>
+          </a:xfrm>
+          <a:prstGeom xmlns:a="http://schemas.openxmlformats.org/drawingml/2006/main" prst="rect">
+            <a:avLst/>
+          </a:prstGeom>
+          <a:noFill xmlns:a="http://schemas.openxmlformats.org/drawingml/2006/main"/>
+          <a:ln xmlns:a="http://schemas.openxmlformats.org/drawingml/2006/main" w="0">
+            <a:noFill/>
+            <a:prstDash val="solid"/>
+          </a:ln>
+        </p:spPr>
+        <p:txBody>
+          <a:bodyPr xmlns:a="http://schemas.openxmlformats.org/drawingml/2006/main" anchor="t"/>
+          <a:lstStyle xmlns:a="http://schemas.openxmlformats.org/drawingml/2006/main"/>
+          <a:p xmlns:a="http://schemas.openxmlformats.org/drawingml/2006/main">
+            <a:pPr algn="l">
+              <a:defRPr sz="1125" b="1" i="0">
                 <a:solidFill>
                   <a:srgbClr val="85A0FF"/>
                 </a:solidFill>
               </a:defRPr>
             </a:pPr>
             <a:r>
-              <a:rPr sz="1200" b="1" i="0">
+              <a:rPr sz="1125" b="1" i="0">
                 <a:solidFill>
                   <a:srgbClr val="85A0FF"/>
                 </a:solidFill>
@@ -13975,7 +13975,57 @@
           <p:cNvPr id="12" name="">
             <a:extLst xmlns:a="http://schemas.openxmlformats.org/drawingml/2006/main">
               <a:ext uri="{FF2B5EF4-FFF2-40B4-BE49-F238E27FC236}">
-                <a16:creationId xmlns:a16="http://schemas.microsoft.com/office/drawing/2014/main" id="{494DDA92-E4E1-4ABF-9776-B4939294415D}"/>
+                <a16:creationId xmlns:a16="http://schemas.microsoft.com/office/drawing/2014/main" id="{41F09B7F-A765-4C22-B1CE-BA1D745EC4A1}"/>
+              </a:ext>
+            </a:extLst>
+          </p:cNvPr>
+          <p:cNvSpPr>
+            <a:spLocks xmlns:a="http://schemas.openxmlformats.org/drawingml/2006/main" noGrp="1"/>
+          </p:cNvSpPr>
+          <p:nvPr/>
+        </p:nvSpPr>
+        <p:spPr>
+          <a:xfrm xmlns:a="http://schemas.openxmlformats.org/drawingml/2006/main">
+            <a:off x="952500" y="4838700"/>
+            <a:ext cx="2381250" cy="228600"/>
+          </a:xfrm>
+          <a:prstGeom xmlns:a="http://schemas.openxmlformats.org/drawingml/2006/main" prst="rect">
+            <a:avLst/>
+          </a:prstGeom>
+          <a:noFill xmlns:a="http://schemas.openxmlformats.org/drawingml/2006/main"/>
+          <a:ln xmlns:a="http://schemas.openxmlformats.org/drawingml/2006/main" w="0">
+            <a:noFill/>
+            <a:prstDash val="solid"/>
+          </a:ln>
+        </p:spPr>
+        <p:txBody>
+          <a:bodyPr xmlns:a="http://schemas.openxmlformats.org/drawingml/2006/main" anchor="t"/>
+          <a:lstStyle xmlns:a="http://schemas.openxmlformats.org/drawingml/2006/main"/>
+          <a:p xmlns:a="http://schemas.openxmlformats.org/drawingml/2006/main">
+            <a:pPr algn="l">
+              <a:defRPr sz="1125" b="1" i="0">
+                <a:solidFill>
+                  <a:srgbClr val="54D3AD"/>
+                </a:solidFill>
+              </a:defRPr>
+            </a:pPr>
+            <a:r>
+              <a:rPr sz="1125" b="1" i="0">
+                <a:solidFill>
+                  <a:srgbClr val="54D3AD"/>
+                </a:solidFill>
+              </a:rPr>
+              <a:t>WebFlux · WebClient</a:t>
+            </a:r>
+          </a:p>
+        </p:txBody>
+      </p:sp>
+      <p:sp>
+        <p:nvSpPr>
+          <p:cNvPr id="13" name="">
+            <a:extLst xmlns:a="http://schemas.openxmlformats.org/drawingml/2006/main">
+              <a:ext uri="{FF2B5EF4-FFF2-40B4-BE49-F238E27FC236}">
+                <a16:creationId xmlns:a16="http://schemas.microsoft.com/office/drawing/2014/main" id="{7DCEBABF-138F-4FCF-95B8-DFE86316FD9D}"/>
               </a:ext>
             </a:extLst>
           </p:cNvPr>
@@ -14022,10 +14072,10 @@
       </p:sp>
       <p:sp>
         <p:nvSpPr>
-          <p:cNvPr id="13" name="">
-            <a:extLst xmlns:a="http://schemas.openxmlformats.org/drawingml/2006/main">
-              <a:ext uri="{FF2B5EF4-FFF2-40B4-BE49-F238E27FC236}">
-                <a16:creationId xmlns:a16="http://schemas.microsoft.com/office/drawing/2014/main" id="{3B88491F-2529-4C3A-9F30-6598D4B54DFD}"/>
+          <p:cNvPr id="14" name="">
+            <a:extLst xmlns:a="http://schemas.openxmlformats.org/drawingml/2006/main">
+              <a:ext uri="{FF2B5EF4-FFF2-40B4-BE49-F238E27FC236}">
+                <a16:creationId xmlns:a16="http://schemas.microsoft.com/office/drawing/2014/main" id="{21B83976-C113-4953-8492-A4B606B133F9}"/>
               </a:ext>
             </a:extLst>
           </p:cNvPr>
@@ -14065,17 +14115,17 @@
                   <a:srgbClr val="121722"/>
                 </a:solidFill>
               </a:rPr>
-              <a:t>호출 분리</a:t>
-            </a:r>
-          </a:p>
-        </p:txBody>
-      </p:sp>
-      <p:sp>
-        <p:nvSpPr>
-          <p:cNvPr id="14" name="">
-            <a:extLst xmlns:a="http://schemas.openxmlformats.org/drawingml/2006/main">
-              <a:ext uri="{FF2B5EF4-FFF2-40B4-BE49-F238E27FC236}">
-                <a16:creationId xmlns:a16="http://schemas.microsoft.com/office/drawing/2014/main" id="{BE5561DC-02FB-4032-A57C-633E2ABC11A6}"/>
+              <a:t>병렬 호출</a:t>
+            </a:r>
+          </a:p>
+        </p:txBody>
+      </p:sp>
+      <p:sp>
+        <p:nvSpPr>
+          <p:cNvPr id="15" name="">
+            <a:extLst xmlns:a="http://schemas.openxmlformats.org/drawingml/2006/main">
+              <a:ext uri="{FF2B5EF4-FFF2-40B4-BE49-F238E27FC236}">
+                <a16:creationId xmlns:a16="http://schemas.microsoft.com/office/drawing/2014/main" id="{0CC5B007-9EFC-4981-A914-48401D0A15D4}"/>
               </a:ext>
             </a:extLst>
           </p:cNvPr>
@@ -14115,17 +14165,17 @@
                   <a:srgbClr val="5B6472"/>
                 </a:solidFill>
               </a:rPr>
-              <a:t>제휴사별 요청과 timeout·예외 경계 분리</a:t>
-            </a:r>
-          </a:p>
-        </p:txBody>
-      </p:sp>
-      <p:sp>
-        <p:nvSpPr>
-          <p:cNvPr id="15" name="">
-            <a:extLst xmlns:a="http://schemas.openxmlformats.org/drawingml/2006/main">
-              <a:ext uri="{FF2B5EF4-FFF2-40B4-BE49-F238E27FC236}">
-                <a16:creationId xmlns:a16="http://schemas.microsoft.com/office/drawing/2014/main" id="{73A9132B-90C3-481B-8A87-6CCD26E81134}"/>
+              <a:t>검색 후보를 제휴사별 API로 동시에 검증</a:t>
+            </a:r>
+          </a:p>
+        </p:txBody>
+      </p:sp>
+      <p:sp>
+        <p:nvSpPr>
+          <p:cNvPr id="16" name="">
+            <a:extLst xmlns:a="http://schemas.openxmlformats.org/drawingml/2006/main">
+              <a:ext uri="{FF2B5EF4-FFF2-40B4-BE49-F238E27FC236}">
+                <a16:creationId xmlns:a16="http://schemas.microsoft.com/office/drawing/2014/main" id="{2DF114A4-457B-44D3-8752-F03BDBCC4AD9}"/>
               </a:ext>
             </a:extLst>
           </p:cNvPr>
@@ -14153,10 +14203,10 @@
       </p:sp>
       <p:sp>
         <p:nvSpPr>
-          <p:cNvPr id="16" name="">
-            <a:extLst xmlns:a="http://schemas.openxmlformats.org/drawingml/2006/main">
-              <a:ext uri="{FF2B5EF4-FFF2-40B4-BE49-F238E27FC236}">
-                <a16:creationId xmlns:a16="http://schemas.microsoft.com/office/drawing/2014/main" id="{895806CA-C4F7-4146-BA08-60131FE5BDAE}"/>
+          <p:cNvPr id="17" name="">
+            <a:extLst xmlns:a="http://schemas.openxmlformats.org/drawingml/2006/main">
+              <a:ext uri="{FF2B5EF4-FFF2-40B4-BE49-F238E27FC236}">
+                <a16:creationId xmlns:a16="http://schemas.microsoft.com/office/drawing/2014/main" id="{B10647A7-090D-4BC3-A0B7-AF32C039C047}"/>
               </a:ext>
             </a:extLst>
           </p:cNvPr>
@@ -14203,10 +14253,10 @@
       </p:sp>
       <p:sp>
         <p:nvSpPr>
-          <p:cNvPr id="17" name="">
-            <a:extLst xmlns:a="http://schemas.openxmlformats.org/drawingml/2006/main">
-              <a:ext uri="{FF2B5EF4-FFF2-40B4-BE49-F238E27FC236}">
-                <a16:creationId xmlns:a16="http://schemas.microsoft.com/office/drawing/2014/main" id="{B87421C3-13BD-4331-B05C-28D07BF99FF0}"/>
+          <p:cNvPr id="18" name="">
+            <a:extLst xmlns:a="http://schemas.openxmlformats.org/drawingml/2006/main">
+              <a:ext uri="{FF2B5EF4-FFF2-40B4-BE49-F238E27FC236}">
+                <a16:creationId xmlns:a16="http://schemas.microsoft.com/office/drawing/2014/main" id="{6930BA38-55A4-480D-8BD6-E3ABA6E83D3A}"/>
               </a:ext>
             </a:extLst>
           </p:cNvPr>
@@ -14246,17 +14296,17 @@
                   <a:srgbClr val="121722"/>
                 </a:solidFill>
               </a:rPr>
-              <a:t>결과 취합</a:t>
-            </a:r>
-          </a:p>
-        </p:txBody>
-      </p:sp>
-      <p:sp>
-        <p:nvSpPr>
-          <p:cNvPr id="18" name="">
-            <a:extLst xmlns:a="http://schemas.openxmlformats.org/drawingml/2006/main">
-              <a:ext uri="{FF2B5EF4-FFF2-40B4-BE49-F238E27FC236}">
-                <a16:creationId xmlns:a16="http://schemas.microsoft.com/office/drawing/2014/main" id="{DCC02F75-3DCF-4FC6-B986-E3A0B2242B40}"/>
+              <a:t>순서 안정화</a:t>
+            </a:r>
+          </a:p>
+        </p:txBody>
+      </p:sp>
+      <p:sp>
+        <p:nvSpPr>
+          <p:cNvPr id="19" name="">
+            <a:extLst xmlns:a="http://schemas.openxmlformats.org/drawingml/2006/main">
+              <a:ext uri="{FF2B5EF4-FFF2-40B4-BE49-F238E27FC236}">
+                <a16:creationId xmlns:a16="http://schemas.microsoft.com/office/drawing/2014/main" id="{8480C028-E9E8-483A-A8CC-DF76B90FE02F}"/>
               </a:ext>
             </a:extLst>
           </p:cNvPr>
@@ -14296,17 +14346,17 @@
                   <a:srgbClr val="5B6472"/>
                 </a:solidFill>
               </a:rPr>
-              <a:t>응답과 오류를 공통 검증 결과로 정리</a:t>
-            </a:r>
-          </a:p>
-        </p:txBody>
-      </p:sp>
-      <p:sp>
-        <p:nvSpPr>
-          <p:cNvPr id="19" name="">
-            <a:extLst xmlns:a="http://schemas.openxmlformats.org/drawingml/2006/main">
-              <a:ext uri="{FF2B5EF4-FFF2-40B4-BE49-F238E27FC236}">
-                <a16:creationId xmlns:a16="http://schemas.microsoft.com/office/drawing/2014/main" id="{C746726B-022D-4AA4-99B5-EC5677D547E0}"/>
+              <a:t>비동기 작업·결과 집계 순서 안정화 참여</a:t>
+            </a:r>
+          </a:p>
+        </p:txBody>
+      </p:sp>
+      <p:sp>
+        <p:nvSpPr>
+          <p:cNvPr id="20" name="">
+            <a:extLst xmlns:a="http://schemas.openxmlformats.org/drawingml/2006/main">
+              <a:ext uri="{FF2B5EF4-FFF2-40B4-BE49-F238E27FC236}">
+                <a16:creationId xmlns:a16="http://schemas.microsoft.com/office/drawing/2014/main" id="{7450B975-BEDB-4021-8598-9D98EC868246}"/>
               </a:ext>
             </a:extLst>
           </p:cNvPr>
@@ -14334,10 +14384,10 @@
       </p:sp>
       <p:sp>
         <p:nvSpPr>
-          <p:cNvPr id="20" name="">
-            <a:extLst xmlns:a="http://schemas.openxmlformats.org/drawingml/2006/main">
-              <a:ext uri="{FF2B5EF4-FFF2-40B4-BE49-F238E27FC236}">
-                <a16:creationId xmlns:a16="http://schemas.microsoft.com/office/drawing/2014/main" id="{82425874-2606-45D8-A257-1D47C09AE9CE}"/>
+          <p:cNvPr id="21" name="">
+            <a:extLst xmlns:a="http://schemas.openxmlformats.org/drawingml/2006/main">
+              <a:ext uri="{FF2B5EF4-FFF2-40B4-BE49-F238E27FC236}">
+                <a16:creationId xmlns:a16="http://schemas.microsoft.com/office/drawing/2014/main" id="{8C381F9B-F2F1-4057-8D26-38FA84549B89}"/>
               </a:ext>
             </a:extLst>
           </p:cNvPr>
@@ -14384,10 +14434,10 @@
       </p:sp>
       <p:sp>
         <p:nvSpPr>
-          <p:cNvPr id="21" name="">
-            <a:extLst xmlns:a="http://schemas.openxmlformats.org/drawingml/2006/main">
-              <a:ext uri="{FF2B5EF4-FFF2-40B4-BE49-F238E27FC236}">
-                <a16:creationId xmlns:a16="http://schemas.microsoft.com/office/drawing/2014/main" id="{CEBE73E7-D11C-4DB2-A405-C19C71DCA429}"/>
+          <p:cNvPr id="22" name="">
+            <a:extLst xmlns:a="http://schemas.openxmlformats.org/drawingml/2006/main">
+              <a:ext uri="{FF2B5EF4-FFF2-40B4-BE49-F238E27FC236}">
+                <a16:creationId xmlns:a16="http://schemas.microsoft.com/office/drawing/2014/main" id="{BE36AB0F-6390-432D-A44C-CED9A6D36CBD}"/>
               </a:ext>
             </a:extLst>
           </p:cNvPr>
@@ -14427,17 +14477,17 @@
                   <a:srgbClr val="121722"/>
                 </a:solidFill>
               </a:rPr>
-              <a:t>단계 확인</a:t>
-            </a:r>
-          </a:p>
-        </p:txBody>
-      </p:sp>
-      <p:sp>
-        <p:nvSpPr>
-          <p:cNvPr id="22" name="">
-            <a:extLst xmlns:a="http://schemas.openxmlformats.org/drawingml/2006/main">
-              <a:ext uri="{FF2B5EF4-FFF2-40B4-BE49-F238E27FC236}">
-                <a16:creationId xmlns:a16="http://schemas.microsoft.com/office/drawing/2014/main" id="{D402E672-727F-4B54-98BB-2F899D39A4D6}"/>
+              <a:t>실패 격리</a:t>
+            </a:r>
+          </a:p>
+        </p:txBody>
+      </p:sp>
+      <p:sp>
+        <p:nvSpPr>
+          <p:cNvPr id="23" name="">
+            <a:extLst xmlns:a="http://schemas.openxmlformats.org/drawingml/2006/main">
+              <a:ext uri="{FF2B5EF4-FFF2-40B4-BE49-F238E27FC236}">
+                <a16:creationId xmlns:a16="http://schemas.microsoft.com/office/drawing/2014/main" id="{30EF20E7-3AD0-4199-AAE4-14BA59CC40A8}"/>
               </a:ext>
             </a:extLst>
           </p:cNvPr>
@@ -14477,17 +14527,17 @@
                   <a:srgbClr val="5B6472"/>
                 </a:solidFill>
               </a:rPr>
-              <a:t>DB 저장, 검색 레코드, 화면 노출의 순차 검증</a:t>
-            </a:r>
-          </a:p>
-        </p:txBody>
-      </p:sp>
-      <p:sp>
-        <p:nvSpPr>
-          <p:cNvPr id="23" name="">
-            <a:extLst xmlns:a="http://schemas.openxmlformats.org/drawingml/2006/main">
-              <a:ext uri="{FF2B5EF4-FFF2-40B4-BE49-F238E27FC236}">
-                <a16:creationId xmlns:a16="http://schemas.microsoft.com/office/drawing/2014/main" id="{98219B63-0981-4C95-B28F-A248664571EC}"/>
+              <a:t>응답 검증과 제휴사 단위 예외 처리 직접 개선</a:t>
+            </a:r>
+          </a:p>
+        </p:txBody>
+      </p:sp>
+      <p:sp>
+        <p:nvSpPr>
+          <p:cNvPr id="24" name="">
+            <a:extLst xmlns:a="http://schemas.openxmlformats.org/drawingml/2006/main">
+              <a:ext uri="{FF2B5EF4-FFF2-40B4-BE49-F238E27FC236}">
+                <a16:creationId xmlns:a16="http://schemas.microsoft.com/office/drawing/2014/main" id="{A77BC9A3-5F95-4994-AF5F-AB3279B7E7A0}"/>
               </a:ext>
             </a:extLst>
           </p:cNvPr>
@@ -14515,10 +14565,10 @@
       </p:sp>
       <p:sp>
         <p:nvSpPr>
-          <p:cNvPr id="24" name="">
-            <a:extLst xmlns:a="http://schemas.openxmlformats.org/drawingml/2006/main">
-              <a:ext uri="{FF2B5EF4-FFF2-40B4-BE49-F238E27FC236}">
-                <a16:creationId xmlns:a16="http://schemas.microsoft.com/office/drawing/2014/main" id="{6EFCC7C9-BD03-4606-9646-E79F6964288E}"/>
+          <p:cNvPr id="25" name="">
+            <a:extLst xmlns:a="http://schemas.openxmlformats.org/drawingml/2006/main">
+              <a:ext uri="{FF2B5EF4-FFF2-40B4-BE49-F238E27FC236}">
+                <a16:creationId xmlns:a16="http://schemas.microsoft.com/office/drawing/2014/main" id="{EE39F715-5D91-4A70-B4F1-1225BD0ADF5B}"/>
               </a:ext>
             </a:extLst>
           </p:cNvPr>
@@ -14565,10 +14615,10 @@
       </p:sp>
       <p:sp>
         <p:nvSpPr>
-          <p:cNvPr id="25" name="">
-            <a:extLst xmlns:a="http://schemas.openxmlformats.org/drawingml/2006/main">
-              <a:ext uri="{FF2B5EF4-FFF2-40B4-BE49-F238E27FC236}">
-                <a16:creationId xmlns:a16="http://schemas.microsoft.com/office/drawing/2014/main" id="{B4ACE043-28D4-499B-B6DA-35C4E096C6CD}"/>
+          <p:cNvPr id="26" name="">
+            <a:extLst xmlns:a="http://schemas.openxmlformats.org/drawingml/2006/main">
+              <a:ext uri="{FF2B5EF4-FFF2-40B4-BE49-F238E27FC236}">
+                <a16:creationId xmlns:a16="http://schemas.microsoft.com/office/drawing/2014/main" id="{8528AF7C-3466-4147-9DE3-DD6A4D1504AA}"/>
               </a:ext>
             </a:extLst>
           </p:cNvPr>
@@ -14608,17 +14658,17 @@
                   <a:srgbClr val="121722"/>
                 </a:solidFill>
               </a:rPr>
-              <a:t>운영 반영</a:t>
-            </a:r>
-          </a:p>
-        </p:txBody>
-      </p:sp>
-      <p:sp>
-        <p:nvSpPr>
-          <p:cNvPr id="26" name="">
-            <a:extLst xmlns:a="http://schemas.openxmlformats.org/drawingml/2006/main">
-              <a:ext uri="{FF2B5EF4-FFF2-40B4-BE49-F238E27FC236}">
-                <a16:creationId xmlns:a16="http://schemas.microsoft.com/office/drawing/2014/main" id="{BA617DAE-2F5C-45E8-A91F-369CD59558F8}"/>
+              <a:t>구조 분석</a:t>
+            </a:r>
+          </a:p>
+        </p:txBody>
+      </p:sp>
+      <p:sp>
+        <p:nvSpPr>
+          <p:cNvPr id="27" name="">
+            <a:extLst xmlns:a="http://schemas.openxmlformats.org/drawingml/2006/main">
+              <a:ext uri="{FF2B5EF4-FFF2-40B4-BE49-F238E27FC236}">
+                <a16:creationId xmlns:a16="http://schemas.microsoft.com/office/drawing/2014/main" id="{86C83B3B-15D5-4CC7-A70F-16A524D36B0B}"/>
               </a:ext>
             </a:extLst>
           </p:cNvPr>
@@ -14658,17 +14708,17 @@
                   <a:srgbClr val="5B6472"/>
                 </a:solidFill>
               </a:rPr>
-              <a:t>반복 사례를 체크리스트와 재처리 기준으로 축적</a:t>
-            </a:r>
-          </a:p>
-        </p:txBody>
-      </p:sp>
-      <p:sp>
-        <p:nvSpPr>
-          <p:cNvPr id="27" name="">
-            <a:extLst xmlns:a="http://schemas.openxmlformats.org/drawingml/2006/main">
-              <a:ext uri="{FF2B5EF4-FFF2-40B4-BE49-F238E27FC236}">
-                <a16:creationId xmlns:a16="http://schemas.microsoft.com/office/drawing/2014/main" id="{E646C7D7-7C83-4F5B-BDDE-E613F29FCD39}"/>
+              <a:t>현재 WebFlux 경로와 선택 가능한 Thread 경로 분석</a:t>
+            </a:r>
+          </a:p>
+        </p:txBody>
+      </p:sp>
+      <p:sp>
+        <p:nvSpPr>
+          <p:cNvPr id="28" name="">
+            <a:extLst xmlns:a="http://schemas.openxmlformats.org/drawingml/2006/main">
+              <a:ext uri="{FF2B5EF4-FFF2-40B4-BE49-F238E27FC236}">
+                <a16:creationId xmlns:a16="http://schemas.microsoft.com/office/drawing/2014/main" id="{8BDCA15E-CFD7-493A-8AF8-B0B9D165B43C}"/>
               </a:ext>
             </a:extLst>
           </p:cNvPr>
@@ -14715,10 +14765,10 @@
       </p:sp>
       <p:sp>
         <p:nvSpPr>
-          <p:cNvPr id="28" name="">
-            <a:extLst xmlns:a="http://schemas.openxmlformats.org/drawingml/2006/main">
-              <a:ext uri="{FF2B5EF4-FFF2-40B4-BE49-F238E27FC236}">
-                <a16:creationId xmlns:a16="http://schemas.microsoft.com/office/drawing/2014/main" id="{515D9FB2-BE24-4414-BFA8-C5065909657E}"/>
+          <p:cNvPr id="29" name="">
+            <a:extLst xmlns:a="http://schemas.openxmlformats.org/drawingml/2006/main">
+              <a:ext uri="{FF2B5EF4-FFF2-40B4-BE49-F238E27FC236}">
+                <a16:creationId xmlns:a16="http://schemas.microsoft.com/office/drawing/2014/main" id="{B4FFC47D-BEBE-45AE-81F0-E1D735E2258F}"/>
               </a:ext>
             </a:extLst>
           </p:cNvPr>
@@ -14758,17 +14808,17 @@
                   <a:srgbClr val="121722"/>
                 </a:solidFill>
               </a:rPr>
-              <a:t>기능 개발·운영, timeout·예외·결과 취합 흐름 분석</a:t>
-            </a:r>
-          </a:p>
-        </p:txBody>
-      </p:sp>
-      <p:sp>
-        <p:nvSpPr>
-          <p:cNvPr id="29" name="">
-            <a:extLst xmlns:a="http://schemas.openxmlformats.org/drawingml/2006/main">
-              <a:ext uri="{FF2B5EF4-FFF2-40B4-BE49-F238E27FC236}">
-                <a16:creationId xmlns:a16="http://schemas.microsoft.com/office/drawing/2014/main" id="{11AC4998-3519-4FD4-AA61-A30EEE1173E0}"/>
+              <a:t>기능 개발·운영 · 순서 안정화 참여 · 실패 격리 직접 개선</a:t>
+            </a:r>
+          </a:p>
+        </p:txBody>
+      </p:sp>
+      <p:sp>
+        <p:nvSpPr>
+          <p:cNvPr id="30" name="">
+            <a:extLst xmlns:a="http://schemas.openxmlformats.org/drawingml/2006/main">
+              <a:ext uri="{FF2B5EF4-FFF2-40B4-BE49-F238E27FC236}">
+                <a16:creationId xmlns:a16="http://schemas.microsoft.com/office/drawing/2014/main" id="{7BFDEA9F-22D7-4F52-A62E-3673D9C937D6}"/>
               </a:ext>
             </a:extLst>
           </p:cNvPr>
@@ -14796,10 +14846,10 @@
       </p:sp>
       <p:sp>
         <p:nvSpPr>
-          <p:cNvPr id="30" name="">
-            <a:extLst xmlns:a="http://schemas.openxmlformats.org/drawingml/2006/main">
-              <a:ext uri="{FF2B5EF4-FFF2-40B4-BE49-F238E27FC236}">
-                <a16:creationId xmlns:a16="http://schemas.microsoft.com/office/drawing/2014/main" id="{D450944C-68EF-45AA-8A1E-42FE2657E772}"/>
+          <p:cNvPr id="31" name="">
+            <a:extLst xmlns:a="http://schemas.openxmlformats.org/drawingml/2006/main">
+              <a:ext uri="{FF2B5EF4-FFF2-40B4-BE49-F238E27FC236}">
+                <a16:creationId xmlns:a16="http://schemas.microsoft.com/office/drawing/2014/main" id="{A04E4D4D-1FF4-4E35-9F38-1F6BE17643C1}"/>
               </a:ext>
             </a:extLst>
           </p:cNvPr>
@@ -14846,10 +14896,10 @@
       </p:sp>
       <p:sp>
         <p:nvSpPr>
-          <p:cNvPr id="31" name="">
-            <a:extLst xmlns:a="http://schemas.openxmlformats.org/drawingml/2006/main">
-              <a:ext uri="{FF2B5EF4-FFF2-40B4-BE49-F238E27FC236}">
-                <a16:creationId xmlns:a16="http://schemas.microsoft.com/office/drawing/2014/main" id="{6B54A25A-E770-4A2C-A1BE-8D3B9EB89C2D}"/>
+          <p:cNvPr id="32" name="">
+            <a:extLst xmlns:a="http://schemas.openxmlformats.org/drawingml/2006/main">
+              <a:ext uri="{FF2B5EF4-FFF2-40B4-BE49-F238E27FC236}">
+                <a16:creationId xmlns:a16="http://schemas.microsoft.com/office/drawing/2014/main" id="{9F28935A-56A2-4A11-965F-4A522B66C3DE}"/>
               </a:ext>
             </a:extLst>
           </p:cNvPr>
@@ -14897,7 +14947,7 @@
     </p:spTree>
     <p:extLst>
       <p:ext uri="{BB962C8B-B14F-4D97-AF65-F5344CB8AC3E}">
-        <p14:creationId xmlns:p14="http://schemas.microsoft.com/office/powerpoint/2010/main" val="870072551"/>
+        <p14:creationId xmlns:p14="http://schemas.microsoft.com/office/powerpoint/2010/main" val="668223647"/>
       </p:ext>
     </p:extLst>
   </p:cSld>
@@ -14928,7 +14978,7 @@
           <p:cNvPr id="27" name="">
             <a:extLst xmlns:a="http://schemas.openxmlformats.org/drawingml/2006/main">
               <a:ext uri="{FF2B5EF4-FFF2-40B4-BE49-F238E27FC236}">
-                <a16:creationId xmlns:a16="http://schemas.microsoft.com/office/drawing/2014/main" id="{CB9804E3-9CD9-4CB0-A047-3EC2C3F9C39E}"/>
+                <a16:creationId xmlns:a16="http://schemas.microsoft.com/office/drawing/2014/main" id="{763F0A8B-6333-42B1-8A88-50EE5226EB32}"/>
               </a:ext>
             </a:extLst>
           </p:cNvPr>
@@ -14978,7 +15028,7 @@
           <p:cNvPr id="2" name="">
             <a:extLst xmlns:a="http://schemas.openxmlformats.org/drawingml/2006/main">
               <a:ext uri="{FF2B5EF4-FFF2-40B4-BE49-F238E27FC236}">
-                <a16:creationId xmlns:a16="http://schemas.microsoft.com/office/drawing/2014/main" id="{1709820E-6113-4F00-91BC-BD0EAFA8368F}"/>
+                <a16:creationId xmlns:a16="http://schemas.microsoft.com/office/drawing/2014/main" id="{79E4CFC1-06D0-47EB-BC67-6C428C43A00C}"/>
               </a:ext>
             </a:extLst>
           </p:cNvPr>
@@ -15009,7 +15059,7 @@
           <p:cNvPr id="3" name="">
             <a:extLst xmlns:a="http://schemas.openxmlformats.org/drawingml/2006/main">
               <a:ext uri="{FF2B5EF4-FFF2-40B4-BE49-F238E27FC236}">
-                <a16:creationId xmlns:a16="http://schemas.microsoft.com/office/drawing/2014/main" id="{B88ED4B8-A66C-47C0-A78F-93AF33FE73D1}"/>
+                <a16:creationId xmlns:a16="http://schemas.microsoft.com/office/drawing/2014/main" id="{0FC0AF9E-59C4-4119-B1AA-5CF0F81E0A60}"/>
               </a:ext>
             </a:extLst>
           </p:cNvPr>
@@ -15059,7 +15109,7 @@
           <p:cNvPr id="4" name="">
             <a:extLst xmlns:a="http://schemas.openxmlformats.org/drawingml/2006/main">
               <a:ext uri="{FF2B5EF4-FFF2-40B4-BE49-F238E27FC236}">
-                <a16:creationId xmlns:a16="http://schemas.microsoft.com/office/drawing/2014/main" id="{76CA2675-46D4-47BA-BC5D-55290E62551D}"/>
+                <a16:creationId xmlns:a16="http://schemas.microsoft.com/office/drawing/2014/main" id="{237C6A3F-59F3-4F73-BC58-23400F42454D}"/>
               </a:ext>
             </a:extLst>
           </p:cNvPr>
@@ -15109,7 +15159,7 @@
           <p:cNvPr id="5" name="">
             <a:extLst xmlns:a="http://schemas.openxmlformats.org/drawingml/2006/main">
               <a:ext uri="{FF2B5EF4-FFF2-40B4-BE49-F238E27FC236}">
-                <a16:creationId xmlns:a16="http://schemas.microsoft.com/office/drawing/2014/main" id="{614E7ADE-8D3B-4C41-BAEE-D8E9606B932D}"/>
+                <a16:creationId xmlns:a16="http://schemas.microsoft.com/office/drawing/2014/main" id="{7AC2D809-2CBA-4008-9012-EA80613DCBD0}"/>
               </a:ext>
             </a:extLst>
           </p:cNvPr>
@@ -15159,7 +15209,7 @@
           <p:cNvPr id="6" name="">
             <a:extLst xmlns:a="http://schemas.openxmlformats.org/drawingml/2006/main">
               <a:ext uri="{FF2B5EF4-FFF2-40B4-BE49-F238E27FC236}">
-                <a16:creationId xmlns:a16="http://schemas.microsoft.com/office/drawing/2014/main" id="{F9379F07-44B8-4924-9305-D9813D906C3F}"/>
+                <a16:creationId xmlns:a16="http://schemas.microsoft.com/office/drawing/2014/main" id="{413E5FF8-8515-4767-9C65-F7CF67FFAF33}"/>
               </a:ext>
             </a:extLst>
           </p:cNvPr>
@@ -15187,7 +15237,7 @@
           <p:cNvPr id="7" name="">
             <a:extLst xmlns:a="http://schemas.openxmlformats.org/drawingml/2006/main">
               <a:ext uri="{FF2B5EF4-FFF2-40B4-BE49-F238E27FC236}">
-                <a16:creationId xmlns:a16="http://schemas.microsoft.com/office/drawing/2014/main" id="{BC4AF54E-9EA1-40B5-9A4B-DF469170A79C}"/>
+                <a16:creationId xmlns:a16="http://schemas.microsoft.com/office/drawing/2014/main" id="{C1ABEECE-849D-4D5E-9E12-9789D1AA4300}"/>
               </a:ext>
             </a:extLst>
           </p:cNvPr>
@@ -15237,7 +15287,7 @@
           <p:cNvPr id="8" name="">
             <a:extLst xmlns:a="http://schemas.openxmlformats.org/drawingml/2006/main">
               <a:ext uri="{FF2B5EF4-FFF2-40B4-BE49-F238E27FC236}">
-                <a16:creationId xmlns:a16="http://schemas.microsoft.com/office/drawing/2014/main" id="{C0A1AA81-1148-4375-9C15-868B875E3BB9}"/>
+                <a16:creationId xmlns:a16="http://schemas.microsoft.com/office/drawing/2014/main" id="{9452D0F8-B3CA-419F-992C-507FBB7F1A35}"/>
               </a:ext>
             </a:extLst>
           </p:cNvPr>
@@ -15287,7 +15337,7 @@
           <p:cNvPr id="9" name="">
             <a:extLst xmlns:a="http://schemas.openxmlformats.org/drawingml/2006/main">
               <a:ext uri="{FF2B5EF4-FFF2-40B4-BE49-F238E27FC236}">
-                <a16:creationId xmlns:a16="http://schemas.microsoft.com/office/drawing/2014/main" id="{69581A8E-878C-4417-98CA-7C5AB3114642}"/>
+                <a16:creationId xmlns:a16="http://schemas.microsoft.com/office/drawing/2014/main" id="{F7258E50-D74E-4FCC-AF37-D8227FE1040C}"/>
               </a:ext>
             </a:extLst>
           </p:cNvPr>
@@ -15315,7 +15365,7 @@
           <p:cNvPr id="10" name="">
             <a:extLst xmlns:a="http://schemas.openxmlformats.org/drawingml/2006/main">
               <a:ext uri="{FF2B5EF4-FFF2-40B4-BE49-F238E27FC236}">
-                <a16:creationId xmlns:a16="http://schemas.microsoft.com/office/drawing/2014/main" id="{FC8794B2-46E5-440C-B70C-04018B7451D6}"/>
+                <a16:creationId xmlns:a16="http://schemas.microsoft.com/office/drawing/2014/main" id="{E7E4BCA9-62B2-4DF8-882F-0820D81795AB}"/>
               </a:ext>
             </a:extLst>
           </p:cNvPr>
@@ -15365,7 +15415,7 @@
           <p:cNvPr id="11" name="">
             <a:extLst xmlns:a="http://schemas.openxmlformats.org/drawingml/2006/main">
               <a:ext uri="{FF2B5EF4-FFF2-40B4-BE49-F238E27FC236}">
-                <a16:creationId xmlns:a16="http://schemas.microsoft.com/office/drawing/2014/main" id="{205C919F-01DB-410E-83EC-40EBA8A02445}"/>
+                <a16:creationId xmlns:a16="http://schemas.microsoft.com/office/drawing/2014/main" id="{DC9A6BDB-851E-4838-B822-7275EBF3FDBC}"/>
               </a:ext>
             </a:extLst>
           </p:cNvPr>
@@ -15415,7 +15465,7 @@
           <p:cNvPr id="12" name="">
             <a:extLst xmlns:a="http://schemas.openxmlformats.org/drawingml/2006/main">
               <a:ext uri="{FF2B5EF4-FFF2-40B4-BE49-F238E27FC236}">
-                <a16:creationId xmlns:a16="http://schemas.microsoft.com/office/drawing/2014/main" id="{B7DCA2FC-4EDC-4B65-AF1B-EB9FE14F91FA}"/>
+                <a16:creationId xmlns:a16="http://schemas.microsoft.com/office/drawing/2014/main" id="{BA687A46-A717-4154-B2D8-BCA311DB7DED}"/>
               </a:ext>
             </a:extLst>
           </p:cNvPr>
@@ -15443,7 +15493,7 @@
           <p:cNvPr id="13" name="">
             <a:extLst xmlns:a="http://schemas.openxmlformats.org/drawingml/2006/main">
               <a:ext uri="{FF2B5EF4-FFF2-40B4-BE49-F238E27FC236}">
-                <a16:creationId xmlns:a16="http://schemas.microsoft.com/office/drawing/2014/main" id="{AF4EE9F5-0D34-4BD9-9F9A-C0FC54B10978}"/>
+                <a16:creationId xmlns:a16="http://schemas.microsoft.com/office/drawing/2014/main" id="{D92E2798-98DE-413A-99F9-E431F0C0DCB8}"/>
               </a:ext>
             </a:extLst>
           </p:cNvPr>
@@ -15493,7 +15543,7 @@
           <p:cNvPr id="14" name="">
             <a:extLst xmlns:a="http://schemas.openxmlformats.org/drawingml/2006/main">
               <a:ext uri="{FF2B5EF4-FFF2-40B4-BE49-F238E27FC236}">
-                <a16:creationId xmlns:a16="http://schemas.microsoft.com/office/drawing/2014/main" id="{2180488D-A37E-4F9D-94E1-EE88532E6EC5}"/>
+                <a16:creationId xmlns:a16="http://schemas.microsoft.com/office/drawing/2014/main" id="{2AF93A7C-AA78-408A-89E6-3B9F0203109D}"/>
               </a:ext>
             </a:extLst>
           </p:cNvPr>
@@ -15543,7 +15593,7 @@
           <p:cNvPr id="15" name="">
             <a:extLst xmlns:a="http://schemas.openxmlformats.org/drawingml/2006/main">
               <a:ext uri="{FF2B5EF4-FFF2-40B4-BE49-F238E27FC236}">
-                <a16:creationId xmlns:a16="http://schemas.microsoft.com/office/drawing/2014/main" id="{FE398901-1ABD-4C27-BADB-906C6B93F4A1}"/>
+                <a16:creationId xmlns:a16="http://schemas.microsoft.com/office/drawing/2014/main" id="{EAEEF429-2CEC-40BE-8B39-9ADE7E9A067E}"/>
               </a:ext>
             </a:extLst>
           </p:cNvPr>
@@ -15593,7 +15643,7 @@
           <p:cNvPr id="16" name="">
             <a:extLst xmlns:a="http://schemas.openxmlformats.org/drawingml/2006/main">
               <a:ext uri="{FF2B5EF4-FFF2-40B4-BE49-F238E27FC236}">
-                <a16:creationId xmlns:a16="http://schemas.microsoft.com/office/drawing/2014/main" id="{F589C14E-3F70-43D0-9C57-2B65A1EF8B0B}"/>
+                <a16:creationId xmlns:a16="http://schemas.microsoft.com/office/drawing/2014/main" id="{D9806E69-547C-49D0-8DB9-5A07A1950190}"/>
               </a:ext>
             </a:extLst>
           </p:cNvPr>
@@ -15624,7 +15674,7 @@
           <p:cNvPr id="17" name="">
             <a:extLst xmlns:a="http://schemas.openxmlformats.org/drawingml/2006/main">
               <a:ext uri="{FF2B5EF4-FFF2-40B4-BE49-F238E27FC236}">
-                <a16:creationId xmlns:a16="http://schemas.microsoft.com/office/drawing/2014/main" id="{67DDD1FB-AAB4-4B6E-8370-D7A63BB1104A}"/>
+                <a16:creationId xmlns:a16="http://schemas.microsoft.com/office/drawing/2014/main" id="{9B1AF9B0-EAF7-4A44-8FC7-1001B3E1B047}"/>
               </a:ext>
             </a:extLst>
           </p:cNvPr>
@@ -15674,7 +15724,7 @@
           <p:cNvPr id="18" name="">
             <a:extLst xmlns:a="http://schemas.openxmlformats.org/drawingml/2006/main">
               <a:ext uri="{FF2B5EF4-FFF2-40B4-BE49-F238E27FC236}">
-                <a16:creationId xmlns:a16="http://schemas.microsoft.com/office/drawing/2014/main" id="{4ABDFF0A-70BF-456B-92B1-58E33780EE34}"/>
+                <a16:creationId xmlns:a16="http://schemas.microsoft.com/office/drawing/2014/main" id="{FED054C7-706A-491F-A328-8B258DA2A17D}"/>
               </a:ext>
             </a:extLst>
           </p:cNvPr>
@@ -15705,7 +15755,7 @@
           <p:cNvPr id="19" name="">
             <a:extLst xmlns:a="http://schemas.openxmlformats.org/drawingml/2006/main">
               <a:ext uri="{FF2B5EF4-FFF2-40B4-BE49-F238E27FC236}">
-                <a16:creationId xmlns:a16="http://schemas.microsoft.com/office/drawing/2014/main" id="{69809C2B-B2AF-4532-BF2B-33C39C461406}"/>
+                <a16:creationId xmlns:a16="http://schemas.microsoft.com/office/drawing/2014/main" id="{3588059B-4AA7-4A53-8CD1-E7CCD1B965C5}"/>
               </a:ext>
             </a:extLst>
           </p:cNvPr>
@@ -15755,7 +15805,7 @@
           <p:cNvPr id="20" name="">
             <a:extLst xmlns:a="http://schemas.openxmlformats.org/drawingml/2006/main">
               <a:ext uri="{FF2B5EF4-FFF2-40B4-BE49-F238E27FC236}">
-                <a16:creationId xmlns:a16="http://schemas.microsoft.com/office/drawing/2014/main" id="{303ECDB6-6CBE-4876-894E-EE6DF9E10C89}"/>
+                <a16:creationId xmlns:a16="http://schemas.microsoft.com/office/drawing/2014/main" id="{2EB57540-42ED-41CD-AA25-BB57F8C80A6B}"/>
               </a:ext>
             </a:extLst>
           </p:cNvPr>
@@ -15786,7 +15836,7 @@
           <p:cNvPr id="21" name="">
             <a:extLst xmlns:a="http://schemas.openxmlformats.org/drawingml/2006/main">
               <a:ext uri="{FF2B5EF4-FFF2-40B4-BE49-F238E27FC236}">
-                <a16:creationId xmlns:a16="http://schemas.microsoft.com/office/drawing/2014/main" id="{CA132CE1-1C65-4933-AF72-DB8F95E293BD}"/>
+                <a16:creationId xmlns:a16="http://schemas.microsoft.com/office/drawing/2014/main" id="{4505F395-1390-4B5D-81C1-8F959A3A5CA1}"/>
               </a:ext>
             </a:extLst>
           </p:cNvPr>
@@ -15836,7 +15886,7 @@
           <p:cNvPr id="22" name="">
             <a:extLst xmlns:a="http://schemas.openxmlformats.org/drawingml/2006/main">
               <a:ext uri="{FF2B5EF4-FFF2-40B4-BE49-F238E27FC236}">
-                <a16:creationId xmlns:a16="http://schemas.microsoft.com/office/drawing/2014/main" id="{8337EF6B-9FDB-45FB-A324-1D9A48D83033}"/>
+                <a16:creationId xmlns:a16="http://schemas.microsoft.com/office/drawing/2014/main" id="{1DD0ACD8-D498-461C-A349-54AC23BA612B}"/>
               </a:ext>
             </a:extLst>
           </p:cNvPr>
@@ -15867,7 +15917,7 @@
           <p:cNvPr id="23" name="">
             <a:extLst xmlns:a="http://schemas.openxmlformats.org/drawingml/2006/main">
               <a:ext uri="{FF2B5EF4-FFF2-40B4-BE49-F238E27FC236}">
-                <a16:creationId xmlns:a16="http://schemas.microsoft.com/office/drawing/2014/main" id="{850EE274-F8F8-45FD-9A0E-D35C5F1EB41A}"/>
+                <a16:creationId xmlns:a16="http://schemas.microsoft.com/office/drawing/2014/main" id="{9ED27C21-532D-45CD-8CEE-657C4497A336}"/>
               </a:ext>
             </a:extLst>
           </p:cNvPr>
@@ -15917,7 +15967,7 @@
           <p:cNvPr id="24" name="">
             <a:extLst xmlns:a="http://schemas.openxmlformats.org/drawingml/2006/main">
               <a:ext uri="{FF2B5EF4-FFF2-40B4-BE49-F238E27FC236}">
-                <a16:creationId xmlns:a16="http://schemas.microsoft.com/office/drawing/2014/main" id="{02C33BF8-0510-4C02-9C5E-F398E11932E6}"/>
+                <a16:creationId xmlns:a16="http://schemas.microsoft.com/office/drawing/2014/main" id="{D45A04E2-4162-4CDA-BCAF-66217FA4360F}"/>
               </a:ext>
             </a:extLst>
           </p:cNvPr>
@@ -15948,7 +15998,7 @@
           <p:cNvPr id="25" name="">
             <a:extLst xmlns:a="http://schemas.openxmlformats.org/drawingml/2006/main">
               <a:ext uri="{FF2B5EF4-FFF2-40B4-BE49-F238E27FC236}">
-                <a16:creationId xmlns:a16="http://schemas.microsoft.com/office/drawing/2014/main" id="{78F98A22-C4D7-4048-8EDC-A0BB44C2F892}"/>
+                <a16:creationId xmlns:a16="http://schemas.microsoft.com/office/drawing/2014/main" id="{32C7A6E4-2709-47C0-A86F-6DB616688C8C}"/>
               </a:ext>
             </a:extLst>
           </p:cNvPr>
@@ -15998,7 +16048,7 @@
           <p:cNvPr id="26" name="">
             <a:extLst xmlns:a="http://schemas.openxmlformats.org/drawingml/2006/main">
               <a:ext uri="{FF2B5EF4-FFF2-40B4-BE49-F238E27FC236}">
-                <a16:creationId xmlns:a16="http://schemas.microsoft.com/office/drawing/2014/main" id="{8AB557A8-9231-41C4-BDF8-137AB9BFD773}"/>
+                <a16:creationId xmlns:a16="http://schemas.microsoft.com/office/drawing/2014/main" id="{6EFFD9F6-3B9A-4C75-A911-007B2E4A4D04}"/>
               </a:ext>
             </a:extLst>
           </p:cNvPr>
@@ -16046,7 +16096,7 @@
     </p:spTree>
     <p:extLst>
       <p:ext uri="{BB962C8B-B14F-4D97-AF65-F5344CB8AC3E}">
-        <p14:creationId xmlns:p14="http://schemas.microsoft.com/office/powerpoint/2010/main" val="1944199654"/>
+        <p14:creationId xmlns:p14="http://schemas.microsoft.com/office/powerpoint/2010/main" val="931401968"/>
       </p:ext>
     </p:extLst>
   </p:cSld>
@@ -16077,7 +16127,7 @@
           <p:cNvPr id="27" name="">
             <a:extLst xmlns:a="http://schemas.openxmlformats.org/drawingml/2006/main">
               <a:ext uri="{FF2B5EF4-FFF2-40B4-BE49-F238E27FC236}">
-                <a16:creationId xmlns:a16="http://schemas.microsoft.com/office/drawing/2014/main" id="{0D9B3F3A-CB11-4ECC-8599-A9C1CF1A6770}"/>
+                <a16:creationId xmlns:a16="http://schemas.microsoft.com/office/drawing/2014/main" id="{2B4D5B7F-DBCA-4033-B9E5-339E46B28669}"/>
               </a:ext>
             </a:extLst>
           </p:cNvPr>
@@ -16127,7 +16177,7 @@
           <p:cNvPr id="2" name="">
             <a:extLst xmlns:a="http://schemas.openxmlformats.org/drawingml/2006/main">
               <a:ext uri="{FF2B5EF4-FFF2-40B4-BE49-F238E27FC236}">
-                <a16:creationId xmlns:a16="http://schemas.microsoft.com/office/drawing/2014/main" id="{495F1445-CED8-45D6-83AC-03A9C543CE9E}"/>
+                <a16:creationId xmlns:a16="http://schemas.microsoft.com/office/drawing/2014/main" id="{96CE8732-6CA4-4003-9FDA-A937104BCD4E}"/>
               </a:ext>
             </a:extLst>
           </p:cNvPr>
@@ -16158,7 +16208,7 @@
           <p:cNvPr id="3" name="">
             <a:extLst xmlns:a="http://schemas.openxmlformats.org/drawingml/2006/main">
               <a:ext uri="{FF2B5EF4-FFF2-40B4-BE49-F238E27FC236}">
-                <a16:creationId xmlns:a16="http://schemas.microsoft.com/office/drawing/2014/main" id="{7201F085-B03D-4C6A-B3E0-98068BA78670}"/>
+                <a16:creationId xmlns:a16="http://schemas.microsoft.com/office/drawing/2014/main" id="{3D513A89-2944-4D6D-A9CA-668E980E9A5F}"/>
               </a:ext>
             </a:extLst>
           </p:cNvPr>
@@ -16198,7 +16248,7 @@
                   <a:srgbClr val="5B6472"/>
                 </a:solidFill>
               </a:rPr>
-              <a:t>PROJECT 03</a:t>
+              <a:t>CLIENT PLATFORM</a:t>
             </a:r>
           </a:p>
         </p:txBody>
@@ -16208,7 +16258,7 @@
           <p:cNvPr id="4" name="">
             <a:extLst xmlns:a="http://schemas.openxmlformats.org/drawingml/2006/main">
               <a:ext uri="{FF2B5EF4-FFF2-40B4-BE49-F238E27FC236}">
-                <a16:creationId xmlns:a16="http://schemas.microsoft.com/office/drawing/2014/main" id="{2680E3C6-7E67-4F2A-B0EC-2CB20404ABD7}"/>
+                <a16:creationId xmlns:a16="http://schemas.microsoft.com/office/drawing/2014/main" id="{2D9F550E-C784-46A8-B823-C7C746E0B76C}"/>
               </a:ext>
             </a:extLst>
           </p:cNvPr>
@@ -16258,7 +16308,7 @@
           <p:cNvPr id="5" name="">
             <a:extLst xmlns:a="http://schemas.openxmlformats.org/drawingml/2006/main">
               <a:ext uri="{FF2B5EF4-FFF2-40B4-BE49-F238E27FC236}">
-                <a16:creationId xmlns:a16="http://schemas.microsoft.com/office/drawing/2014/main" id="{294F9BC2-AF5F-4627-8F9C-6E5B7FA9C5BE}"/>
+                <a16:creationId xmlns:a16="http://schemas.microsoft.com/office/drawing/2014/main" id="{43A15049-D53A-4B8F-BD39-B9F8846E980F}"/>
               </a:ext>
             </a:extLst>
           </p:cNvPr>
@@ -16308,7 +16358,7 @@
           <p:cNvPr id="6" name="">
             <a:extLst xmlns:a="http://schemas.openxmlformats.org/drawingml/2006/main">
               <a:ext uri="{FF2B5EF4-FFF2-40B4-BE49-F238E27FC236}">
-                <a16:creationId xmlns:a16="http://schemas.microsoft.com/office/drawing/2014/main" id="{A41EC0B5-9036-476C-9B90-376D9208DBBF}"/>
+                <a16:creationId xmlns:a16="http://schemas.microsoft.com/office/drawing/2014/main" id="{A0270F7C-045C-4693-834D-260A23058568}"/>
               </a:ext>
             </a:extLst>
           </p:cNvPr>
@@ -16339,7 +16389,7 @@
           <p:cNvPr id="7" name="">
             <a:extLst xmlns:a="http://schemas.openxmlformats.org/drawingml/2006/main">
               <a:ext uri="{FF2B5EF4-FFF2-40B4-BE49-F238E27FC236}">
-                <a16:creationId xmlns:a16="http://schemas.microsoft.com/office/drawing/2014/main" id="{D8E3F311-C32E-4312-B4B8-E1FF123803AA}"/>
+                <a16:creationId xmlns:a16="http://schemas.microsoft.com/office/drawing/2014/main" id="{EE1B049E-2314-4E76-9577-8E0899429FB3}"/>
               </a:ext>
             </a:extLst>
           </p:cNvPr>
@@ -16389,7 +16439,7 @@
           <p:cNvPr id="8" name="">
             <a:extLst xmlns:a="http://schemas.openxmlformats.org/drawingml/2006/main">
               <a:ext uri="{FF2B5EF4-FFF2-40B4-BE49-F238E27FC236}">
-                <a16:creationId xmlns:a16="http://schemas.microsoft.com/office/drawing/2014/main" id="{6AC74125-9691-4D54-912A-FB3CCEE111D2}"/>
+                <a16:creationId xmlns:a16="http://schemas.microsoft.com/office/drawing/2014/main" id="{E758B34D-DA4A-4B1E-BBC7-D336A4723FB4}"/>
               </a:ext>
             </a:extLst>
           </p:cNvPr>
@@ -16439,7 +16489,7 @@
           <p:cNvPr id="9" name="">
             <a:extLst xmlns:a="http://schemas.openxmlformats.org/drawingml/2006/main">
               <a:ext uri="{FF2B5EF4-FFF2-40B4-BE49-F238E27FC236}">
-                <a16:creationId xmlns:a16="http://schemas.microsoft.com/office/drawing/2014/main" id="{0F693507-784E-49E5-BB11-8C7191FDDD77}"/>
+                <a16:creationId xmlns:a16="http://schemas.microsoft.com/office/drawing/2014/main" id="{976DE302-5B79-4F73-91CE-3D8090660D36}"/>
               </a:ext>
             </a:extLst>
           </p:cNvPr>
@@ -16489,7 +16539,7 @@
           <p:cNvPr id="10" name="">
             <a:extLst xmlns:a="http://schemas.openxmlformats.org/drawingml/2006/main">
               <a:ext uri="{FF2B5EF4-FFF2-40B4-BE49-F238E27FC236}">
-                <a16:creationId xmlns:a16="http://schemas.microsoft.com/office/drawing/2014/main" id="{5F000D5F-61F3-4212-BE16-5F9186131C09}"/>
+                <a16:creationId xmlns:a16="http://schemas.microsoft.com/office/drawing/2014/main" id="{ACA02B08-D0D9-4B87-A532-08A5756F1578}"/>
               </a:ext>
             </a:extLst>
           </p:cNvPr>
@@ -16539,7 +16589,7 @@
           <p:cNvPr id="11" name="">
             <a:extLst xmlns:a="http://schemas.openxmlformats.org/drawingml/2006/main">
               <a:ext uri="{FF2B5EF4-FFF2-40B4-BE49-F238E27FC236}">
-                <a16:creationId xmlns:a16="http://schemas.microsoft.com/office/drawing/2014/main" id="{B9567A76-C41F-467C-B109-CB5AA270FCD0}"/>
+                <a16:creationId xmlns:a16="http://schemas.microsoft.com/office/drawing/2014/main" id="{AD9EB2D8-D56B-4B58-87B3-8A3D3917294C}"/>
               </a:ext>
             </a:extLst>
           </p:cNvPr>
@@ -16589,7 +16639,7 @@
           <p:cNvPr id="12" name="">
             <a:extLst xmlns:a="http://schemas.openxmlformats.org/drawingml/2006/main">
               <a:ext uri="{FF2B5EF4-FFF2-40B4-BE49-F238E27FC236}">
-                <a16:creationId xmlns:a16="http://schemas.microsoft.com/office/drawing/2014/main" id="{D4039C12-B876-4433-A16D-ABBB62B23FAA}"/>
+                <a16:creationId xmlns:a16="http://schemas.microsoft.com/office/drawing/2014/main" id="{93EBBA1C-0E2F-47FA-8196-6DE4A7748F14}"/>
               </a:ext>
             </a:extLst>
           </p:cNvPr>
@@ -16620,7 +16670,7 @@
           <p:cNvPr id="13" name="">
             <a:extLst xmlns:a="http://schemas.openxmlformats.org/drawingml/2006/main">
               <a:ext uri="{FF2B5EF4-FFF2-40B4-BE49-F238E27FC236}">
-                <a16:creationId xmlns:a16="http://schemas.microsoft.com/office/drawing/2014/main" id="{C6A1ABFE-ACC1-47C4-B5FE-9F45511BE27C}"/>
+                <a16:creationId xmlns:a16="http://schemas.microsoft.com/office/drawing/2014/main" id="{0692290B-DD82-420B-9AA6-D0488FFFE48C}"/>
               </a:ext>
             </a:extLst>
           </p:cNvPr>
@@ -16687,7 +16737,7 @@
           <p:cNvPr id="14" name="">
             <a:extLst xmlns:a="http://schemas.openxmlformats.org/drawingml/2006/main">
               <a:ext uri="{FF2B5EF4-FFF2-40B4-BE49-F238E27FC236}">
-                <a16:creationId xmlns:a16="http://schemas.microsoft.com/office/drawing/2014/main" id="{7C48F600-15B2-4732-8D4C-0DACD65D0555}"/>
+                <a16:creationId xmlns:a16="http://schemas.microsoft.com/office/drawing/2014/main" id="{F45183F9-1E47-42A0-86CA-F558BE0926BD}"/>
               </a:ext>
             </a:extLst>
           </p:cNvPr>
@@ -16737,7 +16787,7 @@
           <p:cNvPr id="15" name="">
             <a:extLst xmlns:a="http://schemas.openxmlformats.org/drawingml/2006/main">
               <a:ext uri="{FF2B5EF4-FFF2-40B4-BE49-F238E27FC236}">
-                <a16:creationId xmlns:a16="http://schemas.microsoft.com/office/drawing/2014/main" id="{0748AE97-9B7A-4DD6-A821-9BF241B04067}"/>
+                <a16:creationId xmlns:a16="http://schemas.microsoft.com/office/drawing/2014/main" id="{D45A2442-5D4F-4E2E-8E87-EB813965CD31}"/>
               </a:ext>
             </a:extLst>
           </p:cNvPr>
@@ -16768,7 +16818,7 @@
           <p:cNvPr id="16" name="">
             <a:extLst xmlns:a="http://schemas.openxmlformats.org/drawingml/2006/main">
               <a:ext uri="{FF2B5EF4-FFF2-40B4-BE49-F238E27FC236}">
-                <a16:creationId xmlns:a16="http://schemas.microsoft.com/office/drawing/2014/main" id="{B42159EC-94C2-4CE0-AA1B-292089E86E19}"/>
+                <a16:creationId xmlns:a16="http://schemas.microsoft.com/office/drawing/2014/main" id="{BA61DC50-7052-45B9-858C-C0691D9A399B}"/>
               </a:ext>
             </a:extLst>
           </p:cNvPr>
@@ -16818,7 +16868,7 @@
           <p:cNvPr id="17" name="">
             <a:extLst xmlns:a="http://schemas.openxmlformats.org/drawingml/2006/main">
               <a:ext uri="{FF2B5EF4-FFF2-40B4-BE49-F238E27FC236}">
-                <a16:creationId xmlns:a16="http://schemas.microsoft.com/office/drawing/2014/main" id="{0906ECD4-3F6F-41D3-B324-E6F466EF282E}"/>
+                <a16:creationId xmlns:a16="http://schemas.microsoft.com/office/drawing/2014/main" id="{3B07DF77-D8E9-4519-B2A3-5B739AE2EAD6}"/>
               </a:ext>
             </a:extLst>
           </p:cNvPr>
@@ -16849,7 +16899,7 @@
           <p:cNvPr id="18" name="">
             <a:extLst xmlns:a="http://schemas.openxmlformats.org/drawingml/2006/main">
               <a:ext uri="{FF2B5EF4-FFF2-40B4-BE49-F238E27FC236}">
-                <a16:creationId xmlns:a16="http://schemas.microsoft.com/office/drawing/2014/main" id="{68DD5A8F-4378-4DD8-AEFC-F484133D40BE}"/>
+                <a16:creationId xmlns:a16="http://schemas.microsoft.com/office/drawing/2014/main" id="{C51A4EC6-F778-4042-8D78-858878378CA3}"/>
               </a:ext>
             </a:extLst>
           </p:cNvPr>
@@ -16899,7 +16949,7 @@
           <p:cNvPr id="19" name="">
             <a:extLst xmlns:a="http://schemas.openxmlformats.org/drawingml/2006/main">
               <a:ext uri="{FF2B5EF4-FFF2-40B4-BE49-F238E27FC236}">
-                <a16:creationId xmlns:a16="http://schemas.microsoft.com/office/drawing/2014/main" id="{6FC5F5A7-91BB-4110-904E-4D70872089EB}"/>
+                <a16:creationId xmlns:a16="http://schemas.microsoft.com/office/drawing/2014/main" id="{26D110BA-8EB2-4E67-B026-2CA5564E4B43}"/>
               </a:ext>
             </a:extLst>
           </p:cNvPr>
@@ -16930,7 +16980,7 @@
           <p:cNvPr id="20" name="">
             <a:extLst xmlns:a="http://schemas.openxmlformats.org/drawingml/2006/main">
               <a:ext uri="{FF2B5EF4-FFF2-40B4-BE49-F238E27FC236}">
-                <a16:creationId xmlns:a16="http://schemas.microsoft.com/office/drawing/2014/main" id="{EAF6482B-58E3-4F74-8916-CBA14C7EDDD0}"/>
+                <a16:creationId xmlns:a16="http://schemas.microsoft.com/office/drawing/2014/main" id="{0F65CDBF-2154-4E11-83CD-C0F0384651E2}"/>
               </a:ext>
             </a:extLst>
           </p:cNvPr>
@@ -16980,7 +17030,7 @@
           <p:cNvPr id="21" name="">
             <a:extLst xmlns:a="http://schemas.openxmlformats.org/drawingml/2006/main">
               <a:ext uri="{FF2B5EF4-FFF2-40B4-BE49-F238E27FC236}">
-                <a16:creationId xmlns:a16="http://schemas.microsoft.com/office/drawing/2014/main" id="{EF11563E-20C8-4F3A-AF4C-84CF3DF25817}"/>
+                <a16:creationId xmlns:a16="http://schemas.microsoft.com/office/drawing/2014/main" id="{22678716-68A6-4FB7-A5AC-546C9CCD5707}"/>
               </a:ext>
             </a:extLst>
           </p:cNvPr>
@@ -17030,7 +17080,7 @@
           <p:cNvPr id="22" name="">
             <a:extLst xmlns:a="http://schemas.openxmlformats.org/drawingml/2006/main">
               <a:ext uri="{FF2B5EF4-FFF2-40B4-BE49-F238E27FC236}">
-                <a16:creationId xmlns:a16="http://schemas.microsoft.com/office/drawing/2014/main" id="{D5061430-4E42-4508-BE58-7DFA9ED4D8AC}"/>
+                <a16:creationId xmlns:a16="http://schemas.microsoft.com/office/drawing/2014/main" id="{9EEBAAE5-D423-4DC5-86B2-9415D04953F5}"/>
               </a:ext>
             </a:extLst>
           </p:cNvPr>
@@ -17080,7 +17130,7 @@
           <p:cNvPr id="23" name="">
             <a:extLst xmlns:a="http://schemas.openxmlformats.org/drawingml/2006/main">
               <a:ext uri="{FF2B5EF4-FFF2-40B4-BE49-F238E27FC236}">
-                <a16:creationId xmlns:a16="http://schemas.microsoft.com/office/drawing/2014/main" id="{25B3EBEA-4D1C-40F9-B282-964829F2FE71}"/>
+                <a16:creationId xmlns:a16="http://schemas.microsoft.com/office/drawing/2014/main" id="{A0DE492D-A11F-41E4-9C86-56DE8B3E3B1B}"/>
               </a:ext>
             </a:extLst>
           </p:cNvPr>
@@ -17130,7 +17180,7 @@
           <p:cNvPr id="24" name="">
             <a:extLst xmlns:a="http://schemas.openxmlformats.org/drawingml/2006/main">
               <a:ext uri="{FF2B5EF4-FFF2-40B4-BE49-F238E27FC236}">
-                <a16:creationId xmlns:a16="http://schemas.microsoft.com/office/drawing/2014/main" id="{6F91B0A9-F7D4-4A53-8F60-DA7C356FF101}"/>
+                <a16:creationId xmlns:a16="http://schemas.microsoft.com/office/drawing/2014/main" id="{D46E4399-73AD-48E8-A90D-CEB7B63E6E0A}"/>
               </a:ext>
             </a:extLst>
           </p:cNvPr>
@@ -17161,7 +17211,7 @@
           <p:cNvPr id="25" name="">
             <a:extLst xmlns:a="http://schemas.openxmlformats.org/drawingml/2006/main">
               <a:ext uri="{FF2B5EF4-FFF2-40B4-BE49-F238E27FC236}">
-                <a16:creationId xmlns:a16="http://schemas.microsoft.com/office/drawing/2014/main" id="{EAF991E0-7354-4ADB-9294-05D51BEFF928}"/>
+                <a16:creationId xmlns:a16="http://schemas.microsoft.com/office/drawing/2014/main" id="{30F50B2E-F5B9-4841-95B2-9ACC5CCECCB3}"/>
               </a:ext>
             </a:extLst>
           </p:cNvPr>
@@ -17211,7 +17261,7 @@
           <p:cNvPr id="26" name="">
             <a:extLst xmlns:a="http://schemas.openxmlformats.org/drawingml/2006/main">
               <a:ext uri="{FF2B5EF4-FFF2-40B4-BE49-F238E27FC236}">
-                <a16:creationId xmlns:a16="http://schemas.microsoft.com/office/drawing/2014/main" id="{5DB59815-AE4E-4C43-B231-C7CE91F4E766}"/>
+                <a16:creationId xmlns:a16="http://schemas.microsoft.com/office/drawing/2014/main" id="{0920192A-DCCA-41D8-9644-A6817F082F45}"/>
               </a:ext>
             </a:extLst>
           </p:cNvPr>
@@ -17259,7 +17309,7 @@
     </p:spTree>
     <p:extLst>
       <p:ext uri="{BB962C8B-B14F-4D97-AF65-F5344CB8AC3E}">
-        <p14:creationId xmlns:p14="http://schemas.microsoft.com/office/powerpoint/2010/main" val="1445498155"/>
+        <p14:creationId xmlns:p14="http://schemas.microsoft.com/office/powerpoint/2010/main" val="10461217"/>
       </p:ext>
     </p:extLst>
   </p:cSld>
@@ -17290,7 +17340,7 @@
           <p:cNvPr id="25" name="">
             <a:extLst xmlns:a="http://schemas.openxmlformats.org/drawingml/2006/main">
               <a:ext uri="{FF2B5EF4-FFF2-40B4-BE49-F238E27FC236}">
-                <a16:creationId xmlns:a16="http://schemas.microsoft.com/office/drawing/2014/main" id="{0F6CD415-9888-415A-B799-BCADDB09ACE2}"/>
+                <a16:creationId xmlns:a16="http://schemas.microsoft.com/office/drawing/2014/main" id="{869BD8E5-8A9F-4E36-A62C-AD79C1E285BF}"/>
               </a:ext>
             </a:extLst>
           </p:cNvPr>
@@ -17340,7 +17390,7 @@
           <p:cNvPr id="2" name="">
             <a:extLst xmlns:a="http://schemas.openxmlformats.org/drawingml/2006/main">
               <a:ext uri="{FF2B5EF4-FFF2-40B4-BE49-F238E27FC236}">
-                <a16:creationId xmlns:a16="http://schemas.microsoft.com/office/drawing/2014/main" id="{59959A01-986A-48C3-BB98-8DC8F074D447}"/>
+                <a16:creationId xmlns:a16="http://schemas.microsoft.com/office/drawing/2014/main" id="{FF18E3A6-4F81-4DE7-AD1D-5108973B7888}"/>
               </a:ext>
             </a:extLst>
           </p:cNvPr>
@@ -17371,7 +17421,7 @@
           <p:cNvPr id="3" name="">
             <a:extLst xmlns:a="http://schemas.openxmlformats.org/drawingml/2006/main">
               <a:ext uri="{FF2B5EF4-FFF2-40B4-BE49-F238E27FC236}">
-                <a16:creationId xmlns:a16="http://schemas.microsoft.com/office/drawing/2014/main" id="{CF8335BC-002A-4583-9E2B-3901050AE0F2}"/>
+                <a16:creationId xmlns:a16="http://schemas.microsoft.com/office/drawing/2014/main" id="{02D0D6AA-B4E0-4E99-90DC-2A27014CB29B}"/>
               </a:ext>
             </a:extLst>
           </p:cNvPr>
@@ -17421,7 +17471,7 @@
           <p:cNvPr id="4" name="">
             <a:extLst xmlns:a="http://schemas.openxmlformats.org/drawingml/2006/main">
               <a:ext uri="{FF2B5EF4-FFF2-40B4-BE49-F238E27FC236}">
-                <a16:creationId xmlns:a16="http://schemas.microsoft.com/office/drawing/2014/main" id="{C5A7ED17-60FF-4748-A11F-7AC82A832A99}"/>
+                <a16:creationId xmlns:a16="http://schemas.microsoft.com/office/drawing/2014/main" id="{4E0FF9CE-7D3D-49DD-8DC8-DFEA9FE15A04}"/>
               </a:ext>
             </a:extLst>
           </p:cNvPr>
@@ -17471,7 +17521,7 @@
           <p:cNvPr id="5" name="">
             <a:extLst xmlns:a="http://schemas.openxmlformats.org/drawingml/2006/main">
               <a:ext uri="{FF2B5EF4-FFF2-40B4-BE49-F238E27FC236}">
-                <a16:creationId xmlns:a16="http://schemas.microsoft.com/office/drawing/2014/main" id="{06BE152C-A798-4182-A777-0B403F31CCB6}"/>
+                <a16:creationId xmlns:a16="http://schemas.microsoft.com/office/drawing/2014/main" id="{A1680560-760F-4F0D-B898-90D54D820F75}"/>
               </a:ext>
             </a:extLst>
           </p:cNvPr>
@@ -17521,7 +17571,7 @@
           <p:cNvPr id="6" name="">
             <a:extLst xmlns:a="http://schemas.openxmlformats.org/drawingml/2006/main">
               <a:ext uri="{FF2B5EF4-FFF2-40B4-BE49-F238E27FC236}">
-                <a16:creationId xmlns:a16="http://schemas.microsoft.com/office/drawing/2014/main" id="{66AC2BBA-87A1-4456-93B5-1B870FD5936F}"/>
+                <a16:creationId xmlns:a16="http://schemas.microsoft.com/office/drawing/2014/main" id="{B1B31285-A18F-454F-B58B-7B384D5EFB5D}"/>
               </a:ext>
             </a:extLst>
           </p:cNvPr>
@@ -17571,7 +17621,7 @@
           <p:cNvPr id="7" name="">
             <a:extLst xmlns:a="http://schemas.openxmlformats.org/drawingml/2006/main">
               <a:ext uri="{FF2B5EF4-FFF2-40B4-BE49-F238E27FC236}">
-                <a16:creationId xmlns:a16="http://schemas.microsoft.com/office/drawing/2014/main" id="{592ACE47-0284-4233-B311-1EB06AAD2687}"/>
+                <a16:creationId xmlns:a16="http://schemas.microsoft.com/office/drawing/2014/main" id="{E10FE492-DA1B-4A1D-B8FA-2B6601D9AD16}"/>
               </a:ext>
             </a:extLst>
           </p:cNvPr>
@@ -17602,7 +17652,7 @@
           <p:cNvPr id="8" name="">
             <a:extLst xmlns:a="http://schemas.openxmlformats.org/drawingml/2006/main">
               <a:ext uri="{FF2B5EF4-FFF2-40B4-BE49-F238E27FC236}">
-                <a16:creationId xmlns:a16="http://schemas.microsoft.com/office/drawing/2014/main" id="{AF5D09AD-1CD5-4828-B168-CF34A554D5CF}"/>
+                <a16:creationId xmlns:a16="http://schemas.microsoft.com/office/drawing/2014/main" id="{7FE30447-3EE3-40E6-9620-DB0ADFDF2EF1}"/>
               </a:ext>
             </a:extLst>
           </p:cNvPr>
@@ -17652,7 +17702,7 @@
           <p:cNvPr id="9" name="">
             <a:extLst xmlns:a="http://schemas.openxmlformats.org/drawingml/2006/main">
               <a:ext uri="{FF2B5EF4-FFF2-40B4-BE49-F238E27FC236}">
-                <a16:creationId xmlns:a16="http://schemas.microsoft.com/office/drawing/2014/main" id="{ACBADB05-F4E4-4F1F-A4B0-B6634FC48982}"/>
+                <a16:creationId xmlns:a16="http://schemas.microsoft.com/office/drawing/2014/main" id="{33BB50F3-D96E-4A0C-A803-AA8F656714CD}"/>
               </a:ext>
             </a:extLst>
           </p:cNvPr>
@@ -17683,7 +17733,7 @@
           <p:cNvPr id="10" name="">
             <a:extLst xmlns:a="http://schemas.openxmlformats.org/drawingml/2006/main">
               <a:ext uri="{FF2B5EF4-FFF2-40B4-BE49-F238E27FC236}">
-                <a16:creationId xmlns:a16="http://schemas.microsoft.com/office/drawing/2014/main" id="{74E9D291-6607-4E6D-AF7A-33E27BE882F4}"/>
+                <a16:creationId xmlns:a16="http://schemas.microsoft.com/office/drawing/2014/main" id="{0BEE572F-8BC5-40F0-8D47-D3E4AE99613D}"/>
               </a:ext>
             </a:extLst>
           </p:cNvPr>
@@ -17733,7 +17783,7 @@
           <p:cNvPr id="11" name="">
             <a:extLst xmlns:a="http://schemas.openxmlformats.org/drawingml/2006/main">
               <a:ext uri="{FF2B5EF4-FFF2-40B4-BE49-F238E27FC236}">
-                <a16:creationId xmlns:a16="http://schemas.microsoft.com/office/drawing/2014/main" id="{B1CF512A-0829-42AA-BC7A-C2C9424C7F46}"/>
+                <a16:creationId xmlns:a16="http://schemas.microsoft.com/office/drawing/2014/main" id="{95F4EF6F-F3A4-4CE1-A825-77D564EA8FB7}"/>
               </a:ext>
             </a:extLst>
           </p:cNvPr>
@@ -17764,7 +17814,7 @@
           <p:cNvPr id="12" name="">
             <a:extLst xmlns:a="http://schemas.openxmlformats.org/drawingml/2006/main">
               <a:ext uri="{FF2B5EF4-FFF2-40B4-BE49-F238E27FC236}">
-                <a16:creationId xmlns:a16="http://schemas.microsoft.com/office/drawing/2014/main" id="{D80B7471-E281-436C-B576-309A9C597D91}"/>
+                <a16:creationId xmlns:a16="http://schemas.microsoft.com/office/drawing/2014/main" id="{73FF7A74-B739-40FF-AEF7-B6850A31D0DB}"/>
               </a:ext>
             </a:extLst>
           </p:cNvPr>
@@ -17814,7 +17864,7 @@
           <p:cNvPr id="13" name="">
             <a:extLst xmlns:a="http://schemas.openxmlformats.org/drawingml/2006/main">
               <a:ext uri="{FF2B5EF4-FFF2-40B4-BE49-F238E27FC236}">
-                <a16:creationId xmlns:a16="http://schemas.microsoft.com/office/drawing/2014/main" id="{42AA53FA-5E1F-49F6-B7A6-98493E5941DC}"/>
+                <a16:creationId xmlns:a16="http://schemas.microsoft.com/office/drawing/2014/main" id="{BED3F846-9BD9-4FBF-84CB-35900AF62ADF}"/>
               </a:ext>
             </a:extLst>
           </p:cNvPr>
@@ -17845,7 +17895,7 @@
           <p:cNvPr id="14" name="">
             <a:extLst xmlns:a="http://schemas.openxmlformats.org/drawingml/2006/main">
               <a:ext uri="{FF2B5EF4-FFF2-40B4-BE49-F238E27FC236}">
-                <a16:creationId xmlns:a16="http://schemas.microsoft.com/office/drawing/2014/main" id="{6112255E-FE26-47EA-9FC7-6A434E6A9BE8}"/>
+                <a16:creationId xmlns:a16="http://schemas.microsoft.com/office/drawing/2014/main" id="{E42F7FCA-EF8A-4F62-BFBC-AD3FB36BEE63}"/>
               </a:ext>
             </a:extLst>
           </p:cNvPr>
@@ -17895,7 +17945,7 @@
           <p:cNvPr id="15" name="">
             <a:extLst xmlns:a="http://schemas.openxmlformats.org/drawingml/2006/main">
               <a:ext uri="{FF2B5EF4-FFF2-40B4-BE49-F238E27FC236}">
-                <a16:creationId xmlns:a16="http://schemas.microsoft.com/office/drawing/2014/main" id="{66E1F2B9-20D1-4532-99BC-44218425D68A}"/>
+                <a16:creationId xmlns:a16="http://schemas.microsoft.com/office/drawing/2014/main" id="{E5176F4C-5852-42B5-89E6-9CE8999FAD5A}"/>
               </a:ext>
             </a:extLst>
           </p:cNvPr>
@@ -17926,7 +17976,7 @@
           <p:cNvPr id="16" name="">
             <a:extLst xmlns:a="http://schemas.openxmlformats.org/drawingml/2006/main">
               <a:ext uri="{FF2B5EF4-FFF2-40B4-BE49-F238E27FC236}">
-                <a16:creationId xmlns:a16="http://schemas.microsoft.com/office/drawing/2014/main" id="{D4845FFD-4850-4C7E-9D46-ECEFBAE1EF2D}"/>
+                <a16:creationId xmlns:a16="http://schemas.microsoft.com/office/drawing/2014/main" id="{D5F58F70-C612-4A0F-878E-5FA3C4B2AC56}"/>
               </a:ext>
             </a:extLst>
           </p:cNvPr>
@@ -17976,7 +18026,7 @@
           <p:cNvPr id="17" name="">
             <a:extLst xmlns:a="http://schemas.openxmlformats.org/drawingml/2006/main">
               <a:ext uri="{FF2B5EF4-FFF2-40B4-BE49-F238E27FC236}">
-                <a16:creationId xmlns:a16="http://schemas.microsoft.com/office/drawing/2014/main" id="{3D633BC5-C275-46E6-AF1B-C61D967B4CC6}"/>
+                <a16:creationId xmlns:a16="http://schemas.microsoft.com/office/drawing/2014/main" id="{BB76923D-FD32-40D1-A2FB-C289C4488543}"/>
               </a:ext>
             </a:extLst>
           </p:cNvPr>
@@ -18043,7 +18093,7 @@
           <p:cNvPr id="18" name="">
             <a:extLst xmlns:a="http://schemas.openxmlformats.org/drawingml/2006/main">
               <a:ext uri="{FF2B5EF4-FFF2-40B4-BE49-F238E27FC236}">
-                <a16:creationId xmlns:a16="http://schemas.microsoft.com/office/drawing/2014/main" id="{E3957AEF-A1F1-4C15-ABEF-64457B6DE1FC}"/>
+                <a16:creationId xmlns:a16="http://schemas.microsoft.com/office/drawing/2014/main" id="{5A84990B-89CB-4C87-9D59-D3F417A801E0}"/>
               </a:ext>
             </a:extLst>
           </p:cNvPr>
@@ -18080,7 +18130,7 @@
           <p:nvPr/>
         </p:nvPicPr>
         <p:blipFill>
-          <a:blip xmlns:r="http://schemas.openxmlformats.org/officeDocument/2006/relationships" xmlns:a="http://schemas.openxmlformats.org/drawingml/2006/main" r:embed="R95908e3c1fbc47b8"/>
+          <a:blip xmlns:r="http://schemas.openxmlformats.org/officeDocument/2006/relationships" xmlns:a="http://schemas.openxmlformats.org/drawingml/2006/main" r:embed="R5c8e87929b1b4c07"/>
           <a:stretch xmlns:a="http://schemas.openxmlformats.org/drawingml/2006/main"/>
         </p:blipFill>
         <p:spPr>
@@ -18104,7 +18154,7 @@
           <p:nvPr/>
         </p:nvPicPr>
         <p:blipFill>
-          <a:blip xmlns:r="http://schemas.openxmlformats.org/officeDocument/2006/relationships" xmlns:a="http://schemas.openxmlformats.org/drawingml/2006/main" r:embed="Rfa6fc767862f4b51"/>
+          <a:blip xmlns:r="http://schemas.openxmlformats.org/officeDocument/2006/relationships" xmlns:a="http://schemas.openxmlformats.org/drawingml/2006/main" r:embed="Ra62a132447184ec5"/>
           <a:stretch xmlns:a="http://schemas.openxmlformats.org/drawingml/2006/main"/>
         </p:blipFill>
         <p:spPr>
@@ -18128,7 +18178,7 @@
           <p:nvPr/>
         </p:nvPicPr>
         <p:blipFill>
-          <a:blip xmlns:r="http://schemas.openxmlformats.org/officeDocument/2006/relationships" xmlns:a="http://schemas.openxmlformats.org/drawingml/2006/main" r:embed="R369332e2e1fa4b44"/>
+          <a:blip xmlns:r="http://schemas.openxmlformats.org/officeDocument/2006/relationships" xmlns:a="http://schemas.openxmlformats.org/drawingml/2006/main" r:embed="R2286f24b96064e31"/>
           <a:stretch xmlns:a="http://schemas.openxmlformats.org/drawingml/2006/main"/>
         </p:blipFill>
         <p:spPr>
@@ -18148,7 +18198,7 @@
           <p:cNvPr id="22" name="">
             <a:extLst xmlns:a="http://schemas.openxmlformats.org/drawingml/2006/main">
               <a:ext uri="{FF2B5EF4-FFF2-40B4-BE49-F238E27FC236}">
-                <a16:creationId xmlns:a16="http://schemas.microsoft.com/office/drawing/2014/main" id="{64E75BA7-334C-4A19-82C2-8C393123320D}"/>
+                <a16:creationId xmlns:a16="http://schemas.microsoft.com/office/drawing/2014/main" id="{C57017D6-442E-49D9-A4C4-2B3DD8F791B9}"/>
               </a:ext>
             </a:extLst>
           </p:cNvPr>
@@ -18179,7 +18229,7 @@
           <p:cNvPr id="23" name="">
             <a:extLst xmlns:a="http://schemas.openxmlformats.org/drawingml/2006/main">
               <a:ext uri="{FF2B5EF4-FFF2-40B4-BE49-F238E27FC236}">
-                <a16:creationId xmlns:a16="http://schemas.microsoft.com/office/drawing/2014/main" id="{AF30A5CC-B022-4CCB-B7F7-E3774E027F0B}"/>
+                <a16:creationId xmlns:a16="http://schemas.microsoft.com/office/drawing/2014/main" id="{0495AD20-DF6F-44F3-ACC7-90FE1D703CB6}"/>
               </a:ext>
             </a:extLst>
           </p:cNvPr>
@@ -18229,7 +18279,7 @@
           <p:cNvPr id="24" name="">
             <a:extLst xmlns:a="http://schemas.openxmlformats.org/drawingml/2006/main">
               <a:ext uri="{FF2B5EF4-FFF2-40B4-BE49-F238E27FC236}">
-                <a16:creationId xmlns:a16="http://schemas.microsoft.com/office/drawing/2014/main" id="{B0226AFE-E8D7-4FBA-B11F-532FC987B6F1}"/>
+                <a16:creationId xmlns:a16="http://schemas.microsoft.com/office/drawing/2014/main" id="{659FD646-89A1-4FB2-8CEB-725FB99E9774}"/>
               </a:ext>
             </a:extLst>
           </p:cNvPr>
@@ -18277,7 +18327,7 @@
     </p:spTree>
     <p:extLst>
       <p:ext uri="{BB962C8B-B14F-4D97-AF65-F5344CB8AC3E}">
-        <p14:creationId xmlns:p14="http://schemas.microsoft.com/office/powerpoint/2010/main" val="1726660485"/>
+        <p14:creationId xmlns:p14="http://schemas.microsoft.com/office/powerpoint/2010/main" val="800595760"/>
       </p:ext>
     </p:extLst>
   </p:cSld>

</xml_diff>

<commit_message>
Refine portfolio project details
</commit_message>
<xml_diff>
--- a/portfolio/heetae-lee-portfolio.pptx
+++ b/portfolio/heetae-lee-portfolio.pptx
@@ -2,24 +2,24 @@
 <file path=ppt/presentation.xml><?xml version="1.0" encoding="utf-8"?>
 <p:presentation xmlns:p="http://schemas.openxmlformats.org/presentationml/2006/main">
   <p:sldMasterIdLst>
-    <p:sldMasterId xmlns:r="http://schemas.openxmlformats.org/officeDocument/2006/relationships" id="2147483648" r:id="R9e96a826022344ea"/>
+    <p:sldMasterId xmlns:r="http://schemas.openxmlformats.org/officeDocument/2006/relationships" id="2147483648" r:id="R4e06be09b84d468f"/>
   </p:sldMasterIdLst>
   <p:notesMasterIdLst>
-    <p:notesMasterId xmlns:r="http://schemas.openxmlformats.org/officeDocument/2006/relationships" r:id="R65d2d542cded41bf"/>
+    <p:notesMasterId xmlns:r="http://schemas.openxmlformats.org/officeDocument/2006/relationships" r:id="R2d3457316fd24f5f"/>
   </p:notesMasterIdLst>
   <p:sldIdLst>
-    <p:sldId xmlns:r="http://schemas.openxmlformats.org/officeDocument/2006/relationships" id="256" r:id="R97c9d49a475a4916"/>
-    <p:sldId xmlns:r="http://schemas.openxmlformats.org/officeDocument/2006/relationships" id="257" r:id="R5a1d1a507e3e4418"/>
-    <p:sldId xmlns:r="http://schemas.openxmlformats.org/officeDocument/2006/relationships" id="258" r:id="R1a7e0feb59b74fdf"/>
-    <p:sldId xmlns:r="http://schemas.openxmlformats.org/officeDocument/2006/relationships" id="259" r:id="Re267cc6eb61e4ee7"/>
-    <p:sldId xmlns:r="http://schemas.openxmlformats.org/officeDocument/2006/relationships" id="260" r:id="R2f92c15733d045c6"/>
-    <p:sldId xmlns:r="http://schemas.openxmlformats.org/officeDocument/2006/relationships" id="261" r:id="Raf0e74cc7fd8419f"/>
-    <p:sldId xmlns:r="http://schemas.openxmlformats.org/officeDocument/2006/relationships" id="262" r:id="R66a29bac4ca64f2d"/>
-    <p:sldId xmlns:r="http://schemas.openxmlformats.org/officeDocument/2006/relationships" id="263" r:id="R2e5ea82fdf064d4e"/>
-    <p:sldId xmlns:r="http://schemas.openxmlformats.org/officeDocument/2006/relationships" id="264" r:id="Rc1f90e1d8825480a"/>
-    <p:sldId xmlns:r="http://schemas.openxmlformats.org/officeDocument/2006/relationships" id="265" r:id="Rcdf00582d2a2400a"/>
-    <p:sldId xmlns:r="http://schemas.openxmlformats.org/officeDocument/2006/relationships" id="266" r:id="R4c2ce11f843240af"/>
-    <p:sldId xmlns:r="http://schemas.openxmlformats.org/officeDocument/2006/relationships" id="267" r:id="Rc4d4b2d811814f5e"/>
+    <p:sldId xmlns:r="http://schemas.openxmlformats.org/officeDocument/2006/relationships" id="256" r:id="R475f42047c0440b5"/>
+    <p:sldId xmlns:r="http://schemas.openxmlformats.org/officeDocument/2006/relationships" id="257" r:id="Rbb21996d096544bd"/>
+    <p:sldId xmlns:r="http://schemas.openxmlformats.org/officeDocument/2006/relationships" id="258" r:id="Rf1b9fedf51484320"/>
+    <p:sldId xmlns:r="http://schemas.openxmlformats.org/officeDocument/2006/relationships" id="259" r:id="Re67da3bd1f764449"/>
+    <p:sldId xmlns:r="http://schemas.openxmlformats.org/officeDocument/2006/relationships" id="260" r:id="Re9557b4d3a7c40e3"/>
+    <p:sldId xmlns:r="http://schemas.openxmlformats.org/officeDocument/2006/relationships" id="261" r:id="Re0158a08698d4a5a"/>
+    <p:sldId xmlns:r="http://schemas.openxmlformats.org/officeDocument/2006/relationships" id="262" r:id="Rafd58a1634b7438c"/>
+    <p:sldId xmlns:r="http://schemas.openxmlformats.org/officeDocument/2006/relationships" id="263" r:id="R27c3c27090504e4c"/>
+    <p:sldId xmlns:r="http://schemas.openxmlformats.org/officeDocument/2006/relationships" id="264" r:id="R5e0f52efc99846a1"/>
+    <p:sldId xmlns:r="http://schemas.openxmlformats.org/officeDocument/2006/relationships" id="265" r:id="R92e126e843814dd5"/>
+    <p:sldId xmlns:r="http://schemas.openxmlformats.org/officeDocument/2006/relationships" id="266" r:id="Rdc219ff9fce445c8"/>
+    <p:sldId xmlns:r="http://schemas.openxmlformats.org/officeDocument/2006/relationships" id="267" r:id="Ra1aff5472af44d2b"/>
   </p:sldIdLst>
   <p:sldSz cx="12192000" cy="6858000"/>
   <p:notesSz cx="6858000" cy="9144000"/>
@@ -1338,7 +1338,7 @@
   </p:cSld>
   <p:clrMap bg1="lt1" tx1="dk1" bg2="lt2" tx2="dk2" accent1="accent1" accent2="accent2" accent3="accent3" accent4="accent4" accent5="accent5" accent6="accent6" hlink="hlink" folHlink="folHlink"/>
   <p:sldLayoutIdLst>
-    <p:sldLayoutId xmlns:r="http://schemas.openxmlformats.org/officeDocument/2006/relationships" id="2147483649" r:id="Rb7525d82702b4fea"/>
+    <p:sldLayoutId xmlns:r="http://schemas.openxmlformats.org/officeDocument/2006/relationships" id="2147483649" r:id="R6d68f4e744974ff4"/>
   </p:sldLayoutIdLst>
   <p:txStyles>
     <p:titleStyle>
@@ -1948,6 +1948,7 @@
           <a:lstStyle xmlns:a="http://schemas.openxmlformats.org/drawingml/2006/main"/>
           <a:p xmlns:a="http://schemas.openxmlformats.org/drawingml/2006/main">
             <a:pPr algn="l">
+              <a:buNone/>
               <a:defRPr sz="975" b="1" i="0">
                 <a:solidFill>
                   <a:srgbClr val="3157FF"/>
@@ -1998,6 +1999,7 @@
           <a:lstStyle xmlns:a="http://schemas.openxmlformats.org/drawingml/2006/main"/>
           <a:p xmlns:a="http://schemas.openxmlformats.org/drawingml/2006/main">
             <a:pPr algn="l">
+              <a:buNone/>
               <a:defRPr sz="4350" b="1" i="0">
                 <a:solidFill>
                   <a:srgbClr val="121722"/>
@@ -2048,6 +2050,7 @@
           <a:lstStyle xmlns:a="http://schemas.openxmlformats.org/drawingml/2006/main"/>
           <a:p xmlns:a="http://schemas.openxmlformats.org/drawingml/2006/main">
             <a:pPr algn="l">
+              <a:buNone/>
               <a:defRPr sz="2550" b="1" i="0">
                 <a:solidFill>
                   <a:srgbClr val="3157FF"/>
@@ -2098,6 +2101,7 @@
           <a:lstStyle xmlns:a="http://schemas.openxmlformats.org/drawingml/2006/main"/>
           <a:p xmlns:a="http://schemas.openxmlformats.org/drawingml/2006/main">
             <a:pPr algn="l">
+              <a:buNone/>
               <a:defRPr sz="1725" b="0" i="0">
                 <a:solidFill>
                   <a:srgbClr val="5B6472"/>
@@ -2115,6 +2119,7 @@
           </a:p>
           <a:p xmlns:a="http://schemas.openxmlformats.org/drawingml/2006/main">
             <a:pPr algn="l">
+              <a:buNone/>
               <a:defRPr sz="1725" b="0" i="0">
                 <a:solidFill>
                   <a:srgbClr val="5B6472"/>
@@ -2196,6 +2201,7 @@
           <a:lstStyle xmlns:a="http://schemas.openxmlformats.org/drawingml/2006/main"/>
           <a:p xmlns:a="http://schemas.openxmlformats.org/drawingml/2006/main">
             <a:pPr algn="l">
+              <a:buNone/>
               <a:defRPr sz="975" b="1" i="0">
                 <a:solidFill>
                   <a:srgbClr val="9AA3B2"/>
@@ -2246,6 +2252,7 @@
           <a:lstStyle xmlns:a="http://schemas.openxmlformats.org/drawingml/2006/main"/>
           <a:p xmlns:a="http://schemas.openxmlformats.org/drawingml/2006/main">
             <a:pPr algn="l">
+              <a:buNone/>
               <a:defRPr sz="975" b="1" i="0">
                 <a:solidFill>
                   <a:srgbClr val="9AA3B2"/>
@@ -2296,6 +2303,7 @@
           <a:lstStyle xmlns:a="http://schemas.openxmlformats.org/drawingml/2006/main"/>
           <a:p xmlns:a="http://schemas.openxmlformats.org/drawingml/2006/main">
             <a:pPr algn="l">
+              <a:buNone/>
               <a:defRPr sz="975" b="1" i="0">
                 <a:solidFill>
                   <a:srgbClr val="9AA3B2"/>
@@ -2346,6 +2354,7 @@
           <a:lstStyle xmlns:a="http://schemas.openxmlformats.org/drawingml/2006/main"/>
           <a:p xmlns:a="http://schemas.openxmlformats.org/drawingml/2006/main">
             <a:pPr algn="l">
+              <a:buNone/>
               <a:defRPr sz="1050" b="0" i="0">
                 <a:solidFill>
                   <a:srgbClr val="121722"/>
@@ -2427,6 +2436,7 @@
           <a:lstStyle xmlns:a="http://schemas.openxmlformats.org/drawingml/2006/main"/>
           <a:p xmlns:a="http://schemas.openxmlformats.org/drawingml/2006/main">
             <a:pPr algn="l">
+              <a:buNone/>
               <a:defRPr sz="900" b="1" i="0">
                 <a:solidFill>
                   <a:srgbClr val="8993A7"/>
@@ -2477,6 +2487,7 @@
           <a:lstStyle xmlns:a="http://schemas.openxmlformats.org/drawingml/2006/main"/>
           <a:p xmlns:a="http://schemas.openxmlformats.org/drawingml/2006/main">
             <a:pPr algn="l">
+              <a:buNone/>
               <a:defRPr sz="900" b="1" i="0">
                 <a:solidFill>
                   <a:srgbClr val="3157FF"/>
@@ -2527,6 +2538,7 @@
           <a:lstStyle xmlns:a="http://schemas.openxmlformats.org/drawingml/2006/main"/>
           <a:p xmlns:a="http://schemas.openxmlformats.org/drawingml/2006/main">
             <a:pPr algn="l">
+              <a:buNone/>
               <a:defRPr sz="1575" b="1" i="0">
                 <a:solidFill>
                   <a:srgbClr val="FFFFFF"/>
@@ -2577,6 +2589,7 @@
           <a:lstStyle xmlns:a="http://schemas.openxmlformats.org/drawingml/2006/main"/>
           <a:p xmlns:a="http://schemas.openxmlformats.org/drawingml/2006/main">
             <a:pPr algn="l">
+              <a:buNone/>
               <a:defRPr sz="1050" b="0" i="0">
                 <a:solidFill>
                   <a:srgbClr val="AEB6C5"/>
@@ -2658,6 +2671,7 @@
           <a:lstStyle xmlns:a="http://schemas.openxmlformats.org/drawingml/2006/main"/>
           <a:p xmlns:a="http://schemas.openxmlformats.org/drawingml/2006/main">
             <a:pPr algn="l">
+              <a:buNone/>
               <a:defRPr sz="900" b="1" i="0">
                 <a:solidFill>
                   <a:srgbClr val="3157FF"/>
@@ -2708,6 +2722,7 @@
           <a:lstStyle xmlns:a="http://schemas.openxmlformats.org/drawingml/2006/main"/>
           <a:p xmlns:a="http://schemas.openxmlformats.org/drawingml/2006/main">
             <a:pPr algn="l">
+              <a:buNone/>
               <a:defRPr sz="1575" b="1" i="0">
                 <a:solidFill>
                   <a:srgbClr val="FFFFFF"/>
@@ -2758,6 +2773,7 @@
           <a:lstStyle xmlns:a="http://schemas.openxmlformats.org/drawingml/2006/main"/>
           <a:p xmlns:a="http://schemas.openxmlformats.org/drawingml/2006/main">
             <a:pPr algn="l">
+              <a:buNone/>
               <a:defRPr sz="1050" b="0" i="0">
                 <a:solidFill>
                   <a:srgbClr val="AEB6C5"/>
@@ -2839,6 +2855,7 @@
           <a:lstStyle xmlns:a="http://schemas.openxmlformats.org/drawingml/2006/main"/>
           <a:p xmlns:a="http://schemas.openxmlformats.org/drawingml/2006/main">
             <a:pPr algn="l">
+              <a:buNone/>
               <a:defRPr sz="900" b="1" i="0">
                 <a:solidFill>
                   <a:srgbClr val="3157FF"/>
@@ -2889,6 +2906,7 @@
           <a:lstStyle xmlns:a="http://schemas.openxmlformats.org/drawingml/2006/main"/>
           <a:p xmlns:a="http://schemas.openxmlformats.org/drawingml/2006/main">
             <a:pPr algn="l">
+              <a:buNone/>
               <a:defRPr sz="1575" b="1" i="0">
                 <a:solidFill>
                   <a:srgbClr val="FFFFFF"/>
@@ -2939,6 +2957,7 @@
           <a:lstStyle xmlns:a="http://schemas.openxmlformats.org/drawingml/2006/main"/>
           <a:p xmlns:a="http://schemas.openxmlformats.org/drawingml/2006/main">
             <a:pPr algn="l">
+              <a:buNone/>
               <a:defRPr sz="1050" b="0" i="0">
                 <a:solidFill>
                   <a:srgbClr val="AEB6C5"/>
@@ -3020,6 +3039,7 @@
           <a:lstStyle xmlns:a="http://schemas.openxmlformats.org/drawingml/2006/main"/>
           <a:p xmlns:a="http://schemas.openxmlformats.org/drawingml/2006/main">
             <a:pPr algn="l">
+              <a:buNone/>
               <a:defRPr sz="900" b="1" i="0">
                 <a:solidFill>
                   <a:srgbClr val="3157FF"/>
@@ -3070,6 +3090,7 @@
           <a:lstStyle xmlns:a="http://schemas.openxmlformats.org/drawingml/2006/main"/>
           <a:p xmlns:a="http://schemas.openxmlformats.org/drawingml/2006/main">
             <a:pPr algn="l">
+              <a:buNone/>
               <a:defRPr sz="1575" b="1" i="0">
                 <a:solidFill>
                   <a:srgbClr val="FFFFFF"/>
@@ -3120,6 +3141,7 @@
           <a:lstStyle xmlns:a="http://schemas.openxmlformats.org/drawingml/2006/main"/>
           <a:p xmlns:a="http://schemas.openxmlformats.org/drawingml/2006/main">
             <a:pPr algn="l">
+              <a:buNone/>
               <a:defRPr sz="1050" b="0" i="0">
                 <a:solidFill>
                   <a:srgbClr val="AEB6C5"/>
@@ -3199,6 +3221,7 @@
           <a:lstStyle xmlns:a="http://schemas.openxmlformats.org/drawingml/2006/main"/>
           <a:p xmlns:a="http://schemas.openxmlformats.org/drawingml/2006/main">
             <a:pPr algn="l">
+              <a:buNone/>
               <a:defRPr sz="975" b="1" i="0">
                 <a:solidFill>
                   <a:srgbClr val="3157FF"/>
@@ -3280,6 +3303,7 @@
           <a:lstStyle xmlns:a="http://schemas.openxmlformats.org/drawingml/2006/main"/>
           <a:p xmlns:a="http://schemas.openxmlformats.org/drawingml/2006/main">
             <a:pPr algn="l">
+              <a:buNone/>
               <a:defRPr sz="975" b="1" i="0">
                 <a:solidFill>
                   <a:srgbClr val="5B6472"/>
@@ -3330,6 +3354,7 @@
           <a:lstStyle xmlns:a="http://schemas.openxmlformats.org/drawingml/2006/main"/>
           <a:p xmlns:a="http://schemas.openxmlformats.org/drawingml/2006/main">
             <a:pPr algn="l">
+              <a:buNone/>
               <a:defRPr sz="2700" b="1" i="0">
                 <a:solidFill>
                   <a:srgbClr val="121722"/>
@@ -3342,7 +3367,7 @@
                   <a:srgbClr val="121722"/>
                 </a:solidFill>
               </a:rPr>
-              <a:t>AI-DLC: AI를 활용한 문제 분석과 검증</a:t>
+              <a:t>AI-DLC 기반 문제 분석과 검증</a:t>
             </a:r>
           </a:p>
         </p:txBody>
@@ -3380,6 +3405,7 @@
           <a:lstStyle xmlns:a="http://schemas.openxmlformats.org/drawingml/2006/main"/>
           <a:p xmlns:a="http://schemas.openxmlformats.org/drawingml/2006/main">
             <a:pPr algn="l">
+              <a:buNone/>
               <a:defRPr sz="1350" b="0" i="0">
                 <a:solidFill>
                   <a:srgbClr val="5B6472"/>
@@ -3392,7 +3418,7 @@
                   <a:srgbClr val="5B6472"/>
                 </a:solidFill>
               </a:rPr>
-              <a:t>AI의 후보 제안과 개발자의 근거 검증을 분리한 업무 방식</a:t>
+              <a:t>AI-Driven Development Life Cycle · AI가 제안하고 개발자가 근거로 검증하는 업무 방식</a:t>
             </a:r>
           </a:p>
         </p:txBody>
@@ -3430,6 +3456,7 @@
           <a:lstStyle xmlns:a="http://schemas.openxmlformats.org/drawingml/2006/main"/>
           <a:p xmlns:a="http://schemas.openxmlformats.org/drawingml/2006/main">
             <a:pPr algn="l">
+              <a:buNone/>
               <a:defRPr sz="900" b="1" i="0">
                 <a:solidFill>
                   <a:srgbClr val="3157FF"/>
@@ -3511,6 +3538,7 @@
           <a:lstStyle xmlns:a="http://schemas.openxmlformats.org/drawingml/2006/main"/>
           <a:p xmlns:a="http://schemas.openxmlformats.org/drawingml/2006/main">
             <a:pPr algn="l">
+              <a:buNone/>
               <a:defRPr sz="1800" b="1" i="0">
                 <a:solidFill>
                   <a:srgbClr val="121722"/>
@@ -3561,6 +3589,7 @@
           <a:lstStyle xmlns:a="http://schemas.openxmlformats.org/drawingml/2006/main"/>
           <a:p xmlns:a="http://schemas.openxmlformats.org/drawingml/2006/main">
             <a:pPr algn="l">
+              <a:buNone/>
               <a:defRPr sz="1200" b="0" i="0">
                 <a:solidFill>
                   <a:srgbClr val="5B6472"/>
@@ -3578,6 +3607,7 @@
           </a:p>
           <a:p xmlns:a="http://schemas.openxmlformats.org/drawingml/2006/main">
             <a:pPr algn="l">
+              <a:buNone/>
               <a:defRPr sz="1200" b="0" i="0">
                 <a:solidFill>
                   <a:srgbClr val="5B6472"/>
@@ -3628,6 +3658,7 @@
           <a:lstStyle xmlns:a="http://schemas.openxmlformats.org/drawingml/2006/main"/>
           <a:p xmlns:a="http://schemas.openxmlformats.org/drawingml/2006/main">
             <a:pPr algn="l">
+              <a:buNone/>
               <a:defRPr sz="900" b="1" i="0">
                 <a:solidFill>
                   <a:srgbClr val="EE6A5F"/>
@@ -3709,6 +3740,7 @@
           <a:lstStyle xmlns:a="http://schemas.openxmlformats.org/drawingml/2006/main"/>
           <a:p xmlns:a="http://schemas.openxmlformats.org/drawingml/2006/main">
             <a:pPr algn="l">
+              <a:buNone/>
               <a:defRPr sz="1800" b="1" i="0">
                 <a:solidFill>
                   <a:srgbClr val="121722"/>
@@ -3759,6 +3791,7 @@
           <a:lstStyle xmlns:a="http://schemas.openxmlformats.org/drawingml/2006/main"/>
           <a:p xmlns:a="http://schemas.openxmlformats.org/drawingml/2006/main">
             <a:pPr algn="l">
+              <a:buNone/>
               <a:defRPr sz="1200" b="0" i="0">
                 <a:solidFill>
                   <a:srgbClr val="5B6472"/>
@@ -3776,6 +3809,7 @@
           </a:p>
           <a:p xmlns:a="http://schemas.openxmlformats.org/drawingml/2006/main">
             <a:pPr algn="l">
+              <a:buNone/>
               <a:defRPr sz="1200" b="0" i="0">
                 <a:solidFill>
                   <a:srgbClr val="5B6472"/>
@@ -3826,6 +3860,7 @@
           <a:lstStyle xmlns:a="http://schemas.openxmlformats.org/drawingml/2006/main"/>
           <a:p xmlns:a="http://schemas.openxmlformats.org/drawingml/2006/main">
             <a:pPr algn="l">
+              <a:buNone/>
               <a:defRPr sz="900" b="1" i="0">
                 <a:solidFill>
                   <a:srgbClr val="0F9F7A"/>
@@ -3907,6 +3942,7 @@
           <a:lstStyle xmlns:a="http://schemas.openxmlformats.org/drawingml/2006/main"/>
           <a:p xmlns:a="http://schemas.openxmlformats.org/drawingml/2006/main">
             <a:pPr algn="l">
+              <a:buNone/>
               <a:defRPr sz="1800" b="1" i="0">
                 <a:solidFill>
                   <a:srgbClr val="121722"/>
@@ -3957,6 +3993,7 @@
           <a:lstStyle xmlns:a="http://schemas.openxmlformats.org/drawingml/2006/main"/>
           <a:p xmlns:a="http://schemas.openxmlformats.org/drawingml/2006/main">
             <a:pPr algn="l">
+              <a:buNone/>
               <a:defRPr sz="1200" b="0" i="0">
                 <a:solidFill>
                   <a:srgbClr val="5B6472"/>
@@ -3974,6 +4011,7 @@
           </a:p>
           <a:p xmlns:a="http://schemas.openxmlformats.org/drawingml/2006/main">
             <a:pPr algn="l">
+              <a:buNone/>
               <a:defRPr sz="1200" b="0" i="0">
                 <a:solidFill>
                   <a:srgbClr val="5B6472"/>
@@ -4024,6 +4062,7 @@
           <a:lstStyle xmlns:a="http://schemas.openxmlformats.org/drawingml/2006/main"/>
           <a:p xmlns:a="http://schemas.openxmlformats.org/drawingml/2006/main">
             <a:pPr algn="l">
+              <a:buNone/>
               <a:defRPr sz="900" b="1" i="0">
                 <a:solidFill>
                   <a:srgbClr val="3157FF"/>
@@ -4105,6 +4144,7 @@
           <a:lstStyle xmlns:a="http://schemas.openxmlformats.org/drawingml/2006/main"/>
           <a:p xmlns:a="http://schemas.openxmlformats.org/drawingml/2006/main">
             <a:pPr algn="l">
+              <a:buNone/>
               <a:defRPr sz="1800" b="1" i="0">
                 <a:solidFill>
                   <a:srgbClr val="121722"/>
@@ -4155,6 +4195,7 @@
           <a:lstStyle xmlns:a="http://schemas.openxmlformats.org/drawingml/2006/main"/>
           <a:p xmlns:a="http://schemas.openxmlformats.org/drawingml/2006/main">
             <a:pPr algn="l">
+              <a:buNone/>
               <a:defRPr sz="1200" b="0" i="0">
                 <a:solidFill>
                   <a:srgbClr val="5B6472"/>
@@ -4172,6 +4213,7 @@
           </a:p>
           <a:p xmlns:a="http://schemas.openxmlformats.org/drawingml/2006/main">
             <a:pPr algn="l">
+              <a:buNone/>
               <a:defRPr sz="1200" b="0" i="0">
                 <a:solidFill>
                   <a:srgbClr val="5B6472"/>
@@ -4253,6 +4295,7 @@
           <a:lstStyle xmlns:a="http://schemas.openxmlformats.org/drawingml/2006/main"/>
           <a:p xmlns:a="http://schemas.openxmlformats.org/drawingml/2006/main">
             <a:pPr algn="l">
+              <a:buNone/>
               <a:defRPr sz="825" b="1" i="0">
                 <a:solidFill>
                   <a:srgbClr val="8993A7"/>
@@ -4303,6 +4346,7 @@
           <a:lstStyle xmlns:a="http://schemas.openxmlformats.org/drawingml/2006/main"/>
           <a:p xmlns:a="http://schemas.openxmlformats.org/drawingml/2006/main">
             <a:pPr algn="l">
+              <a:buNone/>
               <a:defRPr sz="900" b="1" i="0">
                 <a:solidFill>
                   <a:srgbClr val="85A0FF"/>
@@ -4353,6 +4397,7 @@
           <a:lstStyle xmlns:a="http://schemas.openxmlformats.org/drawingml/2006/main"/>
           <a:p xmlns:a="http://schemas.openxmlformats.org/drawingml/2006/main">
             <a:pPr algn="l">
+              <a:buNone/>
               <a:defRPr sz="1200" b="1" i="0">
                 <a:solidFill>
                   <a:srgbClr val="FFFFFF"/>
@@ -4370,6 +4415,7 @@
           </a:p>
           <a:p xmlns:a="http://schemas.openxmlformats.org/drawingml/2006/main">
             <a:pPr algn="l">
+              <a:buNone/>
               <a:defRPr sz="1200" b="1" i="0">
                 <a:solidFill>
                   <a:srgbClr val="FFFFFF"/>
@@ -4451,6 +4497,7 @@
           <a:lstStyle xmlns:a="http://schemas.openxmlformats.org/drawingml/2006/main"/>
           <a:p xmlns:a="http://schemas.openxmlformats.org/drawingml/2006/main">
             <a:pPr algn="l">
+              <a:buNone/>
               <a:defRPr sz="900" b="1" i="0">
                 <a:solidFill>
                   <a:srgbClr val="54D3AD"/>
@@ -4501,6 +4548,7 @@
           <a:lstStyle xmlns:a="http://schemas.openxmlformats.org/drawingml/2006/main"/>
           <a:p xmlns:a="http://schemas.openxmlformats.org/drawingml/2006/main">
             <a:pPr algn="l">
+              <a:buNone/>
               <a:defRPr sz="1200" b="1" i="0">
                 <a:solidFill>
                   <a:srgbClr val="FFFFFF"/>
@@ -4518,6 +4566,7 @@
           </a:p>
           <a:p xmlns:a="http://schemas.openxmlformats.org/drawingml/2006/main">
             <a:pPr algn="l">
+              <a:buNone/>
               <a:defRPr sz="1200" b="1" i="0">
                 <a:solidFill>
                   <a:srgbClr val="FFFFFF"/>
@@ -4599,6 +4648,7 @@
           <a:lstStyle xmlns:a="http://schemas.openxmlformats.org/drawingml/2006/main"/>
           <a:p xmlns:a="http://schemas.openxmlformats.org/drawingml/2006/main">
             <a:pPr algn="l">
+              <a:buNone/>
               <a:defRPr sz="675" b="1" i="0">
                 <a:solidFill>
                   <a:srgbClr val="9AA3B2"/>
@@ -4649,6 +4699,7 @@
           <a:lstStyle xmlns:a="http://schemas.openxmlformats.org/drawingml/2006/main"/>
           <a:p xmlns:a="http://schemas.openxmlformats.org/drawingml/2006/main">
             <a:pPr algn="r">
+              <a:buNone/>
               <a:defRPr sz="750" b="1" i="0">
                 <a:solidFill>
                   <a:srgbClr val="9AA3B2"/>
@@ -4728,6 +4779,7 @@
           <a:lstStyle xmlns:a="http://schemas.openxmlformats.org/drawingml/2006/main"/>
           <a:p xmlns:a="http://schemas.openxmlformats.org/drawingml/2006/main">
             <a:pPr algn="l">
+              <a:buNone/>
               <a:defRPr sz="975" b="1" i="0">
                 <a:solidFill>
                   <a:srgbClr val="3157FF"/>
@@ -4809,6 +4861,7 @@
           <a:lstStyle xmlns:a="http://schemas.openxmlformats.org/drawingml/2006/main"/>
           <a:p xmlns:a="http://schemas.openxmlformats.org/drawingml/2006/main">
             <a:pPr algn="l">
+              <a:buNone/>
               <a:defRPr sz="975" b="1" i="0">
                 <a:solidFill>
                   <a:srgbClr val="5B6472"/>
@@ -4859,6 +4912,7 @@
           <a:lstStyle xmlns:a="http://schemas.openxmlformats.org/drawingml/2006/main"/>
           <a:p xmlns:a="http://schemas.openxmlformats.org/drawingml/2006/main">
             <a:pPr algn="l">
+              <a:buNone/>
               <a:defRPr sz="2700" b="1" i="0">
                 <a:solidFill>
                   <a:srgbClr val="121722"/>
@@ -4909,6 +4963,7 @@
           <a:lstStyle xmlns:a="http://schemas.openxmlformats.org/drawingml/2006/main"/>
           <a:p xmlns:a="http://schemas.openxmlformats.org/drawingml/2006/main">
             <a:pPr algn="l">
+              <a:buNone/>
               <a:defRPr sz="1350" b="0" i="0">
                 <a:solidFill>
                   <a:srgbClr val="5B6472"/>
@@ -4959,6 +5014,7 @@
           <a:lstStyle xmlns:a="http://schemas.openxmlformats.org/drawingml/2006/main"/>
           <a:p xmlns:a="http://schemas.openxmlformats.org/drawingml/2006/main">
             <a:pPr algn="l">
+              <a:buNone/>
               <a:defRPr sz="825" b="1" i="0">
                 <a:solidFill>
                   <a:srgbClr val="9AA3B2"/>
@@ -5009,6 +5065,7 @@
           <a:lstStyle xmlns:a="http://schemas.openxmlformats.org/drawingml/2006/main"/>
           <a:p xmlns:a="http://schemas.openxmlformats.org/drawingml/2006/main">
             <a:pPr algn="l">
+              <a:buNone/>
               <a:defRPr sz="825" b="1" i="0">
                 <a:solidFill>
                   <a:srgbClr val="9AA3B2"/>
@@ -5059,6 +5116,7 @@
           <a:lstStyle xmlns:a="http://schemas.openxmlformats.org/drawingml/2006/main"/>
           <a:p xmlns:a="http://schemas.openxmlformats.org/drawingml/2006/main">
             <a:pPr algn="l">
+              <a:buNone/>
               <a:defRPr sz="825" b="1" i="0">
                 <a:solidFill>
                   <a:srgbClr val="9AA3B2"/>
@@ -5109,6 +5167,7 @@
           <a:lstStyle xmlns:a="http://schemas.openxmlformats.org/drawingml/2006/main"/>
           <a:p xmlns:a="http://schemas.openxmlformats.org/drawingml/2006/main">
             <a:pPr algn="l">
+              <a:buNone/>
               <a:defRPr sz="825" b="1" i="0">
                 <a:solidFill>
                   <a:srgbClr val="9AA3B2"/>
@@ -5190,6 +5249,7 @@
           <a:lstStyle xmlns:a="http://schemas.openxmlformats.org/drawingml/2006/main"/>
           <a:p xmlns:a="http://schemas.openxmlformats.org/drawingml/2006/main">
             <a:pPr algn="l">
+              <a:buNone/>
               <a:defRPr sz="1350" b="1" i="0">
                 <a:solidFill>
                   <a:srgbClr val="3157FF"/>
@@ -5240,6 +5300,7 @@
           <a:lstStyle xmlns:a="http://schemas.openxmlformats.org/drawingml/2006/main"/>
           <a:p xmlns:a="http://schemas.openxmlformats.org/drawingml/2006/main">
             <a:pPr algn="l">
+              <a:buNone/>
               <a:defRPr sz="1200" b="0" i="0">
                 <a:solidFill>
                   <a:srgbClr val="5B6472"/>
@@ -5290,6 +5351,7 @@
           <a:lstStyle xmlns:a="http://schemas.openxmlformats.org/drawingml/2006/main"/>
           <a:p xmlns:a="http://schemas.openxmlformats.org/drawingml/2006/main">
             <a:pPr algn="l">
+              <a:buNone/>
               <a:defRPr sz="1200" b="0" i="0">
                 <a:solidFill>
                   <a:srgbClr val="5B6472"/>
@@ -5340,6 +5402,7 @@
           <a:lstStyle xmlns:a="http://schemas.openxmlformats.org/drawingml/2006/main"/>
           <a:p xmlns:a="http://schemas.openxmlformats.org/drawingml/2006/main">
             <a:pPr algn="l">
+              <a:buNone/>
               <a:defRPr sz="1200" b="1" i="0">
                 <a:solidFill>
                   <a:srgbClr val="121722"/>
@@ -5421,6 +5484,7 @@
           <a:lstStyle xmlns:a="http://schemas.openxmlformats.org/drawingml/2006/main"/>
           <a:p xmlns:a="http://schemas.openxmlformats.org/drawingml/2006/main">
             <a:pPr algn="l">
+              <a:buNone/>
               <a:defRPr sz="1350" b="1" i="0">
                 <a:solidFill>
                   <a:srgbClr val="121722"/>
@@ -5471,6 +5535,7 @@
           <a:lstStyle xmlns:a="http://schemas.openxmlformats.org/drawingml/2006/main"/>
           <a:p xmlns:a="http://schemas.openxmlformats.org/drawingml/2006/main">
             <a:pPr algn="l">
+              <a:buNone/>
               <a:defRPr sz="1200" b="0" i="0">
                 <a:solidFill>
                   <a:srgbClr val="5B6472"/>
@@ -5521,6 +5586,7 @@
           <a:lstStyle xmlns:a="http://schemas.openxmlformats.org/drawingml/2006/main"/>
           <a:p xmlns:a="http://schemas.openxmlformats.org/drawingml/2006/main">
             <a:pPr algn="l">
+              <a:buNone/>
               <a:defRPr sz="1200" b="0" i="0">
                 <a:solidFill>
                   <a:srgbClr val="5B6472"/>
@@ -5571,6 +5637,7 @@
           <a:lstStyle xmlns:a="http://schemas.openxmlformats.org/drawingml/2006/main"/>
           <a:p xmlns:a="http://schemas.openxmlformats.org/drawingml/2006/main">
             <a:pPr algn="l">
+              <a:buNone/>
               <a:defRPr sz="1200" b="1" i="0">
                 <a:solidFill>
                   <a:srgbClr val="121722"/>
@@ -5652,6 +5719,7 @@
           <a:lstStyle xmlns:a="http://schemas.openxmlformats.org/drawingml/2006/main"/>
           <a:p xmlns:a="http://schemas.openxmlformats.org/drawingml/2006/main">
             <a:pPr algn="l">
+              <a:buNone/>
               <a:defRPr sz="1350" b="1" i="0">
                 <a:solidFill>
                   <a:srgbClr val="121722"/>
@@ -5702,6 +5770,7 @@
           <a:lstStyle xmlns:a="http://schemas.openxmlformats.org/drawingml/2006/main"/>
           <a:p xmlns:a="http://schemas.openxmlformats.org/drawingml/2006/main">
             <a:pPr algn="l">
+              <a:buNone/>
               <a:defRPr sz="1200" b="0" i="0">
                 <a:solidFill>
                   <a:srgbClr val="5B6472"/>
@@ -5752,6 +5821,7 @@
           <a:lstStyle xmlns:a="http://schemas.openxmlformats.org/drawingml/2006/main"/>
           <a:p xmlns:a="http://schemas.openxmlformats.org/drawingml/2006/main">
             <a:pPr algn="l">
+              <a:buNone/>
               <a:defRPr sz="1200" b="0" i="0">
                 <a:solidFill>
                   <a:srgbClr val="5B6472"/>
@@ -5802,6 +5872,7 @@
           <a:lstStyle xmlns:a="http://schemas.openxmlformats.org/drawingml/2006/main"/>
           <a:p xmlns:a="http://schemas.openxmlformats.org/drawingml/2006/main">
             <a:pPr algn="l">
+              <a:buNone/>
               <a:defRPr sz="1200" b="1" i="0">
                 <a:solidFill>
                   <a:srgbClr val="121722"/>
@@ -5883,6 +5954,7 @@
           <a:lstStyle xmlns:a="http://schemas.openxmlformats.org/drawingml/2006/main"/>
           <a:p xmlns:a="http://schemas.openxmlformats.org/drawingml/2006/main">
             <a:pPr algn="l">
+              <a:buNone/>
               <a:defRPr sz="1350" b="1" i="0">
                 <a:solidFill>
                   <a:srgbClr val="121722"/>
@@ -5933,6 +6005,7 @@
           <a:lstStyle xmlns:a="http://schemas.openxmlformats.org/drawingml/2006/main"/>
           <a:p xmlns:a="http://schemas.openxmlformats.org/drawingml/2006/main">
             <a:pPr algn="l">
+              <a:buNone/>
               <a:defRPr sz="1200" b="0" i="0">
                 <a:solidFill>
                   <a:srgbClr val="5B6472"/>
@@ -5983,6 +6056,7 @@
           <a:lstStyle xmlns:a="http://schemas.openxmlformats.org/drawingml/2006/main"/>
           <a:p xmlns:a="http://schemas.openxmlformats.org/drawingml/2006/main">
             <a:pPr algn="l">
+              <a:buNone/>
               <a:defRPr sz="1200" b="0" i="0">
                 <a:solidFill>
                   <a:srgbClr val="5B6472"/>
@@ -6033,6 +6107,7 @@
           <a:lstStyle xmlns:a="http://schemas.openxmlformats.org/drawingml/2006/main"/>
           <a:p xmlns:a="http://schemas.openxmlformats.org/drawingml/2006/main">
             <a:pPr algn="l">
+              <a:buNone/>
               <a:defRPr sz="1200" b="1" i="0">
                 <a:solidFill>
                   <a:srgbClr val="121722"/>
@@ -6114,6 +6189,7 @@
           <a:lstStyle xmlns:a="http://schemas.openxmlformats.org/drawingml/2006/main"/>
           <a:p xmlns:a="http://schemas.openxmlformats.org/drawingml/2006/main">
             <a:pPr algn="l">
+              <a:buNone/>
               <a:defRPr sz="1125" b="1" i="0">
                 <a:solidFill>
                   <a:srgbClr val="3157FF"/>
@@ -6164,6 +6240,7 @@
           <a:lstStyle xmlns:a="http://schemas.openxmlformats.org/drawingml/2006/main"/>
           <a:p xmlns:a="http://schemas.openxmlformats.org/drawingml/2006/main">
             <a:pPr algn="l">
+              <a:buNone/>
               <a:defRPr sz="1275" b="1" i="0">
                 <a:solidFill>
                   <a:srgbClr val="121722"/>
@@ -6245,6 +6322,7 @@
           <a:lstStyle xmlns:a="http://schemas.openxmlformats.org/drawingml/2006/main"/>
           <a:p xmlns:a="http://schemas.openxmlformats.org/drawingml/2006/main">
             <a:pPr algn="l">
+              <a:buNone/>
               <a:defRPr sz="675" b="1" i="0">
                 <a:solidFill>
                   <a:srgbClr val="9AA3B2"/>
@@ -6295,6 +6373,7 @@
           <a:lstStyle xmlns:a="http://schemas.openxmlformats.org/drawingml/2006/main"/>
           <a:p xmlns:a="http://schemas.openxmlformats.org/drawingml/2006/main">
             <a:pPr algn="r">
+              <a:buNone/>
               <a:defRPr sz="750" b="1" i="0">
                 <a:solidFill>
                   <a:srgbClr val="9AA3B2"/>
@@ -6405,6 +6484,7 @@
           <a:lstStyle xmlns:a="http://schemas.openxmlformats.org/drawingml/2006/main"/>
           <a:p xmlns:a="http://schemas.openxmlformats.org/drawingml/2006/main">
             <a:pPr algn="l">
+              <a:buNone/>
               <a:defRPr sz="975" b="1" i="0">
                 <a:solidFill>
                   <a:srgbClr val="3157FF"/>
@@ -6455,6 +6535,7 @@
           <a:lstStyle xmlns:a="http://schemas.openxmlformats.org/drawingml/2006/main"/>
           <a:p xmlns:a="http://schemas.openxmlformats.org/drawingml/2006/main">
             <a:pPr algn="l">
+              <a:buNone/>
               <a:defRPr sz="3450" b="1" i="0">
                 <a:solidFill>
                   <a:srgbClr val="121722"/>
@@ -6472,6 +6553,7 @@
           </a:p>
           <a:p xmlns:a="http://schemas.openxmlformats.org/drawingml/2006/main">
             <a:pPr algn="l">
+              <a:buNone/>
               <a:defRPr sz="3450" b="1" i="0">
                 <a:solidFill>
                   <a:srgbClr val="121722"/>
@@ -6522,6 +6604,7 @@
           <a:lstStyle xmlns:a="http://schemas.openxmlformats.org/drawingml/2006/main"/>
           <a:p xmlns:a="http://schemas.openxmlformats.org/drawingml/2006/main">
             <a:pPr algn="l">
+              <a:buNone/>
               <a:defRPr sz="1575" b="1" i="0">
                 <a:solidFill>
                   <a:srgbClr val="3157FF"/>
@@ -6572,6 +6655,7 @@
           <a:lstStyle xmlns:a="http://schemas.openxmlformats.org/drawingml/2006/main"/>
           <a:p xmlns:a="http://schemas.openxmlformats.org/drawingml/2006/main">
             <a:pPr algn="l">
+              <a:buNone/>
               <a:defRPr sz="1575" b="1" i="0">
                 <a:solidFill>
                   <a:srgbClr val="0F9F7A"/>
@@ -6622,6 +6706,7 @@
           <a:lstStyle xmlns:a="http://schemas.openxmlformats.org/drawingml/2006/main"/>
           <a:p xmlns:a="http://schemas.openxmlformats.org/drawingml/2006/main">
             <a:pPr algn="l">
+              <a:buNone/>
               <a:defRPr sz="1575" b="1" i="0">
                 <a:solidFill>
                   <a:srgbClr val="EE6A5F"/>
@@ -6703,6 +6788,7 @@
           <a:lstStyle xmlns:a="http://schemas.openxmlformats.org/drawingml/2006/main"/>
           <a:p xmlns:a="http://schemas.openxmlformats.org/drawingml/2006/main">
             <a:pPr algn="l">
+              <a:buNone/>
               <a:defRPr sz="900" b="1" i="0">
                 <a:solidFill>
                   <a:srgbClr val="9AA3B2"/>
@@ -6753,6 +6839,7 @@
           <a:lstStyle xmlns:a="http://schemas.openxmlformats.org/drawingml/2006/main"/>
           <a:p xmlns:a="http://schemas.openxmlformats.org/drawingml/2006/main">
             <a:pPr algn="l">
+              <a:buNone/>
               <a:defRPr sz="1200" b="0" i="0">
                 <a:solidFill>
                   <a:srgbClr val="121722"/>
@@ -6834,6 +6921,7 @@
           <a:lstStyle xmlns:a="http://schemas.openxmlformats.org/drawingml/2006/main"/>
           <a:p xmlns:a="http://schemas.openxmlformats.org/drawingml/2006/main">
             <a:pPr algn="l">
+              <a:buNone/>
               <a:defRPr sz="2325" b="1" i="0">
                 <a:solidFill>
                   <a:srgbClr val="FFFFFF"/>
@@ -6884,6 +6972,7 @@
           <a:lstStyle xmlns:a="http://schemas.openxmlformats.org/drawingml/2006/main"/>
           <a:p xmlns:a="http://schemas.openxmlformats.org/drawingml/2006/main">
             <a:pPr algn="l">
+              <a:buNone/>
               <a:defRPr sz="2325" b="1" i="0">
                 <a:solidFill>
                   <a:srgbClr val="FFFFFF"/>
@@ -6934,6 +7023,7 @@
           <a:lstStyle xmlns:a="http://schemas.openxmlformats.org/drawingml/2006/main"/>
           <a:p xmlns:a="http://schemas.openxmlformats.org/drawingml/2006/main">
             <a:pPr algn="l">
+              <a:buNone/>
               <a:defRPr sz="2325" b="1" i="0">
                 <a:solidFill>
                   <a:srgbClr val="FFFFFF"/>
@@ -6984,6 +7074,7 @@
           <a:lstStyle xmlns:a="http://schemas.openxmlformats.org/drawingml/2006/main"/>
           <a:p xmlns:a="http://schemas.openxmlformats.org/drawingml/2006/main">
             <a:pPr algn="l">
+              <a:buNone/>
               <a:defRPr sz="2325" b="1" i="0">
                 <a:solidFill>
                   <a:srgbClr val="FFFFFF"/>
@@ -7065,6 +7156,7 @@
           <a:lstStyle xmlns:a="http://schemas.openxmlformats.org/drawingml/2006/main"/>
           <a:p xmlns:a="http://schemas.openxmlformats.org/drawingml/2006/main">
             <a:pPr algn="l">
+              <a:buNone/>
               <a:defRPr sz="900" b="1" i="0">
                 <a:solidFill>
                   <a:srgbClr val="8993A7"/>
@@ -7144,6 +7236,7 @@
           <a:lstStyle xmlns:a="http://schemas.openxmlformats.org/drawingml/2006/main"/>
           <a:p xmlns:a="http://schemas.openxmlformats.org/drawingml/2006/main">
             <a:pPr algn="l">
+              <a:buNone/>
               <a:defRPr sz="975" b="1" i="0">
                 <a:solidFill>
                   <a:srgbClr val="3157FF"/>
@@ -7225,6 +7318,7 @@
           <a:lstStyle xmlns:a="http://schemas.openxmlformats.org/drawingml/2006/main"/>
           <a:p xmlns:a="http://schemas.openxmlformats.org/drawingml/2006/main">
             <a:pPr algn="l">
+              <a:buNone/>
               <a:defRPr sz="975" b="1" i="0">
                 <a:solidFill>
                   <a:srgbClr val="5B6472"/>
@@ -7275,6 +7369,7 @@
           <a:lstStyle xmlns:a="http://schemas.openxmlformats.org/drawingml/2006/main"/>
           <a:p xmlns:a="http://schemas.openxmlformats.org/drawingml/2006/main">
             <a:pPr algn="l">
+              <a:buNone/>
               <a:defRPr sz="2700" b="1" i="0">
                 <a:solidFill>
                   <a:srgbClr val="121722"/>
@@ -7325,6 +7420,7 @@
           <a:lstStyle xmlns:a="http://schemas.openxmlformats.org/drawingml/2006/main"/>
           <a:p xmlns:a="http://schemas.openxmlformats.org/drawingml/2006/main">
             <a:pPr algn="l">
+              <a:buNone/>
               <a:defRPr sz="1425" b="0" i="0">
                 <a:solidFill>
                   <a:srgbClr val="5B6472"/>
@@ -7375,6 +7471,7 @@
           <a:lstStyle xmlns:a="http://schemas.openxmlformats.org/drawingml/2006/main"/>
           <a:p xmlns:a="http://schemas.openxmlformats.org/drawingml/2006/main">
             <a:pPr algn="l">
+              <a:buNone/>
               <a:defRPr sz="825" b="1" i="0">
                 <a:solidFill>
                   <a:srgbClr val="3157FF"/>
@@ -7425,6 +7522,7 @@
           <a:lstStyle xmlns:a="http://schemas.openxmlformats.org/drawingml/2006/main"/>
           <a:p xmlns:a="http://schemas.openxmlformats.org/drawingml/2006/main">
             <a:pPr algn="l">
+              <a:buNone/>
               <a:defRPr sz="1650" b="1" i="0">
                 <a:solidFill>
                   <a:srgbClr val="121722"/>
@@ -7475,6 +7573,7 @@
           <a:lstStyle xmlns:a="http://schemas.openxmlformats.org/drawingml/2006/main"/>
           <a:p xmlns:a="http://schemas.openxmlformats.org/drawingml/2006/main">
             <a:pPr algn="l">
+              <a:buNone/>
               <a:defRPr sz="825" b="1" i="0">
                 <a:solidFill>
                   <a:srgbClr val="0F9F7A"/>
@@ -7525,6 +7624,7 @@
           <a:lstStyle xmlns:a="http://schemas.openxmlformats.org/drawingml/2006/main"/>
           <a:p xmlns:a="http://schemas.openxmlformats.org/drawingml/2006/main">
             <a:pPr algn="l">
+              <a:buNone/>
               <a:defRPr sz="1650" b="1" i="0">
                 <a:solidFill>
                   <a:srgbClr val="121722"/>
@@ -7575,6 +7675,7 @@
           <a:lstStyle xmlns:a="http://schemas.openxmlformats.org/drawingml/2006/main"/>
           <a:p xmlns:a="http://schemas.openxmlformats.org/drawingml/2006/main">
             <a:pPr algn="l">
+              <a:buNone/>
               <a:defRPr sz="825" b="1" i="0">
                 <a:solidFill>
                   <a:srgbClr val="EE6A5F"/>
@@ -7625,6 +7726,7 @@
           <a:lstStyle xmlns:a="http://schemas.openxmlformats.org/drawingml/2006/main"/>
           <a:p xmlns:a="http://schemas.openxmlformats.org/drawingml/2006/main">
             <a:pPr algn="l">
+              <a:buNone/>
               <a:defRPr sz="1650" b="1" i="0">
                 <a:solidFill>
                   <a:srgbClr val="121722"/>
@@ -7737,6 +7839,7 @@
           <a:lstStyle xmlns:a="http://schemas.openxmlformats.org/drawingml/2006/main"/>
           <a:p xmlns:a="http://schemas.openxmlformats.org/drawingml/2006/main">
             <a:pPr algn="l">
+              <a:buNone/>
               <a:defRPr sz="1350" b="0" i="0">
                 <a:solidFill>
                   <a:srgbClr val="121722"/>
@@ -7818,6 +7921,7 @@
           <a:lstStyle xmlns:a="http://schemas.openxmlformats.org/drawingml/2006/main"/>
           <a:p xmlns:a="http://schemas.openxmlformats.org/drawingml/2006/main">
             <a:pPr algn="l">
+              <a:buNone/>
               <a:defRPr sz="1350" b="0" i="0">
                 <a:solidFill>
                   <a:srgbClr val="121722"/>
@@ -7899,6 +8003,7 @@
           <a:lstStyle xmlns:a="http://schemas.openxmlformats.org/drawingml/2006/main"/>
           <a:p xmlns:a="http://schemas.openxmlformats.org/drawingml/2006/main">
             <a:pPr algn="l">
+              <a:buNone/>
               <a:defRPr sz="1350" b="0" i="0">
                 <a:solidFill>
                   <a:srgbClr val="121722"/>
@@ -7980,6 +8085,7 @@
           <a:lstStyle xmlns:a="http://schemas.openxmlformats.org/drawingml/2006/main"/>
           <a:p xmlns:a="http://schemas.openxmlformats.org/drawingml/2006/main">
             <a:pPr algn="l">
+              <a:buNone/>
               <a:defRPr sz="825" b="1" i="0">
                 <a:solidFill>
                   <a:srgbClr val="8993A7"/>
@@ -8030,6 +8136,7 @@
           <a:lstStyle xmlns:a="http://schemas.openxmlformats.org/drawingml/2006/main"/>
           <a:p xmlns:a="http://schemas.openxmlformats.org/drawingml/2006/main">
             <a:pPr algn="l">
+              <a:buNone/>
               <a:defRPr sz="1575" b="1" i="0">
                 <a:solidFill>
                   <a:srgbClr val="FFFFFF"/>
@@ -8080,6 +8187,7 @@
           <a:lstStyle xmlns:a="http://schemas.openxmlformats.org/drawingml/2006/main"/>
           <a:p xmlns:a="http://schemas.openxmlformats.org/drawingml/2006/main">
             <a:pPr algn="l">
+              <a:buNone/>
               <a:defRPr sz="1575" b="1" i="0">
                 <a:solidFill>
                   <a:srgbClr val="FFFFFF"/>
@@ -8130,6 +8238,7 @@
           <a:lstStyle xmlns:a="http://schemas.openxmlformats.org/drawingml/2006/main"/>
           <a:p xmlns:a="http://schemas.openxmlformats.org/drawingml/2006/main">
             <a:pPr algn="l">
+              <a:buNone/>
               <a:defRPr sz="1575" b="1" i="0">
                 <a:solidFill>
                   <a:srgbClr val="FFFFFF"/>
@@ -8180,6 +8289,7 @@
           <a:lstStyle xmlns:a="http://schemas.openxmlformats.org/drawingml/2006/main"/>
           <a:p xmlns:a="http://schemas.openxmlformats.org/drawingml/2006/main">
             <a:pPr algn="l">
+              <a:buNone/>
               <a:defRPr sz="1575" b="1" i="0">
                 <a:solidFill>
                   <a:srgbClr val="FFFFFF"/>
@@ -8230,6 +8340,7 @@
           <a:lstStyle xmlns:a="http://schemas.openxmlformats.org/drawingml/2006/main"/>
           <a:p xmlns:a="http://schemas.openxmlformats.org/drawingml/2006/main">
             <a:pPr algn="l">
+              <a:buNone/>
               <a:defRPr sz="1125" b="0" i="0">
                 <a:solidFill>
                   <a:srgbClr val="5B6472"/>
@@ -8311,6 +8422,7 @@
           <a:lstStyle xmlns:a="http://schemas.openxmlformats.org/drawingml/2006/main"/>
           <a:p xmlns:a="http://schemas.openxmlformats.org/drawingml/2006/main">
             <a:pPr algn="l">
+              <a:buNone/>
               <a:defRPr sz="675" b="1" i="0">
                 <a:solidFill>
                   <a:srgbClr val="9AA3B2"/>
@@ -8361,6 +8473,7 @@
           <a:lstStyle xmlns:a="http://schemas.openxmlformats.org/drawingml/2006/main"/>
           <a:p xmlns:a="http://schemas.openxmlformats.org/drawingml/2006/main">
             <a:pPr algn="r">
+              <a:buNone/>
               <a:defRPr sz="750" b="1" i="0">
                 <a:solidFill>
                   <a:srgbClr val="9AA3B2"/>
@@ -8440,6 +8553,7 @@
           <a:lstStyle xmlns:a="http://schemas.openxmlformats.org/drawingml/2006/main"/>
           <a:p xmlns:a="http://schemas.openxmlformats.org/drawingml/2006/main">
             <a:pPr algn="l">
+              <a:buNone/>
               <a:defRPr sz="975" b="1" i="0">
                 <a:solidFill>
                   <a:srgbClr val="3157FF"/>
@@ -8521,6 +8635,7 @@
           <a:lstStyle xmlns:a="http://schemas.openxmlformats.org/drawingml/2006/main"/>
           <a:p xmlns:a="http://schemas.openxmlformats.org/drawingml/2006/main">
             <a:pPr algn="l">
+              <a:buNone/>
               <a:defRPr sz="975" b="1" i="0">
                 <a:solidFill>
                   <a:srgbClr val="5B6472"/>
@@ -8571,6 +8686,7 @@
           <a:lstStyle xmlns:a="http://schemas.openxmlformats.org/drawingml/2006/main"/>
           <a:p xmlns:a="http://schemas.openxmlformats.org/drawingml/2006/main">
             <a:pPr algn="l">
+              <a:buNone/>
               <a:defRPr sz="2700" b="1" i="0">
                 <a:solidFill>
                   <a:srgbClr val="121722"/>
@@ -8621,6 +8737,7 @@
           <a:lstStyle xmlns:a="http://schemas.openxmlformats.org/drawingml/2006/main"/>
           <a:p xmlns:a="http://schemas.openxmlformats.org/drawingml/2006/main">
             <a:pPr algn="l">
+              <a:buNone/>
               <a:defRPr sz="1350" b="0" i="0">
                 <a:solidFill>
                   <a:srgbClr val="5B6472"/>
@@ -8671,6 +8788,7 @@
           <a:lstStyle xmlns:a="http://schemas.openxmlformats.org/drawingml/2006/main"/>
           <a:p xmlns:a="http://schemas.openxmlformats.org/drawingml/2006/main">
             <a:pPr algn="l">
+              <a:buNone/>
               <a:defRPr sz="825" b="1" i="0">
                 <a:solidFill>
                   <a:srgbClr val="9AA3B2"/>
@@ -8721,6 +8839,7 @@
           <a:lstStyle xmlns:a="http://schemas.openxmlformats.org/drawingml/2006/main"/>
           <a:p xmlns:a="http://schemas.openxmlformats.org/drawingml/2006/main">
             <a:pPr algn="l">
+              <a:buNone/>
               <a:defRPr sz="825" b="1" i="0">
                 <a:solidFill>
                   <a:srgbClr val="9AA3B2"/>
@@ -8864,6 +8983,7 @@
           <a:lstStyle xmlns:a="http://schemas.openxmlformats.org/drawingml/2006/main"/>
           <a:p xmlns:a="http://schemas.openxmlformats.org/drawingml/2006/main">
             <a:pPr algn="l">
+              <a:buNone/>
               <a:defRPr sz="900" b="1" i="0">
                 <a:solidFill>
                   <a:srgbClr val="9AA3B2"/>
@@ -8914,6 +9034,7 @@
           <a:lstStyle xmlns:a="http://schemas.openxmlformats.org/drawingml/2006/main"/>
           <a:p xmlns:a="http://schemas.openxmlformats.org/drawingml/2006/main">
             <a:pPr algn="l">
+              <a:buNone/>
               <a:defRPr sz="1800" b="1" i="0">
                 <a:solidFill>
                   <a:srgbClr val="121722"/>
@@ -8964,6 +9085,7 @@
           <a:lstStyle xmlns:a="http://schemas.openxmlformats.org/drawingml/2006/main"/>
           <a:p xmlns:a="http://schemas.openxmlformats.org/drawingml/2006/main">
             <a:pPr algn="l">
+              <a:buNone/>
               <a:defRPr sz="1125" b="1" i="0">
                 <a:solidFill>
                   <a:srgbClr val="3157FF"/>
@@ -9014,6 +9136,7 @@
           <a:lstStyle xmlns:a="http://schemas.openxmlformats.org/drawingml/2006/main"/>
           <a:p xmlns:a="http://schemas.openxmlformats.org/drawingml/2006/main">
             <a:pPr algn="l">
+              <a:buNone/>
               <a:defRPr sz="1200" b="0" i="0">
                 <a:solidFill>
                   <a:srgbClr val="5B6472"/>
@@ -9095,6 +9218,7 @@
           <a:lstStyle xmlns:a="http://schemas.openxmlformats.org/drawingml/2006/main"/>
           <a:p xmlns:a="http://schemas.openxmlformats.org/drawingml/2006/main">
             <a:pPr algn="l">
+              <a:buNone/>
               <a:defRPr sz="900" b="1" i="0">
                 <a:solidFill>
                   <a:srgbClr val="3157FF"/>
@@ -9145,6 +9269,7 @@
           <a:lstStyle xmlns:a="http://schemas.openxmlformats.org/drawingml/2006/main"/>
           <a:p xmlns:a="http://schemas.openxmlformats.org/drawingml/2006/main">
             <a:pPr algn="l">
+              <a:buNone/>
               <a:defRPr sz="1800" b="1" i="0">
                 <a:solidFill>
                   <a:srgbClr val="121722"/>
@@ -9195,6 +9320,7 @@
           <a:lstStyle xmlns:a="http://schemas.openxmlformats.org/drawingml/2006/main"/>
           <a:p xmlns:a="http://schemas.openxmlformats.org/drawingml/2006/main">
             <a:pPr algn="l">
+              <a:buNone/>
               <a:defRPr sz="1125" b="1" i="0">
                 <a:solidFill>
                   <a:srgbClr val="3157FF"/>
@@ -9276,6 +9402,7 @@
           <a:lstStyle xmlns:a="http://schemas.openxmlformats.org/drawingml/2006/main"/>
           <a:p xmlns:a="http://schemas.openxmlformats.org/drawingml/2006/main">
             <a:pPr algn="l">
+              <a:buNone/>
               <a:defRPr sz="825" b="1" i="0">
                 <a:solidFill>
                   <a:srgbClr val="3157FF"/>
@@ -9326,6 +9453,7 @@
           <a:lstStyle xmlns:a="http://schemas.openxmlformats.org/drawingml/2006/main"/>
           <a:p xmlns:a="http://schemas.openxmlformats.org/drawingml/2006/main">
             <a:pPr algn="l">
+              <a:buNone/>
               <a:defRPr sz="1425" b="1" i="0">
                 <a:solidFill>
                   <a:srgbClr val="121722"/>
@@ -9376,6 +9504,7 @@
           <a:lstStyle xmlns:a="http://schemas.openxmlformats.org/drawingml/2006/main"/>
           <a:p xmlns:a="http://schemas.openxmlformats.org/drawingml/2006/main">
             <a:pPr algn="l">
+              <a:buNone/>
               <a:defRPr sz="1125" b="0" i="0">
                 <a:solidFill>
                   <a:srgbClr val="5B6472"/>
@@ -9488,6 +9617,7 @@
           <a:lstStyle xmlns:a="http://schemas.openxmlformats.org/drawingml/2006/main"/>
           <a:p xmlns:a="http://schemas.openxmlformats.org/drawingml/2006/main">
             <a:pPr algn="l">
+              <a:buNone/>
               <a:defRPr sz="825" b="1" i="0">
                 <a:solidFill>
                   <a:srgbClr val="EE6A5F"/>
@@ -9538,6 +9668,7 @@
           <a:lstStyle xmlns:a="http://schemas.openxmlformats.org/drawingml/2006/main"/>
           <a:p xmlns:a="http://schemas.openxmlformats.org/drawingml/2006/main">
             <a:pPr algn="l">
+              <a:buNone/>
               <a:defRPr sz="1425" b="1" i="0">
                 <a:solidFill>
                   <a:srgbClr val="121722"/>
@@ -9588,6 +9719,7 @@
           <a:lstStyle xmlns:a="http://schemas.openxmlformats.org/drawingml/2006/main"/>
           <a:p xmlns:a="http://schemas.openxmlformats.org/drawingml/2006/main">
             <a:pPr algn="l">
+              <a:buNone/>
               <a:defRPr sz="1125" b="0" i="0">
                 <a:solidFill>
                   <a:srgbClr val="5B6472"/>
@@ -9700,6 +9832,7 @@
           <a:lstStyle xmlns:a="http://schemas.openxmlformats.org/drawingml/2006/main"/>
           <a:p xmlns:a="http://schemas.openxmlformats.org/drawingml/2006/main">
             <a:pPr algn="l">
+              <a:buNone/>
               <a:defRPr sz="825" b="1" i="0">
                 <a:solidFill>
                   <a:srgbClr val="0F9F7A"/>
@@ -9750,6 +9883,7 @@
           <a:lstStyle xmlns:a="http://schemas.openxmlformats.org/drawingml/2006/main"/>
           <a:p xmlns:a="http://schemas.openxmlformats.org/drawingml/2006/main">
             <a:pPr algn="l">
+              <a:buNone/>
               <a:defRPr sz="1425" b="1" i="0">
                 <a:solidFill>
                   <a:srgbClr val="121722"/>
@@ -9800,6 +9934,7 @@
           <a:lstStyle xmlns:a="http://schemas.openxmlformats.org/drawingml/2006/main"/>
           <a:p xmlns:a="http://schemas.openxmlformats.org/drawingml/2006/main">
             <a:pPr algn="l">
+              <a:buNone/>
               <a:defRPr sz="1125" b="0" i="0">
                 <a:solidFill>
                   <a:srgbClr val="5B6472"/>
@@ -9912,6 +10047,7 @@
           <a:lstStyle xmlns:a="http://schemas.openxmlformats.org/drawingml/2006/main"/>
           <a:p xmlns:a="http://schemas.openxmlformats.org/drawingml/2006/main">
             <a:pPr algn="l">
+              <a:buNone/>
               <a:defRPr sz="825" b="1" i="0">
                 <a:solidFill>
                   <a:srgbClr val="3157FF"/>
@@ -9962,6 +10098,7 @@
           <a:lstStyle xmlns:a="http://schemas.openxmlformats.org/drawingml/2006/main"/>
           <a:p xmlns:a="http://schemas.openxmlformats.org/drawingml/2006/main">
             <a:pPr algn="l">
+              <a:buNone/>
               <a:defRPr sz="1425" b="1" i="0">
                 <a:solidFill>
                   <a:srgbClr val="121722"/>
@@ -10012,6 +10149,7 @@
           <a:lstStyle xmlns:a="http://schemas.openxmlformats.org/drawingml/2006/main"/>
           <a:p xmlns:a="http://schemas.openxmlformats.org/drawingml/2006/main">
             <a:pPr algn="l">
+              <a:buNone/>
               <a:defRPr sz="1125" b="0" i="0">
                 <a:solidFill>
                   <a:srgbClr val="5B6472"/>
@@ -10093,6 +10231,7 @@
           <a:lstStyle xmlns:a="http://schemas.openxmlformats.org/drawingml/2006/main"/>
           <a:p xmlns:a="http://schemas.openxmlformats.org/drawingml/2006/main">
             <a:pPr algn="l">
+              <a:buNone/>
               <a:defRPr sz="675" b="1" i="0">
                 <a:solidFill>
                   <a:srgbClr val="9AA3B2"/>
@@ -10143,6 +10282,7 @@
           <a:lstStyle xmlns:a="http://schemas.openxmlformats.org/drawingml/2006/main"/>
           <a:p xmlns:a="http://schemas.openxmlformats.org/drawingml/2006/main">
             <a:pPr algn="r">
+              <a:buNone/>
               <a:defRPr sz="750" b="1" i="0">
                 <a:solidFill>
                   <a:srgbClr val="9AA3B2"/>
@@ -10222,6 +10362,7 @@
           <a:lstStyle xmlns:a="http://schemas.openxmlformats.org/drawingml/2006/main"/>
           <a:p xmlns:a="http://schemas.openxmlformats.org/drawingml/2006/main">
             <a:pPr algn="l">
+              <a:buNone/>
               <a:defRPr sz="975" b="1" i="0">
                 <a:solidFill>
                   <a:srgbClr val="3157FF"/>
@@ -10303,6 +10444,7 @@
           <a:lstStyle xmlns:a="http://schemas.openxmlformats.org/drawingml/2006/main"/>
           <a:p xmlns:a="http://schemas.openxmlformats.org/drawingml/2006/main">
             <a:pPr algn="l">
+              <a:buNone/>
               <a:defRPr sz="975" b="1" i="0">
                 <a:solidFill>
                   <a:srgbClr val="5B6472"/>
@@ -10353,6 +10495,7 @@
           <a:lstStyle xmlns:a="http://schemas.openxmlformats.org/drawingml/2006/main"/>
           <a:p xmlns:a="http://schemas.openxmlformats.org/drawingml/2006/main">
             <a:pPr algn="l">
+              <a:buNone/>
               <a:defRPr sz="2700" b="1" i="0">
                 <a:solidFill>
                   <a:srgbClr val="121722"/>
@@ -10403,6 +10546,7 @@
           <a:lstStyle xmlns:a="http://schemas.openxmlformats.org/drawingml/2006/main"/>
           <a:p xmlns:a="http://schemas.openxmlformats.org/drawingml/2006/main">
             <a:pPr algn="l">
+              <a:buNone/>
               <a:defRPr sz="1350" b="0" i="0">
                 <a:solidFill>
                   <a:srgbClr val="5B6472"/>
@@ -10486,6 +10630,7 @@
           <a:lstStyle xmlns:a="http://schemas.openxmlformats.org/drawingml/2006/main"/>
           <a:p xmlns:a="http://schemas.openxmlformats.org/drawingml/2006/main">
             <a:pPr algn="ctr">
+              <a:buNone/>
               <a:defRPr sz="900" b="1" i="0">
                 <a:solidFill>
                   <a:srgbClr val="3157FF"/>
@@ -10536,6 +10681,7 @@
           <a:lstStyle xmlns:a="http://schemas.openxmlformats.org/drawingml/2006/main"/>
           <a:p xmlns:a="http://schemas.openxmlformats.org/drawingml/2006/main">
             <a:pPr algn="l">
+              <a:buNone/>
               <a:defRPr sz="1050" b="1" i="0">
                 <a:solidFill>
                   <a:srgbClr val="3157FF"/>
@@ -10586,6 +10732,7 @@
           <a:lstStyle xmlns:a="http://schemas.openxmlformats.org/drawingml/2006/main"/>
           <a:p xmlns:a="http://schemas.openxmlformats.org/drawingml/2006/main">
             <a:pPr algn="l">
+              <a:buNone/>
               <a:defRPr sz="1350" b="1" i="0">
                 <a:solidFill>
                   <a:srgbClr val="121722"/>
@@ -10700,6 +10847,7 @@
           <a:lstStyle xmlns:a="http://schemas.openxmlformats.org/drawingml/2006/main"/>
           <a:p xmlns:a="http://schemas.openxmlformats.org/drawingml/2006/main">
             <a:pPr algn="ctr">
+              <a:buNone/>
               <a:defRPr sz="900" b="1" i="0">
                 <a:solidFill>
                   <a:srgbClr val="0F9F7A"/>
@@ -10750,6 +10898,7 @@
           <a:lstStyle xmlns:a="http://schemas.openxmlformats.org/drawingml/2006/main"/>
           <a:p xmlns:a="http://schemas.openxmlformats.org/drawingml/2006/main">
             <a:pPr algn="l">
+              <a:buNone/>
               <a:defRPr sz="1050" b="1" i="0">
                 <a:solidFill>
                   <a:srgbClr val="0F9F7A"/>
@@ -10800,6 +10949,7 @@
           <a:lstStyle xmlns:a="http://schemas.openxmlformats.org/drawingml/2006/main"/>
           <a:p xmlns:a="http://schemas.openxmlformats.org/drawingml/2006/main">
             <a:pPr algn="l">
+              <a:buNone/>
               <a:defRPr sz="1350" b="1" i="0">
                 <a:solidFill>
                   <a:srgbClr val="121722"/>
@@ -10914,6 +11064,7 @@
           <a:lstStyle xmlns:a="http://schemas.openxmlformats.org/drawingml/2006/main"/>
           <a:p xmlns:a="http://schemas.openxmlformats.org/drawingml/2006/main">
             <a:pPr algn="ctr">
+              <a:buNone/>
               <a:defRPr sz="900" b="1" i="0">
                 <a:solidFill>
                   <a:srgbClr val="EE6A5F"/>
@@ -10964,6 +11115,7 @@
           <a:lstStyle xmlns:a="http://schemas.openxmlformats.org/drawingml/2006/main"/>
           <a:p xmlns:a="http://schemas.openxmlformats.org/drawingml/2006/main">
             <a:pPr algn="l">
+              <a:buNone/>
               <a:defRPr sz="1050" b="1" i="0">
                 <a:solidFill>
                   <a:srgbClr val="EE6A5F"/>
@@ -11014,6 +11166,7 @@
           <a:lstStyle xmlns:a="http://schemas.openxmlformats.org/drawingml/2006/main"/>
           <a:p xmlns:a="http://schemas.openxmlformats.org/drawingml/2006/main">
             <a:pPr algn="l">
+              <a:buNone/>
               <a:defRPr sz="1350" b="1" i="0">
                 <a:solidFill>
                   <a:srgbClr val="121722"/>
@@ -11128,6 +11281,7 @@
           <a:lstStyle xmlns:a="http://schemas.openxmlformats.org/drawingml/2006/main"/>
           <a:p xmlns:a="http://schemas.openxmlformats.org/drawingml/2006/main">
             <a:pPr algn="ctr">
+              <a:buNone/>
               <a:defRPr sz="900" b="1" i="0">
                 <a:solidFill>
                   <a:srgbClr val="3157FF"/>
@@ -11178,6 +11332,7 @@
           <a:lstStyle xmlns:a="http://schemas.openxmlformats.org/drawingml/2006/main"/>
           <a:p xmlns:a="http://schemas.openxmlformats.org/drawingml/2006/main">
             <a:pPr algn="l">
+              <a:buNone/>
               <a:defRPr sz="1050" b="1" i="0">
                 <a:solidFill>
                   <a:srgbClr val="3157FF"/>
@@ -11228,6 +11383,7 @@
           <a:lstStyle xmlns:a="http://schemas.openxmlformats.org/drawingml/2006/main"/>
           <a:p xmlns:a="http://schemas.openxmlformats.org/drawingml/2006/main">
             <a:pPr algn="l">
+              <a:buNone/>
               <a:defRPr sz="1350" b="1" i="0">
                 <a:solidFill>
                   <a:srgbClr val="121722"/>
@@ -11342,6 +11498,7 @@
           <a:lstStyle xmlns:a="http://schemas.openxmlformats.org/drawingml/2006/main"/>
           <a:p xmlns:a="http://schemas.openxmlformats.org/drawingml/2006/main">
             <a:pPr algn="ctr">
+              <a:buNone/>
               <a:defRPr sz="900" b="1" i="0">
                 <a:solidFill>
                   <a:srgbClr val="0F9F7A"/>
@@ -11392,6 +11549,7 @@
           <a:lstStyle xmlns:a="http://schemas.openxmlformats.org/drawingml/2006/main"/>
           <a:p xmlns:a="http://schemas.openxmlformats.org/drawingml/2006/main">
             <a:pPr algn="l">
+              <a:buNone/>
               <a:defRPr sz="1050" b="1" i="0">
                 <a:solidFill>
                   <a:srgbClr val="0F9F7A"/>
@@ -11442,6 +11600,7 @@
           <a:lstStyle xmlns:a="http://schemas.openxmlformats.org/drawingml/2006/main"/>
           <a:p xmlns:a="http://schemas.openxmlformats.org/drawingml/2006/main">
             <a:pPr algn="l">
+              <a:buNone/>
               <a:defRPr sz="1350" b="1" i="0">
                 <a:solidFill>
                   <a:srgbClr val="121722"/>
@@ -11556,6 +11715,7 @@
           <a:lstStyle xmlns:a="http://schemas.openxmlformats.org/drawingml/2006/main"/>
           <a:p xmlns:a="http://schemas.openxmlformats.org/drawingml/2006/main">
             <a:pPr algn="ctr">
+              <a:buNone/>
               <a:defRPr sz="900" b="1" i="0">
                 <a:solidFill>
                   <a:srgbClr val="EE6A5F"/>
@@ -11606,6 +11766,7 @@
           <a:lstStyle xmlns:a="http://schemas.openxmlformats.org/drawingml/2006/main"/>
           <a:p xmlns:a="http://schemas.openxmlformats.org/drawingml/2006/main">
             <a:pPr algn="l">
+              <a:buNone/>
               <a:defRPr sz="1050" b="1" i="0">
                 <a:solidFill>
                   <a:srgbClr val="EE6A5F"/>
@@ -11656,6 +11817,7 @@
           <a:lstStyle xmlns:a="http://schemas.openxmlformats.org/drawingml/2006/main"/>
           <a:p xmlns:a="http://schemas.openxmlformats.org/drawingml/2006/main">
             <a:pPr algn="l">
+              <a:buNone/>
               <a:defRPr sz="1350" b="1" i="0">
                 <a:solidFill>
                   <a:srgbClr val="121722"/>
@@ -11668,7 +11830,7 @@
                   <a:srgbClr val="121722"/>
                 </a:solidFill>
               </a:rPr>
-              <a:t>Python · Flask · Azure OpenAI · Structured Response</a:t>
+              <a:t>Python · Flask · Azure OpenAI · JSON Validation</a:t>
             </a:r>
           </a:p>
         </p:txBody>
@@ -11737,6 +11899,7 @@
           <a:lstStyle xmlns:a="http://schemas.openxmlformats.org/drawingml/2006/main"/>
           <a:p xmlns:a="http://schemas.openxmlformats.org/drawingml/2006/main">
             <a:pPr algn="l">
+              <a:buNone/>
               <a:defRPr sz="675" b="1" i="0">
                 <a:solidFill>
                   <a:srgbClr val="9AA3B2"/>
@@ -11787,6 +11950,7 @@
           <a:lstStyle xmlns:a="http://schemas.openxmlformats.org/drawingml/2006/main"/>
           <a:p xmlns:a="http://schemas.openxmlformats.org/drawingml/2006/main">
             <a:pPr algn="r">
+              <a:buNone/>
               <a:defRPr sz="750" b="1" i="0">
                 <a:solidFill>
                   <a:srgbClr val="9AA3B2"/>
@@ -11866,6 +12030,7 @@
           <a:lstStyle xmlns:a="http://schemas.openxmlformats.org/drawingml/2006/main"/>
           <a:p xmlns:a="http://schemas.openxmlformats.org/drawingml/2006/main">
             <a:pPr algn="l">
+              <a:buNone/>
               <a:defRPr sz="975" b="1" i="0">
                 <a:solidFill>
                   <a:srgbClr val="3157FF"/>
@@ -11947,6 +12112,7 @@
           <a:lstStyle xmlns:a="http://schemas.openxmlformats.org/drawingml/2006/main"/>
           <a:p xmlns:a="http://schemas.openxmlformats.org/drawingml/2006/main">
             <a:pPr algn="l">
+              <a:buNone/>
               <a:defRPr sz="975" b="1" i="0">
                 <a:solidFill>
                   <a:srgbClr val="5B6472"/>
@@ -11997,6 +12163,7 @@
           <a:lstStyle xmlns:a="http://schemas.openxmlformats.org/drawingml/2006/main"/>
           <a:p xmlns:a="http://schemas.openxmlformats.org/drawingml/2006/main">
             <a:pPr algn="l">
+              <a:buNone/>
               <a:defRPr sz="2700" b="1" i="0">
                 <a:solidFill>
                   <a:srgbClr val="121722"/>
@@ -12047,6 +12214,7 @@
           <a:lstStyle xmlns:a="http://schemas.openxmlformats.org/drawingml/2006/main"/>
           <a:p xmlns:a="http://schemas.openxmlformats.org/drawingml/2006/main">
             <a:pPr algn="l">
+              <a:buNone/>
               <a:defRPr sz="975" b="1" i="0">
                 <a:solidFill>
                   <a:srgbClr val="3157FF"/>
@@ -12097,6 +12265,7 @@
           <a:lstStyle xmlns:a="http://schemas.openxmlformats.org/drawingml/2006/main"/>
           <a:p xmlns:a="http://schemas.openxmlformats.org/drawingml/2006/main">
             <a:pPr algn="l">
+              <a:buNone/>
               <a:defRPr sz="1425" b="1" i="0">
                 <a:solidFill>
                   <a:srgbClr val="EE6A5F"/>
@@ -12147,6 +12316,7 @@
           <a:lstStyle xmlns:a="http://schemas.openxmlformats.org/drawingml/2006/main"/>
           <a:p xmlns:a="http://schemas.openxmlformats.org/drawingml/2006/main">
             <a:pPr algn="l">
+              <a:buNone/>
               <a:defRPr sz="1350" b="0" i="0">
                 <a:solidFill>
                   <a:srgbClr val="121722"/>
@@ -12197,6 +12367,7 @@
           <a:lstStyle xmlns:a="http://schemas.openxmlformats.org/drawingml/2006/main"/>
           <a:p xmlns:a="http://schemas.openxmlformats.org/drawingml/2006/main">
             <a:pPr algn="l">
+              <a:buNone/>
               <a:defRPr sz="1425" b="1" i="0">
                 <a:solidFill>
                   <a:srgbClr val="0F9F7A"/>
@@ -12247,6 +12418,7 @@
           <a:lstStyle xmlns:a="http://schemas.openxmlformats.org/drawingml/2006/main"/>
           <a:p xmlns:a="http://schemas.openxmlformats.org/drawingml/2006/main">
             <a:pPr algn="l">
+              <a:buNone/>
               <a:defRPr sz="1350" b="0" i="0">
                 <a:solidFill>
                   <a:srgbClr val="121722"/>
@@ -12297,6 +12469,7 @@
           <a:lstStyle xmlns:a="http://schemas.openxmlformats.org/drawingml/2006/main"/>
           <a:p xmlns:a="http://schemas.openxmlformats.org/drawingml/2006/main">
             <a:pPr algn="l">
+              <a:buNone/>
               <a:defRPr sz="1425" b="1" i="0">
                 <a:solidFill>
                   <a:srgbClr val="3157FF"/>
@@ -12347,6 +12520,7 @@
           <a:lstStyle xmlns:a="http://schemas.openxmlformats.org/drawingml/2006/main"/>
           <a:p xmlns:a="http://schemas.openxmlformats.org/drawingml/2006/main">
             <a:pPr algn="l">
+              <a:buNone/>
               <a:defRPr sz="1350" b="0" i="0">
                 <a:solidFill>
                   <a:srgbClr val="121722"/>
@@ -12359,7 +12533,7 @@
                   <a:srgbClr val="121722"/>
                 </a:solidFill>
               </a:rPr>
-              <a:t>신규 제휴 온보딩 주도, 점검 항목과 대외 기술 커뮤니케이션 기준 표준화</a:t>
+              <a:t>2026년부터 여행·레저 제휴 연동 단독 담당, 신규 온보딩과 대외 기술 커뮤니케이션 주도</a:t>
             </a:r>
           </a:p>
         </p:txBody>
@@ -12459,6 +12633,7 @@
           <a:lstStyle xmlns:a="http://schemas.openxmlformats.org/drawingml/2006/main"/>
           <a:p xmlns:a="http://schemas.openxmlformats.org/drawingml/2006/main">
             <a:pPr algn="ctr">
+              <a:buNone/>
               <a:defRPr sz="825" b="1" i="0">
                 <a:solidFill>
                   <a:srgbClr val="9AA3B2"/>
@@ -12509,6 +12684,7 @@
           <a:lstStyle xmlns:a="http://schemas.openxmlformats.org/drawingml/2006/main"/>
           <a:p xmlns:a="http://schemas.openxmlformats.org/drawingml/2006/main">
             <a:pPr algn="ctr">
+              <a:buNone/>
               <a:defRPr sz="1050" b="1" i="0">
                 <a:solidFill>
                   <a:srgbClr val="121722"/>
@@ -12590,6 +12766,7 @@
           <a:lstStyle xmlns:a="http://schemas.openxmlformats.org/drawingml/2006/main"/>
           <a:p xmlns:a="http://schemas.openxmlformats.org/drawingml/2006/main">
             <a:pPr algn="ctr">
+              <a:buNone/>
               <a:defRPr sz="825" b="1" i="0">
                 <a:solidFill>
                   <a:srgbClr val="9AA3B2"/>
@@ -12640,6 +12817,7 @@
           <a:lstStyle xmlns:a="http://schemas.openxmlformats.org/drawingml/2006/main"/>
           <a:p xmlns:a="http://schemas.openxmlformats.org/drawingml/2006/main">
             <a:pPr algn="ctr">
+              <a:buNone/>
               <a:defRPr sz="1050" b="1" i="0">
                 <a:solidFill>
                   <a:srgbClr val="121722"/>
@@ -12721,6 +12899,7 @@
           <a:lstStyle xmlns:a="http://schemas.openxmlformats.org/drawingml/2006/main"/>
           <a:p xmlns:a="http://schemas.openxmlformats.org/drawingml/2006/main">
             <a:pPr algn="ctr">
+              <a:buNone/>
               <a:defRPr sz="825" b="1" i="0">
                 <a:solidFill>
                   <a:srgbClr val="9AA3B2"/>
@@ -12771,6 +12950,7 @@
           <a:lstStyle xmlns:a="http://schemas.openxmlformats.org/drawingml/2006/main"/>
           <a:p xmlns:a="http://schemas.openxmlformats.org/drawingml/2006/main">
             <a:pPr algn="ctr">
+              <a:buNone/>
               <a:defRPr sz="1050" b="1" i="0">
                 <a:solidFill>
                   <a:srgbClr val="121722"/>
@@ -12852,6 +13032,7 @@
           <a:lstStyle xmlns:a="http://schemas.openxmlformats.org/drawingml/2006/main"/>
           <a:p xmlns:a="http://schemas.openxmlformats.org/drawingml/2006/main">
             <a:pPr algn="ctr">
+              <a:buNone/>
               <a:defRPr sz="825" b="1" i="0">
                 <a:solidFill>
                   <a:srgbClr val="9AA3B2"/>
@@ -12902,6 +13083,7 @@
           <a:lstStyle xmlns:a="http://schemas.openxmlformats.org/drawingml/2006/main"/>
           <a:p xmlns:a="http://schemas.openxmlformats.org/drawingml/2006/main">
             <a:pPr algn="ctr">
+              <a:buNone/>
               <a:defRPr sz="1050" b="1" i="0">
                 <a:solidFill>
                   <a:srgbClr val="121722"/>
@@ -12983,6 +13165,7 @@
           <a:lstStyle xmlns:a="http://schemas.openxmlformats.org/drawingml/2006/main"/>
           <a:p xmlns:a="http://schemas.openxmlformats.org/drawingml/2006/main">
             <a:pPr algn="ctr">
+              <a:buNone/>
               <a:defRPr sz="825" b="1" i="0">
                 <a:solidFill>
                   <a:srgbClr val="9AA3B2"/>
@@ -13033,6 +13216,7 @@
           <a:lstStyle xmlns:a="http://schemas.openxmlformats.org/drawingml/2006/main"/>
           <a:p xmlns:a="http://schemas.openxmlformats.org/drawingml/2006/main">
             <a:pPr algn="ctr">
+              <a:buNone/>
               <a:defRPr sz="1050" b="1" i="0">
                 <a:solidFill>
                   <a:srgbClr val="121722"/>
@@ -13114,6 +13298,7 @@
           <a:lstStyle xmlns:a="http://schemas.openxmlformats.org/drawingml/2006/main"/>
           <a:p xmlns:a="http://schemas.openxmlformats.org/drawingml/2006/main">
             <a:pPr algn="ctr">
+              <a:buNone/>
               <a:defRPr sz="825" b="1" i="0">
                 <a:solidFill>
                   <a:srgbClr val="9AA3B2"/>
@@ -13164,6 +13349,7 @@
           <a:lstStyle xmlns:a="http://schemas.openxmlformats.org/drawingml/2006/main"/>
           <a:p xmlns:a="http://schemas.openxmlformats.org/drawingml/2006/main">
             <a:pPr algn="ctr">
+              <a:buNone/>
               <a:defRPr sz="1050" b="1" i="0">
                 <a:solidFill>
                   <a:srgbClr val="121722"/>
@@ -13214,6 +13400,7 @@
           <a:lstStyle xmlns:a="http://schemas.openxmlformats.org/drawingml/2006/main"/>
           <a:p xmlns:a="http://schemas.openxmlformats.org/drawingml/2006/main">
             <a:pPr algn="l">
+              <a:buNone/>
               <a:defRPr sz="825" b="1" i="0">
                 <a:solidFill>
                   <a:srgbClr val="3157FF"/>
@@ -13264,6 +13451,7 @@
           <a:lstStyle xmlns:a="http://schemas.openxmlformats.org/drawingml/2006/main"/>
           <a:p xmlns:a="http://schemas.openxmlformats.org/drawingml/2006/main">
             <a:pPr algn="l">
+              <a:buNone/>
               <a:defRPr sz="1275" b="1" i="0">
                 <a:solidFill>
                   <a:srgbClr val="121722"/>
@@ -13345,6 +13533,7 @@
           <a:lstStyle xmlns:a="http://schemas.openxmlformats.org/drawingml/2006/main"/>
           <a:p xmlns:a="http://schemas.openxmlformats.org/drawingml/2006/main">
             <a:pPr algn="l">
+              <a:buNone/>
               <a:defRPr sz="675" b="1" i="0">
                 <a:solidFill>
                   <a:srgbClr val="9AA3B2"/>
@@ -13395,6 +13584,7 @@
           <a:lstStyle xmlns:a="http://schemas.openxmlformats.org/drawingml/2006/main"/>
           <a:p xmlns:a="http://schemas.openxmlformats.org/drawingml/2006/main">
             <a:pPr algn="r">
+              <a:buNone/>
               <a:defRPr sz="750" b="1" i="0">
                 <a:solidFill>
                   <a:srgbClr val="9AA3B2"/>
@@ -13474,6 +13664,7 @@
           <a:lstStyle xmlns:a="http://schemas.openxmlformats.org/drawingml/2006/main"/>
           <a:p xmlns:a="http://schemas.openxmlformats.org/drawingml/2006/main">
             <a:pPr algn="l">
+              <a:buNone/>
               <a:defRPr sz="975" b="1" i="0">
                 <a:solidFill>
                   <a:srgbClr val="3157FF"/>
@@ -13555,6 +13746,7 @@
           <a:lstStyle xmlns:a="http://schemas.openxmlformats.org/drawingml/2006/main"/>
           <a:p xmlns:a="http://schemas.openxmlformats.org/drawingml/2006/main">
             <a:pPr algn="l">
+              <a:buNone/>
               <a:defRPr sz="975" b="1" i="0">
                 <a:solidFill>
                   <a:srgbClr val="5B6472"/>
@@ -13605,6 +13797,7 @@
           <a:lstStyle xmlns:a="http://schemas.openxmlformats.org/drawingml/2006/main"/>
           <a:p xmlns:a="http://schemas.openxmlformats.org/drawingml/2006/main">
             <a:pPr algn="l">
+              <a:buNone/>
               <a:defRPr sz="2700" b="1" i="0">
                 <a:solidFill>
                   <a:srgbClr val="121722"/>
@@ -13655,6 +13848,7 @@
           <a:lstStyle xmlns:a="http://schemas.openxmlformats.org/drawingml/2006/main"/>
           <a:p xmlns:a="http://schemas.openxmlformats.org/drawingml/2006/main">
             <a:pPr algn="l">
+              <a:buNone/>
               <a:defRPr sz="1350" b="0" i="0">
                 <a:solidFill>
                   <a:srgbClr val="5B6472"/>
@@ -13736,6 +13930,7 @@
           <a:lstStyle xmlns:a="http://schemas.openxmlformats.org/drawingml/2006/main"/>
           <a:p xmlns:a="http://schemas.openxmlformats.org/drawingml/2006/main">
             <a:pPr algn="l">
+              <a:buNone/>
               <a:defRPr sz="825" b="1" i="0">
                 <a:solidFill>
                   <a:srgbClr val="8993A7"/>
@@ -13786,6 +13981,7 @@
           <a:lstStyle xmlns:a="http://schemas.openxmlformats.org/drawingml/2006/main"/>
           <a:p xmlns:a="http://schemas.openxmlformats.org/drawingml/2006/main">
             <a:pPr algn="l">
+              <a:buNone/>
               <a:defRPr sz="1800" b="1" i="0">
                 <a:solidFill>
                   <a:srgbClr val="FFFFFF"/>
@@ -13836,6 +14032,7 @@
           <a:lstStyle xmlns:a="http://schemas.openxmlformats.org/drawingml/2006/main"/>
           <a:p xmlns:a="http://schemas.openxmlformats.org/drawingml/2006/main">
             <a:pPr algn="l">
+              <a:buNone/>
               <a:defRPr sz="1275" b="0" i="0">
                 <a:solidFill>
                   <a:srgbClr val="B8C0CE"/>
@@ -13853,6 +14050,7 @@
           </a:p>
           <a:p xmlns:a="http://schemas.openxmlformats.org/drawingml/2006/main">
             <a:pPr algn="l">
+              <a:buNone/>
               <a:defRPr sz="1275" b="0" i="0">
                 <a:solidFill>
                   <a:srgbClr val="B8C0CE"/>
@@ -13903,6 +14101,7 @@
           <a:lstStyle xmlns:a="http://schemas.openxmlformats.org/drawingml/2006/main"/>
           <a:p xmlns:a="http://schemas.openxmlformats.org/drawingml/2006/main">
             <a:pPr algn="l">
+              <a:buNone/>
               <a:defRPr sz="1125" b="1" i="0">
                 <a:solidFill>
                   <a:srgbClr val="85A0FF"/>
@@ -13953,6 +14152,7 @@
           <a:lstStyle xmlns:a="http://schemas.openxmlformats.org/drawingml/2006/main"/>
           <a:p xmlns:a="http://schemas.openxmlformats.org/drawingml/2006/main">
             <a:pPr algn="l">
+              <a:buNone/>
               <a:defRPr sz="1125" b="1" i="0">
                 <a:solidFill>
                   <a:srgbClr val="85A0FF"/>
@@ -14003,6 +14203,7 @@
           <a:lstStyle xmlns:a="http://schemas.openxmlformats.org/drawingml/2006/main"/>
           <a:p xmlns:a="http://schemas.openxmlformats.org/drawingml/2006/main">
             <a:pPr algn="l">
+              <a:buNone/>
               <a:defRPr sz="1125" b="1" i="0">
                 <a:solidFill>
                   <a:srgbClr val="54D3AD"/>
@@ -14053,6 +14254,7 @@
           <a:lstStyle xmlns:a="http://schemas.openxmlformats.org/drawingml/2006/main"/>
           <a:p xmlns:a="http://schemas.openxmlformats.org/drawingml/2006/main">
             <a:pPr algn="l">
+              <a:buNone/>
               <a:defRPr sz="900" b="1" i="0">
                 <a:solidFill>
                   <a:srgbClr val="3157FF"/>
@@ -14103,6 +14305,7 @@
           <a:lstStyle xmlns:a="http://schemas.openxmlformats.org/drawingml/2006/main"/>
           <a:p xmlns:a="http://schemas.openxmlformats.org/drawingml/2006/main">
             <a:pPr algn="l">
+              <a:buNone/>
               <a:defRPr sz="1425" b="1" i="0">
                 <a:solidFill>
                   <a:srgbClr val="121722"/>
@@ -14153,6 +14356,7 @@
           <a:lstStyle xmlns:a="http://schemas.openxmlformats.org/drawingml/2006/main"/>
           <a:p xmlns:a="http://schemas.openxmlformats.org/drawingml/2006/main">
             <a:pPr algn="l">
+              <a:buNone/>
               <a:defRPr sz="1200" b="0" i="0">
                 <a:solidFill>
                   <a:srgbClr val="5B6472"/>
@@ -14234,6 +14438,7 @@
           <a:lstStyle xmlns:a="http://schemas.openxmlformats.org/drawingml/2006/main"/>
           <a:p xmlns:a="http://schemas.openxmlformats.org/drawingml/2006/main">
             <a:pPr algn="l">
+              <a:buNone/>
               <a:defRPr sz="900" b="1" i="0">
                 <a:solidFill>
                   <a:srgbClr val="3157FF"/>
@@ -14284,6 +14489,7 @@
           <a:lstStyle xmlns:a="http://schemas.openxmlformats.org/drawingml/2006/main"/>
           <a:p xmlns:a="http://schemas.openxmlformats.org/drawingml/2006/main">
             <a:pPr algn="l">
+              <a:buNone/>
               <a:defRPr sz="1425" b="1" i="0">
                 <a:solidFill>
                   <a:srgbClr val="121722"/>
@@ -14334,6 +14540,7 @@
           <a:lstStyle xmlns:a="http://schemas.openxmlformats.org/drawingml/2006/main"/>
           <a:p xmlns:a="http://schemas.openxmlformats.org/drawingml/2006/main">
             <a:pPr algn="l">
+              <a:buNone/>
               <a:defRPr sz="1200" b="0" i="0">
                 <a:solidFill>
                   <a:srgbClr val="5B6472"/>
@@ -14346,7 +14553,7 @@
                   <a:srgbClr val="5B6472"/>
                 </a:solidFill>
               </a:rPr>
-              <a:t>비동기 작업·결과 집계 순서 안정화 참여</a:t>
+              <a:t>비동기 작업 등록·순회 순서 안정화 개선</a:t>
             </a:r>
           </a:p>
         </p:txBody>
@@ -14415,6 +14622,7 @@
           <a:lstStyle xmlns:a="http://schemas.openxmlformats.org/drawingml/2006/main"/>
           <a:p xmlns:a="http://schemas.openxmlformats.org/drawingml/2006/main">
             <a:pPr algn="l">
+              <a:buNone/>
               <a:defRPr sz="900" b="1" i="0">
                 <a:solidFill>
                   <a:srgbClr val="3157FF"/>
@@ -14465,6 +14673,7 @@
           <a:lstStyle xmlns:a="http://schemas.openxmlformats.org/drawingml/2006/main"/>
           <a:p xmlns:a="http://schemas.openxmlformats.org/drawingml/2006/main">
             <a:pPr algn="l">
+              <a:buNone/>
               <a:defRPr sz="1425" b="1" i="0">
                 <a:solidFill>
                   <a:srgbClr val="121722"/>
@@ -14515,6 +14724,7 @@
           <a:lstStyle xmlns:a="http://schemas.openxmlformats.org/drawingml/2006/main"/>
           <a:p xmlns:a="http://schemas.openxmlformats.org/drawingml/2006/main">
             <a:pPr algn="l">
+              <a:buNone/>
               <a:defRPr sz="1200" b="0" i="0">
                 <a:solidFill>
                   <a:srgbClr val="5B6472"/>
@@ -14596,6 +14806,7 @@
           <a:lstStyle xmlns:a="http://schemas.openxmlformats.org/drawingml/2006/main"/>
           <a:p xmlns:a="http://schemas.openxmlformats.org/drawingml/2006/main">
             <a:pPr algn="l">
+              <a:buNone/>
               <a:defRPr sz="900" b="1" i="0">
                 <a:solidFill>
                   <a:srgbClr val="0F9F7A"/>
@@ -14646,6 +14857,7 @@
           <a:lstStyle xmlns:a="http://schemas.openxmlformats.org/drawingml/2006/main"/>
           <a:p xmlns:a="http://schemas.openxmlformats.org/drawingml/2006/main">
             <a:pPr algn="l">
+              <a:buNone/>
               <a:defRPr sz="1425" b="1" i="0">
                 <a:solidFill>
                   <a:srgbClr val="121722"/>
@@ -14696,6 +14908,7 @@
           <a:lstStyle xmlns:a="http://schemas.openxmlformats.org/drawingml/2006/main"/>
           <a:p xmlns:a="http://schemas.openxmlformats.org/drawingml/2006/main">
             <a:pPr algn="l">
+              <a:buNone/>
               <a:defRPr sz="1200" b="0" i="0">
                 <a:solidFill>
                   <a:srgbClr val="5B6472"/>
@@ -14746,6 +14959,7 @@
           <a:lstStyle xmlns:a="http://schemas.openxmlformats.org/drawingml/2006/main"/>
           <a:p xmlns:a="http://schemas.openxmlformats.org/drawingml/2006/main">
             <a:pPr algn="l">
+              <a:buNone/>
               <a:defRPr sz="1050" b="1" i="0">
                 <a:solidFill>
                   <a:srgbClr val="EE6A5F"/>
@@ -14796,6 +15010,7 @@
           <a:lstStyle xmlns:a="http://schemas.openxmlformats.org/drawingml/2006/main"/>
           <a:p xmlns:a="http://schemas.openxmlformats.org/drawingml/2006/main">
             <a:pPr algn="l">
+              <a:buNone/>
               <a:defRPr sz="1200" b="1" i="0">
                 <a:solidFill>
                   <a:srgbClr val="121722"/>
@@ -14808,7 +15023,7 @@
                   <a:srgbClr val="121722"/>
                 </a:solidFill>
               </a:rPr>
-              <a:t>기능 개발·운영 · 순서 안정화 참여 · 실패 격리 직접 개선</a:t>
+              <a:t>기능 개발·운영 · 작업 순서 안정화 · 실패 격리 개선</a:t>
             </a:r>
           </a:p>
         </p:txBody>
@@ -14877,6 +15092,7 @@
           <a:lstStyle xmlns:a="http://schemas.openxmlformats.org/drawingml/2006/main"/>
           <a:p xmlns:a="http://schemas.openxmlformats.org/drawingml/2006/main">
             <a:pPr algn="l">
+              <a:buNone/>
               <a:defRPr sz="675" b="1" i="0">
                 <a:solidFill>
                   <a:srgbClr val="9AA3B2"/>
@@ -14927,6 +15143,7 @@
           <a:lstStyle xmlns:a="http://schemas.openxmlformats.org/drawingml/2006/main"/>
           <a:p xmlns:a="http://schemas.openxmlformats.org/drawingml/2006/main">
             <a:pPr algn="r">
+              <a:buNone/>
               <a:defRPr sz="750" b="1" i="0">
                 <a:solidFill>
                   <a:srgbClr val="9AA3B2"/>
@@ -15006,6 +15223,7 @@
           <a:lstStyle xmlns:a="http://schemas.openxmlformats.org/drawingml/2006/main"/>
           <a:p xmlns:a="http://schemas.openxmlformats.org/drawingml/2006/main">
             <a:pPr algn="l">
+              <a:buNone/>
               <a:defRPr sz="975" b="1" i="0">
                 <a:solidFill>
                   <a:srgbClr val="3157FF"/>
@@ -15087,6 +15305,7 @@
           <a:lstStyle xmlns:a="http://schemas.openxmlformats.org/drawingml/2006/main"/>
           <a:p xmlns:a="http://schemas.openxmlformats.org/drawingml/2006/main">
             <a:pPr algn="l">
+              <a:buNone/>
               <a:defRPr sz="975" b="1" i="0">
                 <a:solidFill>
                   <a:srgbClr val="5B6472"/>
@@ -15137,6 +15356,7 @@
           <a:lstStyle xmlns:a="http://schemas.openxmlformats.org/drawingml/2006/main"/>
           <a:p xmlns:a="http://schemas.openxmlformats.org/drawingml/2006/main">
             <a:pPr algn="l">
+              <a:buNone/>
               <a:defRPr sz="2700" b="1" i="0">
                 <a:solidFill>
                   <a:srgbClr val="121722"/>
@@ -15187,6 +15407,7 @@
           <a:lstStyle xmlns:a="http://schemas.openxmlformats.org/drawingml/2006/main"/>
           <a:p xmlns:a="http://schemas.openxmlformats.org/drawingml/2006/main">
             <a:pPr algn="l">
+              <a:buNone/>
               <a:defRPr sz="975" b="1" i="0">
                 <a:solidFill>
                   <a:srgbClr val="0F9F7A"/>
@@ -15265,6 +15486,7 @@
           <a:lstStyle xmlns:a="http://schemas.openxmlformats.org/drawingml/2006/main"/>
           <a:p xmlns:a="http://schemas.openxmlformats.org/drawingml/2006/main">
             <a:pPr algn="l">
+              <a:buNone/>
               <a:defRPr sz="975" b="1" i="0">
                 <a:solidFill>
                   <a:srgbClr val="3157FF"/>
@@ -15315,6 +15537,7 @@
           <a:lstStyle xmlns:a="http://schemas.openxmlformats.org/drawingml/2006/main"/>
           <a:p xmlns:a="http://schemas.openxmlformats.org/drawingml/2006/main">
             <a:pPr algn="l">
+              <a:buNone/>
               <a:defRPr sz="1425" b="1" i="0">
                 <a:solidFill>
                   <a:srgbClr val="121722"/>
@@ -15393,6 +15616,7 @@
           <a:lstStyle xmlns:a="http://schemas.openxmlformats.org/drawingml/2006/main"/>
           <a:p xmlns:a="http://schemas.openxmlformats.org/drawingml/2006/main">
             <a:pPr algn="l">
+              <a:buNone/>
               <a:defRPr sz="975" b="1" i="0">
                 <a:solidFill>
                   <a:srgbClr val="EE6A5F"/>
@@ -15443,6 +15667,7 @@
           <a:lstStyle xmlns:a="http://schemas.openxmlformats.org/drawingml/2006/main"/>
           <a:p xmlns:a="http://schemas.openxmlformats.org/drawingml/2006/main">
             <a:pPr algn="l">
+              <a:buNone/>
               <a:defRPr sz="1425" b="1" i="0">
                 <a:solidFill>
                   <a:srgbClr val="121722"/>
@@ -15521,6 +15746,7 @@
           <a:lstStyle xmlns:a="http://schemas.openxmlformats.org/drawingml/2006/main"/>
           <a:p xmlns:a="http://schemas.openxmlformats.org/drawingml/2006/main">
             <a:pPr algn="l">
+              <a:buNone/>
               <a:defRPr sz="975" b="1" i="0">
                 <a:solidFill>
                   <a:srgbClr val="0F9F7A"/>
@@ -15571,6 +15797,7 @@
           <a:lstStyle xmlns:a="http://schemas.openxmlformats.org/drawingml/2006/main"/>
           <a:p xmlns:a="http://schemas.openxmlformats.org/drawingml/2006/main">
             <a:pPr algn="l">
+              <a:buNone/>
               <a:defRPr sz="1425" b="1" i="0">
                 <a:solidFill>
                   <a:srgbClr val="121722"/>
@@ -15621,6 +15848,7 @@
           <a:lstStyle xmlns:a="http://schemas.openxmlformats.org/drawingml/2006/main"/>
           <a:p xmlns:a="http://schemas.openxmlformats.org/drawingml/2006/main">
             <a:pPr algn="l">
+              <a:buNone/>
               <a:defRPr sz="1425" b="1" i="0">
                 <a:solidFill>
                   <a:srgbClr val="121722"/>
@@ -15702,6 +15930,7 @@
           <a:lstStyle xmlns:a="http://schemas.openxmlformats.org/drawingml/2006/main"/>
           <a:p xmlns:a="http://schemas.openxmlformats.org/drawingml/2006/main">
             <a:pPr algn="l">
+              <a:buNone/>
               <a:defRPr sz="1200" b="0" i="0">
                 <a:solidFill>
                   <a:srgbClr val="121722"/>
@@ -15783,6 +16012,7 @@
           <a:lstStyle xmlns:a="http://schemas.openxmlformats.org/drawingml/2006/main"/>
           <a:p xmlns:a="http://schemas.openxmlformats.org/drawingml/2006/main">
             <a:pPr algn="l">
+              <a:buNone/>
               <a:defRPr sz="1200" b="0" i="0">
                 <a:solidFill>
                   <a:srgbClr val="121722"/>
@@ -15864,6 +16094,7 @@
           <a:lstStyle xmlns:a="http://schemas.openxmlformats.org/drawingml/2006/main"/>
           <a:p xmlns:a="http://schemas.openxmlformats.org/drawingml/2006/main">
             <a:pPr algn="l">
+              <a:buNone/>
               <a:defRPr sz="1200" b="0" i="0">
                 <a:solidFill>
                   <a:srgbClr val="121722"/>
@@ -15945,6 +16176,7 @@
           <a:lstStyle xmlns:a="http://schemas.openxmlformats.org/drawingml/2006/main"/>
           <a:p xmlns:a="http://schemas.openxmlformats.org/drawingml/2006/main">
             <a:pPr algn="l">
+              <a:buNone/>
               <a:defRPr sz="1200" b="0" i="0">
                 <a:solidFill>
                   <a:srgbClr val="121722"/>
@@ -16026,6 +16258,7 @@
           <a:lstStyle xmlns:a="http://schemas.openxmlformats.org/drawingml/2006/main"/>
           <a:p xmlns:a="http://schemas.openxmlformats.org/drawingml/2006/main">
             <a:pPr algn="l">
+              <a:buNone/>
               <a:defRPr sz="675" b="1" i="0">
                 <a:solidFill>
                   <a:srgbClr val="9AA3B2"/>
@@ -16076,6 +16309,7 @@
           <a:lstStyle xmlns:a="http://schemas.openxmlformats.org/drawingml/2006/main"/>
           <a:p xmlns:a="http://schemas.openxmlformats.org/drawingml/2006/main">
             <a:pPr algn="r">
+              <a:buNone/>
               <a:defRPr sz="750" b="1" i="0">
                 <a:solidFill>
                   <a:srgbClr val="9AA3B2"/>
@@ -16155,6 +16389,7 @@
           <a:lstStyle xmlns:a="http://schemas.openxmlformats.org/drawingml/2006/main"/>
           <a:p xmlns:a="http://schemas.openxmlformats.org/drawingml/2006/main">
             <a:pPr algn="l">
+              <a:buNone/>
               <a:defRPr sz="975" b="1" i="0">
                 <a:solidFill>
                   <a:srgbClr val="3157FF"/>
@@ -16236,6 +16471,7 @@
           <a:lstStyle xmlns:a="http://schemas.openxmlformats.org/drawingml/2006/main"/>
           <a:p xmlns:a="http://schemas.openxmlformats.org/drawingml/2006/main">
             <a:pPr algn="l">
+              <a:buNone/>
               <a:defRPr sz="975" b="1" i="0">
                 <a:solidFill>
                   <a:srgbClr val="5B6472"/>
@@ -16286,6 +16522,7 @@
           <a:lstStyle xmlns:a="http://schemas.openxmlformats.org/drawingml/2006/main"/>
           <a:p xmlns:a="http://schemas.openxmlformats.org/drawingml/2006/main">
             <a:pPr algn="l">
+              <a:buNone/>
               <a:defRPr sz="2700" b="1" i="0">
                 <a:solidFill>
                   <a:srgbClr val="121722"/>
@@ -16336,6 +16573,7 @@
           <a:lstStyle xmlns:a="http://schemas.openxmlformats.org/drawingml/2006/main"/>
           <a:p xmlns:a="http://schemas.openxmlformats.org/drawingml/2006/main">
             <a:pPr algn="l">
+              <a:buNone/>
               <a:defRPr sz="975" b="1" i="0">
                 <a:solidFill>
                   <a:srgbClr val="EE6A5F"/>
@@ -16417,6 +16655,7 @@
           <a:lstStyle xmlns:a="http://schemas.openxmlformats.org/drawingml/2006/main"/>
           <a:p xmlns:a="http://schemas.openxmlformats.org/drawingml/2006/main">
             <a:pPr algn="l">
+              <a:buNone/>
               <a:defRPr sz="825" b="1" i="0">
                 <a:solidFill>
                   <a:srgbClr val="8993A7"/>
@@ -16467,6 +16706,7 @@
           <a:lstStyle xmlns:a="http://schemas.openxmlformats.org/drawingml/2006/main"/>
           <a:p xmlns:a="http://schemas.openxmlformats.org/drawingml/2006/main">
             <a:pPr algn="l">
+              <a:buNone/>
               <a:defRPr sz="1650" b="1" i="0">
                 <a:solidFill>
                   <a:srgbClr val="FFFFFF"/>
@@ -16517,6 +16757,7 @@
           <a:lstStyle xmlns:a="http://schemas.openxmlformats.org/drawingml/2006/main"/>
           <a:p xmlns:a="http://schemas.openxmlformats.org/drawingml/2006/main">
             <a:pPr algn="l">
+              <a:buNone/>
               <a:defRPr sz="1650" b="1" i="0">
                 <a:solidFill>
                   <a:srgbClr val="FFFFFF"/>
@@ -16567,6 +16808,7 @@
           <a:lstStyle xmlns:a="http://schemas.openxmlformats.org/drawingml/2006/main"/>
           <a:p xmlns:a="http://schemas.openxmlformats.org/drawingml/2006/main">
             <a:pPr algn="l">
+              <a:buNone/>
               <a:defRPr sz="1650" b="1" i="0">
                 <a:solidFill>
                   <a:srgbClr val="FFFFFF"/>
@@ -16617,6 +16859,7 @@
           <a:lstStyle xmlns:a="http://schemas.openxmlformats.org/drawingml/2006/main"/>
           <a:p xmlns:a="http://schemas.openxmlformats.org/drawingml/2006/main">
             <a:pPr algn="l">
+              <a:buNone/>
               <a:defRPr sz="1650" b="1" i="0">
                 <a:solidFill>
                   <a:srgbClr val="FFFFFF"/>
@@ -16698,6 +16941,7 @@
           <a:lstStyle xmlns:a="http://schemas.openxmlformats.org/drawingml/2006/main"/>
           <a:p xmlns:a="http://schemas.openxmlformats.org/drawingml/2006/main">
             <a:pPr algn="l">
+              <a:buNone/>
               <a:defRPr sz="1125" b="0" i="0">
                 <a:solidFill>
                   <a:srgbClr val="B8C0CE"/>
@@ -16710,11 +16954,12 @@
                   <a:srgbClr val="B8C0CE"/>
                 </a:solidFill>
               </a:rPr>
-              <a:t>공통 동선과 다른 고객사에</a:t>
-            </a:r>
-          </a:p>
-          <a:p xmlns:a="http://schemas.openxmlformats.org/drawingml/2006/main">
-            <a:pPr algn="l">
+              <a:t>공통 플랫폼 유지와</a:t>
+            </a:r>
+          </a:p>
+          <a:p xmlns:a="http://schemas.openxmlformats.org/drawingml/2006/main">
+            <a:pPr algn="l">
+              <a:buNone/>
               <a:defRPr sz="1125" b="0" i="0">
                 <a:solidFill>
                   <a:srgbClr val="B8C0CE"/>
@@ -16727,7 +16972,7 @@
                   <a:srgbClr val="B8C0CE"/>
                 </a:solidFill>
               </a:rPr>
-              <a:t>영향이 없는 범위로 분리</a:t>
+              <a:t>고객사별 영향 범위 분리</a:t>
             </a:r>
           </a:p>
         </p:txBody>
@@ -16765,6 +17010,7 @@
           <a:lstStyle xmlns:a="http://schemas.openxmlformats.org/drawingml/2006/main"/>
           <a:p xmlns:a="http://schemas.openxmlformats.org/drawingml/2006/main">
             <a:pPr algn="l">
+              <a:buNone/>
               <a:defRPr sz="1500" b="1" i="0">
                 <a:solidFill>
                   <a:srgbClr val="3157FF"/>
@@ -16777,7 +17023,7 @@
                   <a:srgbClr val="3157FF"/>
                 </a:solidFill>
               </a:rPr>
-              <a:t>고객사별 요구</a:t>
+              <a:t>고객사별 기능·정책</a:t>
             </a:r>
           </a:p>
         </p:txBody>
@@ -16846,6 +17092,7 @@
           <a:lstStyle xmlns:a="http://schemas.openxmlformats.org/drawingml/2006/main"/>
           <a:p xmlns:a="http://schemas.openxmlformats.org/drawingml/2006/main">
             <a:pPr algn="l">
+              <a:buNone/>
               <a:defRPr sz="1350" b="0" i="0">
                 <a:solidFill>
                   <a:srgbClr val="121722"/>
@@ -16858,7 +17105,7 @@
                   <a:srgbClr val="121722"/>
                 </a:solidFill>
               </a:rPr>
-              <a:t>복지카드 · 예약/신청 · 개인정보/동의</a:t>
+              <a:t>복지카드 · 예약/신청 · 개인정보/동의 기능 개발</a:t>
             </a:r>
           </a:p>
         </p:txBody>
@@ -16927,6 +17174,7 @@
           <a:lstStyle xmlns:a="http://schemas.openxmlformats.org/drawingml/2006/main"/>
           <a:p xmlns:a="http://schemas.openxmlformats.org/drawingml/2006/main">
             <a:pPr algn="l">
+              <a:buNone/>
               <a:defRPr sz="1350" b="0" i="0">
                 <a:solidFill>
                   <a:srgbClr val="121722"/>
@@ -16939,7 +17187,7 @@
                   <a:srgbClr val="121722"/>
                 </a:solidFill>
               </a:rPr>
-              <a:t>PC/Mobile 화면과 백오피스 데이터 동시 반영</a:t>
+              <a:t>PC/Mobile과 백오피스 간 데이터 정합성 유지</a:t>
             </a:r>
           </a:p>
         </p:txBody>
@@ -17008,6 +17256,7 @@
           <a:lstStyle xmlns:a="http://schemas.openxmlformats.org/drawingml/2006/main"/>
           <a:p xmlns:a="http://schemas.openxmlformats.org/drawingml/2006/main">
             <a:pPr algn="l">
+              <a:buNone/>
               <a:defRPr sz="1350" b="0" i="0">
                 <a:solidFill>
                   <a:srgbClr val="121722"/>
@@ -17020,7 +17269,7 @@
                   <a:srgbClr val="121722"/>
                 </a:solidFill>
               </a:rPr>
-              <a:t>현재값과 변경 이력을 함께 관리하는 데이터 구조</a:t>
+              <a:t>현재값과 변경 이력을 분리 관리해 변경 추적성 확보</a:t>
             </a:r>
           </a:p>
         </p:txBody>
@@ -17058,6 +17307,7 @@
           <a:lstStyle xmlns:a="http://schemas.openxmlformats.org/drawingml/2006/main"/>
           <a:p xmlns:a="http://schemas.openxmlformats.org/drawingml/2006/main">
             <a:pPr algn="l">
+              <a:buNone/>
               <a:defRPr sz="1500" b="1" i="0">
                 <a:solidFill>
                   <a:srgbClr val="3157FF"/>
@@ -17070,7 +17320,7 @@
                   <a:srgbClr val="3157FF"/>
                 </a:solidFill>
               </a:rPr>
-              <a:t>검증 기준</a:t>
+              <a:t>보안 점검 및 개선</a:t>
             </a:r>
           </a:p>
         </p:txBody>
@@ -17108,6 +17358,7 @@
           <a:lstStyle xmlns:a="http://schemas.openxmlformats.org/drawingml/2006/main"/>
           <a:p xmlns:a="http://schemas.openxmlformats.org/drawingml/2006/main">
             <a:pPr algn="l">
+              <a:buNone/>
               <a:defRPr sz="1275" b="0" i="0">
                 <a:solidFill>
                   <a:srgbClr val="121722"/>
@@ -17120,7 +17371,7 @@
                   <a:srgbClr val="121722"/>
                 </a:solidFill>
               </a:rPr>
-              <a:t>로그인·신청·조회·동의 저장 흐름을 유지한 상태에서 XSS/CSRF, 접근제어, 세션, 정보노출 항목 조치</a:t>
+              <a:t>기존 업무 흐름을 유지하며 XSS/CSRF, 접근제어, 세션, 정보노출 항목 개선</a:t>
             </a:r>
           </a:p>
         </p:txBody>
@@ -17158,6 +17409,7 @@
           <a:lstStyle xmlns:a="http://schemas.openxmlformats.org/drawingml/2006/main"/>
           <a:p xmlns:a="http://schemas.openxmlformats.org/drawingml/2006/main">
             <a:pPr algn="l">
+              <a:buNone/>
               <a:defRPr sz="900" b="1" i="0">
                 <a:solidFill>
                   <a:srgbClr val="EE6A5F"/>
@@ -17170,7 +17422,7 @@
                   <a:srgbClr val="EE6A5F"/>
                 </a:solidFill>
               </a:rPr>
-              <a:t>ISMS / e-privacy</a:t>
+              <a:t>ISMS / e-Privacy</a:t>
             </a:r>
           </a:p>
         </p:txBody>
@@ -17239,6 +17491,7 @@
           <a:lstStyle xmlns:a="http://schemas.openxmlformats.org/drawingml/2006/main"/>
           <a:p xmlns:a="http://schemas.openxmlformats.org/drawingml/2006/main">
             <a:pPr algn="l">
+              <a:buNone/>
               <a:defRPr sz="675" b="1" i="0">
                 <a:solidFill>
                   <a:srgbClr val="9AA3B2"/>
@@ -17289,6 +17542,7 @@
           <a:lstStyle xmlns:a="http://schemas.openxmlformats.org/drawingml/2006/main"/>
           <a:p xmlns:a="http://schemas.openxmlformats.org/drawingml/2006/main">
             <a:pPr algn="r">
+              <a:buNone/>
               <a:defRPr sz="750" b="1" i="0">
                 <a:solidFill>
                   <a:srgbClr val="9AA3B2"/>
@@ -17368,6 +17622,7 @@
           <a:lstStyle xmlns:a="http://schemas.openxmlformats.org/drawingml/2006/main"/>
           <a:p xmlns:a="http://schemas.openxmlformats.org/drawingml/2006/main">
             <a:pPr algn="l">
+              <a:buNone/>
               <a:defRPr sz="975" b="1" i="0">
                 <a:solidFill>
                   <a:srgbClr val="3157FF"/>
@@ -17449,6 +17704,7 @@
           <a:lstStyle xmlns:a="http://schemas.openxmlformats.org/drawingml/2006/main"/>
           <a:p xmlns:a="http://schemas.openxmlformats.org/drawingml/2006/main">
             <a:pPr algn="l">
+              <a:buNone/>
               <a:defRPr sz="975" b="1" i="0">
                 <a:solidFill>
                   <a:srgbClr val="5B6472"/>
@@ -17499,6 +17755,7 @@
           <a:lstStyle xmlns:a="http://schemas.openxmlformats.org/drawingml/2006/main"/>
           <a:p xmlns:a="http://schemas.openxmlformats.org/drawingml/2006/main">
             <a:pPr algn="l">
+              <a:buNone/>
               <a:defRPr sz="2700" b="1" i="0">
                 <a:solidFill>
                   <a:srgbClr val="121722"/>
@@ -17511,7 +17768,7 @@
                   <a:srgbClr val="121722"/>
                 </a:solidFill>
               </a:rPr>
-              <a:t>Python AI API 구축과 운영 배포</a:t>
+              <a:t>여행 AI Q&amp;A Gateway API 구축과 운영 배포</a:t>
             </a:r>
           </a:p>
         </p:txBody>
@@ -17549,6 +17806,7 @@
           <a:lstStyle xmlns:a="http://schemas.openxmlformats.org/drawingml/2006/main"/>
           <a:p xmlns:a="http://schemas.openxmlformats.org/drawingml/2006/main">
             <a:pPr algn="l">
+              <a:buNone/>
               <a:defRPr sz="975" b="1" i="0">
                 <a:solidFill>
                   <a:srgbClr val="3157FF"/>
@@ -17561,7 +17819,7 @@
                   <a:srgbClr val="3157FF"/>
                 </a:solidFill>
               </a:rPr>
-              <a:t>여행 AI Q&amp;A API  ·  2023 TF</a:t>
+              <a:t>2023 · CTO와 2인 TF · Azure OpenAI GPT-3.5 Turbo</a:t>
             </a:r>
           </a:p>
         </p:txBody>
@@ -17599,6 +17857,7 @@
           <a:lstStyle xmlns:a="http://schemas.openxmlformats.org/drawingml/2006/main"/>
           <a:p xmlns:a="http://schemas.openxmlformats.org/drawingml/2006/main">
             <a:pPr algn="l">
+              <a:buNone/>
               <a:defRPr sz="1500" b="1" i="0">
                 <a:solidFill>
                   <a:srgbClr val="121722"/>
@@ -17680,6 +17939,7 @@
           <a:lstStyle xmlns:a="http://schemas.openxmlformats.org/drawingml/2006/main"/>
           <a:p xmlns:a="http://schemas.openxmlformats.org/drawingml/2006/main">
             <a:pPr algn="l">
+              <a:buNone/>
               <a:defRPr sz="1275" b="0" i="0">
                 <a:solidFill>
                   <a:srgbClr val="121722"/>
@@ -17692,7 +17952,7 @@
                   <a:srgbClr val="121722"/>
                 </a:solidFill>
               </a:rPr>
-              <a:t>Python/Flask Gateway API와 요청·응답 JSON 설계</a:t>
+              <a:t>Python/Flask Gateway API와 JSON 응답 규격·형식 이탈 검증</a:t>
             </a:r>
           </a:p>
         </p:txBody>
@@ -17761,6 +18021,7 @@
           <a:lstStyle xmlns:a="http://schemas.openxmlformats.org/drawingml/2006/main"/>
           <a:p xmlns:a="http://schemas.openxmlformats.org/drawingml/2006/main">
             <a:pPr algn="l">
+              <a:buNone/>
               <a:defRPr sz="1275" b="0" i="0">
                 <a:solidFill>
                   <a:srgbClr val="121722"/>
@@ -17842,6 +18103,7 @@
           <a:lstStyle xmlns:a="http://schemas.openxmlformats.org/drawingml/2006/main"/>
           <a:p xmlns:a="http://schemas.openxmlformats.org/drawingml/2006/main">
             <a:pPr algn="l">
+              <a:buNone/>
               <a:defRPr sz="1275" b="0" i="0">
                 <a:solidFill>
                   <a:srgbClr val="121722"/>
@@ -17854,7 +18116,7 @@
                   <a:srgbClr val="121722"/>
                 </a:solidFill>
               </a:rPr>
-              <a:t>Oracle 대화 이력과 세션별 최근 맥락 관리</a:t>
+              <a:t>질문·답변 이력은 Oracle, 최근 맥락은 인메모리 LRU 캐시로 관리</a:t>
             </a:r>
           </a:p>
         </p:txBody>
@@ -17923,6 +18185,7 @@
           <a:lstStyle xmlns:a="http://schemas.openxmlformats.org/drawingml/2006/main"/>
           <a:p xmlns:a="http://schemas.openxmlformats.org/drawingml/2006/main">
             <a:pPr algn="l">
+              <a:buNone/>
               <a:defRPr sz="1275" b="0" i="0">
                 <a:solidFill>
                   <a:srgbClr val="121722"/>
@@ -17935,7 +18198,7 @@
                   <a:srgbClr val="121722"/>
                 </a:solidFill>
               </a:rPr>
-              <a:t>Docker · GitLab CI · Nomad · health check 검증</a:t>
+              <a:t>Docker · GitLab CI · Nomad 배포와 Proxy · 로그 · health check 검증</a:t>
             </a:r>
           </a:p>
         </p:txBody>
@@ -18004,6 +18267,7 @@
           <a:lstStyle xmlns:a="http://schemas.openxmlformats.org/drawingml/2006/main"/>
           <a:p xmlns:a="http://schemas.openxmlformats.org/drawingml/2006/main">
             <a:pPr algn="l">
+              <a:buNone/>
               <a:defRPr sz="825" b="1" i="0">
                 <a:solidFill>
                   <a:srgbClr val="8993A7"/>
@@ -18054,6 +18318,7 @@
           <a:lstStyle xmlns:a="http://schemas.openxmlformats.org/drawingml/2006/main"/>
           <a:p xmlns:a="http://schemas.openxmlformats.org/drawingml/2006/main">
             <a:pPr algn="l">
+              <a:buNone/>
               <a:defRPr sz="1275" b="1" i="0">
                 <a:solidFill>
                   <a:srgbClr val="FFFFFF"/>
@@ -18066,11 +18331,12 @@
                   <a:srgbClr val="FFFFFF"/>
                 </a:solidFill>
               </a:rPr>
-              <a:t>전사 첫 Python/Flask 기반 AI Gateway API 구현,</a:t>
-            </a:r>
-          </a:p>
-          <a:p xmlns:a="http://schemas.openxmlformats.org/drawingml/2006/main">
-            <a:pPr algn="l">
+              <a:t>전사 첫 Python 기반 생성형 AI API 구축,</a:t>
+            </a:r>
+          </a:p>
+          <a:p xmlns:a="http://schemas.openxmlformats.org/drawingml/2006/main">
+            <a:pPr algn="l">
+              <a:buNone/>
               <a:defRPr sz="1275" b="1" i="0">
                 <a:solidFill>
                   <a:srgbClr val="FFFFFF"/>
@@ -18083,7 +18349,7 @@
                   <a:srgbClr val="FFFFFF"/>
                 </a:solidFill>
               </a:rPr>
-              <a:t>서비스 API와 운영 런타임 연결</a:t>
+              <a:t>API 설계부터 운영 배포까지 연결</a:t>
             </a:r>
           </a:p>
         </p:txBody>
@@ -18123,14 +18389,14 @@
       </p:sp>
       <p:pic>
         <p:nvPicPr>
-          <p:cNvPr id="43" name=""/>
+          <p:cNvPr id="47" name=""/>
           <p:cNvPicPr>
             <a:picLocks xmlns:a="http://schemas.openxmlformats.org/drawingml/2006/main" noChangeAspect="1"/>
           </p:cNvPicPr>
           <p:nvPr/>
         </p:nvPicPr>
         <p:blipFill>
-          <a:blip xmlns:r="http://schemas.openxmlformats.org/officeDocument/2006/relationships" xmlns:a="http://schemas.openxmlformats.org/drawingml/2006/main" r:embed="R5c8e87929b1b4c07"/>
+          <a:blip xmlns:r="http://schemas.openxmlformats.org/officeDocument/2006/relationships" xmlns:a="http://schemas.openxmlformats.org/drawingml/2006/main" r:embed="R523baa63eba7478e"/>
           <a:stretch xmlns:a="http://schemas.openxmlformats.org/drawingml/2006/main"/>
         </p:blipFill>
         <p:spPr>
@@ -18147,14 +18413,14 @@
       </p:pic>
       <p:pic>
         <p:nvPicPr>
-          <p:cNvPr id="44" name=""/>
+          <p:cNvPr id="48" name=""/>
           <p:cNvPicPr>
             <a:picLocks xmlns:a="http://schemas.openxmlformats.org/drawingml/2006/main" noChangeAspect="1"/>
           </p:cNvPicPr>
           <p:nvPr/>
         </p:nvPicPr>
         <p:blipFill>
-          <a:blip xmlns:r="http://schemas.openxmlformats.org/officeDocument/2006/relationships" xmlns:a="http://schemas.openxmlformats.org/drawingml/2006/main" r:embed="Ra62a132447184ec5"/>
+          <a:blip xmlns:r="http://schemas.openxmlformats.org/officeDocument/2006/relationships" xmlns:a="http://schemas.openxmlformats.org/drawingml/2006/main" r:embed="R50b9a4fa7ad64c98"/>
           <a:stretch xmlns:a="http://schemas.openxmlformats.org/drawingml/2006/main"/>
         </p:blipFill>
         <p:spPr>
@@ -18171,14 +18437,14 @@
       </p:pic>
       <p:pic>
         <p:nvPicPr>
-          <p:cNvPr id="45" name=""/>
+          <p:cNvPr id="49" name=""/>
           <p:cNvPicPr>
             <a:picLocks xmlns:a="http://schemas.openxmlformats.org/drawingml/2006/main" noChangeAspect="1"/>
           </p:cNvPicPr>
           <p:nvPr/>
         </p:nvPicPr>
         <p:blipFill>
-          <a:blip xmlns:r="http://schemas.openxmlformats.org/officeDocument/2006/relationships" xmlns:a="http://schemas.openxmlformats.org/drawingml/2006/main" r:embed="R2286f24b96064e31"/>
+          <a:blip xmlns:r="http://schemas.openxmlformats.org/officeDocument/2006/relationships" xmlns:a="http://schemas.openxmlformats.org/drawingml/2006/main" r:embed="Re2437d7200034c75"/>
           <a:stretch xmlns:a="http://schemas.openxmlformats.org/drawingml/2006/main"/>
         </p:blipFill>
         <p:spPr>
@@ -18257,6 +18523,7 @@
           <a:lstStyle xmlns:a="http://schemas.openxmlformats.org/drawingml/2006/main"/>
           <a:p xmlns:a="http://schemas.openxmlformats.org/drawingml/2006/main">
             <a:pPr algn="l">
+              <a:buNone/>
               <a:defRPr sz="675" b="1" i="0">
                 <a:solidFill>
                   <a:srgbClr val="9AA3B2"/>
@@ -18307,6 +18574,7 @@
           <a:lstStyle xmlns:a="http://schemas.openxmlformats.org/drawingml/2006/main"/>
           <a:p xmlns:a="http://schemas.openxmlformats.org/drawingml/2006/main">
             <a:pPr algn="r">
+              <a:buNone/>
               <a:defRPr sz="750" b="1" i="0">
                 <a:solidFill>
                   <a:srgbClr val="9AA3B2"/>

</xml_diff>

<commit_message>
refine public portfolio content
</commit_message>
<xml_diff>
--- a/portfolio/heetae-lee-portfolio.pptx
+++ b/portfolio/heetae-lee-portfolio.pptx
@@ -2,122 +2,27 @@
 <file path=ppt/presentation.xml><?xml version="1.0" encoding="utf-8"?>
 <p:presentation xmlns:p="http://schemas.openxmlformats.org/presentationml/2006/main">
   <p:sldMasterIdLst>
-    <p:sldMasterId xmlns:r="http://schemas.openxmlformats.org/officeDocument/2006/relationships" id="2147483648" r:id="R4e06be09b84d468f"/>
+    <p:sldMasterId xmlns:r="http://schemas.openxmlformats.org/officeDocument/2006/relationships" id="2147483648" r:id="R4ef3a3ec77a44719"/>
   </p:sldMasterIdLst>
   <p:notesMasterIdLst>
-    <p:notesMasterId xmlns:r="http://schemas.openxmlformats.org/officeDocument/2006/relationships" r:id="R2d3457316fd24f5f"/>
+    <p:notesMasterId xmlns:r="http://schemas.openxmlformats.org/officeDocument/2006/relationships" r:id="Re7f2a0a43e1e482a"/>
   </p:notesMasterIdLst>
   <p:sldIdLst>
-    <p:sldId xmlns:r="http://schemas.openxmlformats.org/officeDocument/2006/relationships" id="256" r:id="R475f42047c0440b5"/>
-    <p:sldId xmlns:r="http://schemas.openxmlformats.org/officeDocument/2006/relationships" id="257" r:id="Rbb21996d096544bd"/>
-    <p:sldId xmlns:r="http://schemas.openxmlformats.org/officeDocument/2006/relationships" id="258" r:id="Rf1b9fedf51484320"/>
-    <p:sldId xmlns:r="http://schemas.openxmlformats.org/officeDocument/2006/relationships" id="259" r:id="Re67da3bd1f764449"/>
-    <p:sldId xmlns:r="http://schemas.openxmlformats.org/officeDocument/2006/relationships" id="260" r:id="Re9557b4d3a7c40e3"/>
-    <p:sldId xmlns:r="http://schemas.openxmlformats.org/officeDocument/2006/relationships" id="261" r:id="Re0158a08698d4a5a"/>
-    <p:sldId xmlns:r="http://schemas.openxmlformats.org/officeDocument/2006/relationships" id="262" r:id="Rafd58a1634b7438c"/>
-    <p:sldId xmlns:r="http://schemas.openxmlformats.org/officeDocument/2006/relationships" id="263" r:id="R27c3c27090504e4c"/>
-    <p:sldId xmlns:r="http://schemas.openxmlformats.org/officeDocument/2006/relationships" id="264" r:id="R5e0f52efc99846a1"/>
-    <p:sldId xmlns:r="http://schemas.openxmlformats.org/officeDocument/2006/relationships" id="265" r:id="R92e126e843814dd5"/>
-    <p:sldId xmlns:r="http://schemas.openxmlformats.org/officeDocument/2006/relationships" id="266" r:id="Rdc219ff9fce445c8"/>
-    <p:sldId xmlns:r="http://schemas.openxmlformats.org/officeDocument/2006/relationships" id="267" r:id="Ra1aff5472af44d2b"/>
+    <p:sldId xmlns:r="http://schemas.openxmlformats.org/officeDocument/2006/relationships" id="256" r:id="Rb7646f7ee8f9441a"/>
+    <p:sldId xmlns:r="http://schemas.openxmlformats.org/officeDocument/2006/relationships" id="257" r:id="Rb09a72833a8346a1"/>
+    <p:sldId xmlns:r="http://schemas.openxmlformats.org/officeDocument/2006/relationships" id="258" r:id="R8cf48e6bdc574141"/>
+    <p:sldId xmlns:r="http://schemas.openxmlformats.org/officeDocument/2006/relationships" id="259" r:id="R67c540ab5f5446cb"/>
+    <p:sldId xmlns:r="http://schemas.openxmlformats.org/officeDocument/2006/relationships" id="260" r:id="R83df26787397448d"/>
+    <p:sldId xmlns:r="http://schemas.openxmlformats.org/officeDocument/2006/relationships" id="261" r:id="R6489144410c447bf"/>
+    <p:sldId xmlns:r="http://schemas.openxmlformats.org/officeDocument/2006/relationships" id="262" r:id="R47dc6b68cd844b80"/>
+    <p:sldId xmlns:r="http://schemas.openxmlformats.org/officeDocument/2006/relationships" id="263" r:id="R882da648e35f4862"/>
+    <p:sldId xmlns:r="http://schemas.openxmlformats.org/officeDocument/2006/relationships" id="264" r:id="Rd75448a664124a63"/>
+    <p:sldId xmlns:r="http://schemas.openxmlformats.org/officeDocument/2006/relationships" id="265" r:id="Rca19bf16e50a45a7"/>
+    <p:sldId xmlns:r="http://schemas.openxmlformats.org/officeDocument/2006/relationships" id="266" r:id="Rcd8774d6658547d6"/>
+    <p:sldId xmlns:r="http://schemas.openxmlformats.org/officeDocument/2006/relationships" id="267" r:id="R56f8a430845e4e08"/>
   </p:sldIdLst>
   <p:sldSz cx="12192000" cy="6858000"/>
   <p:notesSz cx="6858000" cy="9144000"/>
-  <p:defaultTextStyle>
-    <a:defPPr xmlns:a="http://schemas.openxmlformats.org/drawingml/2006/main">
-      <a:defRPr lang="en-US"/>
-    </a:defPPr>
-    <a:lvl1pPr xmlns:a="http://schemas.openxmlformats.org/drawingml/2006/main" marL="0" indent="0" algn="l" defTabSz="914400">
-      <a:defRPr sz="1800" kern="1200">
-        <a:solidFill>
-          <a:schemeClr val="tx1"/>
-        </a:solidFill>
-        <a:latin typeface="+mn-lt"/>
-        <a:ea typeface="+mn-ea"/>
-        <a:cs typeface="+mn-cs"/>
-      </a:defRPr>
-    </a:lvl1pPr>
-    <a:lvl2pPr xmlns:a="http://schemas.openxmlformats.org/drawingml/2006/main" marL="457200" indent="0" algn="l" defTabSz="914400">
-      <a:defRPr sz="1800" kern="1200">
-        <a:solidFill>
-          <a:schemeClr val="tx1"/>
-        </a:solidFill>
-        <a:latin typeface="+mn-lt"/>
-        <a:ea typeface="+mn-ea"/>
-        <a:cs typeface="+mn-cs"/>
-      </a:defRPr>
-    </a:lvl2pPr>
-    <a:lvl3pPr xmlns:a="http://schemas.openxmlformats.org/drawingml/2006/main" marL="914400" indent="0" algn="l" defTabSz="914400">
-      <a:defRPr sz="1800" kern="1200">
-        <a:solidFill>
-          <a:schemeClr val="tx1"/>
-        </a:solidFill>
-        <a:latin typeface="+mn-lt"/>
-        <a:ea typeface="+mn-ea"/>
-        <a:cs typeface="+mn-cs"/>
-      </a:defRPr>
-    </a:lvl3pPr>
-    <a:lvl4pPr xmlns:a="http://schemas.openxmlformats.org/drawingml/2006/main" marL="1371600" indent="0" algn="l" defTabSz="914400">
-      <a:defRPr sz="1800" kern="1200">
-        <a:solidFill>
-          <a:schemeClr val="tx1"/>
-        </a:solidFill>
-        <a:latin typeface="+mn-lt"/>
-        <a:ea typeface="+mn-ea"/>
-        <a:cs typeface="+mn-cs"/>
-      </a:defRPr>
-    </a:lvl4pPr>
-    <a:lvl5pPr xmlns:a="http://schemas.openxmlformats.org/drawingml/2006/main" marL="1828800" indent="0" algn="l" defTabSz="914400">
-      <a:defRPr sz="1800" kern="1200">
-        <a:solidFill>
-          <a:schemeClr val="tx1"/>
-        </a:solidFill>
-        <a:latin typeface="+mn-lt"/>
-        <a:ea typeface="+mn-ea"/>
-        <a:cs typeface="+mn-cs"/>
-      </a:defRPr>
-    </a:lvl5pPr>
-    <a:lvl6pPr xmlns:a="http://schemas.openxmlformats.org/drawingml/2006/main" marL="2286000" indent="0" algn="l" defTabSz="914400">
-      <a:defRPr sz="1800" kern="1200">
-        <a:solidFill>
-          <a:schemeClr val="tx1"/>
-        </a:solidFill>
-        <a:latin typeface="+mn-lt"/>
-        <a:ea typeface="+mn-ea"/>
-        <a:cs typeface="+mn-cs"/>
-      </a:defRPr>
-    </a:lvl6pPr>
-    <a:lvl7pPr xmlns:a="http://schemas.openxmlformats.org/drawingml/2006/main" marL="2743200" indent="0" algn="l" defTabSz="914400">
-      <a:defRPr sz="1800" kern="1200">
-        <a:solidFill>
-          <a:schemeClr val="tx1"/>
-        </a:solidFill>
-        <a:latin typeface="+mn-lt"/>
-        <a:ea typeface="+mn-ea"/>
-        <a:cs typeface="+mn-cs"/>
-      </a:defRPr>
-    </a:lvl7pPr>
-    <a:lvl8pPr xmlns:a="http://schemas.openxmlformats.org/drawingml/2006/main" marL="3200400" indent="0" algn="l" defTabSz="914400">
-      <a:defRPr sz="1800" kern="1200">
-        <a:solidFill>
-          <a:schemeClr val="tx1"/>
-        </a:solidFill>
-        <a:latin typeface="+mn-lt"/>
-        <a:ea typeface="+mn-ea"/>
-        <a:cs typeface="+mn-cs"/>
-      </a:defRPr>
-    </a:lvl8pPr>
-    <a:lvl9pPr xmlns:a="http://schemas.openxmlformats.org/drawingml/2006/main" marL="3657600" indent="0" algn="l" defTabSz="914400">
-      <a:defRPr sz="1800" kern="1200">
-        <a:solidFill>
-          <a:schemeClr val="tx1"/>
-        </a:solidFill>
-        <a:latin typeface="+mn-lt"/>
-        <a:ea typeface="+mn-ea"/>
-        <a:cs typeface="+mn-cs"/>
-      </a:defRPr>
-    </a:lvl9pPr>
-  </p:defaultTextStyle>
 </p:presentation>
 </file>
 
@@ -1338,7 +1243,7 @@
   </p:cSld>
   <p:clrMap bg1="lt1" tx1="dk1" bg2="lt2" tx2="dk2" accent1="accent1" accent2="accent2" accent3="accent3" accent4="accent4" accent5="accent5" accent6="accent6" hlink="hlink" folHlink="folHlink"/>
   <p:sldLayoutIdLst>
-    <p:sldLayoutId xmlns:r="http://schemas.openxmlformats.org/officeDocument/2006/relationships" id="2147483649" r:id="R6d68f4e744974ff4"/>
+    <p:sldLayoutId xmlns:r="http://schemas.openxmlformats.org/officeDocument/2006/relationships" id="2147483649" r:id="R83a1b0fbb5c840b2"/>
   </p:sldLayoutIdLst>
   <p:txStyles>
     <p:titleStyle>
@@ -5364,7 +5269,7 @@
                   <a:srgbClr val="5B6472"/>
                 </a:solidFill>
               </a:rPr>
-              <a:t>Java · Concurrency · WebFlux</a:t>
+              <a:t>Java · Transaction · WebFlux</a:t>
             </a:r>
           </a:p>
         </p:txBody>
@@ -5415,7 +5320,7 @@
                   <a:srgbClr val="121722"/>
                 </a:solidFill>
               </a:rPr>
-              <a:t>순서 안정화·실패 격리</a:t>
+              <a:t>트랜잭션 경계·실패 격리</a:t>
             </a:r>
           </a:p>
         </p:txBody>
@@ -10745,7 +10650,7 @@
                   <a:srgbClr val="121722"/>
                 </a:solidFill>
               </a:rPr>
-              <a:t>Java · Spring Boot · REST API · Batch</a:t>
+              <a:t>Java · Spring Boot · REST API · Batch · Transaction</a:t>
             </a:r>
           </a:p>
         </p:txBody>
@@ -12431,7 +12336,7 @@
                   <a:srgbClr val="121722"/>
                 </a:solidFill>
               </a:rPr>
-              <a:t>실시간 주문 API와 일배치, 적재·정규화·재처리·검색 노출을 연결한 검증 흐름</a:t>
+              <a:t>복수 제휴사의 주문·상품 데이터를 API·배치·DB·검색 노출 기준으로 검증</a:t>
             </a:r>
           </a:p>
         </p:txBody>
@@ -13464,7 +13369,7 @@
                   <a:srgbClr val="121722"/>
                 </a:solidFill>
               </a:rPr>
-              <a:t>재사용 가능한 온보딩 체크리스트 구축, 데이터 불일치 원인 추적 범위 축소</a:t>
+              <a:t>온보딩 검증 표준화 · 주문/후속 처리 트랜잭션 경계 분리</a:t>
             </a:r>
           </a:p>
         </p:txBody>
@@ -13861,7 +13766,7 @@
                   <a:srgbClr val="5B6472"/>
                 </a:solidFill>
               </a:rPr>
-              <a:t>적용된 Thread·WebFlux 경로를 분석하고, 순서 안정화와 부분 실패 격리를 개선</a:t>
+              <a:t>비동기 작업 집계와 실패 격리를 개선하고, Thread·WebFlux 기반 검색 경로를 분석·운영</a:t>
             </a:r>
           </a:p>
         </p:txBody>
@@ -14045,7 +13950,7 @@
                   <a:srgbClr val="B8C0CE"/>
                 </a:solidFill>
               </a:rPr>
-              <a:t>Thread / WebFlux 경로가</a:t>
+              <a:t>비동기 검색 경로 +</a:t>
             </a:r>
           </a:p>
           <a:p xmlns:a="http://schemas.openxmlformats.org/drawingml/2006/main">
@@ -14063,7 +13968,7 @@
                   <a:srgbClr val="B8C0CE"/>
                 </a:solidFill>
               </a:rPr>
-              <a:t>공존하는 운영 서비스</a:t>
+              <a:t>Thread / WebFlux</a:t>
             </a:r>
           </a:p>
         </p:txBody>
@@ -14369,7 +14274,7 @@
                   <a:srgbClr val="5B6472"/>
                 </a:solidFill>
               </a:rPr>
-              <a:t>검색 후보를 제휴사별 API로 동시에 검증</a:t>
+              <a:t>검색 후보를 복수 제휴 API로 병렬 검증</a:t>
             </a:r>
           </a:p>
         </p:txBody>
@@ -14870,7 +14775,7 @@
                   <a:srgbClr val="121722"/>
                 </a:solidFill>
               </a:rPr>
-              <a:t>구조 분석</a:t>
+              <a:t>검색 경로 운영</a:t>
             </a:r>
           </a:p>
         </p:txBody>
@@ -14921,7 +14826,7 @@
                   <a:srgbClr val="5B6472"/>
                 </a:solidFill>
               </a:rPr>
-              <a:t>현재 WebFlux 경로와 선택 가능한 Thread 경로 분석</a:t>
+              <a:t>Thread·WebFlux 기반 검색 경로 분석·운영</a:t>
             </a:r>
           </a:p>
         </p:txBody>
@@ -15023,7 +14928,7 @@
                   <a:srgbClr val="121722"/>
                 </a:solidFill>
               </a:rPr>
-              <a:t>기능 개발·운영 · 작업 순서 안정화 · 실패 격리 개선</a:t>
+              <a:t>작업 집계·실패 격리 개선 · Thread·WebFlux 경로 분석·운영</a:t>
             </a:r>
           </a:p>
         </p:txBody>
@@ -18396,7 +18301,7 @@
           <p:nvPr/>
         </p:nvPicPr>
         <p:blipFill>
-          <a:blip xmlns:r="http://schemas.openxmlformats.org/officeDocument/2006/relationships" xmlns:a="http://schemas.openxmlformats.org/drawingml/2006/main" r:embed="R523baa63eba7478e"/>
+          <a:blip xmlns:r="http://schemas.openxmlformats.org/officeDocument/2006/relationships" xmlns:a="http://schemas.openxmlformats.org/drawingml/2006/main" r:embed="R428773015e1d441e"/>
           <a:stretch xmlns:a="http://schemas.openxmlformats.org/drawingml/2006/main"/>
         </p:blipFill>
         <p:spPr>
@@ -18420,7 +18325,7 @@
           <p:nvPr/>
         </p:nvPicPr>
         <p:blipFill>
-          <a:blip xmlns:r="http://schemas.openxmlformats.org/officeDocument/2006/relationships" xmlns:a="http://schemas.openxmlformats.org/drawingml/2006/main" r:embed="R50b9a4fa7ad64c98"/>
+          <a:blip xmlns:r="http://schemas.openxmlformats.org/officeDocument/2006/relationships" xmlns:a="http://schemas.openxmlformats.org/drawingml/2006/main" r:embed="R33e4a4f4ff394956"/>
           <a:stretch xmlns:a="http://schemas.openxmlformats.org/drawingml/2006/main"/>
         </p:blipFill>
         <p:spPr>
@@ -18444,7 +18349,7 @@
           <p:nvPr/>
         </p:nvPicPr>
         <p:blipFill>
-          <a:blip xmlns:r="http://schemas.openxmlformats.org/officeDocument/2006/relationships" xmlns:a="http://schemas.openxmlformats.org/drawingml/2006/main" r:embed="Re2437d7200034c75"/>
+          <a:blip xmlns:r="http://schemas.openxmlformats.org/officeDocument/2006/relationships" xmlns:a="http://schemas.openxmlformats.org/drawingml/2006/main" r:embed="Rc8352f64eb4d4528"/>
           <a:stretch xmlns:a="http://schemas.openxmlformats.org/drawingml/2006/main"/>
         </p:blipFill>
         <p:spPr>

</xml_diff>